<commit_message>
Clean project documentation and deliverables
</commit_message>
<xml_diff>
--- a/output/presentation/CricketShot_Presentation.pptx
+++ b/output/presentation/CricketShot_Presentation.pptx
@@ -205,7 +205,7 @@
             </a:lvl1pPr>
           </a:lstStyle>
           <a:p>
-            <a:fld id="{0C5AE9AC-E438-49A9-8ABC-84DD776DB387}" type="datetimeFigureOut">
+            <a:fld id="{8EA1E190-EFFB-42FC-9DC9-28C1116B9AC7}" type="datetimeFigureOut">
               <a:rPr lang="en-IN" smtClean="0"/>
               <a:t>19-10-2026</a:t>
             </a:fld>
@@ -364,7 +364,7 @@
             </a:lvl1pPr>
           </a:lstStyle>
           <a:p>
-            <a:fld id="{0F264B00-0AA8-414D-9EBF-42C01D614C40}" type="slidenum">
+            <a:fld id="{934E0F31-365A-4FEA-968B-76B74F55F034}" type="slidenum">
               <a:rPr lang="en-IN" smtClean="0"/>
               <a:t>‹#›</a:t>
             </a:fld>
@@ -375,7 +375,7 @@
     </p:spTree>
     <p:extLst>
       <p:ext uri="{BB962C8B-B14F-4D97-AF65-F5344CB8AC3E}">
-        <p14:creationId xmlns:p14="http://schemas.microsoft.com/office/powerpoint/2010/main" val="3346762105"/>
+        <p14:creationId xmlns:p14="http://schemas.microsoft.com/office/powerpoint/2010/main" val="961058890"/>
       </p:ext>
     </p:extLst>
   </p:cSld>
@@ -521,7 +521,7 @@
           <a:p>
             <a:r>
               <a:rPr lang="en-US"/>
-              <a:t>Introduce one-image classification. HOG and frozen features connect directly to lectures 10 and 15. The two-view difference is a small extension to test, not a new backbone. Cover image: selected held-out source image, https://www.kaggle.com/datasets/aneesh10/cricket-shot-dataset v2. Assistance and actual contributions must be attributed accurately.</a:t>
+              <a:t>Introduce one-image classification. HOG and frozen features connect directly to lectures 10 and 15. The two-view difference is a small extension to test, not a new backbone. Cover image: selected held-out source image, https://www.kaggle.com/datasets/aneesh10/cricket-shot-dataset v2.</a:t>
             </a:r>
             <a:endParaRPr lang="en-IN"/>
           </a:p>
@@ -542,7 +542,7 @@
           <a:bodyPr/>
           <a:lstStyle/>
           <a:p>
-            <a:fld id="{0F264B00-0AA8-414D-9EBF-42C01D614C40}" type="slidenum">
+            <a:fld id="{934E0F31-365A-4FEA-968B-76B74F55F034}" type="slidenum">
               <a:rPr lang="en-IN" smtClean="0"/>
               <a:t>1</a:t>
             </a:fld>
@@ -553,7 +553,7 @@
     </p:spTree>
     <p:extLst>
       <p:ext uri="{BB962C8B-B14F-4D97-AF65-F5344CB8AC3E}">
-        <p14:creationId xmlns:p14="http://schemas.microsoft.com/office/powerpoint/2010/main" val="4060814377"/>
+        <p14:creationId xmlns:p14="http://schemas.microsoft.com/office/powerpoint/2010/main" val="1310685476"/>
       </p:ext>
     </p:extLst>
   </p:cSld>
@@ -630,7 +630,7 @@
           <a:bodyPr/>
           <a:lstStyle/>
           <a:p>
-            <a:fld id="{0F264B00-0AA8-414D-9EBF-42C01D614C40}" type="slidenum">
+            <a:fld id="{934E0F31-365A-4FEA-968B-76B74F55F034}" type="slidenum">
               <a:rPr lang="en-IN" smtClean="0"/>
               <a:t>10</a:t>
             </a:fld>
@@ -641,7 +641,7 @@
     </p:spTree>
     <p:extLst>
       <p:ext uri="{BB962C8B-B14F-4D97-AF65-F5344CB8AC3E}">
-        <p14:creationId xmlns:p14="http://schemas.microsoft.com/office/powerpoint/2010/main" val="402697440"/>
+        <p14:creationId xmlns:p14="http://schemas.microsoft.com/office/powerpoint/2010/main" val="866634024"/>
       </p:ext>
     </p:extLst>
   </p:cSld>
@@ -718,7 +718,7 @@
           <a:bodyPr/>
           <a:lstStyle/>
           <a:p>
-            <a:fld id="{0F264B00-0AA8-414D-9EBF-42C01D614C40}" type="slidenum">
+            <a:fld id="{934E0F31-365A-4FEA-968B-76B74F55F034}" type="slidenum">
               <a:rPr lang="en-IN" smtClean="0"/>
               <a:t>11</a:t>
             </a:fld>
@@ -729,7 +729,7 @@
     </p:spTree>
     <p:extLst>
       <p:ext uri="{BB962C8B-B14F-4D97-AF65-F5344CB8AC3E}">
-        <p14:creationId xmlns:p14="http://schemas.microsoft.com/office/powerpoint/2010/main" val="3676693255"/>
+        <p14:creationId xmlns:p14="http://schemas.microsoft.com/office/powerpoint/2010/main" val="1833032259"/>
       </p:ext>
     </p:extLst>
   </p:cSld>
@@ -806,7 +806,7 @@
           <a:bodyPr/>
           <a:lstStyle/>
           <a:p>
-            <a:fld id="{0F264B00-0AA8-414D-9EBF-42C01D614C40}" type="slidenum">
+            <a:fld id="{934E0F31-365A-4FEA-968B-76B74F55F034}" type="slidenum">
               <a:rPr lang="en-IN" smtClean="0"/>
               <a:t>12</a:t>
             </a:fld>
@@ -817,7 +817,7 @@
     </p:spTree>
     <p:extLst>
       <p:ext uri="{BB962C8B-B14F-4D97-AF65-F5344CB8AC3E}">
-        <p14:creationId xmlns:p14="http://schemas.microsoft.com/office/powerpoint/2010/main" val="3412121706"/>
+        <p14:creationId xmlns:p14="http://schemas.microsoft.com/office/powerpoint/2010/main" val="1422000428"/>
       </p:ext>
     </p:extLst>
   </p:cSld>
@@ -894,7 +894,7 @@
           <a:bodyPr/>
           <a:lstStyle/>
           <a:p>
-            <a:fld id="{0F264B00-0AA8-414D-9EBF-42C01D614C40}" type="slidenum">
+            <a:fld id="{934E0F31-365A-4FEA-968B-76B74F55F034}" type="slidenum">
               <a:rPr lang="en-IN" smtClean="0"/>
               <a:t>13</a:t>
             </a:fld>
@@ -905,7 +905,7 @@
     </p:spTree>
     <p:extLst>
       <p:ext uri="{BB962C8B-B14F-4D97-AF65-F5344CB8AC3E}">
-        <p14:creationId xmlns:p14="http://schemas.microsoft.com/office/powerpoint/2010/main" val="3384749289"/>
+        <p14:creationId xmlns:p14="http://schemas.microsoft.com/office/powerpoint/2010/main" val="2491217905"/>
       </p:ext>
     </p:extLst>
   </p:cSld>
@@ -982,7 +982,7 @@
           <a:bodyPr/>
           <a:lstStyle/>
           <a:p>
-            <a:fld id="{0F264B00-0AA8-414D-9EBF-42C01D614C40}" type="slidenum">
+            <a:fld id="{934E0F31-365A-4FEA-968B-76B74F55F034}" type="slidenum">
               <a:rPr lang="en-IN" smtClean="0"/>
               <a:t>14</a:t>
             </a:fld>
@@ -993,7 +993,7 @@
     </p:spTree>
     <p:extLst>
       <p:ext uri="{BB962C8B-B14F-4D97-AF65-F5344CB8AC3E}">
-        <p14:creationId xmlns:p14="http://schemas.microsoft.com/office/powerpoint/2010/main" val="430979655"/>
+        <p14:creationId xmlns:p14="http://schemas.microsoft.com/office/powerpoint/2010/main" val="2178512906"/>
       </p:ext>
     </p:extLst>
   </p:cSld>
@@ -1049,7 +1049,7 @@
           <a:p>
             <a:r>
               <a:rPr lang="en-US"/>
-              <a:t>Novelty remains a weakness, not a promise of marks. Do not claim a new architecture, detector or state-of-the-art result. Mention unknown upstream license, possible missed copies and unverified labels. Course mapping and viva guide contain actual page references and a tensor-shape trace. Team identities and the real repository URL are on the cover; assistance is attributed.</a:t>
+              <a:t>Novelty remains a weakness, not a promise of marks. Do not claim a new architecture, detector or state-of-the-art result. Mention unknown upstream license, possible missed copies and unverified labels. Course mapping and viva guide contain actual page references and a tensor-shape trace. Team identities and the real repository URL are on the cover.</a:t>
             </a:r>
             <a:endParaRPr lang="en-IN"/>
           </a:p>
@@ -1070,7 +1070,7 @@
           <a:bodyPr/>
           <a:lstStyle/>
           <a:p>
-            <a:fld id="{0F264B00-0AA8-414D-9EBF-42C01D614C40}" type="slidenum">
+            <a:fld id="{934E0F31-365A-4FEA-968B-76B74F55F034}" type="slidenum">
               <a:rPr lang="en-IN" smtClean="0"/>
               <a:t>15</a:t>
             </a:fld>
@@ -1081,7 +1081,7 @@
     </p:spTree>
     <p:extLst>
       <p:ext uri="{BB962C8B-B14F-4D97-AF65-F5344CB8AC3E}">
-        <p14:creationId xmlns:p14="http://schemas.microsoft.com/office/powerpoint/2010/main" val="3252886878"/>
+        <p14:creationId xmlns:p14="http://schemas.microsoft.com/office/powerpoint/2010/main" val="105600643"/>
       </p:ext>
     </p:extLst>
   </p:cSld>
@@ -1158,7 +1158,7 @@
           <a:bodyPr/>
           <a:lstStyle/>
           <a:p>
-            <a:fld id="{0F264B00-0AA8-414D-9EBF-42C01D614C40}" type="slidenum">
+            <a:fld id="{934E0F31-365A-4FEA-968B-76B74F55F034}" type="slidenum">
               <a:rPr lang="en-IN" smtClean="0"/>
               <a:t>16</a:t>
             </a:fld>
@@ -1169,7 +1169,7 @@
     </p:spTree>
     <p:extLst>
       <p:ext uri="{BB962C8B-B14F-4D97-AF65-F5344CB8AC3E}">
-        <p14:creationId xmlns:p14="http://schemas.microsoft.com/office/powerpoint/2010/main" val="1364226351"/>
+        <p14:creationId xmlns:p14="http://schemas.microsoft.com/office/powerpoint/2010/main" val="1171336055"/>
       </p:ext>
     </p:extLst>
   </p:cSld>
@@ -1246,7 +1246,7 @@
           <a:bodyPr/>
           <a:lstStyle/>
           <a:p>
-            <a:fld id="{0F264B00-0AA8-414D-9EBF-42C01D614C40}" type="slidenum">
+            <a:fld id="{934E0F31-365A-4FEA-968B-76B74F55F034}" type="slidenum">
               <a:rPr lang="en-IN" smtClean="0"/>
               <a:t>2</a:t>
             </a:fld>
@@ -1257,7 +1257,7 @@
     </p:spTree>
     <p:extLst>
       <p:ext uri="{BB962C8B-B14F-4D97-AF65-F5344CB8AC3E}">
-        <p14:creationId xmlns:p14="http://schemas.microsoft.com/office/powerpoint/2010/main" val="2644724424"/>
+        <p14:creationId xmlns:p14="http://schemas.microsoft.com/office/powerpoint/2010/main" val="395087188"/>
       </p:ext>
     </p:extLst>
   </p:cSld>
@@ -1334,7 +1334,7 @@
           <a:bodyPr/>
           <a:lstStyle/>
           <a:p>
-            <a:fld id="{0F264B00-0AA8-414D-9EBF-42C01D614C40}" type="slidenum">
+            <a:fld id="{934E0F31-365A-4FEA-968B-76B74F55F034}" type="slidenum">
               <a:rPr lang="en-IN" smtClean="0"/>
               <a:t>3</a:t>
             </a:fld>
@@ -1345,7 +1345,7 @@
     </p:spTree>
     <p:extLst>
       <p:ext uri="{BB962C8B-B14F-4D97-AF65-F5344CB8AC3E}">
-        <p14:creationId xmlns:p14="http://schemas.microsoft.com/office/powerpoint/2010/main" val="4072303798"/>
+        <p14:creationId xmlns:p14="http://schemas.microsoft.com/office/powerpoint/2010/main" val="1826402980"/>
       </p:ext>
     </p:extLst>
   </p:cSld>
@@ -1422,7 +1422,7 @@
           <a:bodyPr/>
           <a:lstStyle/>
           <a:p>
-            <a:fld id="{0F264B00-0AA8-414D-9EBF-42C01D614C40}" type="slidenum">
+            <a:fld id="{934E0F31-365A-4FEA-968B-76B74F55F034}" type="slidenum">
               <a:rPr lang="en-IN" smtClean="0"/>
               <a:t>4</a:t>
             </a:fld>
@@ -1433,7 +1433,7 @@
     </p:spTree>
     <p:extLst>
       <p:ext uri="{BB962C8B-B14F-4D97-AF65-F5344CB8AC3E}">
-        <p14:creationId xmlns:p14="http://schemas.microsoft.com/office/powerpoint/2010/main" val="3391916371"/>
+        <p14:creationId xmlns:p14="http://schemas.microsoft.com/office/powerpoint/2010/main" val="2199411617"/>
       </p:ext>
     </p:extLst>
   </p:cSld>
@@ -1510,7 +1510,7 @@
           <a:bodyPr/>
           <a:lstStyle/>
           <a:p>
-            <a:fld id="{0F264B00-0AA8-414D-9EBF-42C01D614C40}" type="slidenum">
+            <a:fld id="{934E0F31-365A-4FEA-968B-76B74F55F034}" type="slidenum">
               <a:rPr lang="en-IN" smtClean="0"/>
               <a:t>5</a:t>
             </a:fld>
@@ -1521,7 +1521,7 @@
     </p:spTree>
     <p:extLst>
       <p:ext uri="{BB962C8B-B14F-4D97-AF65-F5344CB8AC3E}">
-        <p14:creationId xmlns:p14="http://schemas.microsoft.com/office/powerpoint/2010/main" val="3474111990"/>
+        <p14:creationId xmlns:p14="http://schemas.microsoft.com/office/powerpoint/2010/main" val="1676332016"/>
       </p:ext>
     </p:extLst>
   </p:cSld>
@@ -1598,7 +1598,7 @@
           <a:bodyPr/>
           <a:lstStyle/>
           <a:p>
-            <a:fld id="{0F264B00-0AA8-414D-9EBF-42C01D614C40}" type="slidenum">
+            <a:fld id="{934E0F31-365A-4FEA-968B-76B74F55F034}" type="slidenum">
               <a:rPr lang="en-IN" smtClean="0"/>
               <a:t>6</a:t>
             </a:fld>
@@ -1609,7 +1609,7 @@
     </p:spTree>
     <p:extLst>
       <p:ext uri="{BB962C8B-B14F-4D97-AF65-F5344CB8AC3E}">
-        <p14:creationId xmlns:p14="http://schemas.microsoft.com/office/powerpoint/2010/main" val="1334930448"/>
+        <p14:creationId xmlns:p14="http://schemas.microsoft.com/office/powerpoint/2010/main" val="3276891441"/>
       </p:ext>
     </p:extLst>
   </p:cSld>
@@ -1686,7 +1686,7 @@
           <a:bodyPr/>
           <a:lstStyle/>
           <a:p>
-            <a:fld id="{0F264B00-0AA8-414D-9EBF-42C01D614C40}" type="slidenum">
+            <a:fld id="{934E0F31-365A-4FEA-968B-76B74F55F034}" type="slidenum">
               <a:rPr lang="en-IN" smtClean="0"/>
               <a:t>7</a:t>
             </a:fld>
@@ -1697,7 +1697,7 @@
     </p:spTree>
     <p:extLst>
       <p:ext uri="{BB962C8B-B14F-4D97-AF65-F5344CB8AC3E}">
-        <p14:creationId xmlns:p14="http://schemas.microsoft.com/office/powerpoint/2010/main" val="2518848281"/>
+        <p14:creationId xmlns:p14="http://schemas.microsoft.com/office/powerpoint/2010/main" val="2688697625"/>
       </p:ext>
     </p:extLst>
   </p:cSld>
@@ -1774,7 +1774,7 @@
           <a:bodyPr/>
           <a:lstStyle/>
           <a:p>
-            <a:fld id="{0F264B00-0AA8-414D-9EBF-42C01D614C40}" type="slidenum">
+            <a:fld id="{934E0F31-365A-4FEA-968B-76B74F55F034}" type="slidenum">
               <a:rPr lang="en-IN" smtClean="0"/>
               <a:t>8</a:t>
             </a:fld>
@@ -1785,7 +1785,7 @@
     </p:spTree>
     <p:extLst>
       <p:ext uri="{BB962C8B-B14F-4D97-AF65-F5344CB8AC3E}">
-        <p14:creationId xmlns:p14="http://schemas.microsoft.com/office/powerpoint/2010/main" val="683777228"/>
+        <p14:creationId xmlns:p14="http://schemas.microsoft.com/office/powerpoint/2010/main" val="2886447352"/>
       </p:ext>
     </p:extLst>
   </p:cSld>
@@ -1862,7 +1862,7 @@
           <a:bodyPr/>
           <a:lstStyle/>
           <a:p>
-            <a:fld id="{0F264B00-0AA8-414D-9EBF-42C01D614C40}" type="slidenum">
+            <a:fld id="{934E0F31-365A-4FEA-968B-76B74F55F034}" type="slidenum">
               <a:rPr lang="en-IN" smtClean="0"/>
               <a:t>9</a:t>
             </a:fld>
@@ -1873,7 +1873,7 @@
     </p:spTree>
     <p:extLst>
       <p:ext uri="{BB962C8B-B14F-4D97-AF65-F5344CB8AC3E}">
-        <p14:creationId xmlns:p14="http://schemas.microsoft.com/office/powerpoint/2010/main" val="346763729"/>
+        <p14:creationId xmlns:p14="http://schemas.microsoft.com/office/powerpoint/2010/main" val="523788481"/>
       </p:ext>
     </p:extLst>
   </p:cSld>
@@ -1905,7 +1905,7 @@
           <p:cNvPr id="2" name="Title 1">
             <a:extLst>
               <a:ext uri="{FF2B5EF4-FFF2-40B4-BE49-F238E27FC236}">
-                <a16:creationId xmlns:a16="http://schemas.microsoft.com/office/drawing/2014/main" id="{317E7775-BC27-D112-BC9A-4CE6FB409BF1}"/>
+                <a16:creationId xmlns:a16="http://schemas.microsoft.com/office/drawing/2014/main" id="{85378D40-9661-583E-AF10-7F610D1CB0CE}"/>
               </a:ext>
             </a:extLst>
           </p:cNvPr>
@@ -1943,7 +1943,7 @@
           <p:cNvPr id="3" name="Subtitle 2">
             <a:extLst>
               <a:ext uri="{FF2B5EF4-FFF2-40B4-BE49-F238E27FC236}">
-                <a16:creationId xmlns:a16="http://schemas.microsoft.com/office/drawing/2014/main" id="{57A9A5C1-9096-8D3E-F5F1-A551976CEAF8}"/>
+                <a16:creationId xmlns:a16="http://schemas.microsoft.com/office/drawing/2014/main" id="{15CBB958-3499-6C40-8DBC-800609043900}"/>
               </a:ext>
             </a:extLst>
           </p:cNvPr>
@@ -2014,7 +2014,7 @@
           <p:cNvPr id="4" name="Date Placeholder 3">
             <a:extLst>
               <a:ext uri="{FF2B5EF4-FFF2-40B4-BE49-F238E27FC236}">
-                <a16:creationId xmlns:a16="http://schemas.microsoft.com/office/drawing/2014/main" id="{CDAFDB28-5AE7-9EC3-2A8D-FE0091A3C0C8}"/>
+                <a16:creationId xmlns:a16="http://schemas.microsoft.com/office/drawing/2014/main" id="{7C274BAA-2ED7-996F-C799-DD58575E2DB0}"/>
               </a:ext>
             </a:extLst>
           </p:cNvPr>
@@ -2030,7 +2030,7 @@
           <a:bodyPr/>
           <a:lstStyle/>
           <a:p>
-            <a:fld id="{54911CCE-F181-4E10-AF95-3F54776DA9B7}" type="datetimeFigureOut">
+            <a:fld id="{DDAEBF46-9B97-4AC3-A0AF-444D94E4545E}" type="datetimeFigureOut">
               <a:rPr lang="en-IN" smtClean="0"/>
               <a:t>19-10-2026</a:t>
             </a:fld>
@@ -2043,7 +2043,7 @@
           <p:cNvPr id="5" name="Footer Placeholder 4">
             <a:extLst>
               <a:ext uri="{FF2B5EF4-FFF2-40B4-BE49-F238E27FC236}">
-                <a16:creationId xmlns:a16="http://schemas.microsoft.com/office/drawing/2014/main" id="{D2D3573B-FDF0-E106-B9C6-7EBEA5BC6ADD}"/>
+                <a16:creationId xmlns:a16="http://schemas.microsoft.com/office/drawing/2014/main" id="{5613BA31-87A2-C3B0-0121-9AA28F6096D2}"/>
               </a:ext>
             </a:extLst>
           </p:cNvPr>
@@ -2068,7 +2068,7 @@
           <p:cNvPr id="6" name="Slide Number Placeholder 5">
             <a:extLst>
               <a:ext uri="{FF2B5EF4-FFF2-40B4-BE49-F238E27FC236}">
-                <a16:creationId xmlns:a16="http://schemas.microsoft.com/office/drawing/2014/main" id="{B6A57C3A-1630-B820-18B3-BB7725CB0D2F}"/>
+                <a16:creationId xmlns:a16="http://schemas.microsoft.com/office/drawing/2014/main" id="{64C794F3-688E-8684-ABF0-7A1A19509A33}"/>
               </a:ext>
             </a:extLst>
           </p:cNvPr>
@@ -2084,7 +2084,7 @@
           <a:bodyPr/>
           <a:lstStyle/>
           <a:p>
-            <a:fld id="{EFA1B90F-2A8B-40BD-9E06-A35D3CBEF0A9}" type="slidenum">
+            <a:fld id="{174159CA-C179-45FE-86F2-186D70961591}" type="slidenum">
               <a:rPr lang="en-IN" smtClean="0"/>
               <a:t>‹#›</a:t>
             </a:fld>
@@ -2095,7 +2095,7 @@
     </p:spTree>
     <p:extLst>
       <p:ext uri="{BB962C8B-B14F-4D97-AF65-F5344CB8AC3E}">
-        <p14:creationId xmlns:p14="http://schemas.microsoft.com/office/powerpoint/2010/main" val="4189584525"/>
+        <p14:creationId xmlns:p14="http://schemas.microsoft.com/office/powerpoint/2010/main" val="3160138518"/>
       </p:ext>
     </p:extLst>
   </p:cSld>
@@ -2127,7 +2127,7 @@
           <p:cNvPr id="2" name="Title 1">
             <a:extLst>
               <a:ext uri="{FF2B5EF4-FFF2-40B4-BE49-F238E27FC236}">
-                <a16:creationId xmlns:a16="http://schemas.microsoft.com/office/drawing/2014/main" id="{546478DB-9649-6B97-8378-20B07E4AF374}"/>
+                <a16:creationId xmlns:a16="http://schemas.microsoft.com/office/drawing/2014/main" id="{72B6F813-DC1B-8283-F30A-708E20FB5F58}"/>
               </a:ext>
             </a:extLst>
           </p:cNvPr>
@@ -2156,7 +2156,7 @@
           <p:cNvPr id="3" name="Vertical Text Placeholder 2">
             <a:extLst>
               <a:ext uri="{FF2B5EF4-FFF2-40B4-BE49-F238E27FC236}">
-                <a16:creationId xmlns:a16="http://schemas.microsoft.com/office/drawing/2014/main" id="{48198104-8105-05D4-0CDA-34A972F7CFE9}"/>
+                <a16:creationId xmlns:a16="http://schemas.microsoft.com/office/drawing/2014/main" id="{5C8F356C-B888-56F2-38AB-67CCFAB938FC}"/>
               </a:ext>
             </a:extLst>
           </p:cNvPr>
@@ -2214,7 +2214,7 @@
           <p:cNvPr id="4" name="Date Placeholder 3">
             <a:extLst>
               <a:ext uri="{FF2B5EF4-FFF2-40B4-BE49-F238E27FC236}">
-                <a16:creationId xmlns:a16="http://schemas.microsoft.com/office/drawing/2014/main" id="{75B91C0E-5CDC-D34F-9598-D3CB47B3D135}"/>
+                <a16:creationId xmlns:a16="http://schemas.microsoft.com/office/drawing/2014/main" id="{D46D3EE4-0F5C-D9CD-A286-92219206721A}"/>
               </a:ext>
             </a:extLst>
           </p:cNvPr>
@@ -2230,7 +2230,7 @@
           <a:bodyPr/>
           <a:lstStyle/>
           <a:p>
-            <a:fld id="{54911CCE-F181-4E10-AF95-3F54776DA9B7}" type="datetimeFigureOut">
+            <a:fld id="{DDAEBF46-9B97-4AC3-A0AF-444D94E4545E}" type="datetimeFigureOut">
               <a:rPr lang="en-IN" smtClean="0"/>
               <a:t>19-10-2026</a:t>
             </a:fld>
@@ -2243,7 +2243,7 @@
           <p:cNvPr id="5" name="Footer Placeholder 4">
             <a:extLst>
               <a:ext uri="{FF2B5EF4-FFF2-40B4-BE49-F238E27FC236}">
-                <a16:creationId xmlns:a16="http://schemas.microsoft.com/office/drawing/2014/main" id="{1FD7E2D9-D108-267C-11C6-0B2F00BF6503}"/>
+                <a16:creationId xmlns:a16="http://schemas.microsoft.com/office/drawing/2014/main" id="{58A299BA-FDF6-2DF8-20E4-116DBC38AE07}"/>
               </a:ext>
             </a:extLst>
           </p:cNvPr>
@@ -2268,7 +2268,7 @@
           <p:cNvPr id="6" name="Slide Number Placeholder 5">
             <a:extLst>
               <a:ext uri="{FF2B5EF4-FFF2-40B4-BE49-F238E27FC236}">
-                <a16:creationId xmlns:a16="http://schemas.microsoft.com/office/drawing/2014/main" id="{6DE1ED39-2776-85DE-2E7E-4595718FC5A7}"/>
+                <a16:creationId xmlns:a16="http://schemas.microsoft.com/office/drawing/2014/main" id="{AD5F83F4-4729-3BE4-AE55-48F5F0EB55B6}"/>
               </a:ext>
             </a:extLst>
           </p:cNvPr>
@@ -2284,7 +2284,7 @@
           <a:bodyPr/>
           <a:lstStyle/>
           <a:p>
-            <a:fld id="{EFA1B90F-2A8B-40BD-9E06-A35D3CBEF0A9}" type="slidenum">
+            <a:fld id="{174159CA-C179-45FE-86F2-186D70961591}" type="slidenum">
               <a:rPr lang="en-IN" smtClean="0"/>
               <a:t>‹#›</a:t>
             </a:fld>
@@ -2295,7 +2295,7 @@
     </p:spTree>
     <p:extLst>
       <p:ext uri="{BB962C8B-B14F-4D97-AF65-F5344CB8AC3E}">
-        <p14:creationId xmlns:p14="http://schemas.microsoft.com/office/powerpoint/2010/main" val="3175887147"/>
+        <p14:creationId xmlns:p14="http://schemas.microsoft.com/office/powerpoint/2010/main" val="3275301831"/>
       </p:ext>
     </p:extLst>
   </p:cSld>
@@ -2327,7 +2327,7 @@
           <p:cNvPr id="2" name="Vertical Title 1">
             <a:extLst>
               <a:ext uri="{FF2B5EF4-FFF2-40B4-BE49-F238E27FC236}">
-                <a16:creationId xmlns:a16="http://schemas.microsoft.com/office/drawing/2014/main" id="{70980BEE-A4C8-CD70-19A0-00D6CAD49993}"/>
+                <a16:creationId xmlns:a16="http://schemas.microsoft.com/office/drawing/2014/main" id="{BE73F166-F08F-A009-70A2-A496B6474DB7}"/>
               </a:ext>
             </a:extLst>
           </p:cNvPr>
@@ -2361,7 +2361,7 @@
           <p:cNvPr id="3" name="Vertical Text Placeholder 2">
             <a:extLst>
               <a:ext uri="{FF2B5EF4-FFF2-40B4-BE49-F238E27FC236}">
-                <a16:creationId xmlns:a16="http://schemas.microsoft.com/office/drawing/2014/main" id="{39EB09BE-758D-41BA-097E-249D440B25D6}"/>
+                <a16:creationId xmlns:a16="http://schemas.microsoft.com/office/drawing/2014/main" id="{B2BA1AB7-CFC4-624A-E8CA-A10CF5F62228}"/>
               </a:ext>
             </a:extLst>
           </p:cNvPr>
@@ -2424,7 +2424,7 @@
           <p:cNvPr id="4" name="Date Placeholder 3">
             <a:extLst>
               <a:ext uri="{FF2B5EF4-FFF2-40B4-BE49-F238E27FC236}">
-                <a16:creationId xmlns:a16="http://schemas.microsoft.com/office/drawing/2014/main" id="{27ECBF9D-9B05-202E-5B64-2C36CF80D6FD}"/>
+                <a16:creationId xmlns:a16="http://schemas.microsoft.com/office/drawing/2014/main" id="{5980E4E2-8391-46CF-2AD8-ED25C4FC5629}"/>
               </a:ext>
             </a:extLst>
           </p:cNvPr>
@@ -2440,7 +2440,7 @@
           <a:bodyPr/>
           <a:lstStyle/>
           <a:p>
-            <a:fld id="{54911CCE-F181-4E10-AF95-3F54776DA9B7}" type="datetimeFigureOut">
+            <a:fld id="{DDAEBF46-9B97-4AC3-A0AF-444D94E4545E}" type="datetimeFigureOut">
               <a:rPr lang="en-IN" smtClean="0"/>
               <a:t>19-10-2026</a:t>
             </a:fld>
@@ -2453,7 +2453,7 @@
           <p:cNvPr id="5" name="Footer Placeholder 4">
             <a:extLst>
               <a:ext uri="{FF2B5EF4-FFF2-40B4-BE49-F238E27FC236}">
-                <a16:creationId xmlns:a16="http://schemas.microsoft.com/office/drawing/2014/main" id="{14668725-F6A9-136A-E014-29744B538703}"/>
+                <a16:creationId xmlns:a16="http://schemas.microsoft.com/office/drawing/2014/main" id="{DE23B39E-7882-22C6-49FD-02164FCDE728}"/>
               </a:ext>
             </a:extLst>
           </p:cNvPr>
@@ -2478,7 +2478,7 @@
           <p:cNvPr id="6" name="Slide Number Placeholder 5">
             <a:extLst>
               <a:ext uri="{FF2B5EF4-FFF2-40B4-BE49-F238E27FC236}">
-                <a16:creationId xmlns:a16="http://schemas.microsoft.com/office/drawing/2014/main" id="{A1B249E3-C3B2-AD77-F8C4-0D85CF8D461D}"/>
+                <a16:creationId xmlns:a16="http://schemas.microsoft.com/office/drawing/2014/main" id="{06D4CA1B-8F76-868A-6C11-9419B7232D99}"/>
               </a:ext>
             </a:extLst>
           </p:cNvPr>
@@ -2494,7 +2494,7 @@
           <a:bodyPr/>
           <a:lstStyle/>
           <a:p>
-            <a:fld id="{EFA1B90F-2A8B-40BD-9E06-A35D3CBEF0A9}" type="slidenum">
+            <a:fld id="{174159CA-C179-45FE-86F2-186D70961591}" type="slidenum">
               <a:rPr lang="en-IN" smtClean="0"/>
               <a:t>‹#›</a:t>
             </a:fld>
@@ -2505,7 +2505,7 @@
     </p:spTree>
     <p:extLst>
       <p:ext uri="{BB962C8B-B14F-4D97-AF65-F5344CB8AC3E}">
-        <p14:creationId xmlns:p14="http://schemas.microsoft.com/office/powerpoint/2010/main" val="61408730"/>
+        <p14:creationId xmlns:p14="http://schemas.microsoft.com/office/powerpoint/2010/main" val="1425051160"/>
       </p:ext>
     </p:extLst>
   </p:cSld>
@@ -2537,7 +2537,7 @@
           <p:cNvPr id="2" name="Title 1">
             <a:extLst>
               <a:ext uri="{FF2B5EF4-FFF2-40B4-BE49-F238E27FC236}">
-                <a16:creationId xmlns:a16="http://schemas.microsoft.com/office/drawing/2014/main" id="{A3C77F71-B283-D574-2734-4D413B24D8A9}"/>
+                <a16:creationId xmlns:a16="http://schemas.microsoft.com/office/drawing/2014/main" id="{C8D82365-72FF-9F0F-E6A4-B02AF185C005}"/>
               </a:ext>
             </a:extLst>
           </p:cNvPr>
@@ -2566,7 +2566,7 @@
           <p:cNvPr id="3" name="Content Placeholder 2">
             <a:extLst>
               <a:ext uri="{FF2B5EF4-FFF2-40B4-BE49-F238E27FC236}">
-                <a16:creationId xmlns:a16="http://schemas.microsoft.com/office/drawing/2014/main" id="{55EB33EB-E0F8-BC1E-7AA8-50D5BC57D8E9}"/>
+                <a16:creationId xmlns:a16="http://schemas.microsoft.com/office/drawing/2014/main" id="{A9DE4717-3B75-ABF0-08E0-6B51327C0A2C}"/>
               </a:ext>
             </a:extLst>
           </p:cNvPr>
@@ -2624,7 +2624,7 @@
           <p:cNvPr id="4" name="Date Placeholder 3">
             <a:extLst>
               <a:ext uri="{FF2B5EF4-FFF2-40B4-BE49-F238E27FC236}">
-                <a16:creationId xmlns:a16="http://schemas.microsoft.com/office/drawing/2014/main" id="{0AF54965-45C9-FAF6-1746-7C846E8553D3}"/>
+                <a16:creationId xmlns:a16="http://schemas.microsoft.com/office/drawing/2014/main" id="{67DEB12C-D0B0-EC56-CF54-2CDBC78AACAA}"/>
               </a:ext>
             </a:extLst>
           </p:cNvPr>
@@ -2640,7 +2640,7 @@
           <a:bodyPr/>
           <a:lstStyle/>
           <a:p>
-            <a:fld id="{54911CCE-F181-4E10-AF95-3F54776DA9B7}" type="datetimeFigureOut">
+            <a:fld id="{DDAEBF46-9B97-4AC3-A0AF-444D94E4545E}" type="datetimeFigureOut">
               <a:rPr lang="en-IN" smtClean="0"/>
               <a:t>19-10-2026</a:t>
             </a:fld>
@@ -2653,7 +2653,7 @@
           <p:cNvPr id="5" name="Footer Placeholder 4">
             <a:extLst>
               <a:ext uri="{FF2B5EF4-FFF2-40B4-BE49-F238E27FC236}">
-                <a16:creationId xmlns:a16="http://schemas.microsoft.com/office/drawing/2014/main" id="{66DEAFFD-827F-C0EE-C2D2-031446281E1A}"/>
+                <a16:creationId xmlns:a16="http://schemas.microsoft.com/office/drawing/2014/main" id="{40838DBB-1B1E-C3E2-7A0A-0B7E457A3771}"/>
               </a:ext>
             </a:extLst>
           </p:cNvPr>
@@ -2678,7 +2678,7 @@
           <p:cNvPr id="6" name="Slide Number Placeholder 5">
             <a:extLst>
               <a:ext uri="{FF2B5EF4-FFF2-40B4-BE49-F238E27FC236}">
-                <a16:creationId xmlns:a16="http://schemas.microsoft.com/office/drawing/2014/main" id="{4DCD0810-C1E1-D8C7-1B0D-1147D729366C}"/>
+                <a16:creationId xmlns:a16="http://schemas.microsoft.com/office/drawing/2014/main" id="{8D2CF156-5405-668C-125C-8E9E316E742C}"/>
               </a:ext>
             </a:extLst>
           </p:cNvPr>
@@ -2694,7 +2694,7 @@
           <a:bodyPr/>
           <a:lstStyle/>
           <a:p>
-            <a:fld id="{EFA1B90F-2A8B-40BD-9E06-A35D3CBEF0A9}" type="slidenum">
+            <a:fld id="{174159CA-C179-45FE-86F2-186D70961591}" type="slidenum">
               <a:rPr lang="en-IN" smtClean="0"/>
               <a:t>‹#›</a:t>
             </a:fld>
@@ -2705,7 +2705,7 @@
     </p:spTree>
     <p:extLst>
       <p:ext uri="{BB962C8B-B14F-4D97-AF65-F5344CB8AC3E}">
-        <p14:creationId xmlns:p14="http://schemas.microsoft.com/office/powerpoint/2010/main" val="796094717"/>
+        <p14:creationId xmlns:p14="http://schemas.microsoft.com/office/powerpoint/2010/main" val="3779387966"/>
       </p:ext>
     </p:extLst>
   </p:cSld>
@@ -2737,7 +2737,7 @@
           <p:cNvPr id="2" name="Title 1">
             <a:extLst>
               <a:ext uri="{FF2B5EF4-FFF2-40B4-BE49-F238E27FC236}">
-                <a16:creationId xmlns:a16="http://schemas.microsoft.com/office/drawing/2014/main" id="{4866ACEF-06C7-006B-6501-2E64317FBFC9}"/>
+                <a16:creationId xmlns:a16="http://schemas.microsoft.com/office/drawing/2014/main" id="{D3EED1ED-1884-6393-2F71-F0F4FABEBCB4}"/>
               </a:ext>
             </a:extLst>
           </p:cNvPr>
@@ -2775,7 +2775,7 @@
           <p:cNvPr id="3" name="Text Placeholder 2">
             <a:extLst>
               <a:ext uri="{FF2B5EF4-FFF2-40B4-BE49-F238E27FC236}">
-                <a16:creationId xmlns:a16="http://schemas.microsoft.com/office/drawing/2014/main" id="{3AA0A6B5-8463-02E7-48F4-9884C8A1EB45}"/>
+                <a16:creationId xmlns:a16="http://schemas.microsoft.com/office/drawing/2014/main" id="{A53DDF80-9157-1738-D1C2-AADB87157B7A}"/>
               </a:ext>
             </a:extLst>
           </p:cNvPr>
@@ -2900,7 +2900,7 @@
           <p:cNvPr id="4" name="Date Placeholder 3">
             <a:extLst>
               <a:ext uri="{FF2B5EF4-FFF2-40B4-BE49-F238E27FC236}">
-                <a16:creationId xmlns:a16="http://schemas.microsoft.com/office/drawing/2014/main" id="{ECCBAB0E-5CD1-7C56-4B54-AA0BB137B444}"/>
+                <a16:creationId xmlns:a16="http://schemas.microsoft.com/office/drawing/2014/main" id="{1688EC6B-9B12-5E88-3303-48162B3A308B}"/>
               </a:ext>
             </a:extLst>
           </p:cNvPr>
@@ -2916,7 +2916,7 @@
           <a:bodyPr/>
           <a:lstStyle/>
           <a:p>
-            <a:fld id="{54911CCE-F181-4E10-AF95-3F54776DA9B7}" type="datetimeFigureOut">
+            <a:fld id="{DDAEBF46-9B97-4AC3-A0AF-444D94E4545E}" type="datetimeFigureOut">
               <a:rPr lang="en-IN" smtClean="0"/>
               <a:t>19-10-2026</a:t>
             </a:fld>
@@ -2929,7 +2929,7 @@
           <p:cNvPr id="5" name="Footer Placeholder 4">
             <a:extLst>
               <a:ext uri="{FF2B5EF4-FFF2-40B4-BE49-F238E27FC236}">
-                <a16:creationId xmlns:a16="http://schemas.microsoft.com/office/drawing/2014/main" id="{F0D5022E-8F4F-D371-746E-5333BA386BBD}"/>
+                <a16:creationId xmlns:a16="http://schemas.microsoft.com/office/drawing/2014/main" id="{3F25E26B-CC79-6989-17E9-5EBCE6E070EE}"/>
               </a:ext>
             </a:extLst>
           </p:cNvPr>
@@ -2954,7 +2954,7 @@
           <p:cNvPr id="6" name="Slide Number Placeholder 5">
             <a:extLst>
               <a:ext uri="{FF2B5EF4-FFF2-40B4-BE49-F238E27FC236}">
-                <a16:creationId xmlns:a16="http://schemas.microsoft.com/office/drawing/2014/main" id="{570B63FB-1DD1-9CF6-59C8-7B25B42D9602}"/>
+                <a16:creationId xmlns:a16="http://schemas.microsoft.com/office/drawing/2014/main" id="{C873D7C4-8743-5810-EF5C-E9ED6303620E}"/>
               </a:ext>
             </a:extLst>
           </p:cNvPr>
@@ -2970,7 +2970,7 @@
           <a:bodyPr/>
           <a:lstStyle/>
           <a:p>
-            <a:fld id="{EFA1B90F-2A8B-40BD-9E06-A35D3CBEF0A9}" type="slidenum">
+            <a:fld id="{174159CA-C179-45FE-86F2-186D70961591}" type="slidenum">
               <a:rPr lang="en-IN" smtClean="0"/>
               <a:t>‹#›</a:t>
             </a:fld>
@@ -2981,7 +2981,7 @@
     </p:spTree>
     <p:extLst>
       <p:ext uri="{BB962C8B-B14F-4D97-AF65-F5344CB8AC3E}">
-        <p14:creationId xmlns:p14="http://schemas.microsoft.com/office/powerpoint/2010/main" val="1550708207"/>
+        <p14:creationId xmlns:p14="http://schemas.microsoft.com/office/powerpoint/2010/main" val="3090168809"/>
       </p:ext>
     </p:extLst>
   </p:cSld>
@@ -3013,7 +3013,7 @@
           <p:cNvPr id="2" name="Title 1">
             <a:extLst>
               <a:ext uri="{FF2B5EF4-FFF2-40B4-BE49-F238E27FC236}">
-                <a16:creationId xmlns:a16="http://schemas.microsoft.com/office/drawing/2014/main" id="{FCD4C23E-DC37-6DF9-BDCC-D8357EAD6EA5}"/>
+                <a16:creationId xmlns:a16="http://schemas.microsoft.com/office/drawing/2014/main" id="{A202F5AF-96F5-74CC-CE6F-81B093FEF4BC}"/>
               </a:ext>
             </a:extLst>
           </p:cNvPr>
@@ -3042,7 +3042,7 @@
           <p:cNvPr id="3" name="Content Placeholder 2">
             <a:extLst>
               <a:ext uri="{FF2B5EF4-FFF2-40B4-BE49-F238E27FC236}">
-                <a16:creationId xmlns:a16="http://schemas.microsoft.com/office/drawing/2014/main" id="{3D823512-C708-7DA8-E61D-C49567D9D906}"/>
+                <a16:creationId xmlns:a16="http://schemas.microsoft.com/office/drawing/2014/main" id="{9BD1FBC7-1477-B7FB-F246-6CC0469AC8F2}"/>
               </a:ext>
             </a:extLst>
           </p:cNvPr>
@@ -3105,7 +3105,7 @@
           <p:cNvPr id="4" name="Content Placeholder 3">
             <a:extLst>
               <a:ext uri="{FF2B5EF4-FFF2-40B4-BE49-F238E27FC236}">
-                <a16:creationId xmlns:a16="http://schemas.microsoft.com/office/drawing/2014/main" id="{0B610035-4943-4C15-4F37-26ADB13ACC92}"/>
+                <a16:creationId xmlns:a16="http://schemas.microsoft.com/office/drawing/2014/main" id="{70A8A3F3-9AD7-3417-8F31-AC92C502DC4B}"/>
               </a:ext>
             </a:extLst>
           </p:cNvPr>
@@ -3168,7 +3168,7 @@
           <p:cNvPr id="5" name="Date Placeholder 4">
             <a:extLst>
               <a:ext uri="{FF2B5EF4-FFF2-40B4-BE49-F238E27FC236}">
-                <a16:creationId xmlns:a16="http://schemas.microsoft.com/office/drawing/2014/main" id="{4D1B7023-5A44-BFB8-6956-A8282CCBAEDD}"/>
+                <a16:creationId xmlns:a16="http://schemas.microsoft.com/office/drawing/2014/main" id="{EEC30507-4205-1B3A-AE2A-2BD5F1DC0515}"/>
               </a:ext>
             </a:extLst>
           </p:cNvPr>
@@ -3184,7 +3184,7 @@
           <a:bodyPr/>
           <a:lstStyle/>
           <a:p>
-            <a:fld id="{54911CCE-F181-4E10-AF95-3F54776DA9B7}" type="datetimeFigureOut">
+            <a:fld id="{DDAEBF46-9B97-4AC3-A0AF-444D94E4545E}" type="datetimeFigureOut">
               <a:rPr lang="en-IN" smtClean="0"/>
               <a:t>19-10-2026</a:t>
             </a:fld>
@@ -3197,7 +3197,7 @@
           <p:cNvPr id="6" name="Footer Placeholder 5">
             <a:extLst>
               <a:ext uri="{FF2B5EF4-FFF2-40B4-BE49-F238E27FC236}">
-                <a16:creationId xmlns:a16="http://schemas.microsoft.com/office/drawing/2014/main" id="{50F948AF-26F8-413B-0170-02CF76142F56}"/>
+                <a16:creationId xmlns:a16="http://schemas.microsoft.com/office/drawing/2014/main" id="{CAF29C3B-207E-2373-261F-383CA33E9AC2}"/>
               </a:ext>
             </a:extLst>
           </p:cNvPr>
@@ -3222,7 +3222,7 @@
           <p:cNvPr id="7" name="Slide Number Placeholder 6">
             <a:extLst>
               <a:ext uri="{FF2B5EF4-FFF2-40B4-BE49-F238E27FC236}">
-                <a16:creationId xmlns:a16="http://schemas.microsoft.com/office/drawing/2014/main" id="{71583ED8-CE49-23B7-74E7-F39D407DB435}"/>
+                <a16:creationId xmlns:a16="http://schemas.microsoft.com/office/drawing/2014/main" id="{AE854A7A-1C94-05BF-0BAC-7F3922B72DAE}"/>
               </a:ext>
             </a:extLst>
           </p:cNvPr>
@@ -3238,7 +3238,7 @@
           <a:bodyPr/>
           <a:lstStyle/>
           <a:p>
-            <a:fld id="{EFA1B90F-2A8B-40BD-9E06-A35D3CBEF0A9}" type="slidenum">
+            <a:fld id="{174159CA-C179-45FE-86F2-186D70961591}" type="slidenum">
               <a:rPr lang="en-IN" smtClean="0"/>
               <a:t>‹#›</a:t>
             </a:fld>
@@ -3249,7 +3249,7 @@
     </p:spTree>
     <p:extLst>
       <p:ext uri="{BB962C8B-B14F-4D97-AF65-F5344CB8AC3E}">
-        <p14:creationId xmlns:p14="http://schemas.microsoft.com/office/powerpoint/2010/main" val="1139700018"/>
+        <p14:creationId xmlns:p14="http://schemas.microsoft.com/office/powerpoint/2010/main" val="2296981858"/>
       </p:ext>
     </p:extLst>
   </p:cSld>
@@ -3281,7 +3281,7 @@
           <p:cNvPr id="2" name="Title 1">
             <a:extLst>
               <a:ext uri="{FF2B5EF4-FFF2-40B4-BE49-F238E27FC236}">
-                <a16:creationId xmlns:a16="http://schemas.microsoft.com/office/drawing/2014/main" id="{CF702D1D-037D-F844-BAA3-A28139F33885}"/>
+                <a16:creationId xmlns:a16="http://schemas.microsoft.com/office/drawing/2014/main" id="{3BC71C4F-AC15-EAFE-F1AB-4AB7D24F30DC}"/>
               </a:ext>
             </a:extLst>
           </p:cNvPr>
@@ -3315,7 +3315,7 @@
           <p:cNvPr id="3" name="Text Placeholder 2">
             <a:extLst>
               <a:ext uri="{FF2B5EF4-FFF2-40B4-BE49-F238E27FC236}">
-                <a16:creationId xmlns:a16="http://schemas.microsoft.com/office/drawing/2014/main" id="{D216FE85-BBC1-726D-5165-D71723C509B0}"/>
+                <a16:creationId xmlns:a16="http://schemas.microsoft.com/office/drawing/2014/main" id="{0CA2561B-2BE8-DA4F-730A-5A6778E53716}"/>
               </a:ext>
             </a:extLst>
           </p:cNvPr>
@@ -3386,7 +3386,7 @@
           <p:cNvPr id="4" name="Content Placeholder 3">
             <a:extLst>
               <a:ext uri="{FF2B5EF4-FFF2-40B4-BE49-F238E27FC236}">
-                <a16:creationId xmlns:a16="http://schemas.microsoft.com/office/drawing/2014/main" id="{9042C6A6-D409-70F8-1B15-669E89159A9A}"/>
+                <a16:creationId xmlns:a16="http://schemas.microsoft.com/office/drawing/2014/main" id="{03B4733C-C103-20BE-8FCB-41C54FE6AA53}"/>
               </a:ext>
             </a:extLst>
           </p:cNvPr>
@@ -3449,7 +3449,7 @@
           <p:cNvPr id="5" name="Text Placeholder 4">
             <a:extLst>
               <a:ext uri="{FF2B5EF4-FFF2-40B4-BE49-F238E27FC236}">
-                <a16:creationId xmlns:a16="http://schemas.microsoft.com/office/drawing/2014/main" id="{DF530C74-A835-D094-E010-690E95F27F49}"/>
+                <a16:creationId xmlns:a16="http://schemas.microsoft.com/office/drawing/2014/main" id="{C8D9341A-287F-7E71-68AA-657B24C3A32C}"/>
               </a:ext>
             </a:extLst>
           </p:cNvPr>
@@ -3520,7 +3520,7 @@
           <p:cNvPr id="6" name="Content Placeholder 5">
             <a:extLst>
               <a:ext uri="{FF2B5EF4-FFF2-40B4-BE49-F238E27FC236}">
-                <a16:creationId xmlns:a16="http://schemas.microsoft.com/office/drawing/2014/main" id="{E66C5FBD-8F87-600A-4A12-6A4C1B84FD47}"/>
+                <a16:creationId xmlns:a16="http://schemas.microsoft.com/office/drawing/2014/main" id="{FB94593B-0D23-43A4-6E49-DAC581E49BE4}"/>
               </a:ext>
             </a:extLst>
           </p:cNvPr>
@@ -3583,7 +3583,7 @@
           <p:cNvPr id="7" name="Date Placeholder 6">
             <a:extLst>
               <a:ext uri="{FF2B5EF4-FFF2-40B4-BE49-F238E27FC236}">
-                <a16:creationId xmlns:a16="http://schemas.microsoft.com/office/drawing/2014/main" id="{C41623B4-83E9-E374-FC74-49C5D4D82110}"/>
+                <a16:creationId xmlns:a16="http://schemas.microsoft.com/office/drawing/2014/main" id="{53C0F5F9-DF13-090C-053A-2E49E75DABB0}"/>
               </a:ext>
             </a:extLst>
           </p:cNvPr>
@@ -3599,7 +3599,7 @@
           <a:bodyPr/>
           <a:lstStyle/>
           <a:p>
-            <a:fld id="{54911CCE-F181-4E10-AF95-3F54776DA9B7}" type="datetimeFigureOut">
+            <a:fld id="{DDAEBF46-9B97-4AC3-A0AF-444D94E4545E}" type="datetimeFigureOut">
               <a:rPr lang="en-IN" smtClean="0"/>
               <a:t>19-10-2026</a:t>
             </a:fld>
@@ -3612,7 +3612,7 @@
           <p:cNvPr id="8" name="Footer Placeholder 7">
             <a:extLst>
               <a:ext uri="{FF2B5EF4-FFF2-40B4-BE49-F238E27FC236}">
-                <a16:creationId xmlns:a16="http://schemas.microsoft.com/office/drawing/2014/main" id="{A74984B3-BCC3-8CBA-EF92-ED57790272F9}"/>
+                <a16:creationId xmlns:a16="http://schemas.microsoft.com/office/drawing/2014/main" id="{3D4851A9-D20F-AF16-4069-211794ECB4BE}"/>
               </a:ext>
             </a:extLst>
           </p:cNvPr>
@@ -3637,7 +3637,7 @@
           <p:cNvPr id="9" name="Slide Number Placeholder 8">
             <a:extLst>
               <a:ext uri="{FF2B5EF4-FFF2-40B4-BE49-F238E27FC236}">
-                <a16:creationId xmlns:a16="http://schemas.microsoft.com/office/drawing/2014/main" id="{676A51C5-91EC-F1DE-670C-908FD18A8ED2}"/>
+                <a16:creationId xmlns:a16="http://schemas.microsoft.com/office/drawing/2014/main" id="{AC8BC0D2-8234-6828-8F80-E08E913AB3E7}"/>
               </a:ext>
             </a:extLst>
           </p:cNvPr>
@@ -3653,7 +3653,7 @@
           <a:bodyPr/>
           <a:lstStyle/>
           <a:p>
-            <a:fld id="{EFA1B90F-2A8B-40BD-9E06-A35D3CBEF0A9}" type="slidenum">
+            <a:fld id="{174159CA-C179-45FE-86F2-186D70961591}" type="slidenum">
               <a:rPr lang="en-IN" smtClean="0"/>
               <a:t>‹#›</a:t>
             </a:fld>
@@ -3664,7 +3664,7 @@
     </p:spTree>
     <p:extLst>
       <p:ext uri="{BB962C8B-B14F-4D97-AF65-F5344CB8AC3E}">
-        <p14:creationId xmlns:p14="http://schemas.microsoft.com/office/powerpoint/2010/main" val="3844902594"/>
+        <p14:creationId xmlns:p14="http://schemas.microsoft.com/office/powerpoint/2010/main" val="3092111439"/>
       </p:ext>
     </p:extLst>
   </p:cSld>
@@ -3696,7 +3696,7 @@
           <p:cNvPr id="2" name="Title 1">
             <a:extLst>
               <a:ext uri="{FF2B5EF4-FFF2-40B4-BE49-F238E27FC236}">
-                <a16:creationId xmlns:a16="http://schemas.microsoft.com/office/drawing/2014/main" id="{31A780EC-CE2A-28FB-3A08-943399AB6D38}"/>
+                <a16:creationId xmlns:a16="http://schemas.microsoft.com/office/drawing/2014/main" id="{D6D79FB5-B504-D9C9-94CF-82C31A3A065D}"/>
               </a:ext>
             </a:extLst>
           </p:cNvPr>
@@ -3725,7 +3725,7 @@
           <p:cNvPr id="3" name="Date Placeholder 2">
             <a:extLst>
               <a:ext uri="{FF2B5EF4-FFF2-40B4-BE49-F238E27FC236}">
-                <a16:creationId xmlns:a16="http://schemas.microsoft.com/office/drawing/2014/main" id="{CD41A7C2-391E-CD5C-42CF-D0D81724776D}"/>
+                <a16:creationId xmlns:a16="http://schemas.microsoft.com/office/drawing/2014/main" id="{C1998237-B6D8-B0E3-D535-DF8F0B583BA8}"/>
               </a:ext>
             </a:extLst>
           </p:cNvPr>
@@ -3741,7 +3741,7 @@
           <a:bodyPr/>
           <a:lstStyle/>
           <a:p>
-            <a:fld id="{54911CCE-F181-4E10-AF95-3F54776DA9B7}" type="datetimeFigureOut">
+            <a:fld id="{DDAEBF46-9B97-4AC3-A0AF-444D94E4545E}" type="datetimeFigureOut">
               <a:rPr lang="en-IN" smtClean="0"/>
               <a:t>19-10-2026</a:t>
             </a:fld>
@@ -3754,7 +3754,7 @@
           <p:cNvPr id="4" name="Footer Placeholder 3">
             <a:extLst>
               <a:ext uri="{FF2B5EF4-FFF2-40B4-BE49-F238E27FC236}">
-                <a16:creationId xmlns:a16="http://schemas.microsoft.com/office/drawing/2014/main" id="{5913A0F2-2FD9-49CE-C347-258EDA805B9D}"/>
+                <a16:creationId xmlns:a16="http://schemas.microsoft.com/office/drawing/2014/main" id="{FD6A02A9-B13F-7632-0B88-2A3D6D67EEEF}"/>
               </a:ext>
             </a:extLst>
           </p:cNvPr>
@@ -3779,7 +3779,7 @@
           <p:cNvPr id="5" name="Slide Number Placeholder 4">
             <a:extLst>
               <a:ext uri="{FF2B5EF4-FFF2-40B4-BE49-F238E27FC236}">
-                <a16:creationId xmlns:a16="http://schemas.microsoft.com/office/drawing/2014/main" id="{96169F12-A2E9-1075-30DB-9766353A24DC}"/>
+                <a16:creationId xmlns:a16="http://schemas.microsoft.com/office/drawing/2014/main" id="{4CD2EE5E-F0B6-D9D8-FE74-F09927787CDF}"/>
               </a:ext>
             </a:extLst>
           </p:cNvPr>
@@ -3795,7 +3795,7 @@
           <a:bodyPr/>
           <a:lstStyle/>
           <a:p>
-            <a:fld id="{EFA1B90F-2A8B-40BD-9E06-A35D3CBEF0A9}" type="slidenum">
+            <a:fld id="{174159CA-C179-45FE-86F2-186D70961591}" type="slidenum">
               <a:rPr lang="en-IN" smtClean="0"/>
               <a:t>‹#›</a:t>
             </a:fld>
@@ -3806,7 +3806,7 @@
     </p:spTree>
     <p:extLst>
       <p:ext uri="{BB962C8B-B14F-4D97-AF65-F5344CB8AC3E}">
-        <p14:creationId xmlns:p14="http://schemas.microsoft.com/office/powerpoint/2010/main" val="1339119874"/>
+        <p14:creationId xmlns:p14="http://schemas.microsoft.com/office/powerpoint/2010/main" val="2421413901"/>
       </p:ext>
     </p:extLst>
   </p:cSld>
@@ -3838,7 +3838,7 @@
           <p:cNvPr id="2" name="Date Placeholder 1">
             <a:extLst>
               <a:ext uri="{FF2B5EF4-FFF2-40B4-BE49-F238E27FC236}">
-                <a16:creationId xmlns:a16="http://schemas.microsoft.com/office/drawing/2014/main" id="{E5C48671-7BBB-5DB0-5DBA-7785160D603C}"/>
+                <a16:creationId xmlns:a16="http://schemas.microsoft.com/office/drawing/2014/main" id="{E4CE79CB-9C7A-B2B0-D530-09ACD050C640}"/>
               </a:ext>
             </a:extLst>
           </p:cNvPr>
@@ -3854,7 +3854,7 @@
           <a:bodyPr/>
           <a:lstStyle/>
           <a:p>
-            <a:fld id="{54911CCE-F181-4E10-AF95-3F54776DA9B7}" type="datetimeFigureOut">
+            <a:fld id="{DDAEBF46-9B97-4AC3-A0AF-444D94E4545E}" type="datetimeFigureOut">
               <a:rPr lang="en-IN" smtClean="0"/>
               <a:t>19-10-2026</a:t>
             </a:fld>
@@ -3867,7 +3867,7 @@
           <p:cNvPr id="3" name="Footer Placeholder 2">
             <a:extLst>
               <a:ext uri="{FF2B5EF4-FFF2-40B4-BE49-F238E27FC236}">
-                <a16:creationId xmlns:a16="http://schemas.microsoft.com/office/drawing/2014/main" id="{BC3CAE62-1E5D-B2EA-70BC-3A15860EB2F1}"/>
+                <a16:creationId xmlns:a16="http://schemas.microsoft.com/office/drawing/2014/main" id="{3F3E4261-85CA-7B47-66FC-E4B225DE0951}"/>
               </a:ext>
             </a:extLst>
           </p:cNvPr>
@@ -3892,7 +3892,7 @@
           <p:cNvPr id="4" name="Slide Number Placeholder 3">
             <a:extLst>
               <a:ext uri="{FF2B5EF4-FFF2-40B4-BE49-F238E27FC236}">
-                <a16:creationId xmlns:a16="http://schemas.microsoft.com/office/drawing/2014/main" id="{BB70B7B3-9A03-5A45-FD77-423190F43720}"/>
+                <a16:creationId xmlns:a16="http://schemas.microsoft.com/office/drawing/2014/main" id="{4CB469FA-7B3D-A86B-CF40-89863D7F7341}"/>
               </a:ext>
             </a:extLst>
           </p:cNvPr>
@@ -3908,7 +3908,7 @@
           <a:bodyPr/>
           <a:lstStyle/>
           <a:p>
-            <a:fld id="{EFA1B90F-2A8B-40BD-9E06-A35D3CBEF0A9}" type="slidenum">
+            <a:fld id="{174159CA-C179-45FE-86F2-186D70961591}" type="slidenum">
               <a:rPr lang="en-IN" smtClean="0"/>
               <a:t>‹#›</a:t>
             </a:fld>
@@ -3919,7 +3919,7 @@
     </p:spTree>
     <p:extLst>
       <p:ext uri="{BB962C8B-B14F-4D97-AF65-F5344CB8AC3E}">
-        <p14:creationId xmlns:p14="http://schemas.microsoft.com/office/powerpoint/2010/main" val="2748164135"/>
+        <p14:creationId xmlns:p14="http://schemas.microsoft.com/office/powerpoint/2010/main" val="2189890881"/>
       </p:ext>
     </p:extLst>
   </p:cSld>
@@ -3951,7 +3951,7 @@
           <p:cNvPr id="2" name="Title 1">
             <a:extLst>
               <a:ext uri="{FF2B5EF4-FFF2-40B4-BE49-F238E27FC236}">
-                <a16:creationId xmlns:a16="http://schemas.microsoft.com/office/drawing/2014/main" id="{B1ECCC5C-E9BD-8E63-79EF-658BF301956E}"/>
+                <a16:creationId xmlns:a16="http://schemas.microsoft.com/office/drawing/2014/main" id="{9C784784-F7C6-F78C-20A1-C2ACD7897B0D}"/>
               </a:ext>
             </a:extLst>
           </p:cNvPr>
@@ -3989,7 +3989,7 @@
           <p:cNvPr id="3" name="Content Placeholder 2">
             <a:extLst>
               <a:ext uri="{FF2B5EF4-FFF2-40B4-BE49-F238E27FC236}">
-                <a16:creationId xmlns:a16="http://schemas.microsoft.com/office/drawing/2014/main" id="{3BE87423-FD5A-49CA-C022-2EC696C70F54}"/>
+                <a16:creationId xmlns:a16="http://schemas.microsoft.com/office/drawing/2014/main" id="{461CC8CC-BB5A-83A3-F982-A6A83D0885C4}"/>
               </a:ext>
             </a:extLst>
           </p:cNvPr>
@@ -4080,7 +4080,7 @@
           <p:cNvPr id="4" name="Text Placeholder 3">
             <a:extLst>
               <a:ext uri="{FF2B5EF4-FFF2-40B4-BE49-F238E27FC236}">
-                <a16:creationId xmlns:a16="http://schemas.microsoft.com/office/drawing/2014/main" id="{9375889B-44AD-812C-8EA0-B071CE2183EC}"/>
+                <a16:creationId xmlns:a16="http://schemas.microsoft.com/office/drawing/2014/main" id="{2DCCF31F-AE3B-AB44-4188-F73222D7CAF3}"/>
               </a:ext>
             </a:extLst>
           </p:cNvPr>
@@ -4151,7 +4151,7 @@
           <p:cNvPr id="5" name="Date Placeholder 4">
             <a:extLst>
               <a:ext uri="{FF2B5EF4-FFF2-40B4-BE49-F238E27FC236}">
-                <a16:creationId xmlns:a16="http://schemas.microsoft.com/office/drawing/2014/main" id="{26CB612B-0F14-B5C4-6BA6-BC4E3DA99537}"/>
+                <a16:creationId xmlns:a16="http://schemas.microsoft.com/office/drawing/2014/main" id="{D2D9D01A-2A04-0A27-DF78-5E01C6B88D94}"/>
               </a:ext>
             </a:extLst>
           </p:cNvPr>
@@ -4167,7 +4167,7 @@
           <a:bodyPr/>
           <a:lstStyle/>
           <a:p>
-            <a:fld id="{54911CCE-F181-4E10-AF95-3F54776DA9B7}" type="datetimeFigureOut">
+            <a:fld id="{DDAEBF46-9B97-4AC3-A0AF-444D94E4545E}" type="datetimeFigureOut">
               <a:rPr lang="en-IN" smtClean="0"/>
               <a:t>19-10-2026</a:t>
             </a:fld>
@@ -4180,7 +4180,7 @@
           <p:cNvPr id="6" name="Footer Placeholder 5">
             <a:extLst>
               <a:ext uri="{FF2B5EF4-FFF2-40B4-BE49-F238E27FC236}">
-                <a16:creationId xmlns:a16="http://schemas.microsoft.com/office/drawing/2014/main" id="{7638D8D7-15D6-3732-759B-35292044D843}"/>
+                <a16:creationId xmlns:a16="http://schemas.microsoft.com/office/drawing/2014/main" id="{528C9C5B-9952-992F-42A5-1616F0AB6F51}"/>
               </a:ext>
             </a:extLst>
           </p:cNvPr>
@@ -4205,7 +4205,7 @@
           <p:cNvPr id="7" name="Slide Number Placeholder 6">
             <a:extLst>
               <a:ext uri="{FF2B5EF4-FFF2-40B4-BE49-F238E27FC236}">
-                <a16:creationId xmlns:a16="http://schemas.microsoft.com/office/drawing/2014/main" id="{FD8636A6-CD1D-BBF7-CD1D-866861D31D1A}"/>
+                <a16:creationId xmlns:a16="http://schemas.microsoft.com/office/drawing/2014/main" id="{8D372F0E-A98F-1D7A-7B9D-E15EF11FE034}"/>
               </a:ext>
             </a:extLst>
           </p:cNvPr>
@@ -4221,7 +4221,7 @@
           <a:bodyPr/>
           <a:lstStyle/>
           <a:p>
-            <a:fld id="{EFA1B90F-2A8B-40BD-9E06-A35D3CBEF0A9}" type="slidenum">
+            <a:fld id="{174159CA-C179-45FE-86F2-186D70961591}" type="slidenum">
               <a:rPr lang="en-IN" smtClean="0"/>
               <a:t>‹#›</a:t>
             </a:fld>
@@ -4232,7 +4232,7 @@
     </p:spTree>
     <p:extLst>
       <p:ext uri="{BB962C8B-B14F-4D97-AF65-F5344CB8AC3E}">
-        <p14:creationId xmlns:p14="http://schemas.microsoft.com/office/powerpoint/2010/main" val="281159621"/>
+        <p14:creationId xmlns:p14="http://schemas.microsoft.com/office/powerpoint/2010/main" val="88824160"/>
       </p:ext>
     </p:extLst>
   </p:cSld>
@@ -4264,7 +4264,7 @@
           <p:cNvPr id="2" name="Title 1">
             <a:extLst>
               <a:ext uri="{FF2B5EF4-FFF2-40B4-BE49-F238E27FC236}">
-                <a16:creationId xmlns:a16="http://schemas.microsoft.com/office/drawing/2014/main" id="{FD8985C6-CE2B-7210-7492-48E6F65054CB}"/>
+                <a16:creationId xmlns:a16="http://schemas.microsoft.com/office/drawing/2014/main" id="{E593876E-89AB-A6BC-F810-2CE97F46496E}"/>
               </a:ext>
             </a:extLst>
           </p:cNvPr>
@@ -4302,7 +4302,7 @@
           <p:cNvPr id="3" name="Picture Placeholder 2">
             <a:extLst>
               <a:ext uri="{FF2B5EF4-FFF2-40B4-BE49-F238E27FC236}">
-                <a16:creationId xmlns:a16="http://schemas.microsoft.com/office/drawing/2014/main" id="{FC22FE94-508A-D0BE-A53B-A0733209A4C6}"/>
+                <a16:creationId xmlns:a16="http://schemas.microsoft.com/office/drawing/2014/main" id="{99B0B362-0D6E-5212-768A-1125EB88F314}"/>
               </a:ext>
             </a:extLst>
           </p:cNvPr>
@@ -4369,7 +4369,7 @@
           <p:cNvPr id="4" name="Text Placeholder 3">
             <a:extLst>
               <a:ext uri="{FF2B5EF4-FFF2-40B4-BE49-F238E27FC236}">
-                <a16:creationId xmlns:a16="http://schemas.microsoft.com/office/drawing/2014/main" id="{8D9361BC-27BA-F301-9883-D934D78D890D}"/>
+                <a16:creationId xmlns:a16="http://schemas.microsoft.com/office/drawing/2014/main" id="{9DA25B96-6AF3-A99B-15FA-246AC4E19181}"/>
               </a:ext>
             </a:extLst>
           </p:cNvPr>
@@ -4440,7 +4440,7 @@
           <p:cNvPr id="5" name="Date Placeholder 4">
             <a:extLst>
               <a:ext uri="{FF2B5EF4-FFF2-40B4-BE49-F238E27FC236}">
-                <a16:creationId xmlns:a16="http://schemas.microsoft.com/office/drawing/2014/main" id="{614C56BC-D4C7-02A5-BE2D-E7E13A584881}"/>
+                <a16:creationId xmlns:a16="http://schemas.microsoft.com/office/drawing/2014/main" id="{59409775-B8F5-1866-D56E-B964406CEBE1}"/>
               </a:ext>
             </a:extLst>
           </p:cNvPr>
@@ -4456,7 +4456,7 @@
           <a:bodyPr/>
           <a:lstStyle/>
           <a:p>
-            <a:fld id="{54911CCE-F181-4E10-AF95-3F54776DA9B7}" type="datetimeFigureOut">
+            <a:fld id="{DDAEBF46-9B97-4AC3-A0AF-444D94E4545E}" type="datetimeFigureOut">
               <a:rPr lang="en-IN" smtClean="0"/>
               <a:t>19-10-2026</a:t>
             </a:fld>
@@ -4469,7 +4469,7 @@
           <p:cNvPr id="6" name="Footer Placeholder 5">
             <a:extLst>
               <a:ext uri="{FF2B5EF4-FFF2-40B4-BE49-F238E27FC236}">
-                <a16:creationId xmlns:a16="http://schemas.microsoft.com/office/drawing/2014/main" id="{C0272E92-5DF1-68DA-28F1-9246D62F4E28}"/>
+                <a16:creationId xmlns:a16="http://schemas.microsoft.com/office/drawing/2014/main" id="{03CB5122-ECFE-5D50-BE72-CB4B7ABDB665}"/>
               </a:ext>
             </a:extLst>
           </p:cNvPr>
@@ -4494,7 +4494,7 @@
           <p:cNvPr id="7" name="Slide Number Placeholder 6">
             <a:extLst>
               <a:ext uri="{FF2B5EF4-FFF2-40B4-BE49-F238E27FC236}">
-                <a16:creationId xmlns:a16="http://schemas.microsoft.com/office/drawing/2014/main" id="{9D6F30D5-A1D9-EB87-C4E2-DD29929BD26A}"/>
+                <a16:creationId xmlns:a16="http://schemas.microsoft.com/office/drawing/2014/main" id="{444C570F-B8E1-F67A-A5E5-D27E509272FA}"/>
               </a:ext>
             </a:extLst>
           </p:cNvPr>
@@ -4510,7 +4510,7 @@
           <a:bodyPr/>
           <a:lstStyle/>
           <a:p>
-            <a:fld id="{EFA1B90F-2A8B-40BD-9E06-A35D3CBEF0A9}" type="slidenum">
+            <a:fld id="{174159CA-C179-45FE-86F2-186D70961591}" type="slidenum">
               <a:rPr lang="en-IN" smtClean="0"/>
               <a:t>‹#›</a:t>
             </a:fld>
@@ -4521,7 +4521,7 @@
     </p:spTree>
     <p:extLst>
       <p:ext uri="{BB962C8B-B14F-4D97-AF65-F5344CB8AC3E}">
-        <p14:creationId xmlns:p14="http://schemas.microsoft.com/office/powerpoint/2010/main" val="875117478"/>
+        <p14:creationId xmlns:p14="http://schemas.microsoft.com/office/powerpoint/2010/main" val="3162236949"/>
       </p:ext>
     </p:extLst>
   </p:cSld>
@@ -4558,7 +4558,7 @@
           <p:cNvPr id="2" name="Title Placeholder 1">
             <a:extLst>
               <a:ext uri="{FF2B5EF4-FFF2-40B4-BE49-F238E27FC236}">
-                <a16:creationId xmlns:a16="http://schemas.microsoft.com/office/drawing/2014/main" id="{4EB37BC3-B303-4F0B-5E45-C5C1C48AC719}"/>
+                <a16:creationId xmlns:a16="http://schemas.microsoft.com/office/drawing/2014/main" id="{F73F0FA9-6314-1C33-4236-68B1465D3410}"/>
               </a:ext>
             </a:extLst>
           </p:cNvPr>
@@ -4597,7 +4597,7 @@
           <p:cNvPr id="3" name="Text Placeholder 2">
             <a:extLst>
               <a:ext uri="{FF2B5EF4-FFF2-40B4-BE49-F238E27FC236}">
-                <a16:creationId xmlns:a16="http://schemas.microsoft.com/office/drawing/2014/main" id="{9B006216-1E21-426A-1741-A3E5AA75EA1D}"/>
+                <a16:creationId xmlns:a16="http://schemas.microsoft.com/office/drawing/2014/main" id="{553E494C-04E5-D934-FD03-6C7BAB4A4C50}"/>
               </a:ext>
             </a:extLst>
           </p:cNvPr>
@@ -4665,7 +4665,7 @@
           <p:cNvPr id="4" name="Date Placeholder 3">
             <a:extLst>
               <a:ext uri="{FF2B5EF4-FFF2-40B4-BE49-F238E27FC236}">
-                <a16:creationId xmlns:a16="http://schemas.microsoft.com/office/drawing/2014/main" id="{1373156E-1BBF-38ED-CD64-93C0CEC3ACEB}"/>
+                <a16:creationId xmlns:a16="http://schemas.microsoft.com/office/drawing/2014/main" id="{4011260A-AD9F-8D0C-D358-4FCCAF80E841}"/>
               </a:ext>
             </a:extLst>
           </p:cNvPr>
@@ -4699,7 +4699,7 @@
             </a:lvl1pPr>
           </a:lstStyle>
           <a:p>
-            <a:fld id="{54911CCE-F181-4E10-AF95-3F54776DA9B7}" type="datetimeFigureOut">
+            <a:fld id="{DDAEBF46-9B97-4AC3-A0AF-444D94E4545E}" type="datetimeFigureOut">
               <a:rPr lang="en-IN" smtClean="0"/>
               <a:t>19-10-2026</a:t>
             </a:fld>
@@ -4712,7 +4712,7 @@
           <p:cNvPr id="5" name="Footer Placeholder 4">
             <a:extLst>
               <a:ext uri="{FF2B5EF4-FFF2-40B4-BE49-F238E27FC236}">
-                <a16:creationId xmlns:a16="http://schemas.microsoft.com/office/drawing/2014/main" id="{66CEA3F1-0B0A-B365-3441-9413971987E2}"/>
+                <a16:creationId xmlns:a16="http://schemas.microsoft.com/office/drawing/2014/main" id="{DCB457B6-92B4-9786-E565-B7B779352C09}"/>
               </a:ext>
             </a:extLst>
           </p:cNvPr>
@@ -4755,7 +4755,7 @@
           <p:cNvPr id="6" name="Slide Number Placeholder 5">
             <a:extLst>
               <a:ext uri="{FF2B5EF4-FFF2-40B4-BE49-F238E27FC236}">
-                <a16:creationId xmlns:a16="http://schemas.microsoft.com/office/drawing/2014/main" id="{7EC3E9E6-54B8-3342-95B1-DA9201F728E5}"/>
+                <a16:creationId xmlns:a16="http://schemas.microsoft.com/office/drawing/2014/main" id="{DDFBC57E-4ABF-095E-99DA-38C209BE83FE}"/>
               </a:ext>
             </a:extLst>
           </p:cNvPr>
@@ -4789,7 +4789,7 @@
             </a:lvl1pPr>
           </a:lstStyle>
           <a:p>
-            <a:fld id="{EFA1B90F-2A8B-40BD-9E06-A35D3CBEF0A9}" type="slidenum">
+            <a:fld id="{174159CA-C179-45FE-86F2-186D70961591}" type="slidenum">
               <a:rPr lang="en-IN" smtClean="0"/>
               <a:t>‹#›</a:t>
             </a:fld>
@@ -4800,7 +4800,7 @@
     </p:spTree>
     <p:extLst>
       <p:ext uri="{BB962C8B-B14F-4D97-AF65-F5344CB8AC3E}">
-        <p14:creationId xmlns:p14="http://schemas.microsoft.com/office/powerpoint/2010/main" val="2142919947"/>
+        <p14:creationId xmlns:p14="http://schemas.microsoft.com/office/powerpoint/2010/main" val="719731784"/>
       </p:ext>
     </p:extLst>
   </p:cSld>
@@ -5131,7 +5131,7 @@
           <p:cNvPr id="2" name="TextBox 1">
             <a:extLst>
               <a:ext uri="{FF2B5EF4-FFF2-40B4-BE49-F238E27FC236}">
-                <a16:creationId xmlns:a16="http://schemas.microsoft.com/office/drawing/2014/main" id="{50E74EEB-05B4-CE2A-5A2A-FD5506B07EB7}"/>
+                <a16:creationId xmlns:a16="http://schemas.microsoft.com/office/drawing/2014/main" id="{A512ED3F-1650-A897-12A0-C0A8E2E2E6CF}"/>
               </a:ext>
             </a:extLst>
           </p:cNvPr>
@@ -5176,7 +5176,7 @@
           <p:cNvPr id="3" name="TextBox 2">
             <a:extLst>
               <a:ext uri="{FF2B5EF4-FFF2-40B4-BE49-F238E27FC236}">
-                <a16:creationId xmlns:a16="http://schemas.microsoft.com/office/drawing/2014/main" id="{91F2B3D5-4108-57CB-EB4F-4712A1D19E9D}"/>
+                <a16:creationId xmlns:a16="http://schemas.microsoft.com/office/drawing/2014/main" id="{2E345214-036A-AE64-9C17-03ED3FD53722}"/>
               </a:ext>
             </a:extLst>
           </p:cNvPr>
@@ -5222,7 +5222,7 @@
           <p:cNvPr id="4" name="TextBox 3">
             <a:extLst>
               <a:ext uri="{FF2B5EF4-FFF2-40B4-BE49-F238E27FC236}">
-                <a16:creationId xmlns:a16="http://schemas.microsoft.com/office/drawing/2014/main" id="{96A6A15E-A840-1484-F8EA-1523244A2A97}"/>
+                <a16:creationId xmlns:a16="http://schemas.microsoft.com/office/drawing/2014/main" id="{B83A1794-9817-2255-9460-597E45B095CB}"/>
               </a:ext>
             </a:extLst>
           </p:cNvPr>
@@ -5274,7 +5274,7 @@
           <p:cNvPr id="6" name="Picture 5">
             <a:extLst>
               <a:ext uri="{FF2B5EF4-FFF2-40B4-BE49-F238E27FC236}">
-                <a16:creationId xmlns:a16="http://schemas.microsoft.com/office/drawing/2014/main" id="{08DEE3ED-1BB6-6E4F-8105-4E82AE59BB0E}"/>
+                <a16:creationId xmlns:a16="http://schemas.microsoft.com/office/drawing/2014/main" id="{9B7D2DD4-32AA-042F-2869-D8FD728BCDDB}"/>
               </a:ext>
             </a:extLst>
           </p:cNvPr>
@@ -5310,7 +5310,7 @@
           <p:cNvPr id="7" name="TextBox 6">
             <a:extLst>
               <a:ext uri="{FF2B5EF4-FFF2-40B4-BE49-F238E27FC236}">
-                <a16:creationId xmlns:a16="http://schemas.microsoft.com/office/drawing/2014/main" id="{97D825DA-A0B3-8D46-9CA0-CB56354668F8}"/>
+                <a16:creationId xmlns:a16="http://schemas.microsoft.com/office/drawing/2014/main" id="{2997694D-B5DD-91EB-21CF-DA012080EC4B}"/>
               </a:ext>
             </a:extLst>
           </p:cNvPr>
@@ -5357,7 +5357,7 @@
           <p:cNvPr id="8" name="TextBox 7">
             <a:extLst>
               <a:ext uri="{FF2B5EF4-FFF2-40B4-BE49-F238E27FC236}">
-                <a16:creationId xmlns:a16="http://schemas.microsoft.com/office/drawing/2014/main" id="{68179D1C-F1F2-39E8-08F5-F06AC1D24180}"/>
+                <a16:creationId xmlns:a16="http://schemas.microsoft.com/office/drawing/2014/main" id="{CFDA2127-4BC1-8F03-AF1F-35B42DF38ADB}"/>
               </a:ext>
             </a:extLst>
           </p:cNvPr>
@@ -5400,7 +5400,7 @@
     </p:spTree>
     <p:extLst>
       <p:ext uri="{BB962C8B-B14F-4D97-AF65-F5344CB8AC3E}">
-        <p14:creationId xmlns:p14="http://schemas.microsoft.com/office/powerpoint/2010/main" val="93219057"/>
+        <p14:creationId xmlns:p14="http://schemas.microsoft.com/office/powerpoint/2010/main" val="2838229100"/>
       </p:ext>
     </p:extLst>
   </p:cSld>
@@ -5440,7 +5440,7 @@
           <p:cNvPr id="2" name="TextBox 1">
             <a:extLst>
               <a:ext uri="{FF2B5EF4-FFF2-40B4-BE49-F238E27FC236}">
-                <a16:creationId xmlns:a16="http://schemas.microsoft.com/office/drawing/2014/main" id="{858D2EF8-2179-66A1-03EF-E6E47C93C6E4}"/>
+                <a16:creationId xmlns:a16="http://schemas.microsoft.com/office/drawing/2014/main" id="{A3AE1CED-7637-4EF3-00F6-D76CB8ADF37E}"/>
               </a:ext>
             </a:extLst>
           </p:cNvPr>
@@ -5491,7 +5491,7 @@
           <p:cNvPr id="3" name="TextBox 2">
             <a:extLst>
               <a:ext uri="{FF2B5EF4-FFF2-40B4-BE49-F238E27FC236}">
-                <a16:creationId xmlns:a16="http://schemas.microsoft.com/office/drawing/2014/main" id="{95157593-03AA-2AE5-26CE-E045E630AB43}"/>
+                <a16:creationId xmlns:a16="http://schemas.microsoft.com/office/drawing/2014/main" id="{3EE48752-3EB9-CEB6-809A-B7A471C94B00}"/>
               </a:ext>
             </a:extLst>
           </p:cNvPr>
@@ -5542,7 +5542,7 @@
           <p:cNvPr id="4" name="Table 3">
             <a:extLst>
               <a:ext uri="{FF2B5EF4-FFF2-40B4-BE49-F238E27FC236}">
-                <a16:creationId xmlns:a16="http://schemas.microsoft.com/office/drawing/2014/main" id="{1D9318D2-ECE7-19F7-A9A2-A037F55E9E4E}"/>
+                <a16:creationId xmlns:a16="http://schemas.microsoft.com/office/drawing/2014/main" id="{4420A0CF-8166-CE4E-A224-9C7C567ED3D1}"/>
               </a:ext>
             </a:extLst>
           </p:cNvPr>
@@ -5552,7 +5552,7 @@
           <p:nvPr>
             <p:extLst>
               <p:ext uri="{D42A27DB-BD31-4B8C-83A1-F6EECF244321}">
-                <p14:modId xmlns:p14="http://schemas.microsoft.com/office/powerpoint/2010/main" val="1526737402"/>
+                <p14:modId xmlns:p14="http://schemas.microsoft.com/office/powerpoint/2010/main" val="1177215710"/>
               </p:ext>
             </p:extLst>
           </p:nvPr>
@@ -5571,21 +5571,21 @@
                 <a:gridCol w="3810000">
                   <a:extLst>
                     <a:ext uri="{9D8B030D-6E8A-4147-A177-3AD203B41FA5}">
-                      <a16:colId xmlns:a16="http://schemas.microsoft.com/office/drawing/2014/main" val="1665243247"/>
+                      <a16:colId xmlns:a16="http://schemas.microsoft.com/office/drawing/2014/main" val="1318158259"/>
                     </a:ext>
                   </a:extLst>
                 </a:gridCol>
                 <a:gridCol w="2286000">
                   <a:extLst>
                     <a:ext uri="{9D8B030D-6E8A-4147-A177-3AD203B41FA5}">
-                      <a16:colId xmlns:a16="http://schemas.microsoft.com/office/drawing/2014/main" val="3385580825"/>
+                      <a16:colId xmlns:a16="http://schemas.microsoft.com/office/drawing/2014/main" val="392563919"/>
                     </a:ext>
                   </a:extLst>
                 </a:gridCol>
                 <a:gridCol w="4826000">
                   <a:extLst>
                     <a:ext uri="{9D8B030D-6E8A-4147-A177-3AD203B41FA5}">
-                      <a16:colId xmlns:a16="http://schemas.microsoft.com/office/drawing/2014/main" val="3280739368"/>
+                      <a16:colId xmlns:a16="http://schemas.microsoft.com/office/drawing/2014/main" val="1719317968"/>
                     </a:ext>
                   </a:extLst>
                 </a:gridCol>
@@ -5719,7 +5719,7 @@
                 </a:tc>
                 <a:extLst>
                   <a:ext uri="{0D108BD9-81ED-4DB2-BD59-A6C34878D82A}">
-                    <a16:rowId xmlns:a16="http://schemas.microsoft.com/office/drawing/2014/main" val="2955828774"/>
+                    <a16:rowId xmlns:a16="http://schemas.microsoft.com/office/drawing/2014/main" val="2529469606"/>
                   </a:ext>
                 </a:extLst>
               </a:tr>
@@ -5852,7 +5852,7 @@
                 </a:tc>
                 <a:extLst>
                   <a:ext uri="{0D108BD9-81ED-4DB2-BD59-A6C34878D82A}">
-                    <a16:rowId xmlns:a16="http://schemas.microsoft.com/office/drawing/2014/main" val="3936939931"/>
+                    <a16:rowId xmlns:a16="http://schemas.microsoft.com/office/drawing/2014/main" val="2906696692"/>
                   </a:ext>
                 </a:extLst>
               </a:tr>
@@ -5985,7 +5985,7 @@
                 </a:tc>
                 <a:extLst>
                   <a:ext uri="{0D108BD9-81ED-4DB2-BD59-A6C34878D82A}">
-                    <a16:rowId xmlns:a16="http://schemas.microsoft.com/office/drawing/2014/main" val="3392926135"/>
+                    <a16:rowId xmlns:a16="http://schemas.microsoft.com/office/drawing/2014/main" val="3681396691"/>
                   </a:ext>
                 </a:extLst>
               </a:tr>
@@ -6118,7 +6118,7 @@
                 </a:tc>
                 <a:extLst>
                   <a:ext uri="{0D108BD9-81ED-4DB2-BD59-A6C34878D82A}">
-                    <a16:rowId xmlns:a16="http://schemas.microsoft.com/office/drawing/2014/main" val="79124776"/>
+                    <a16:rowId xmlns:a16="http://schemas.microsoft.com/office/drawing/2014/main" val="2689524873"/>
                   </a:ext>
                 </a:extLst>
               </a:tr>
@@ -6251,7 +6251,7 @@
                 </a:tc>
                 <a:extLst>
                   <a:ext uri="{0D108BD9-81ED-4DB2-BD59-A6C34878D82A}">
-                    <a16:rowId xmlns:a16="http://schemas.microsoft.com/office/drawing/2014/main" val="3655281954"/>
+                    <a16:rowId xmlns:a16="http://schemas.microsoft.com/office/drawing/2014/main" val="1695482550"/>
                   </a:ext>
                 </a:extLst>
               </a:tr>
@@ -6384,7 +6384,7 @@
                 </a:tc>
                 <a:extLst>
                   <a:ext uri="{0D108BD9-81ED-4DB2-BD59-A6C34878D82A}">
-                    <a16:rowId xmlns:a16="http://schemas.microsoft.com/office/drawing/2014/main" val="1009551982"/>
+                    <a16:rowId xmlns:a16="http://schemas.microsoft.com/office/drawing/2014/main" val="247883380"/>
                   </a:ext>
                 </a:extLst>
               </a:tr>
@@ -6397,7 +6397,7 @@
           <p:cNvPr id="5" name="TextBox 4">
             <a:extLst>
               <a:ext uri="{FF2B5EF4-FFF2-40B4-BE49-F238E27FC236}">
-                <a16:creationId xmlns:a16="http://schemas.microsoft.com/office/drawing/2014/main" id="{F38BD2C4-6BCC-FFD9-207E-C01AD7A154F7}"/>
+                <a16:creationId xmlns:a16="http://schemas.microsoft.com/office/drawing/2014/main" id="{92C05C1A-C42F-DC43-2209-77475F6894A0}"/>
               </a:ext>
             </a:extLst>
           </p:cNvPr>
@@ -6448,7 +6448,7 @@
           <p:cNvPr id="6" name="TextBox 5">
             <a:extLst>
               <a:ext uri="{FF2B5EF4-FFF2-40B4-BE49-F238E27FC236}">
-                <a16:creationId xmlns:a16="http://schemas.microsoft.com/office/drawing/2014/main" id="{06D0FCD9-3057-A49C-D039-DCF2C584B86B}"/>
+                <a16:creationId xmlns:a16="http://schemas.microsoft.com/office/drawing/2014/main" id="{AA90BDBE-8BE0-EA4C-B8A3-175D64D0BEB0}"/>
               </a:ext>
             </a:extLst>
           </p:cNvPr>
@@ -6493,7 +6493,7 @@
           <p:cNvPr id="7" name="TextBox 6">
             <a:extLst>
               <a:ext uri="{FF2B5EF4-FFF2-40B4-BE49-F238E27FC236}">
-                <a16:creationId xmlns:a16="http://schemas.microsoft.com/office/drawing/2014/main" id="{19E70E48-DE86-6170-D400-2F9C0E374B74}"/>
+                <a16:creationId xmlns:a16="http://schemas.microsoft.com/office/drawing/2014/main" id="{D5452298-B9B2-3A6F-6507-6FDF50965A41}"/>
               </a:ext>
             </a:extLst>
           </p:cNvPr>
@@ -6536,7 +6536,7 @@
     </p:spTree>
     <p:extLst>
       <p:ext uri="{BB962C8B-B14F-4D97-AF65-F5344CB8AC3E}">
-        <p14:creationId xmlns:p14="http://schemas.microsoft.com/office/powerpoint/2010/main" val="2429429674"/>
+        <p14:creationId xmlns:p14="http://schemas.microsoft.com/office/powerpoint/2010/main" val="3127543949"/>
       </p:ext>
     </p:extLst>
   </p:cSld>
@@ -6576,7 +6576,7 @@
           <p:cNvPr id="2" name="TextBox 1">
             <a:extLst>
               <a:ext uri="{FF2B5EF4-FFF2-40B4-BE49-F238E27FC236}">
-                <a16:creationId xmlns:a16="http://schemas.microsoft.com/office/drawing/2014/main" id="{DF1538D4-4D61-A71B-6A42-27EF012E9DEC}"/>
+                <a16:creationId xmlns:a16="http://schemas.microsoft.com/office/drawing/2014/main" id="{DA09D009-5977-94AF-BA06-B19F096B0DBF}"/>
               </a:ext>
             </a:extLst>
           </p:cNvPr>
@@ -6621,7 +6621,7 @@
           <p:cNvPr id="3" name="TextBox 2">
             <a:extLst>
               <a:ext uri="{FF2B5EF4-FFF2-40B4-BE49-F238E27FC236}">
-                <a16:creationId xmlns:a16="http://schemas.microsoft.com/office/drawing/2014/main" id="{D4A172C5-8B5C-C52A-3869-31B77951D89C}"/>
+                <a16:creationId xmlns:a16="http://schemas.microsoft.com/office/drawing/2014/main" id="{1D148D85-53D1-60B1-A09C-C1B7FBCE4459}"/>
               </a:ext>
             </a:extLst>
           </p:cNvPr>
@@ -6672,7 +6672,7 @@
           <p:cNvPr id="4" name="Table 3">
             <a:extLst>
               <a:ext uri="{FF2B5EF4-FFF2-40B4-BE49-F238E27FC236}">
-                <a16:creationId xmlns:a16="http://schemas.microsoft.com/office/drawing/2014/main" id="{3E150B72-7E70-EEF8-9369-3CF483E6893A}"/>
+                <a16:creationId xmlns:a16="http://schemas.microsoft.com/office/drawing/2014/main" id="{87F1EFEF-E5A7-B09B-30C5-AE7CE9ABCEFC}"/>
               </a:ext>
             </a:extLst>
           </p:cNvPr>
@@ -6682,7 +6682,7 @@
           <p:nvPr>
             <p:extLst>
               <p:ext uri="{D42A27DB-BD31-4B8C-83A1-F6EECF244321}">
-                <p14:modId xmlns:p14="http://schemas.microsoft.com/office/powerpoint/2010/main" val="482817285"/>
+                <p14:modId xmlns:p14="http://schemas.microsoft.com/office/powerpoint/2010/main" val="3745530732"/>
               </p:ext>
             </p:extLst>
           </p:nvPr>
@@ -6701,35 +6701,35 @@
                 <a:gridCol w="3302000">
                   <a:extLst>
                     <a:ext uri="{9D8B030D-6E8A-4147-A177-3AD203B41FA5}">
-                      <a16:colId xmlns:a16="http://schemas.microsoft.com/office/drawing/2014/main" val="3990143140"/>
+                      <a16:colId xmlns:a16="http://schemas.microsoft.com/office/drawing/2014/main" val="1220213133"/>
                     </a:ext>
                   </a:extLst>
                 </a:gridCol>
                 <a:gridCol w="1905000">
                   <a:extLst>
                     <a:ext uri="{9D8B030D-6E8A-4147-A177-3AD203B41FA5}">
-                      <a16:colId xmlns:a16="http://schemas.microsoft.com/office/drawing/2014/main" val="2503880740"/>
+                      <a16:colId xmlns:a16="http://schemas.microsoft.com/office/drawing/2014/main" val="578638584"/>
                     </a:ext>
                   </a:extLst>
                 </a:gridCol>
                 <a:gridCol w="1905000">
                   <a:extLst>
                     <a:ext uri="{9D8B030D-6E8A-4147-A177-3AD203B41FA5}">
-                      <a16:colId xmlns:a16="http://schemas.microsoft.com/office/drawing/2014/main" val="50833751"/>
+                      <a16:colId xmlns:a16="http://schemas.microsoft.com/office/drawing/2014/main" val="2220236956"/>
                     </a:ext>
                   </a:extLst>
                 </a:gridCol>
                 <a:gridCol w="1905000">
                   <a:extLst>
                     <a:ext uri="{9D8B030D-6E8A-4147-A177-3AD203B41FA5}">
-                      <a16:colId xmlns:a16="http://schemas.microsoft.com/office/drawing/2014/main" val="4057254018"/>
+                      <a16:colId xmlns:a16="http://schemas.microsoft.com/office/drawing/2014/main" val="3433233931"/>
                     </a:ext>
                   </a:extLst>
                 </a:gridCol>
                 <a:gridCol w="1905000">
                   <a:extLst>
                     <a:ext uri="{9D8B030D-6E8A-4147-A177-3AD203B41FA5}">
-                      <a16:colId xmlns:a16="http://schemas.microsoft.com/office/drawing/2014/main" val="3126353475"/>
+                      <a16:colId xmlns:a16="http://schemas.microsoft.com/office/drawing/2014/main" val="3830974525"/>
                     </a:ext>
                   </a:extLst>
                 </a:gridCol>
@@ -6947,7 +6947,7 @@
                 </a:tc>
                 <a:extLst>
                   <a:ext uri="{0D108BD9-81ED-4DB2-BD59-A6C34878D82A}">
-                    <a16:rowId xmlns:a16="http://schemas.microsoft.com/office/drawing/2014/main" val="4227412876"/>
+                    <a16:rowId xmlns:a16="http://schemas.microsoft.com/office/drawing/2014/main" val="3376695512"/>
                   </a:ext>
                 </a:extLst>
               </a:tr>
@@ -7164,7 +7164,7 @@
                 </a:tc>
                 <a:extLst>
                   <a:ext uri="{0D108BD9-81ED-4DB2-BD59-A6C34878D82A}">
-                    <a16:rowId xmlns:a16="http://schemas.microsoft.com/office/drawing/2014/main" val="2974472184"/>
+                    <a16:rowId xmlns:a16="http://schemas.microsoft.com/office/drawing/2014/main" val="2333021820"/>
                   </a:ext>
                 </a:extLst>
               </a:tr>
@@ -7381,7 +7381,7 @@
                 </a:tc>
                 <a:extLst>
                   <a:ext uri="{0D108BD9-81ED-4DB2-BD59-A6C34878D82A}">
-                    <a16:rowId xmlns:a16="http://schemas.microsoft.com/office/drawing/2014/main" val="2991735878"/>
+                    <a16:rowId xmlns:a16="http://schemas.microsoft.com/office/drawing/2014/main" val="1264617560"/>
                   </a:ext>
                 </a:extLst>
               </a:tr>
@@ -7598,7 +7598,7 @@
                 </a:tc>
                 <a:extLst>
                   <a:ext uri="{0D108BD9-81ED-4DB2-BD59-A6C34878D82A}">
-                    <a16:rowId xmlns:a16="http://schemas.microsoft.com/office/drawing/2014/main" val="2230144120"/>
+                    <a16:rowId xmlns:a16="http://schemas.microsoft.com/office/drawing/2014/main" val="2531557295"/>
                   </a:ext>
                 </a:extLst>
               </a:tr>
@@ -7815,7 +7815,7 @@
                 </a:tc>
                 <a:extLst>
                   <a:ext uri="{0D108BD9-81ED-4DB2-BD59-A6C34878D82A}">
-                    <a16:rowId xmlns:a16="http://schemas.microsoft.com/office/drawing/2014/main" val="605923062"/>
+                    <a16:rowId xmlns:a16="http://schemas.microsoft.com/office/drawing/2014/main" val="257310939"/>
                   </a:ext>
                 </a:extLst>
               </a:tr>
@@ -7828,7 +7828,7 @@
           <p:cNvPr id="5" name="TextBox 4">
             <a:extLst>
               <a:ext uri="{FF2B5EF4-FFF2-40B4-BE49-F238E27FC236}">
-                <a16:creationId xmlns:a16="http://schemas.microsoft.com/office/drawing/2014/main" id="{3AD39AE0-CFCF-A0EE-9D09-7CC6B99B34B8}"/>
+                <a16:creationId xmlns:a16="http://schemas.microsoft.com/office/drawing/2014/main" id="{16D2D64E-9CCF-30C8-6598-3E1BAB74936B}"/>
               </a:ext>
             </a:extLst>
           </p:cNvPr>
@@ -7879,7 +7879,7 @@
           <p:cNvPr id="6" name="TextBox 5">
             <a:extLst>
               <a:ext uri="{FF2B5EF4-FFF2-40B4-BE49-F238E27FC236}">
-                <a16:creationId xmlns:a16="http://schemas.microsoft.com/office/drawing/2014/main" id="{D6919AC3-EC34-5DFB-5788-9A684EE79364}"/>
+                <a16:creationId xmlns:a16="http://schemas.microsoft.com/office/drawing/2014/main" id="{9668968F-6323-816E-8A55-9DF05429715E}"/>
               </a:ext>
             </a:extLst>
           </p:cNvPr>
@@ -7924,7 +7924,7 @@
           <p:cNvPr id="7" name="TextBox 6">
             <a:extLst>
               <a:ext uri="{FF2B5EF4-FFF2-40B4-BE49-F238E27FC236}">
-                <a16:creationId xmlns:a16="http://schemas.microsoft.com/office/drawing/2014/main" id="{E5FED9A1-FF90-EF30-6EE0-6CF91AE0599F}"/>
+                <a16:creationId xmlns:a16="http://schemas.microsoft.com/office/drawing/2014/main" id="{88C1FD88-2A81-852B-59C4-66CA9DC49E5A}"/>
               </a:ext>
             </a:extLst>
           </p:cNvPr>
@@ -7967,7 +7967,7 @@
     </p:spTree>
     <p:extLst>
       <p:ext uri="{BB962C8B-B14F-4D97-AF65-F5344CB8AC3E}">
-        <p14:creationId xmlns:p14="http://schemas.microsoft.com/office/powerpoint/2010/main" val="752388964"/>
+        <p14:creationId xmlns:p14="http://schemas.microsoft.com/office/powerpoint/2010/main" val="993026198"/>
       </p:ext>
     </p:extLst>
   </p:cSld>
@@ -8007,7 +8007,7 @@
           <p:cNvPr id="2" name="TextBox 1">
             <a:extLst>
               <a:ext uri="{FF2B5EF4-FFF2-40B4-BE49-F238E27FC236}">
-                <a16:creationId xmlns:a16="http://schemas.microsoft.com/office/drawing/2014/main" id="{D3CECB48-D8F2-BF1D-7DB1-6CE0C466F485}"/>
+                <a16:creationId xmlns:a16="http://schemas.microsoft.com/office/drawing/2014/main" id="{1B89FBD7-82D9-862A-60CC-E8533D8C2D28}"/>
               </a:ext>
             </a:extLst>
           </p:cNvPr>
@@ -8058,7 +8058,7 @@
           <p:cNvPr id="3" name="TextBox 2">
             <a:extLst>
               <a:ext uri="{FF2B5EF4-FFF2-40B4-BE49-F238E27FC236}">
-                <a16:creationId xmlns:a16="http://schemas.microsoft.com/office/drawing/2014/main" id="{2B0BA158-B2F1-568D-89AB-030D8B9C361E}"/>
+                <a16:creationId xmlns:a16="http://schemas.microsoft.com/office/drawing/2014/main" id="{70ABA883-094B-4DFF-DCC1-C7B7B0E8178A}"/>
               </a:ext>
             </a:extLst>
           </p:cNvPr>
@@ -8109,7 +8109,7 @@
           <p:cNvPr id="4" name="TextBox 3">
             <a:extLst>
               <a:ext uri="{FF2B5EF4-FFF2-40B4-BE49-F238E27FC236}">
-                <a16:creationId xmlns:a16="http://schemas.microsoft.com/office/drawing/2014/main" id="{0F4B3695-AF9F-3214-16FC-D1AB0BB75691}"/>
+                <a16:creationId xmlns:a16="http://schemas.microsoft.com/office/drawing/2014/main" id="{D88F9F1A-AE43-2FC4-1FDD-853FC6890388}"/>
               </a:ext>
             </a:extLst>
           </p:cNvPr>
@@ -8162,7 +8162,7 @@
           <p:cNvPr id="5" name="TextBox 4">
             <a:extLst>
               <a:ext uri="{FF2B5EF4-FFF2-40B4-BE49-F238E27FC236}">
-                <a16:creationId xmlns:a16="http://schemas.microsoft.com/office/drawing/2014/main" id="{C9B7A4A4-3C36-BD9C-FC62-B1AB36699698}"/>
+                <a16:creationId xmlns:a16="http://schemas.microsoft.com/office/drawing/2014/main" id="{79F3F2D7-FC14-DBA3-6A8A-AB778C57ABD9}"/>
               </a:ext>
             </a:extLst>
           </p:cNvPr>
@@ -8214,7 +8214,7 @@
           <p:cNvPr id="6" name="Table 5">
             <a:extLst>
               <a:ext uri="{FF2B5EF4-FFF2-40B4-BE49-F238E27FC236}">
-                <a16:creationId xmlns:a16="http://schemas.microsoft.com/office/drawing/2014/main" id="{0CD3354D-23A0-E81F-A799-0DF6E2B47313}"/>
+                <a16:creationId xmlns:a16="http://schemas.microsoft.com/office/drawing/2014/main" id="{F804803D-F63A-EA2C-353C-3F5904CB55D4}"/>
               </a:ext>
             </a:extLst>
           </p:cNvPr>
@@ -8224,7 +8224,7 @@
           <p:nvPr>
             <p:extLst>
               <p:ext uri="{D42A27DB-BD31-4B8C-83A1-F6EECF244321}">
-                <p14:modId xmlns:p14="http://schemas.microsoft.com/office/powerpoint/2010/main" val="3751473148"/>
+                <p14:modId xmlns:p14="http://schemas.microsoft.com/office/powerpoint/2010/main" val="372680739"/>
               </p:ext>
             </p:extLst>
           </p:nvPr>
@@ -8243,21 +8243,21 @@
                 <a:gridCol w="2540000">
                   <a:extLst>
                     <a:ext uri="{9D8B030D-6E8A-4147-A177-3AD203B41FA5}">
-                      <a16:colId xmlns:a16="http://schemas.microsoft.com/office/drawing/2014/main" val="3855220244"/>
+                      <a16:colId xmlns:a16="http://schemas.microsoft.com/office/drawing/2014/main" val="3999907509"/>
                     </a:ext>
                   </a:extLst>
                 </a:gridCol>
                 <a:gridCol w="1397000">
                   <a:extLst>
                     <a:ext uri="{9D8B030D-6E8A-4147-A177-3AD203B41FA5}">
-                      <a16:colId xmlns:a16="http://schemas.microsoft.com/office/drawing/2014/main" val="3798176132"/>
+                      <a16:colId xmlns:a16="http://schemas.microsoft.com/office/drawing/2014/main" val="1963920576"/>
                     </a:ext>
                   </a:extLst>
                 </a:gridCol>
                 <a:gridCol w="1397000">
                   <a:extLst>
                     <a:ext uri="{9D8B030D-6E8A-4147-A177-3AD203B41FA5}">
-                      <a16:colId xmlns:a16="http://schemas.microsoft.com/office/drawing/2014/main" val="54405339"/>
+                      <a16:colId xmlns:a16="http://schemas.microsoft.com/office/drawing/2014/main" val="1299044863"/>
                     </a:ext>
                   </a:extLst>
                 </a:gridCol>
@@ -8391,7 +8391,7 @@
                 </a:tc>
                 <a:extLst>
                   <a:ext uri="{0D108BD9-81ED-4DB2-BD59-A6C34878D82A}">
-                    <a16:rowId xmlns:a16="http://schemas.microsoft.com/office/drawing/2014/main" val="4270010600"/>
+                    <a16:rowId xmlns:a16="http://schemas.microsoft.com/office/drawing/2014/main" val="2430294862"/>
                   </a:ext>
                 </a:extLst>
               </a:tr>
@@ -8524,7 +8524,7 @@
                 </a:tc>
                 <a:extLst>
                   <a:ext uri="{0D108BD9-81ED-4DB2-BD59-A6C34878D82A}">
-                    <a16:rowId xmlns:a16="http://schemas.microsoft.com/office/drawing/2014/main" val="1379785652"/>
+                    <a16:rowId xmlns:a16="http://schemas.microsoft.com/office/drawing/2014/main" val="1027262477"/>
                   </a:ext>
                 </a:extLst>
               </a:tr>
@@ -8657,7 +8657,7 @@
                 </a:tc>
                 <a:extLst>
                   <a:ext uri="{0D108BD9-81ED-4DB2-BD59-A6C34878D82A}">
-                    <a16:rowId xmlns:a16="http://schemas.microsoft.com/office/drawing/2014/main" val="2357324109"/>
+                    <a16:rowId xmlns:a16="http://schemas.microsoft.com/office/drawing/2014/main" val="4207949571"/>
                   </a:ext>
                 </a:extLst>
               </a:tr>
@@ -8670,7 +8670,7 @@
           <p:cNvPr id="7" name="TextBox 6">
             <a:extLst>
               <a:ext uri="{FF2B5EF4-FFF2-40B4-BE49-F238E27FC236}">
-                <a16:creationId xmlns:a16="http://schemas.microsoft.com/office/drawing/2014/main" id="{C408ADDA-D6EE-2B7E-AC45-C8F1A3A71320}"/>
+                <a16:creationId xmlns:a16="http://schemas.microsoft.com/office/drawing/2014/main" id="{8499B071-3A07-1399-5D92-D0355502E9E5}"/>
               </a:ext>
             </a:extLst>
           </p:cNvPr>
@@ -8721,7 +8721,7 @@
           <p:cNvPr id="8" name="TextBox 7">
             <a:extLst>
               <a:ext uri="{FF2B5EF4-FFF2-40B4-BE49-F238E27FC236}">
-                <a16:creationId xmlns:a16="http://schemas.microsoft.com/office/drawing/2014/main" id="{5A74E242-C261-CE9F-0841-BFA2EBF56B5D}"/>
+                <a16:creationId xmlns:a16="http://schemas.microsoft.com/office/drawing/2014/main" id="{A72991C2-5068-5692-291E-A94AD3B04B90}"/>
               </a:ext>
             </a:extLst>
           </p:cNvPr>
@@ -8766,7 +8766,7 @@
           <p:cNvPr id="9" name="TextBox 8">
             <a:extLst>
               <a:ext uri="{FF2B5EF4-FFF2-40B4-BE49-F238E27FC236}">
-                <a16:creationId xmlns:a16="http://schemas.microsoft.com/office/drawing/2014/main" id="{F9BB39F3-87F4-4D14-5438-4F4BB5651D7F}"/>
+                <a16:creationId xmlns:a16="http://schemas.microsoft.com/office/drawing/2014/main" id="{EE440815-7D55-9291-C934-6141E0819D72}"/>
               </a:ext>
             </a:extLst>
           </p:cNvPr>
@@ -8809,7 +8809,7 @@
     </p:spTree>
     <p:extLst>
       <p:ext uri="{BB962C8B-B14F-4D97-AF65-F5344CB8AC3E}">
-        <p14:creationId xmlns:p14="http://schemas.microsoft.com/office/powerpoint/2010/main" val="3635485083"/>
+        <p14:creationId xmlns:p14="http://schemas.microsoft.com/office/powerpoint/2010/main" val="2257365528"/>
       </p:ext>
     </p:extLst>
   </p:cSld>
@@ -8849,7 +8849,7 @@
           <p:cNvPr id="2" name="TextBox 1">
             <a:extLst>
               <a:ext uri="{FF2B5EF4-FFF2-40B4-BE49-F238E27FC236}">
-                <a16:creationId xmlns:a16="http://schemas.microsoft.com/office/drawing/2014/main" id="{79C09906-B52E-8EA9-9D3E-C3E7B6729AF6}"/>
+                <a16:creationId xmlns:a16="http://schemas.microsoft.com/office/drawing/2014/main" id="{2D466AC5-A920-8418-8A47-9BD19594FC24}"/>
               </a:ext>
             </a:extLst>
           </p:cNvPr>
@@ -8900,7 +8900,7 @@
           <p:cNvPr id="3" name="TextBox 2">
             <a:extLst>
               <a:ext uri="{FF2B5EF4-FFF2-40B4-BE49-F238E27FC236}">
-                <a16:creationId xmlns:a16="http://schemas.microsoft.com/office/drawing/2014/main" id="{31B5ADC3-5FD8-5077-349F-E84C316D20E5}"/>
+                <a16:creationId xmlns:a16="http://schemas.microsoft.com/office/drawing/2014/main" id="{9BD1A495-778F-EBFB-D967-6D7A65F5CFCB}"/>
               </a:ext>
             </a:extLst>
           </p:cNvPr>
@@ -8951,7 +8951,7 @@
           <p:cNvPr id="5" name="Picture 4">
             <a:extLst>
               <a:ext uri="{FF2B5EF4-FFF2-40B4-BE49-F238E27FC236}">
-                <a16:creationId xmlns:a16="http://schemas.microsoft.com/office/drawing/2014/main" id="{94F2652C-F510-6C56-E9C9-2253CB4B1F3A}"/>
+                <a16:creationId xmlns:a16="http://schemas.microsoft.com/office/drawing/2014/main" id="{001F64E5-EF3F-2CD7-974C-C0F9988C5773}"/>
               </a:ext>
             </a:extLst>
           </p:cNvPr>
@@ -8987,7 +8987,7 @@
           <p:cNvPr id="6" name="TextBox 5">
             <a:extLst>
               <a:ext uri="{FF2B5EF4-FFF2-40B4-BE49-F238E27FC236}">
-                <a16:creationId xmlns:a16="http://schemas.microsoft.com/office/drawing/2014/main" id="{8ED11B16-8328-D833-A7BA-89EB435EB2EE}"/>
+                <a16:creationId xmlns:a16="http://schemas.microsoft.com/office/drawing/2014/main" id="{C0D09CE3-CFC2-4BE3-C5F9-D26747610D46}"/>
               </a:ext>
             </a:extLst>
           </p:cNvPr>
@@ -9038,7 +9038,7 @@
           <p:cNvPr id="7" name="TextBox 6">
             <a:extLst>
               <a:ext uri="{FF2B5EF4-FFF2-40B4-BE49-F238E27FC236}">
-                <a16:creationId xmlns:a16="http://schemas.microsoft.com/office/drawing/2014/main" id="{ACB1CB34-25D9-CFF4-D0A8-DBA21CC5EA22}"/>
+                <a16:creationId xmlns:a16="http://schemas.microsoft.com/office/drawing/2014/main" id="{EF5496D2-228E-B235-50C8-654B24FEDFDB}"/>
               </a:ext>
             </a:extLst>
           </p:cNvPr>
@@ -9083,7 +9083,7 @@
           <p:cNvPr id="8" name="TextBox 7">
             <a:extLst>
               <a:ext uri="{FF2B5EF4-FFF2-40B4-BE49-F238E27FC236}">
-                <a16:creationId xmlns:a16="http://schemas.microsoft.com/office/drawing/2014/main" id="{3BE14FDC-4D29-A9E5-C14B-BCC2DFFEC430}"/>
+                <a16:creationId xmlns:a16="http://schemas.microsoft.com/office/drawing/2014/main" id="{FFC0679D-A331-17B2-07E9-C9F8B48536AC}"/>
               </a:ext>
             </a:extLst>
           </p:cNvPr>
@@ -9126,7 +9126,7 @@
     </p:spTree>
     <p:extLst>
       <p:ext uri="{BB962C8B-B14F-4D97-AF65-F5344CB8AC3E}">
-        <p14:creationId xmlns:p14="http://schemas.microsoft.com/office/powerpoint/2010/main" val="2014551478"/>
+        <p14:creationId xmlns:p14="http://schemas.microsoft.com/office/powerpoint/2010/main" val="3617846772"/>
       </p:ext>
     </p:extLst>
   </p:cSld>
@@ -9166,7 +9166,7 @@
           <p:cNvPr id="2" name="TextBox 1">
             <a:extLst>
               <a:ext uri="{FF2B5EF4-FFF2-40B4-BE49-F238E27FC236}">
-                <a16:creationId xmlns:a16="http://schemas.microsoft.com/office/drawing/2014/main" id="{35F9849B-8D4C-C15A-19A1-96EA443154DE}"/>
+                <a16:creationId xmlns:a16="http://schemas.microsoft.com/office/drawing/2014/main" id="{C55E80F4-8FED-A408-0A7A-0962FCDD91FE}"/>
               </a:ext>
             </a:extLst>
           </p:cNvPr>
@@ -9211,7 +9211,7 @@
           <p:cNvPr id="3" name="TextBox 2">
             <a:extLst>
               <a:ext uri="{FF2B5EF4-FFF2-40B4-BE49-F238E27FC236}">
-                <a16:creationId xmlns:a16="http://schemas.microsoft.com/office/drawing/2014/main" id="{3A23A4DF-44CC-FABF-842B-4A1E5DB15564}"/>
+                <a16:creationId xmlns:a16="http://schemas.microsoft.com/office/drawing/2014/main" id="{55E2395D-5C35-1217-89BA-B2C5EC253A3F}"/>
               </a:ext>
             </a:extLst>
           </p:cNvPr>
@@ -9262,7 +9262,7 @@
           <p:cNvPr id="5" name="Picture 4">
             <a:extLst>
               <a:ext uri="{FF2B5EF4-FFF2-40B4-BE49-F238E27FC236}">
-                <a16:creationId xmlns:a16="http://schemas.microsoft.com/office/drawing/2014/main" id="{92C2D023-24B8-B8AC-41FF-EE116801A6B7}"/>
+                <a16:creationId xmlns:a16="http://schemas.microsoft.com/office/drawing/2014/main" id="{0E691191-716D-F694-B8C0-DF927A7A7D74}"/>
               </a:ext>
             </a:extLst>
           </p:cNvPr>
@@ -9298,7 +9298,7 @@
           <p:cNvPr id="6" name="TextBox 5">
             <a:extLst>
               <a:ext uri="{FF2B5EF4-FFF2-40B4-BE49-F238E27FC236}">
-                <a16:creationId xmlns:a16="http://schemas.microsoft.com/office/drawing/2014/main" id="{EF4A9E2B-FC6F-949B-DAC8-357CDD771523}"/>
+                <a16:creationId xmlns:a16="http://schemas.microsoft.com/office/drawing/2014/main" id="{1CCF43B4-58DE-F49C-D912-98C2B5C7D03A}"/>
               </a:ext>
             </a:extLst>
           </p:cNvPr>
@@ -9343,7 +9343,7 @@
           <p:cNvPr id="7" name="TextBox 6">
             <a:extLst>
               <a:ext uri="{FF2B5EF4-FFF2-40B4-BE49-F238E27FC236}">
-                <a16:creationId xmlns:a16="http://schemas.microsoft.com/office/drawing/2014/main" id="{21BA8767-F11D-DA08-17A2-A2EFED87A2E3}"/>
+                <a16:creationId xmlns:a16="http://schemas.microsoft.com/office/drawing/2014/main" id="{B1272838-C23D-A248-A45A-8E506064B8F4}"/>
               </a:ext>
             </a:extLst>
           </p:cNvPr>
@@ -9386,7 +9386,7 @@
     </p:spTree>
     <p:extLst>
       <p:ext uri="{BB962C8B-B14F-4D97-AF65-F5344CB8AC3E}">
-        <p14:creationId xmlns:p14="http://schemas.microsoft.com/office/powerpoint/2010/main" val="2013962644"/>
+        <p14:creationId xmlns:p14="http://schemas.microsoft.com/office/powerpoint/2010/main" val="239801929"/>
       </p:ext>
     </p:extLst>
   </p:cSld>
@@ -9426,7 +9426,7 @@
           <p:cNvPr id="2" name="TextBox 1">
             <a:extLst>
               <a:ext uri="{FF2B5EF4-FFF2-40B4-BE49-F238E27FC236}">
-                <a16:creationId xmlns:a16="http://schemas.microsoft.com/office/drawing/2014/main" id="{1DDFEE02-6C42-662C-BA67-72077EF5ED04}"/>
+                <a16:creationId xmlns:a16="http://schemas.microsoft.com/office/drawing/2014/main" id="{E91EDC7D-0557-179D-5D6E-6882E0C4B96B}"/>
               </a:ext>
             </a:extLst>
           </p:cNvPr>
@@ -9471,7 +9471,7 @@
           <p:cNvPr id="3" name="TextBox 2">
             <a:extLst>
               <a:ext uri="{FF2B5EF4-FFF2-40B4-BE49-F238E27FC236}">
-                <a16:creationId xmlns:a16="http://schemas.microsoft.com/office/drawing/2014/main" id="{CF66BD13-C102-88FC-EC2B-44C607F549D9}"/>
+                <a16:creationId xmlns:a16="http://schemas.microsoft.com/office/drawing/2014/main" id="{89B8BD77-FE4C-C63B-5F81-A2EA901C1116}"/>
               </a:ext>
             </a:extLst>
           </p:cNvPr>
@@ -9522,7 +9522,7 @@
           <p:cNvPr id="4" name="TextBox 3">
             <a:extLst>
               <a:ext uri="{FF2B5EF4-FFF2-40B4-BE49-F238E27FC236}">
-                <a16:creationId xmlns:a16="http://schemas.microsoft.com/office/drawing/2014/main" id="{F698332B-46B6-68B2-2BA0-224AC082C050}"/>
+                <a16:creationId xmlns:a16="http://schemas.microsoft.com/office/drawing/2014/main" id="{40B055B8-64AD-CCEF-2C95-44C626270929}"/>
               </a:ext>
             </a:extLst>
           </p:cNvPr>
@@ -9567,7 +9567,7 @@
           <p:cNvPr id="5" name="TextBox 4">
             <a:extLst>
               <a:ext uri="{FF2B5EF4-FFF2-40B4-BE49-F238E27FC236}">
-                <a16:creationId xmlns:a16="http://schemas.microsoft.com/office/drawing/2014/main" id="{90C1DF84-5A02-FD98-EFA6-1645E35C251A}"/>
+                <a16:creationId xmlns:a16="http://schemas.microsoft.com/office/drawing/2014/main" id="{0F911C7E-6DD9-EC75-1CDC-59E5A17EAE2C}"/>
               </a:ext>
             </a:extLst>
           </p:cNvPr>
@@ -9618,7 +9618,7 @@
           <p:cNvPr id="6" name="TextBox 5">
             <a:extLst>
               <a:ext uri="{FF2B5EF4-FFF2-40B4-BE49-F238E27FC236}">
-                <a16:creationId xmlns:a16="http://schemas.microsoft.com/office/drawing/2014/main" id="{824CCFAA-2382-381B-7EF9-79D11A541CA7}"/>
+                <a16:creationId xmlns:a16="http://schemas.microsoft.com/office/drawing/2014/main" id="{2691A923-0DA8-0E0B-8B20-AA8D469C3C18}"/>
               </a:ext>
             </a:extLst>
           </p:cNvPr>
@@ -9663,7 +9663,7 @@
           <p:cNvPr id="7" name="TextBox 6">
             <a:extLst>
               <a:ext uri="{FF2B5EF4-FFF2-40B4-BE49-F238E27FC236}">
-                <a16:creationId xmlns:a16="http://schemas.microsoft.com/office/drawing/2014/main" id="{D3253FA0-47F8-5911-C825-1ECBAE3D0272}"/>
+                <a16:creationId xmlns:a16="http://schemas.microsoft.com/office/drawing/2014/main" id="{9BE67537-7707-5179-3168-070FA6732429}"/>
               </a:ext>
             </a:extLst>
           </p:cNvPr>
@@ -9715,7 +9715,7 @@
           <p:cNvPr id="8" name="TextBox 7">
             <a:extLst>
               <a:ext uri="{FF2B5EF4-FFF2-40B4-BE49-F238E27FC236}">
-                <a16:creationId xmlns:a16="http://schemas.microsoft.com/office/drawing/2014/main" id="{07C66896-AF6B-05B8-61BE-E3E2D9EF6DD7}"/>
+                <a16:creationId xmlns:a16="http://schemas.microsoft.com/office/drawing/2014/main" id="{54BFF95A-20B7-6FEA-0956-9C60BF6CFAC1}"/>
               </a:ext>
             </a:extLst>
           </p:cNvPr>
@@ -9766,7 +9766,7 @@
           <p:cNvPr id="9" name="TextBox 8">
             <a:extLst>
               <a:ext uri="{FF2B5EF4-FFF2-40B4-BE49-F238E27FC236}">
-                <a16:creationId xmlns:a16="http://schemas.microsoft.com/office/drawing/2014/main" id="{272C336C-8853-858C-0620-DD6F7CA76FA2}"/>
+                <a16:creationId xmlns:a16="http://schemas.microsoft.com/office/drawing/2014/main" id="{9DAAF8A1-3DEB-C974-0C78-03636FAD1B23}"/>
               </a:ext>
             </a:extLst>
           </p:cNvPr>
@@ -9811,7 +9811,7 @@
           <p:cNvPr id="10" name="TextBox 9">
             <a:extLst>
               <a:ext uri="{FF2B5EF4-FFF2-40B4-BE49-F238E27FC236}">
-                <a16:creationId xmlns:a16="http://schemas.microsoft.com/office/drawing/2014/main" id="{49FDD077-F322-E13A-0CAC-9A874B736C3C}"/>
+                <a16:creationId xmlns:a16="http://schemas.microsoft.com/office/drawing/2014/main" id="{6EF0211F-24C4-3175-0B04-C9927C831BCA}"/>
               </a:ext>
             </a:extLst>
           </p:cNvPr>
@@ -9854,7 +9854,7 @@
     </p:spTree>
     <p:extLst>
       <p:ext uri="{BB962C8B-B14F-4D97-AF65-F5344CB8AC3E}">
-        <p14:creationId xmlns:p14="http://schemas.microsoft.com/office/powerpoint/2010/main" val="3516614794"/>
+        <p14:creationId xmlns:p14="http://schemas.microsoft.com/office/powerpoint/2010/main" val="1584205888"/>
       </p:ext>
     </p:extLst>
   </p:cSld>
@@ -9894,7 +9894,7 @@
           <p:cNvPr id="2" name="TextBox 1">
             <a:extLst>
               <a:ext uri="{FF2B5EF4-FFF2-40B4-BE49-F238E27FC236}">
-                <a16:creationId xmlns:a16="http://schemas.microsoft.com/office/drawing/2014/main" id="{8454D82D-FF48-331D-0B6C-A6FEF94CF2C0}"/>
+                <a16:creationId xmlns:a16="http://schemas.microsoft.com/office/drawing/2014/main" id="{B3859F40-25A0-7BA2-55FB-6D47A4E54527}"/>
               </a:ext>
             </a:extLst>
           </p:cNvPr>
@@ -9945,7 +9945,7 @@
           <p:cNvPr id="3" name="TextBox 2">
             <a:extLst>
               <a:ext uri="{FF2B5EF4-FFF2-40B4-BE49-F238E27FC236}">
-                <a16:creationId xmlns:a16="http://schemas.microsoft.com/office/drawing/2014/main" id="{D18A2BA9-1ADE-A72C-0001-0CD6555D5FD5}"/>
+                <a16:creationId xmlns:a16="http://schemas.microsoft.com/office/drawing/2014/main" id="{59541F0B-541A-0B8B-AE50-F45F0B236683}"/>
               </a:ext>
             </a:extLst>
           </p:cNvPr>
@@ -9996,7 +9996,7 @@
           <p:cNvPr id="4" name="TextBox 3">
             <a:extLst>
               <a:ext uri="{FF2B5EF4-FFF2-40B4-BE49-F238E27FC236}">
-                <a16:creationId xmlns:a16="http://schemas.microsoft.com/office/drawing/2014/main" id="{E67C7FC9-4B14-17F0-5D50-281855BCA985}"/>
+                <a16:creationId xmlns:a16="http://schemas.microsoft.com/office/drawing/2014/main" id="{8058FE8E-DA21-ACA6-6496-0F87C1942518}"/>
               </a:ext>
             </a:extLst>
           </p:cNvPr>
@@ -10048,7 +10048,7 @@
           <p:cNvPr id="5" name="Table 4">
             <a:extLst>
               <a:ext uri="{FF2B5EF4-FFF2-40B4-BE49-F238E27FC236}">
-                <a16:creationId xmlns:a16="http://schemas.microsoft.com/office/drawing/2014/main" id="{5B197E21-B64F-4F81-B650-B86E8B97466F}"/>
+                <a16:creationId xmlns:a16="http://schemas.microsoft.com/office/drawing/2014/main" id="{1704CDCD-81DA-678A-3CF3-A6263EA24AEE}"/>
               </a:ext>
             </a:extLst>
           </p:cNvPr>
@@ -10058,7 +10058,7 @@
           <p:nvPr>
             <p:extLst>
               <p:ext uri="{D42A27DB-BD31-4B8C-83A1-F6EECF244321}">
-                <p14:modId xmlns:p14="http://schemas.microsoft.com/office/powerpoint/2010/main" val="3158243547"/>
+                <p14:modId xmlns:p14="http://schemas.microsoft.com/office/powerpoint/2010/main" val="4287573543"/>
               </p:ext>
             </p:extLst>
           </p:nvPr>
@@ -10077,21 +10077,21 @@
                 <a:gridCol w="5715000">
                   <a:extLst>
                     <a:ext uri="{9D8B030D-6E8A-4147-A177-3AD203B41FA5}">
-                      <a16:colId xmlns:a16="http://schemas.microsoft.com/office/drawing/2014/main" val="3224847817"/>
+                      <a16:colId xmlns:a16="http://schemas.microsoft.com/office/drawing/2014/main" val="2346158843"/>
                     </a:ext>
                   </a:extLst>
                 </a:gridCol>
                 <a:gridCol w="2603500">
                   <a:extLst>
                     <a:ext uri="{9D8B030D-6E8A-4147-A177-3AD203B41FA5}">
-                      <a16:colId xmlns:a16="http://schemas.microsoft.com/office/drawing/2014/main" val="1011869927"/>
+                      <a16:colId xmlns:a16="http://schemas.microsoft.com/office/drawing/2014/main" val="2355496660"/>
                     </a:ext>
                   </a:extLst>
                 </a:gridCol>
                 <a:gridCol w="2603500">
                   <a:extLst>
                     <a:ext uri="{9D8B030D-6E8A-4147-A177-3AD203B41FA5}">
-                      <a16:colId xmlns:a16="http://schemas.microsoft.com/office/drawing/2014/main" val="1248266132"/>
+                      <a16:colId xmlns:a16="http://schemas.microsoft.com/office/drawing/2014/main" val="3189824586"/>
                     </a:ext>
                   </a:extLst>
                 </a:gridCol>
@@ -10225,7 +10225,7 @@
                 </a:tc>
                 <a:extLst>
                   <a:ext uri="{0D108BD9-81ED-4DB2-BD59-A6C34878D82A}">
-                    <a16:rowId xmlns:a16="http://schemas.microsoft.com/office/drawing/2014/main" val="118558128"/>
+                    <a16:rowId xmlns:a16="http://schemas.microsoft.com/office/drawing/2014/main" val="1565506149"/>
                   </a:ext>
                 </a:extLst>
               </a:tr>
@@ -10358,7 +10358,7 @@
                 </a:tc>
                 <a:extLst>
                   <a:ext uri="{0D108BD9-81ED-4DB2-BD59-A6C34878D82A}">
-                    <a16:rowId xmlns:a16="http://schemas.microsoft.com/office/drawing/2014/main" val="3675691656"/>
+                    <a16:rowId xmlns:a16="http://schemas.microsoft.com/office/drawing/2014/main" val="1947812611"/>
                   </a:ext>
                 </a:extLst>
               </a:tr>
@@ -10491,7 +10491,7 @@
                 </a:tc>
                 <a:extLst>
                   <a:ext uri="{0D108BD9-81ED-4DB2-BD59-A6C34878D82A}">
-                    <a16:rowId xmlns:a16="http://schemas.microsoft.com/office/drawing/2014/main" val="3986333502"/>
+                    <a16:rowId xmlns:a16="http://schemas.microsoft.com/office/drawing/2014/main" val="3043222174"/>
                   </a:ext>
                 </a:extLst>
               </a:tr>
@@ -10624,7 +10624,7 @@
                 </a:tc>
                 <a:extLst>
                   <a:ext uri="{0D108BD9-81ED-4DB2-BD59-A6C34878D82A}">
-                    <a16:rowId xmlns:a16="http://schemas.microsoft.com/office/drawing/2014/main" val="1223964819"/>
+                    <a16:rowId xmlns:a16="http://schemas.microsoft.com/office/drawing/2014/main" val="1213984595"/>
                   </a:ext>
                 </a:extLst>
               </a:tr>
@@ -10637,7 +10637,7 @@
           <p:cNvPr id="6" name="TextBox 5">
             <a:extLst>
               <a:ext uri="{FF2B5EF4-FFF2-40B4-BE49-F238E27FC236}">
-                <a16:creationId xmlns:a16="http://schemas.microsoft.com/office/drawing/2014/main" id="{B24BF050-598F-5A2E-5520-D09DB450ABC7}"/>
+                <a16:creationId xmlns:a16="http://schemas.microsoft.com/office/drawing/2014/main" id="{6116F05A-83E9-B9E0-79CE-E60C5758CCA8}"/>
               </a:ext>
             </a:extLst>
           </p:cNvPr>
@@ -10682,7 +10682,7 @@
           <p:cNvPr id="7" name="TextBox 6">
             <a:extLst>
               <a:ext uri="{FF2B5EF4-FFF2-40B4-BE49-F238E27FC236}">
-                <a16:creationId xmlns:a16="http://schemas.microsoft.com/office/drawing/2014/main" id="{49942E09-34D0-A880-E505-1AB05B985365}"/>
+                <a16:creationId xmlns:a16="http://schemas.microsoft.com/office/drawing/2014/main" id="{C699471F-7F36-CDC0-0728-8F530CE0691C}"/>
               </a:ext>
             </a:extLst>
           </p:cNvPr>
@@ -10725,7 +10725,7 @@
     </p:spTree>
     <p:extLst>
       <p:ext uri="{BB962C8B-B14F-4D97-AF65-F5344CB8AC3E}">
-        <p14:creationId xmlns:p14="http://schemas.microsoft.com/office/powerpoint/2010/main" val="211233907"/>
+        <p14:creationId xmlns:p14="http://schemas.microsoft.com/office/powerpoint/2010/main" val="543356652"/>
       </p:ext>
     </p:extLst>
   </p:cSld>
@@ -10765,7 +10765,7 @@
           <p:cNvPr id="2" name="TextBox 1">
             <a:extLst>
               <a:ext uri="{FF2B5EF4-FFF2-40B4-BE49-F238E27FC236}">
-                <a16:creationId xmlns:a16="http://schemas.microsoft.com/office/drawing/2014/main" id="{1EC4E0D3-21E8-ECEF-5D80-64B28594D59E}"/>
+                <a16:creationId xmlns:a16="http://schemas.microsoft.com/office/drawing/2014/main" id="{B57A51C8-A676-9450-1AEB-7C7FBA21D0E4}"/>
               </a:ext>
             </a:extLst>
           </p:cNvPr>
@@ -10810,7 +10810,7 @@
           <p:cNvPr id="3" name="TextBox 2">
             <a:extLst>
               <a:ext uri="{FF2B5EF4-FFF2-40B4-BE49-F238E27FC236}">
-                <a16:creationId xmlns:a16="http://schemas.microsoft.com/office/drawing/2014/main" id="{67BD6CD9-E734-370C-38EC-A5546D5D2443}"/>
+                <a16:creationId xmlns:a16="http://schemas.microsoft.com/office/drawing/2014/main" id="{1AF60C53-D3BE-D552-A407-CCE88C8DB843}"/>
               </a:ext>
             </a:extLst>
           </p:cNvPr>
@@ -10861,7 +10861,7 @@
           <p:cNvPr id="4" name="TextBox 3">
             <a:extLst>
               <a:ext uri="{FF2B5EF4-FFF2-40B4-BE49-F238E27FC236}">
-                <a16:creationId xmlns:a16="http://schemas.microsoft.com/office/drawing/2014/main" id="{6C66C994-59AD-F35B-4F63-1E9A4B61577D}"/>
+                <a16:creationId xmlns:a16="http://schemas.microsoft.com/office/drawing/2014/main" id="{FAFF5387-5544-5AE4-7401-926049076030}"/>
               </a:ext>
             </a:extLst>
           </p:cNvPr>
@@ -10915,7 +10915,7 @@
           <p:cNvPr id="5" name="TextBox 4">
             <a:extLst>
               <a:ext uri="{FF2B5EF4-FFF2-40B4-BE49-F238E27FC236}">
-                <a16:creationId xmlns:a16="http://schemas.microsoft.com/office/drawing/2014/main" id="{A39578F3-4A60-1CFB-CDEB-17B4D2C04DD3}"/>
+                <a16:creationId xmlns:a16="http://schemas.microsoft.com/office/drawing/2014/main" id="{A9C05934-E5F8-5E9D-8638-C344753D55A7}"/>
               </a:ext>
             </a:extLst>
           </p:cNvPr>
@@ -10968,7 +10968,7 @@
           <p:cNvPr id="7" name="Picture 6">
             <a:extLst>
               <a:ext uri="{FF2B5EF4-FFF2-40B4-BE49-F238E27FC236}">
-                <a16:creationId xmlns:a16="http://schemas.microsoft.com/office/drawing/2014/main" id="{EA4C9B57-DA38-21C7-9528-FF5E6B387686}"/>
+                <a16:creationId xmlns:a16="http://schemas.microsoft.com/office/drawing/2014/main" id="{50ED75BE-89A6-F9F5-FA13-5A74904F7066}"/>
               </a:ext>
             </a:extLst>
           </p:cNvPr>
@@ -11004,7 +11004,7 @@
           <p:cNvPr id="8" name="TextBox 7">
             <a:extLst>
               <a:ext uri="{FF2B5EF4-FFF2-40B4-BE49-F238E27FC236}">
-                <a16:creationId xmlns:a16="http://schemas.microsoft.com/office/drawing/2014/main" id="{48A06530-7263-2906-48E0-EE39A7A39E18}"/>
+                <a16:creationId xmlns:a16="http://schemas.microsoft.com/office/drawing/2014/main" id="{1B157421-7C28-6654-C521-40FFAABCE1B9}"/>
               </a:ext>
             </a:extLst>
           </p:cNvPr>
@@ -11049,7 +11049,7 @@
           <p:cNvPr id="9" name="TextBox 8">
             <a:extLst>
               <a:ext uri="{FF2B5EF4-FFF2-40B4-BE49-F238E27FC236}">
-                <a16:creationId xmlns:a16="http://schemas.microsoft.com/office/drawing/2014/main" id="{DCF9AD12-C205-294F-0004-63CF9DF25D09}"/>
+                <a16:creationId xmlns:a16="http://schemas.microsoft.com/office/drawing/2014/main" id="{C8605736-214A-8AB2-235E-51F21BF487AF}"/>
               </a:ext>
             </a:extLst>
           </p:cNvPr>
@@ -11092,7 +11092,7 @@
     </p:spTree>
     <p:extLst>
       <p:ext uri="{BB962C8B-B14F-4D97-AF65-F5344CB8AC3E}">
-        <p14:creationId xmlns:p14="http://schemas.microsoft.com/office/powerpoint/2010/main" val="1386251605"/>
+        <p14:creationId xmlns:p14="http://schemas.microsoft.com/office/powerpoint/2010/main" val="173723156"/>
       </p:ext>
     </p:extLst>
   </p:cSld>
@@ -11132,7 +11132,7 @@
           <p:cNvPr id="2" name="TextBox 1">
             <a:extLst>
               <a:ext uri="{FF2B5EF4-FFF2-40B4-BE49-F238E27FC236}">
-                <a16:creationId xmlns:a16="http://schemas.microsoft.com/office/drawing/2014/main" id="{9DB94653-8899-1A75-BB62-2A658752C150}"/>
+                <a16:creationId xmlns:a16="http://schemas.microsoft.com/office/drawing/2014/main" id="{4664EBEC-1092-89C7-4793-ADB73A26FA20}"/>
               </a:ext>
             </a:extLst>
           </p:cNvPr>
@@ -11183,7 +11183,7 @@
           <p:cNvPr id="3" name="TextBox 2">
             <a:extLst>
               <a:ext uri="{FF2B5EF4-FFF2-40B4-BE49-F238E27FC236}">
-                <a16:creationId xmlns:a16="http://schemas.microsoft.com/office/drawing/2014/main" id="{0A389926-51FE-F6CF-B4E6-CC2EA6EF403B}"/>
+                <a16:creationId xmlns:a16="http://schemas.microsoft.com/office/drawing/2014/main" id="{DC6C68E4-CA28-37FA-904E-03A90AB9D511}"/>
               </a:ext>
             </a:extLst>
           </p:cNvPr>
@@ -11234,7 +11234,7 @@
           <p:cNvPr id="4" name="Table 3">
             <a:extLst>
               <a:ext uri="{FF2B5EF4-FFF2-40B4-BE49-F238E27FC236}">
-                <a16:creationId xmlns:a16="http://schemas.microsoft.com/office/drawing/2014/main" id="{9B97EE9F-155B-70CA-917C-D4263E2BA16F}"/>
+                <a16:creationId xmlns:a16="http://schemas.microsoft.com/office/drawing/2014/main" id="{584630EB-E21E-BEC7-C92D-EC7810CA206D}"/>
               </a:ext>
             </a:extLst>
           </p:cNvPr>
@@ -11244,7 +11244,7 @@
           <p:nvPr>
             <p:extLst>
               <p:ext uri="{D42A27DB-BD31-4B8C-83A1-F6EECF244321}">
-                <p14:modId xmlns:p14="http://schemas.microsoft.com/office/powerpoint/2010/main" val="3571057206"/>
+                <p14:modId xmlns:p14="http://schemas.microsoft.com/office/powerpoint/2010/main" val="2561002737"/>
               </p:ext>
             </p:extLst>
           </p:nvPr>
@@ -11263,21 +11263,21 @@
                 <a:gridCol w="2921000">
                   <a:extLst>
                     <a:ext uri="{9D8B030D-6E8A-4147-A177-3AD203B41FA5}">
-                      <a16:colId xmlns:a16="http://schemas.microsoft.com/office/drawing/2014/main" val="2049185780"/>
+                      <a16:colId xmlns:a16="http://schemas.microsoft.com/office/drawing/2014/main" val="408300688"/>
                     </a:ext>
                   </a:extLst>
                 </a:gridCol>
                 <a:gridCol w="4191000">
                   <a:extLst>
                     <a:ext uri="{9D8B030D-6E8A-4147-A177-3AD203B41FA5}">
-                      <a16:colId xmlns:a16="http://schemas.microsoft.com/office/drawing/2014/main" val="378192211"/>
+                      <a16:colId xmlns:a16="http://schemas.microsoft.com/office/drawing/2014/main" val="621236663"/>
                     </a:ext>
                   </a:extLst>
                 </a:gridCol>
                 <a:gridCol w="3810000">
                   <a:extLst>
                     <a:ext uri="{9D8B030D-6E8A-4147-A177-3AD203B41FA5}">
-                      <a16:colId xmlns:a16="http://schemas.microsoft.com/office/drawing/2014/main" val="671016490"/>
+                      <a16:colId xmlns:a16="http://schemas.microsoft.com/office/drawing/2014/main" val="1125884526"/>
                     </a:ext>
                   </a:extLst>
                 </a:gridCol>
@@ -11411,7 +11411,7 @@
                 </a:tc>
                 <a:extLst>
                   <a:ext uri="{0D108BD9-81ED-4DB2-BD59-A6C34878D82A}">
-                    <a16:rowId xmlns:a16="http://schemas.microsoft.com/office/drawing/2014/main" val="133895981"/>
+                    <a16:rowId xmlns:a16="http://schemas.microsoft.com/office/drawing/2014/main" val="1508988066"/>
                   </a:ext>
                 </a:extLst>
               </a:tr>
@@ -11544,7 +11544,7 @@
                 </a:tc>
                 <a:extLst>
                   <a:ext uri="{0D108BD9-81ED-4DB2-BD59-A6C34878D82A}">
-                    <a16:rowId xmlns:a16="http://schemas.microsoft.com/office/drawing/2014/main" val="3951258233"/>
+                    <a16:rowId xmlns:a16="http://schemas.microsoft.com/office/drawing/2014/main" val="3351625309"/>
                   </a:ext>
                 </a:extLst>
               </a:tr>
@@ -11677,7 +11677,7 @@
                 </a:tc>
                 <a:extLst>
                   <a:ext uri="{0D108BD9-81ED-4DB2-BD59-A6C34878D82A}">
-                    <a16:rowId xmlns:a16="http://schemas.microsoft.com/office/drawing/2014/main" val="269049951"/>
+                    <a16:rowId xmlns:a16="http://schemas.microsoft.com/office/drawing/2014/main" val="2591119937"/>
                   </a:ext>
                 </a:extLst>
               </a:tr>
@@ -11810,7 +11810,7 @@
                 </a:tc>
                 <a:extLst>
                   <a:ext uri="{0D108BD9-81ED-4DB2-BD59-A6C34878D82A}">
-                    <a16:rowId xmlns:a16="http://schemas.microsoft.com/office/drawing/2014/main" val="1477551466"/>
+                    <a16:rowId xmlns:a16="http://schemas.microsoft.com/office/drawing/2014/main" val="2715193796"/>
                   </a:ext>
                 </a:extLst>
               </a:tr>
@@ -11943,7 +11943,7 @@
                 </a:tc>
                 <a:extLst>
                   <a:ext uri="{0D108BD9-81ED-4DB2-BD59-A6C34878D82A}">
-                    <a16:rowId xmlns:a16="http://schemas.microsoft.com/office/drawing/2014/main" val="873626517"/>
+                    <a16:rowId xmlns:a16="http://schemas.microsoft.com/office/drawing/2014/main" val="1366709441"/>
                   </a:ext>
                 </a:extLst>
               </a:tr>
@@ -11956,7 +11956,7 @@
           <p:cNvPr id="5" name="TextBox 4">
             <a:extLst>
               <a:ext uri="{FF2B5EF4-FFF2-40B4-BE49-F238E27FC236}">
-                <a16:creationId xmlns:a16="http://schemas.microsoft.com/office/drawing/2014/main" id="{986BE51D-8514-C218-BE14-8F44F41421EE}"/>
+                <a16:creationId xmlns:a16="http://schemas.microsoft.com/office/drawing/2014/main" id="{6D585153-2F37-0EB8-C5A8-DCB107AE704E}"/>
               </a:ext>
             </a:extLst>
           </p:cNvPr>
@@ -12007,7 +12007,7 @@
           <p:cNvPr id="6" name="TextBox 5">
             <a:extLst>
               <a:ext uri="{FF2B5EF4-FFF2-40B4-BE49-F238E27FC236}">
-                <a16:creationId xmlns:a16="http://schemas.microsoft.com/office/drawing/2014/main" id="{4493C885-845E-46D5-C887-D117AC24DC25}"/>
+                <a16:creationId xmlns:a16="http://schemas.microsoft.com/office/drawing/2014/main" id="{43697F08-BEA1-CD88-3872-FE3A38813CAE}"/>
               </a:ext>
             </a:extLst>
           </p:cNvPr>
@@ -12052,7 +12052,7 @@
           <p:cNvPr id="7" name="TextBox 6">
             <a:extLst>
               <a:ext uri="{FF2B5EF4-FFF2-40B4-BE49-F238E27FC236}">
-                <a16:creationId xmlns:a16="http://schemas.microsoft.com/office/drawing/2014/main" id="{2D193225-2891-BC91-F605-E9C9F6CE6D63}"/>
+                <a16:creationId xmlns:a16="http://schemas.microsoft.com/office/drawing/2014/main" id="{8A65E634-E0E7-3E31-EDCA-96214762C713}"/>
               </a:ext>
             </a:extLst>
           </p:cNvPr>
@@ -12095,7 +12095,7 @@
     </p:spTree>
     <p:extLst>
       <p:ext uri="{BB962C8B-B14F-4D97-AF65-F5344CB8AC3E}">
-        <p14:creationId xmlns:p14="http://schemas.microsoft.com/office/powerpoint/2010/main" val="800680071"/>
+        <p14:creationId xmlns:p14="http://schemas.microsoft.com/office/powerpoint/2010/main" val="2757662218"/>
       </p:ext>
     </p:extLst>
   </p:cSld>
@@ -12135,7 +12135,7 @@
           <p:cNvPr id="2" name="TextBox 1">
             <a:extLst>
               <a:ext uri="{FF2B5EF4-FFF2-40B4-BE49-F238E27FC236}">
-                <a16:creationId xmlns:a16="http://schemas.microsoft.com/office/drawing/2014/main" id="{41172AD4-B9AA-5EAC-30C5-ABFFFDF53740}"/>
+                <a16:creationId xmlns:a16="http://schemas.microsoft.com/office/drawing/2014/main" id="{A941A79B-45B2-B1EF-30E6-09494665AE0D}"/>
               </a:ext>
             </a:extLst>
           </p:cNvPr>
@@ -12186,7 +12186,7 @@
           <p:cNvPr id="3" name="TextBox 2">
             <a:extLst>
               <a:ext uri="{FF2B5EF4-FFF2-40B4-BE49-F238E27FC236}">
-                <a16:creationId xmlns:a16="http://schemas.microsoft.com/office/drawing/2014/main" id="{090ACE6C-2A78-4F79-0D99-EE3EE99BA310}"/>
+                <a16:creationId xmlns:a16="http://schemas.microsoft.com/office/drawing/2014/main" id="{92A8D015-FE8D-5C0C-EE4B-7F526AB5D9E9}"/>
               </a:ext>
             </a:extLst>
           </p:cNvPr>
@@ -12237,7 +12237,7 @@
           <p:cNvPr id="4" name="TextBox 3">
             <a:extLst>
               <a:ext uri="{FF2B5EF4-FFF2-40B4-BE49-F238E27FC236}">
-                <a16:creationId xmlns:a16="http://schemas.microsoft.com/office/drawing/2014/main" id="{2A495A79-EAE4-CF75-D39D-F8AE83BC4BE8}"/>
+                <a16:creationId xmlns:a16="http://schemas.microsoft.com/office/drawing/2014/main" id="{029C40B4-18EB-F43E-64DE-CA8B623BF865}"/>
               </a:ext>
             </a:extLst>
           </p:cNvPr>
@@ -12289,7 +12289,7 @@
           <p:cNvPr id="5" name="Table 4">
             <a:extLst>
               <a:ext uri="{FF2B5EF4-FFF2-40B4-BE49-F238E27FC236}">
-                <a16:creationId xmlns:a16="http://schemas.microsoft.com/office/drawing/2014/main" id="{BBA56065-5DB8-4605-2533-2ED3F02603C3}"/>
+                <a16:creationId xmlns:a16="http://schemas.microsoft.com/office/drawing/2014/main" id="{6456D932-A02B-7954-E810-05933208296F}"/>
               </a:ext>
             </a:extLst>
           </p:cNvPr>
@@ -12299,7 +12299,7 @@
           <p:nvPr>
             <p:extLst>
               <p:ext uri="{D42A27DB-BD31-4B8C-83A1-F6EECF244321}">
-                <p14:modId xmlns:p14="http://schemas.microsoft.com/office/powerpoint/2010/main" val="1301145046"/>
+                <p14:modId xmlns:p14="http://schemas.microsoft.com/office/powerpoint/2010/main" val="1219331328"/>
               </p:ext>
             </p:extLst>
           </p:nvPr>
@@ -12318,28 +12318,28 @@
                 <a:gridCol w="4064000">
                   <a:extLst>
                     <a:ext uri="{9D8B030D-6E8A-4147-A177-3AD203B41FA5}">
-                      <a16:colId xmlns:a16="http://schemas.microsoft.com/office/drawing/2014/main" val="3009100778"/>
+                      <a16:colId xmlns:a16="http://schemas.microsoft.com/office/drawing/2014/main" val="886453714"/>
                     </a:ext>
                   </a:extLst>
                 </a:gridCol>
                 <a:gridCol w="2286000">
                   <a:extLst>
                     <a:ext uri="{9D8B030D-6E8A-4147-A177-3AD203B41FA5}">
-                      <a16:colId xmlns:a16="http://schemas.microsoft.com/office/drawing/2014/main" val="4045210376"/>
+                      <a16:colId xmlns:a16="http://schemas.microsoft.com/office/drawing/2014/main" val="1463371730"/>
                     </a:ext>
                   </a:extLst>
                 </a:gridCol>
                 <a:gridCol w="2286000">
                   <a:extLst>
                     <a:ext uri="{9D8B030D-6E8A-4147-A177-3AD203B41FA5}">
-                      <a16:colId xmlns:a16="http://schemas.microsoft.com/office/drawing/2014/main" val="2594822297"/>
+                      <a16:colId xmlns:a16="http://schemas.microsoft.com/office/drawing/2014/main" val="290804893"/>
                     </a:ext>
                   </a:extLst>
                 </a:gridCol>
                 <a:gridCol w="2286000">
                   <a:extLst>
                     <a:ext uri="{9D8B030D-6E8A-4147-A177-3AD203B41FA5}">
-                      <a16:colId xmlns:a16="http://schemas.microsoft.com/office/drawing/2014/main" val="1239833553"/>
+                      <a16:colId xmlns:a16="http://schemas.microsoft.com/office/drawing/2014/main" val="935935079"/>
                     </a:ext>
                   </a:extLst>
                 </a:gridCol>
@@ -12515,7 +12515,7 @@
                 </a:tc>
                 <a:extLst>
                   <a:ext uri="{0D108BD9-81ED-4DB2-BD59-A6C34878D82A}">
-                    <a16:rowId xmlns:a16="http://schemas.microsoft.com/office/drawing/2014/main" val="2046717989"/>
+                    <a16:rowId xmlns:a16="http://schemas.microsoft.com/office/drawing/2014/main" val="3024712218"/>
                   </a:ext>
                 </a:extLst>
               </a:tr>
@@ -12690,7 +12690,7 @@
                 </a:tc>
                 <a:extLst>
                   <a:ext uri="{0D108BD9-81ED-4DB2-BD59-A6C34878D82A}">
-                    <a16:rowId xmlns:a16="http://schemas.microsoft.com/office/drawing/2014/main" val="913814147"/>
+                    <a16:rowId xmlns:a16="http://schemas.microsoft.com/office/drawing/2014/main" val="2059798148"/>
                   </a:ext>
                 </a:extLst>
               </a:tr>
@@ -12865,7 +12865,7 @@
                 </a:tc>
                 <a:extLst>
                   <a:ext uri="{0D108BD9-81ED-4DB2-BD59-A6C34878D82A}">
-                    <a16:rowId xmlns:a16="http://schemas.microsoft.com/office/drawing/2014/main" val="721030348"/>
+                    <a16:rowId xmlns:a16="http://schemas.microsoft.com/office/drawing/2014/main" val="606718861"/>
                   </a:ext>
                 </a:extLst>
               </a:tr>
@@ -13040,7 +13040,7 @@
                 </a:tc>
                 <a:extLst>
                   <a:ext uri="{0D108BD9-81ED-4DB2-BD59-A6C34878D82A}">
-                    <a16:rowId xmlns:a16="http://schemas.microsoft.com/office/drawing/2014/main" val="3762050048"/>
+                    <a16:rowId xmlns:a16="http://schemas.microsoft.com/office/drawing/2014/main" val="2082011026"/>
                   </a:ext>
                 </a:extLst>
               </a:tr>
@@ -13215,7 +13215,7 @@
                 </a:tc>
                 <a:extLst>
                   <a:ext uri="{0D108BD9-81ED-4DB2-BD59-A6C34878D82A}">
-                    <a16:rowId xmlns:a16="http://schemas.microsoft.com/office/drawing/2014/main" val="3510758981"/>
+                    <a16:rowId xmlns:a16="http://schemas.microsoft.com/office/drawing/2014/main" val="1141003386"/>
                   </a:ext>
                 </a:extLst>
               </a:tr>
@@ -13228,7 +13228,7 @@
           <p:cNvPr id="6" name="TextBox 5">
             <a:extLst>
               <a:ext uri="{FF2B5EF4-FFF2-40B4-BE49-F238E27FC236}">
-                <a16:creationId xmlns:a16="http://schemas.microsoft.com/office/drawing/2014/main" id="{8E56F0E2-5645-78FD-B649-A8DBC55E39ED}"/>
+                <a16:creationId xmlns:a16="http://schemas.microsoft.com/office/drawing/2014/main" id="{A1AB72BE-A940-EC88-4833-9CA2B8DC4CEA}"/>
               </a:ext>
             </a:extLst>
           </p:cNvPr>
@@ -13273,7 +13273,7 @@
           <p:cNvPr id="7" name="TextBox 6">
             <a:extLst>
               <a:ext uri="{FF2B5EF4-FFF2-40B4-BE49-F238E27FC236}">
-                <a16:creationId xmlns:a16="http://schemas.microsoft.com/office/drawing/2014/main" id="{57D5E040-A380-FEED-4050-1328D4A8C266}"/>
+                <a16:creationId xmlns:a16="http://schemas.microsoft.com/office/drawing/2014/main" id="{3BFBEBCC-2C2D-98A2-FC3E-56B0A611CFBE}"/>
               </a:ext>
             </a:extLst>
           </p:cNvPr>
@@ -13316,7 +13316,7 @@
     </p:spTree>
     <p:extLst>
       <p:ext uri="{BB962C8B-B14F-4D97-AF65-F5344CB8AC3E}">
-        <p14:creationId xmlns:p14="http://schemas.microsoft.com/office/powerpoint/2010/main" val="3348267733"/>
+        <p14:creationId xmlns:p14="http://schemas.microsoft.com/office/powerpoint/2010/main" val="509101031"/>
       </p:ext>
     </p:extLst>
   </p:cSld>
@@ -13356,7 +13356,7 @@
           <p:cNvPr id="2" name="TextBox 1">
             <a:extLst>
               <a:ext uri="{FF2B5EF4-FFF2-40B4-BE49-F238E27FC236}">
-                <a16:creationId xmlns:a16="http://schemas.microsoft.com/office/drawing/2014/main" id="{FADC5378-36CA-E8E7-62FA-41A552F7BAB0}"/>
+                <a16:creationId xmlns:a16="http://schemas.microsoft.com/office/drawing/2014/main" id="{81D3CB5C-2DB2-D6CC-7503-A5020D35043F}"/>
               </a:ext>
             </a:extLst>
           </p:cNvPr>
@@ -13407,7 +13407,7 @@
           <p:cNvPr id="3" name="TextBox 2">
             <a:extLst>
               <a:ext uri="{FF2B5EF4-FFF2-40B4-BE49-F238E27FC236}">
-                <a16:creationId xmlns:a16="http://schemas.microsoft.com/office/drawing/2014/main" id="{22F0D03F-CC8C-ABB2-A522-794F814BF74B}"/>
+                <a16:creationId xmlns:a16="http://schemas.microsoft.com/office/drawing/2014/main" id="{E2DD2BA1-B6D5-1DA2-9A04-A1DA7C1BAEC5}"/>
               </a:ext>
             </a:extLst>
           </p:cNvPr>
@@ -13458,7 +13458,7 @@
           <p:cNvPr id="4" name="Table 3">
             <a:extLst>
               <a:ext uri="{FF2B5EF4-FFF2-40B4-BE49-F238E27FC236}">
-                <a16:creationId xmlns:a16="http://schemas.microsoft.com/office/drawing/2014/main" id="{8B8ACB70-E913-C494-B313-9C85DBE0334F}"/>
+                <a16:creationId xmlns:a16="http://schemas.microsoft.com/office/drawing/2014/main" id="{E8A126D5-0D50-4A99-1491-8DAD6705FD31}"/>
               </a:ext>
             </a:extLst>
           </p:cNvPr>
@@ -13468,7 +13468,7 @@
           <p:nvPr>
             <p:extLst>
               <p:ext uri="{D42A27DB-BD31-4B8C-83A1-F6EECF244321}">
-                <p14:modId xmlns:p14="http://schemas.microsoft.com/office/powerpoint/2010/main" val="819168339"/>
+                <p14:modId xmlns:p14="http://schemas.microsoft.com/office/powerpoint/2010/main" val="3637985668"/>
               </p:ext>
             </p:extLst>
           </p:nvPr>
@@ -13487,21 +13487,21 @@
                 <a:gridCol w="3810000">
                   <a:extLst>
                     <a:ext uri="{9D8B030D-6E8A-4147-A177-3AD203B41FA5}">
-                      <a16:colId xmlns:a16="http://schemas.microsoft.com/office/drawing/2014/main" val="1086060163"/>
+                      <a16:colId xmlns:a16="http://schemas.microsoft.com/office/drawing/2014/main" val="712449813"/>
                     </a:ext>
                   </a:extLst>
                 </a:gridCol>
                 <a:gridCol w="3302000">
                   <a:extLst>
                     <a:ext uri="{9D8B030D-6E8A-4147-A177-3AD203B41FA5}">
-                      <a16:colId xmlns:a16="http://schemas.microsoft.com/office/drawing/2014/main" val="426578516"/>
+                      <a16:colId xmlns:a16="http://schemas.microsoft.com/office/drawing/2014/main" val="951722510"/>
                     </a:ext>
                   </a:extLst>
                 </a:gridCol>
                 <a:gridCol w="3810000">
                   <a:extLst>
                     <a:ext uri="{9D8B030D-6E8A-4147-A177-3AD203B41FA5}">
-                      <a16:colId xmlns:a16="http://schemas.microsoft.com/office/drawing/2014/main" val="3431522384"/>
+                      <a16:colId xmlns:a16="http://schemas.microsoft.com/office/drawing/2014/main" val="1888829560"/>
                     </a:ext>
                   </a:extLst>
                 </a:gridCol>
@@ -13635,7 +13635,7 @@
                 </a:tc>
                 <a:extLst>
                   <a:ext uri="{0D108BD9-81ED-4DB2-BD59-A6C34878D82A}">
-                    <a16:rowId xmlns:a16="http://schemas.microsoft.com/office/drawing/2014/main" val="3200566887"/>
+                    <a16:rowId xmlns:a16="http://schemas.microsoft.com/office/drawing/2014/main" val="1620108320"/>
                   </a:ext>
                 </a:extLst>
               </a:tr>
@@ -13768,7 +13768,7 @@
                 </a:tc>
                 <a:extLst>
                   <a:ext uri="{0D108BD9-81ED-4DB2-BD59-A6C34878D82A}">
-                    <a16:rowId xmlns:a16="http://schemas.microsoft.com/office/drawing/2014/main" val="3756204372"/>
+                    <a16:rowId xmlns:a16="http://schemas.microsoft.com/office/drawing/2014/main" val="466921648"/>
                   </a:ext>
                 </a:extLst>
               </a:tr>
@@ -13907,7 +13907,7 @@
                 </a:tc>
                 <a:extLst>
                   <a:ext uri="{0D108BD9-81ED-4DB2-BD59-A6C34878D82A}">
-                    <a16:rowId xmlns:a16="http://schemas.microsoft.com/office/drawing/2014/main" val="2366331738"/>
+                    <a16:rowId xmlns:a16="http://schemas.microsoft.com/office/drawing/2014/main" val="126026058"/>
                   </a:ext>
                 </a:extLst>
               </a:tr>
@@ -14040,7 +14040,7 @@
                 </a:tc>
                 <a:extLst>
                   <a:ext uri="{0D108BD9-81ED-4DB2-BD59-A6C34878D82A}">
-                    <a16:rowId xmlns:a16="http://schemas.microsoft.com/office/drawing/2014/main" val="1553331927"/>
+                    <a16:rowId xmlns:a16="http://schemas.microsoft.com/office/drawing/2014/main" val="431691177"/>
                   </a:ext>
                 </a:extLst>
               </a:tr>
@@ -14179,7 +14179,7 @@
                 </a:tc>
                 <a:extLst>
                   <a:ext uri="{0D108BD9-81ED-4DB2-BD59-A6C34878D82A}">
-                    <a16:rowId xmlns:a16="http://schemas.microsoft.com/office/drawing/2014/main" val="1002743363"/>
+                    <a16:rowId xmlns:a16="http://schemas.microsoft.com/office/drawing/2014/main" val="767539793"/>
                   </a:ext>
                 </a:extLst>
               </a:tr>
@@ -14192,7 +14192,7 @@
           <p:cNvPr id="5" name="TextBox 4">
             <a:extLst>
               <a:ext uri="{FF2B5EF4-FFF2-40B4-BE49-F238E27FC236}">
-                <a16:creationId xmlns:a16="http://schemas.microsoft.com/office/drawing/2014/main" id="{D4DA9723-A229-E7F3-ED98-3FD5D3BD3BF8}"/>
+                <a16:creationId xmlns:a16="http://schemas.microsoft.com/office/drawing/2014/main" id="{1275FB98-989E-7A79-3793-0E1C61DBC344}"/>
               </a:ext>
             </a:extLst>
           </p:cNvPr>
@@ -14243,7 +14243,7 @@
           <p:cNvPr id="6" name="TextBox 5">
             <a:extLst>
               <a:ext uri="{FF2B5EF4-FFF2-40B4-BE49-F238E27FC236}">
-                <a16:creationId xmlns:a16="http://schemas.microsoft.com/office/drawing/2014/main" id="{E416F736-5FC5-CA61-2838-4C82BBEA72C7}"/>
+                <a16:creationId xmlns:a16="http://schemas.microsoft.com/office/drawing/2014/main" id="{56B8E78C-AB5D-06C3-8585-B1A0D6014367}"/>
               </a:ext>
             </a:extLst>
           </p:cNvPr>
@@ -14288,7 +14288,7 @@
           <p:cNvPr id="7" name="TextBox 6">
             <a:extLst>
               <a:ext uri="{FF2B5EF4-FFF2-40B4-BE49-F238E27FC236}">
-                <a16:creationId xmlns:a16="http://schemas.microsoft.com/office/drawing/2014/main" id="{DEB439AE-EF1E-151D-3C62-4972A6B1A85D}"/>
+                <a16:creationId xmlns:a16="http://schemas.microsoft.com/office/drawing/2014/main" id="{90188989-4D22-7C83-8E60-6F008B93CF0A}"/>
               </a:ext>
             </a:extLst>
           </p:cNvPr>
@@ -14331,7 +14331,7 @@
     </p:spTree>
     <p:extLst>
       <p:ext uri="{BB962C8B-B14F-4D97-AF65-F5344CB8AC3E}">
-        <p14:creationId xmlns:p14="http://schemas.microsoft.com/office/powerpoint/2010/main" val="2065980414"/>
+        <p14:creationId xmlns:p14="http://schemas.microsoft.com/office/powerpoint/2010/main" val="4236093407"/>
       </p:ext>
     </p:extLst>
   </p:cSld>
@@ -14371,7 +14371,7 @@
           <p:cNvPr id="2" name="TextBox 1">
             <a:extLst>
               <a:ext uri="{FF2B5EF4-FFF2-40B4-BE49-F238E27FC236}">
-                <a16:creationId xmlns:a16="http://schemas.microsoft.com/office/drawing/2014/main" id="{1ADA5530-ECBA-09F0-7BA2-30694B5622E5}"/>
+                <a16:creationId xmlns:a16="http://schemas.microsoft.com/office/drawing/2014/main" id="{47031FC0-92C2-9B5F-5297-19F293AA7119}"/>
               </a:ext>
             </a:extLst>
           </p:cNvPr>
@@ -14416,7 +14416,7 @@
           <p:cNvPr id="3" name="TextBox 2">
             <a:extLst>
               <a:ext uri="{FF2B5EF4-FFF2-40B4-BE49-F238E27FC236}">
-                <a16:creationId xmlns:a16="http://schemas.microsoft.com/office/drawing/2014/main" id="{10A38917-1F78-CB3F-0F87-35776960F70C}"/>
+                <a16:creationId xmlns:a16="http://schemas.microsoft.com/office/drawing/2014/main" id="{6D96A9B4-C81A-12F2-0E85-1DC103189024}"/>
               </a:ext>
             </a:extLst>
           </p:cNvPr>
@@ -14467,7 +14467,7 @@
           <p:cNvPr id="5" name="Picture 4">
             <a:extLst>
               <a:ext uri="{FF2B5EF4-FFF2-40B4-BE49-F238E27FC236}">
-                <a16:creationId xmlns:a16="http://schemas.microsoft.com/office/drawing/2014/main" id="{26A61A0F-B55E-72D6-0A2D-89130BEF6BE3}"/>
+                <a16:creationId xmlns:a16="http://schemas.microsoft.com/office/drawing/2014/main" id="{50D84910-82AF-F8FC-5F68-9565FDC9B38B}"/>
               </a:ext>
             </a:extLst>
           </p:cNvPr>
@@ -14503,7 +14503,7 @@
           <p:cNvPr id="6" name="TextBox 5">
             <a:extLst>
               <a:ext uri="{FF2B5EF4-FFF2-40B4-BE49-F238E27FC236}">
-                <a16:creationId xmlns:a16="http://schemas.microsoft.com/office/drawing/2014/main" id="{E8EDD1BD-3949-CC75-0E48-4C24F3B257ED}"/>
+                <a16:creationId xmlns:a16="http://schemas.microsoft.com/office/drawing/2014/main" id="{1C642973-332D-B4C9-DF2A-C8B7E55A7366}"/>
               </a:ext>
             </a:extLst>
           </p:cNvPr>
@@ -14554,7 +14554,7 @@
           <p:cNvPr id="7" name="TextBox 6">
             <a:extLst>
               <a:ext uri="{FF2B5EF4-FFF2-40B4-BE49-F238E27FC236}">
-                <a16:creationId xmlns:a16="http://schemas.microsoft.com/office/drawing/2014/main" id="{F42F9510-22C3-2BC7-B36D-AB4D9162BBAB}"/>
+                <a16:creationId xmlns:a16="http://schemas.microsoft.com/office/drawing/2014/main" id="{604EA817-3C81-5DF6-9990-7479804D4CB3}"/>
               </a:ext>
             </a:extLst>
           </p:cNvPr>
@@ -14599,7 +14599,7 @@
           <p:cNvPr id="8" name="TextBox 7">
             <a:extLst>
               <a:ext uri="{FF2B5EF4-FFF2-40B4-BE49-F238E27FC236}">
-                <a16:creationId xmlns:a16="http://schemas.microsoft.com/office/drawing/2014/main" id="{18353E63-AD24-9C2E-1AFF-87EFD982B1E9}"/>
+                <a16:creationId xmlns:a16="http://schemas.microsoft.com/office/drawing/2014/main" id="{86B29DD2-C2F8-1BCC-2E8F-416987682EFC}"/>
               </a:ext>
             </a:extLst>
           </p:cNvPr>
@@ -14642,7 +14642,7 @@
     </p:spTree>
     <p:extLst>
       <p:ext uri="{BB962C8B-B14F-4D97-AF65-F5344CB8AC3E}">
-        <p14:creationId xmlns:p14="http://schemas.microsoft.com/office/powerpoint/2010/main" val="532874350"/>
+        <p14:creationId xmlns:p14="http://schemas.microsoft.com/office/powerpoint/2010/main" val="2949761323"/>
       </p:ext>
     </p:extLst>
   </p:cSld>
@@ -14682,7 +14682,7 @@
           <p:cNvPr id="2" name="TextBox 1">
             <a:extLst>
               <a:ext uri="{FF2B5EF4-FFF2-40B4-BE49-F238E27FC236}">
-                <a16:creationId xmlns:a16="http://schemas.microsoft.com/office/drawing/2014/main" id="{76264F36-1CA8-08E4-33B4-7988A35AD62F}"/>
+                <a16:creationId xmlns:a16="http://schemas.microsoft.com/office/drawing/2014/main" id="{F146BA80-67C9-B403-41B9-FEBFFEDF4DA4}"/>
               </a:ext>
             </a:extLst>
           </p:cNvPr>
@@ -14733,7 +14733,7 @@
           <p:cNvPr id="3" name="TextBox 2">
             <a:extLst>
               <a:ext uri="{FF2B5EF4-FFF2-40B4-BE49-F238E27FC236}">
-                <a16:creationId xmlns:a16="http://schemas.microsoft.com/office/drawing/2014/main" id="{3FE89E1B-8F59-E26F-F351-63B32896A86B}"/>
+                <a16:creationId xmlns:a16="http://schemas.microsoft.com/office/drawing/2014/main" id="{DF94234D-D2AF-3510-8A4B-D70A73418EE3}"/>
               </a:ext>
             </a:extLst>
           </p:cNvPr>
@@ -14784,7 +14784,7 @@
           <p:cNvPr id="5" name="Picture 4">
             <a:extLst>
               <a:ext uri="{FF2B5EF4-FFF2-40B4-BE49-F238E27FC236}">
-                <a16:creationId xmlns:a16="http://schemas.microsoft.com/office/drawing/2014/main" id="{AD00B4B3-EAB5-9B96-C393-054A20B8DC58}"/>
+                <a16:creationId xmlns:a16="http://schemas.microsoft.com/office/drawing/2014/main" id="{20881419-538B-8D41-C51B-58CB99C1BFCC}"/>
               </a:ext>
             </a:extLst>
           </p:cNvPr>
@@ -14820,7 +14820,7 @@
           <p:cNvPr id="6" name="Table 5">
             <a:extLst>
               <a:ext uri="{FF2B5EF4-FFF2-40B4-BE49-F238E27FC236}">
-                <a16:creationId xmlns:a16="http://schemas.microsoft.com/office/drawing/2014/main" id="{5C027157-71B2-E47B-EBF1-6858FB20939E}"/>
+                <a16:creationId xmlns:a16="http://schemas.microsoft.com/office/drawing/2014/main" id="{2C10FF5F-B446-0627-AA02-54195B1ADBB3}"/>
               </a:ext>
             </a:extLst>
           </p:cNvPr>
@@ -14830,7 +14830,7 @@
           <p:nvPr>
             <p:extLst>
               <p:ext uri="{D42A27DB-BD31-4B8C-83A1-F6EECF244321}">
-                <p14:modId xmlns:p14="http://schemas.microsoft.com/office/powerpoint/2010/main" val="1286784358"/>
+                <p14:modId xmlns:p14="http://schemas.microsoft.com/office/powerpoint/2010/main" val="2180220539"/>
               </p:ext>
             </p:extLst>
           </p:nvPr>
@@ -14849,14 +14849,14 @@
                 <a:gridCol w="2095500">
                   <a:extLst>
                     <a:ext uri="{9D8B030D-6E8A-4147-A177-3AD203B41FA5}">
-                      <a16:colId xmlns:a16="http://schemas.microsoft.com/office/drawing/2014/main" val="175095751"/>
+                      <a16:colId xmlns:a16="http://schemas.microsoft.com/office/drawing/2014/main" val="1835909476"/>
                     </a:ext>
                   </a:extLst>
                 </a:gridCol>
                 <a:gridCol w="3683000">
                   <a:extLst>
                     <a:ext uri="{9D8B030D-6E8A-4147-A177-3AD203B41FA5}">
-                      <a16:colId xmlns:a16="http://schemas.microsoft.com/office/drawing/2014/main" val="2332320393"/>
+                      <a16:colId xmlns:a16="http://schemas.microsoft.com/office/drawing/2014/main" val="2386834482"/>
                     </a:ext>
                   </a:extLst>
                 </a:gridCol>
@@ -14948,7 +14948,7 @@
                 </a:tc>
                 <a:extLst>
                   <a:ext uri="{0D108BD9-81ED-4DB2-BD59-A6C34878D82A}">
-                    <a16:rowId xmlns:a16="http://schemas.microsoft.com/office/drawing/2014/main" val="52508345"/>
+                    <a16:rowId xmlns:a16="http://schemas.microsoft.com/office/drawing/2014/main" val="1042222663"/>
                   </a:ext>
                 </a:extLst>
               </a:tr>
@@ -15039,7 +15039,7 @@
                 </a:tc>
                 <a:extLst>
                   <a:ext uri="{0D108BD9-81ED-4DB2-BD59-A6C34878D82A}">
-                    <a16:rowId xmlns:a16="http://schemas.microsoft.com/office/drawing/2014/main" val="2849633909"/>
+                    <a16:rowId xmlns:a16="http://schemas.microsoft.com/office/drawing/2014/main" val="1174358643"/>
                   </a:ext>
                 </a:extLst>
               </a:tr>
@@ -15130,7 +15130,7 @@
                 </a:tc>
                 <a:extLst>
                   <a:ext uri="{0D108BD9-81ED-4DB2-BD59-A6C34878D82A}">
-                    <a16:rowId xmlns:a16="http://schemas.microsoft.com/office/drawing/2014/main" val="1041013595"/>
+                    <a16:rowId xmlns:a16="http://schemas.microsoft.com/office/drawing/2014/main" val="550369042"/>
                   </a:ext>
                 </a:extLst>
               </a:tr>
@@ -15227,7 +15227,7 @@
                 </a:tc>
                 <a:extLst>
                   <a:ext uri="{0D108BD9-81ED-4DB2-BD59-A6C34878D82A}">
-                    <a16:rowId xmlns:a16="http://schemas.microsoft.com/office/drawing/2014/main" val="720497084"/>
+                    <a16:rowId xmlns:a16="http://schemas.microsoft.com/office/drawing/2014/main" val="564642736"/>
                   </a:ext>
                 </a:extLst>
               </a:tr>
@@ -15318,7 +15318,7 @@
                 </a:tc>
                 <a:extLst>
                   <a:ext uri="{0D108BD9-81ED-4DB2-BD59-A6C34878D82A}">
-                    <a16:rowId xmlns:a16="http://schemas.microsoft.com/office/drawing/2014/main" val="265127029"/>
+                    <a16:rowId xmlns:a16="http://schemas.microsoft.com/office/drawing/2014/main" val="4007471541"/>
                   </a:ext>
                 </a:extLst>
               </a:tr>
@@ -15415,7 +15415,7 @@
                 </a:tc>
                 <a:extLst>
                   <a:ext uri="{0D108BD9-81ED-4DB2-BD59-A6C34878D82A}">
-                    <a16:rowId xmlns:a16="http://schemas.microsoft.com/office/drawing/2014/main" val="3930613913"/>
+                    <a16:rowId xmlns:a16="http://schemas.microsoft.com/office/drawing/2014/main" val="1100197873"/>
                   </a:ext>
                 </a:extLst>
               </a:tr>
@@ -15428,7 +15428,7 @@
           <p:cNvPr id="7" name="TextBox 6">
             <a:extLst>
               <a:ext uri="{FF2B5EF4-FFF2-40B4-BE49-F238E27FC236}">
-                <a16:creationId xmlns:a16="http://schemas.microsoft.com/office/drawing/2014/main" id="{3A10141E-DD28-07E1-DC74-2807631DCDB8}"/>
+                <a16:creationId xmlns:a16="http://schemas.microsoft.com/office/drawing/2014/main" id="{014D3635-14E1-0FAE-8798-265559B9949B}"/>
               </a:ext>
             </a:extLst>
           </p:cNvPr>
@@ -15479,7 +15479,7 @@
           <p:cNvPr id="8" name="TextBox 7">
             <a:extLst>
               <a:ext uri="{FF2B5EF4-FFF2-40B4-BE49-F238E27FC236}">
-                <a16:creationId xmlns:a16="http://schemas.microsoft.com/office/drawing/2014/main" id="{9D90283B-EF6B-5D69-498D-42FB1F0D7DED}"/>
+                <a16:creationId xmlns:a16="http://schemas.microsoft.com/office/drawing/2014/main" id="{9D925CA3-E4A7-CD9D-606A-CB33A8C799F6}"/>
               </a:ext>
             </a:extLst>
           </p:cNvPr>
@@ -15524,7 +15524,7 @@
           <p:cNvPr id="9" name="TextBox 8">
             <a:extLst>
               <a:ext uri="{FF2B5EF4-FFF2-40B4-BE49-F238E27FC236}">
-                <a16:creationId xmlns:a16="http://schemas.microsoft.com/office/drawing/2014/main" id="{98416241-CF4D-630F-1B45-DDDE99CA3208}"/>
+                <a16:creationId xmlns:a16="http://schemas.microsoft.com/office/drawing/2014/main" id="{1787F6E5-F335-1E24-1D82-BA109A2E32AD}"/>
               </a:ext>
             </a:extLst>
           </p:cNvPr>
@@ -15567,7 +15567,7 @@
     </p:spTree>
     <p:extLst>
       <p:ext uri="{BB962C8B-B14F-4D97-AF65-F5344CB8AC3E}">
-        <p14:creationId xmlns:p14="http://schemas.microsoft.com/office/powerpoint/2010/main" val="2591739468"/>
+        <p14:creationId xmlns:p14="http://schemas.microsoft.com/office/powerpoint/2010/main" val="674186113"/>
       </p:ext>
     </p:extLst>
   </p:cSld>
@@ -15607,7 +15607,7 @@
           <p:cNvPr id="2" name="TextBox 1">
             <a:extLst>
               <a:ext uri="{FF2B5EF4-FFF2-40B4-BE49-F238E27FC236}">
-                <a16:creationId xmlns:a16="http://schemas.microsoft.com/office/drawing/2014/main" id="{EF9D47E0-2ECE-4AA2-8027-B17E7F5AACFF}"/>
+                <a16:creationId xmlns:a16="http://schemas.microsoft.com/office/drawing/2014/main" id="{B757166E-FAF1-F18F-C2C5-D9D7824D0CB2}"/>
               </a:ext>
             </a:extLst>
           </p:cNvPr>
@@ -15658,7 +15658,7 @@
           <p:cNvPr id="3" name="TextBox 2">
             <a:extLst>
               <a:ext uri="{FF2B5EF4-FFF2-40B4-BE49-F238E27FC236}">
-                <a16:creationId xmlns:a16="http://schemas.microsoft.com/office/drawing/2014/main" id="{67F1B673-FFF2-8209-9C20-9DA75FD7ED84}"/>
+                <a16:creationId xmlns:a16="http://schemas.microsoft.com/office/drawing/2014/main" id="{F39BE7F8-9B97-F6FC-D73C-77723E17C295}"/>
               </a:ext>
             </a:extLst>
           </p:cNvPr>
@@ -15709,7 +15709,7 @@
           <p:cNvPr id="4" name="TextBox 3">
             <a:extLst>
               <a:ext uri="{FF2B5EF4-FFF2-40B4-BE49-F238E27FC236}">
-                <a16:creationId xmlns:a16="http://schemas.microsoft.com/office/drawing/2014/main" id="{D7858C8C-3189-B185-33FD-FE3042B6F7B6}"/>
+                <a16:creationId xmlns:a16="http://schemas.microsoft.com/office/drawing/2014/main" id="{940A8781-9E69-6C02-F391-D7DB94AFD438}"/>
               </a:ext>
             </a:extLst>
           </p:cNvPr>
@@ -15761,7 +15761,7 @@
           <p:cNvPr id="5" name="Table 4">
             <a:extLst>
               <a:ext uri="{FF2B5EF4-FFF2-40B4-BE49-F238E27FC236}">
-                <a16:creationId xmlns:a16="http://schemas.microsoft.com/office/drawing/2014/main" id="{F13516CE-61EF-BDA1-6441-E667995D5F0D}"/>
+                <a16:creationId xmlns:a16="http://schemas.microsoft.com/office/drawing/2014/main" id="{777A143D-4857-3CED-9EDA-C34D4724D00D}"/>
               </a:ext>
             </a:extLst>
           </p:cNvPr>
@@ -15771,7 +15771,7 @@
           <p:nvPr>
             <p:extLst>
               <p:ext uri="{D42A27DB-BD31-4B8C-83A1-F6EECF244321}">
-                <p14:modId xmlns:p14="http://schemas.microsoft.com/office/powerpoint/2010/main" val="2210288687"/>
+                <p14:modId xmlns:p14="http://schemas.microsoft.com/office/powerpoint/2010/main" val="973656349"/>
               </p:ext>
             </p:extLst>
           </p:nvPr>
@@ -15790,21 +15790,21 @@
                 <a:gridCol w="3810000">
                   <a:extLst>
                     <a:ext uri="{9D8B030D-6E8A-4147-A177-3AD203B41FA5}">
-                      <a16:colId xmlns:a16="http://schemas.microsoft.com/office/drawing/2014/main" val="3958982426"/>
+                      <a16:colId xmlns:a16="http://schemas.microsoft.com/office/drawing/2014/main" val="1367436227"/>
                     </a:ext>
                   </a:extLst>
                 </a:gridCol>
                 <a:gridCol w="4572000">
                   <a:extLst>
                     <a:ext uri="{9D8B030D-6E8A-4147-A177-3AD203B41FA5}">
-                      <a16:colId xmlns:a16="http://schemas.microsoft.com/office/drawing/2014/main" val="891725673"/>
+                      <a16:colId xmlns:a16="http://schemas.microsoft.com/office/drawing/2014/main" val="2543235757"/>
                     </a:ext>
                   </a:extLst>
                 </a:gridCol>
                 <a:gridCol w="2540000">
                   <a:extLst>
                     <a:ext uri="{9D8B030D-6E8A-4147-A177-3AD203B41FA5}">
-                      <a16:colId xmlns:a16="http://schemas.microsoft.com/office/drawing/2014/main" val="3312176358"/>
+                      <a16:colId xmlns:a16="http://schemas.microsoft.com/office/drawing/2014/main" val="4121217250"/>
                     </a:ext>
                   </a:extLst>
                 </a:gridCol>
@@ -15938,7 +15938,7 @@
                 </a:tc>
                 <a:extLst>
                   <a:ext uri="{0D108BD9-81ED-4DB2-BD59-A6C34878D82A}">
-                    <a16:rowId xmlns:a16="http://schemas.microsoft.com/office/drawing/2014/main" val="302273742"/>
+                    <a16:rowId xmlns:a16="http://schemas.microsoft.com/office/drawing/2014/main" val="3086867157"/>
                   </a:ext>
                 </a:extLst>
               </a:tr>
@@ -16071,7 +16071,7 @@
                 </a:tc>
                 <a:extLst>
                   <a:ext uri="{0D108BD9-81ED-4DB2-BD59-A6C34878D82A}">
-                    <a16:rowId xmlns:a16="http://schemas.microsoft.com/office/drawing/2014/main" val="2543013430"/>
+                    <a16:rowId xmlns:a16="http://schemas.microsoft.com/office/drawing/2014/main" val="3949444652"/>
                   </a:ext>
                 </a:extLst>
               </a:tr>
@@ -16204,7 +16204,7 @@
                 </a:tc>
                 <a:extLst>
                   <a:ext uri="{0D108BD9-81ED-4DB2-BD59-A6C34878D82A}">
-                    <a16:rowId xmlns:a16="http://schemas.microsoft.com/office/drawing/2014/main" val="1003265848"/>
+                    <a16:rowId xmlns:a16="http://schemas.microsoft.com/office/drawing/2014/main" val="514384930"/>
                   </a:ext>
                 </a:extLst>
               </a:tr>
@@ -16337,7 +16337,7 @@
                 </a:tc>
                 <a:extLst>
                   <a:ext uri="{0D108BD9-81ED-4DB2-BD59-A6C34878D82A}">
-                    <a16:rowId xmlns:a16="http://schemas.microsoft.com/office/drawing/2014/main" val="4016178556"/>
+                    <a16:rowId xmlns:a16="http://schemas.microsoft.com/office/drawing/2014/main" val="3178105032"/>
                   </a:ext>
                 </a:extLst>
               </a:tr>
@@ -16470,7 +16470,7 @@
                 </a:tc>
                 <a:extLst>
                   <a:ext uri="{0D108BD9-81ED-4DB2-BD59-A6C34878D82A}">
-                    <a16:rowId xmlns:a16="http://schemas.microsoft.com/office/drawing/2014/main" val="2990970329"/>
+                    <a16:rowId xmlns:a16="http://schemas.microsoft.com/office/drawing/2014/main" val="2996618080"/>
                   </a:ext>
                 </a:extLst>
               </a:tr>
@@ -16483,7 +16483,7 @@
           <p:cNvPr id="6" name="TextBox 5">
             <a:extLst>
               <a:ext uri="{FF2B5EF4-FFF2-40B4-BE49-F238E27FC236}">
-                <a16:creationId xmlns:a16="http://schemas.microsoft.com/office/drawing/2014/main" id="{A7732662-AACB-EFA6-1FEB-0E92CD71099F}"/>
+                <a16:creationId xmlns:a16="http://schemas.microsoft.com/office/drawing/2014/main" id="{3003F5CC-F7FE-7A69-DBB9-C203550A2B36}"/>
               </a:ext>
             </a:extLst>
           </p:cNvPr>
@@ -16528,7 +16528,7 @@
           <p:cNvPr id="7" name="TextBox 6">
             <a:extLst>
               <a:ext uri="{FF2B5EF4-FFF2-40B4-BE49-F238E27FC236}">
-                <a16:creationId xmlns:a16="http://schemas.microsoft.com/office/drawing/2014/main" id="{937F7336-9C30-66B6-DCDF-234B5011380B}"/>
+                <a16:creationId xmlns:a16="http://schemas.microsoft.com/office/drawing/2014/main" id="{5C1F75AC-743E-E911-CA9D-0603C665F5D4}"/>
               </a:ext>
             </a:extLst>
           </p:cNvPr>
@@ -16571,7 +16571,7 @@
     </p:spTree>
     <p:extLst>
       <p:ext uri="{BB962C8B-B14F-4D97-AF65-F5344CB8AC3E}">
-        <p14:creationId xmlns:p14="http://schemas.microsoft.com/office/powerpoint/2010/main" val="1327795101"/>
+        <p14:creationId xmlns:p14="http://schemas.microsoft.com/office/powerpoint/2010/main" val="1628352625"/>
       </p:ext>
     </p:extLst>
   </p:cSld>
@@ -16611,7 +16611,7 @@
           <p:cNvPr id="2" name="TextBox 1">
             <a:extLst>
               <a:ext uri="{FF2B5EF4-FFF2-40B4-BE49-F238E27FC236}">
-                <a16:creationId xmlns:a16="http://schemas.microsoft.com/office/drawing/2014/main" id="{A073EBE2-83A4-2C93-A8DD-DC3764FB465F}"/>
+                <a16:creationId xmlns:a16="http://schemas.microsoft.com/office/drawing/2014/main" id="{3CEBBBB1-D908-6978-6DAB-CFB195E16130}"/>
               </a:ext>
             </a:extLst>
           </p:cNvPr>
@@ -16656,7 +16656,7 @@
           <p:cNvPr id="3" name="TextBox 2">
             <a:extLst>
               <a:ext uri="{FF2B5EF4-FFF2-40B4-BE49-F238E27FC236}">
-                <a16:creationId xmlns:a16="http://schemas.microsoft.com/office/drawing/2014/main" id="{214916B2-F9D8-149F-3BAC-76CA06ED0756}"/>
+                <a16:creationId xmlns:a16="http://schemas.microsoft.com/office/drawing/2014/main" id="{0384101A-3B0A-E005-21F2-A32A23BD12C3}"/>
               </a:ext>
             </a:extLst>
           </p:cNvPr>
@@ -16707,7 +16707,7 @@
           <p:cNvPr id="4" name="Table 3">
             <a:extLst>
               <a:ext uri="{FF2B5EF4-FFF2-40B4-BE49-F238E27FC236}">
-                <a16:creationId xmlns:a16="http://schemas.microsoft.com/office/drawing/2014/main" id="{D4D31FCE-8451-8D52-227C-D64451AF83F7}"/>
+                <a16:creationId xmlns:a16="http://schemas.microsoft.com/office/drawing/2014/main" id="{839EF2DC-4849-8EB8-41FB-5CC08BE4C7BB}"/>
               </a:ext>
             </a:extLst>
           </p:cNvPr>
@@ -16717,7 +16717,7 @@
           <p:nvPr>
             <p:extLst>
               <p:ext uri="{D42A27DB-BD31-4B8C-83A1-F6EECF244321}">
-                <p14:modId xmlns:p14="http://schemas.microsoft.com/office/powerpoint/2010/main" val="1534242760"/>
+                <p14:modId xmlns:p14="http://schemas.microsoft.com/office/powerpoint/2010/main" val="3939285875"/>
               </p:ext>
             </p:extLst>
           </p:nvPr>
@@ -16736,35 +16736,35 @@
                 <a:gridCol w="3810000">
                   <a:extLst>
                     <a:ext uri="{9D8B030D-6E8A-4147-A177-3AD203B41FA5}">
-                      <a16:colId xmlns:a16="http://schemas.microsoft.com/office/drawing/2014/main" val="445352412"/>
+                      <a16:colId xmlns:a16="http://schemas.microsoft.com/office/drawing/2014/main" val="2802902501"/>
                     </a:ext>
                   </a:extLst>
                 </a:gridCol>
                 <a:gridCol w="1016000">
                   <a:extLst>
                     <a:ext uri="{9D8B030D-6E8A-4147-A177-3AD203B41FA5}">
-                      <a16:colId xmlns:a16="http://schemas.microsoft.com/office/drawing/2014/main" val="1013814129"/>
+                      <a16:colId xmlns:a16="http://schemas.microsoft.com/office/drawing/2014/main" val="2474154842"/>
                     </a:ext>
                   </a:extLst>
                 </a:gridCol>
                 <a:gridCol w="2032000">
                   <a:extLst>
                     <a:ext uri="{9D8B030D-6E8A-4147-A177-3AD203B41FA5}">
-                      <a16:colId xmlns:a16="http://schemas.microsoft.com/office/drawing/2014/main" val="1244165194"/>
+                      <a16:colId xmlns:a16="http://schemas.microsoft.com/office/drawing/2014/main" val="3157022336"/>
                     </a:ext>
                   </a:extLst>
                 </a:gridCol>
                 <a:gridCol w="2032000">
                   <a:extLst>
                     <a:ext uri="{9D8B030D-6E8A-4147-A177-3AD203B41FA5}">
-                      <a16:colId xmlns:a16="http://schemas.microsoft.com/office/drawing/2014/main" val="321676116"/>
+                      <a16:colId xmlns:a16="http://schemas.microsoft.com/office/drawing/2014/main" val="3387723779"/>
                     </a:ext>
                   </a:extLst>
                 </a:gridCol>
                 <a:gridCol w="2032000">
                   <a:extLst>
                     <a:ext uri="{9D8B030D-6E8A-4147-A177-3AD203B41FA5}">
-                      <a16:colId xmlns:a16="http://schemas.microsoft.com/office/drawing/2014/main" val="3767235273"/>
+                      <a16:colId xmlns:a16="http://schemas.microsoft.com/office/drawing/2014/main" val="462388645"/>
                     </a:ext>
                   </a:extLst>
                 </a:gridCol>
@@ -16982,7 +16982,7 @@
                 </a:tc>
                 <a:extLst>
                   <a:ext uri="{0D108BD9-81ED-4DB2-BD59-A6C34878D82A}">
-                    <a16:rowId xmlns:a16="http://schemas.microsoft.com/office/drawing/2014/main" val="4179468418"/>
+                    <a16:rowId xmlns:a16="http://schemas.microsoft.com/office/drawing/2014/main" val="2668157392"/>
                   </a:ext>
                 </a:extLst>
               </a:tr>
@@ -17199,7 +17199,7 @@
                 </a:tc>
                 <a:extLst>
                   <a:ext uri="{0D108BD9-81ED-4DB2-BD59-A6C34878D82A}">
-                    <a16:rowId xmlns:a16="http://schemas.microsoft.com/office/drawing/2014/main" val="2231428031"/>
+                    <a16:rowId xmlns:a16="http://schemas.microsoft.com/office/drawing/2014/main" val="2033613068"/>
                   </a:ext>
                 </a:extLst>
               </a:tr>
@@ -17416,7 +17416,7 @@
                 </a:tc>
                 <a:extLst>
                   <a:ext uri="{0D108BD9-81ED-4DB2-BD59-A6C34878D82A}">
-                    <a16:rowId xmlns:a16="http://schemas.microsoft.com/office/drawing/2014/main" val="1942479881"/>
+                    <a16:rowId xmlns:a16="http://schemas.microsoft.com/office/drawing/2014/main" val="862856242"/>
                   </a:ext>
                 </a:extLst>
               </a:tr>
@@ -17633,7 +17633,7 @@
                 </a:tc>
                 <a:extLst>
                   <a:ext uri="{0D108BD9-81ED-4DB2-BD59-A6C34878D82A}">
-                    <a16:rowId xmlns:a16="http://schemas.microsoft.com/office/drawing/2014/main" val="2957260858"/>
+                    <a16:rowId xmlns:a16="http://schemas.microsoft.com/office/drawing/2014/main" val="701161998"/>
                   </a:ext>
                 </a:extLst>
               </a:tr>
@@ -17850,7 +17850,7 @@
                 </a:tc>
                 <a:extLst>
                   <a:ext uri="{0D108BD9-81ED-4DB2-BD59-A6C34878D82A}">
-                    <a16:rowId xmlns:a16="http://schemas.microsoft.com/office/drawing/2014/main" val="1285951065"/>
+                    <a16:rowId xmlns:a16="http://schemas.microsoft.com/office/drawing/2014/main" val="1503710281"/>
                   </a:ext>
                 </a:extLst>
               </a:tr>
@@ -18067,7 +18067,7 @@
                 </a:tc>
                 <a:extLst>
                   <a:ext uri="{0D108BD9-81ED-4DB2-BD59-A6C34878D82A}">
-                    <a16:rowId xmlns:a16="http://schemas.microsoft.com/office/drawing/2014/main" val="2912325238"/>
+                    <a16:rowId xmlns:a16="http://schemas.microsoft.com/office/drawing/2014/main" val="71782302"/>
                   </a:ext>
                 </a:extLst>
               </a:tr>
@@ -18080,7 +18080,7 @@
           <p:cNvPr id="5" name="TextBox 4">
             <a:extLst>
               <a:ext uri="{FF2B5EF4-FFF2-40B4-BE49-F238E27FC236}">
-                <a16:creationId xmlns:a16="http://schemas.microsoft.com/office/drawing/2014/main" id="{87994B80-D284-37B5-2FC9-2A190FBF7162}"/>
+                <a16:creationId xmlns:a16="http://schemas.microsoft.com/office/drawing/2014/main" id="{6FAD10B0-1FBB-21D2-79FB-A060440A3E6D}"/>
               </a:ext>
             </a:extLst>
           </p:cNvPr>
@@ -18131,7 +18131,7 @@
           <p:cNvPr id="6" name="TextBox 5">
             <a:extLst>
               <a:ext uri="{FF2B5EF4-FFF2-40B4-BE49-F238E27FC236}">
-                <a16:creationId xmlns:a16="http://schemas.microsoft.com/office/drawing/2014/main" id="{ACEFA128-5183-3120-4448-030AAF5CF050}"/>
+                <a16:creationId xmlns:a16="http://schemas.microsoft.com/office/drawing/2014/main" id="{BFF7A516-2D02-D2F8-DFE2-1E156D12C1C8}"/>
               </a:ext>
             </a:extLst>
           </p:cNvPr>
@@ -18176,7 +18176,7 @@
           <p:cNvPr id="7" name="TextBox 6">
             <a:extLst>
               <a:ext uri="{FF2B5EF4-FFF2-40B4-BE49-F238E27FC236}">
-                <a16:creationId xmlns:a16="http://schemas.microsoft.com/office/drawing/2014/main" id="{B6FD86EE-7438-73D2-D783-2524697E75A7}"/>
+                <a16:creationId xmlns:a16="http://schemas.microsoft.com/office/drawing/2014/main" id="{41F58AD5-C6CA-3647-2797-7CAB30692BC2}"/>
               </a:ext>
             </a:extLst>
           </p:cNvPr>
@@ -18219,7 +18219,7 @@
     </p:spTree>
     <p:extLst>
       <p:ext uri="{BB962C8B-B14F-4D97-AF65-F5344CB8AC3E}">
-        <p14:creationId xmlns:p14="http://schemas.microsoft.com/office/powerpoint/2010/main" val="2691169166"/>
+        <p14:creationId xmlns:p14="http://schemas.microsoft.com/office/powerpoint/2010/main" val="462564666"/>
       </p:ext>
     </p:extLst>
   </p:cSld>

</xml_diff>

<commit_message>
Update team member name for roll number 230303
</commit_message>
<xml_diff>
--- a/output/presentation/CricketShot_Presentation.pptx
+++ b/output/presentation/CricketShot_Presentation.pptx
@@ -205,7 +205,7 @@
             </a:lvl1pPr>
           </a:lstStyle>
           <a:p>
-            <a:fld id="{8EA1E190-EFFB-42FC-9DC9-28C1116B9AC7}" type="datetimeFigureOut">
+            <a:fld id="{7A8255CF-EF48-4FE2-9F24-AFB83501EFF9}" type="datetimeFigureOut">
               <a:rPr lang="en-IN" smtClean="0"/>
               <a:t>19-10-2026</a:t>
             </a:fld>
@@ -364,7 +364,7 @@
             </a:lvl1pPr>
           </a:lstStyle>
           <a:p>
-            <a:fld id="{934E0F31-365A-4FEA-968B-76B74F55F034}" type="slidenum">
+            <a:fld id="{37BF998F-1D90-427D-8AB2-4E508FBD6897}" type="slidenum">
               <a:rPr lang="en-IN" smtClean="0"/>
               <a:t>‹#›</a:t>
             </a:fld>
@@ -375,7 +375,7 @@
     </p:spTree>
     <p:extLst>
       <p:ext uri="{BB962C8B-B14F-4D97-AF65-F5344CB8AC3E}">
-        <p14:creationId xmlns:p14="http://schemas.microsoft.com/office/powerpoint/2010/main" val="961058890"/>
+        <p14:creationId xmlns:p14="http://schemas.microsoft.com/office/powerpoint/2010/main" val="1902088556"/>
       </p:ext>
     </p:extLst>
   </p:cSld>
@@ -542,7 +542,7 @@
           <a:bodyPr/>
           <a:lstStyle/>
           <a:p>
-            <a:fld id="{934E0F31-365A-4FEA-968B-76B74F55F034}" type="slidenum">
+            <a:fld id="{37BF998F-1D90-427D-8AB2-4E508FBD6897}" type="slidenum">
               <a:rPr lang="en-IN" smtClean="0"/>
               <a:t>1</a:t>
             </a:fld>
@@ -553,7 +553,7 @@
     </p:spTree>
     <p:extLst>
       <p:ext uri="{BB962C8B-B14F-4D97-AF65-F5344CB8AC3E}">
-        <p14:creationId xmlns:p14="http://schemas.microsoft.com/office/powerpoint/2010/main" val="1310685476"/>
+        <p14:creationId xmlns:p14="http://schemas.microsoft.com/office/powerpoint/2010/main" val="3431530483"/>
       </p:ext>
     </p:extLst>
   </p:cSld>
@@ -630,7 +630,7 @@
           <a:bodyPr/>
           <a:lstStyle/>
           <a:p>
-            <a:fld id="{934E0F31-365A-4FEA-968B-76B74F55F034}" type="slidenum">
+            <a:fld id="{37BF998F-1D90-427D-8AB2-4E508FBD6897}" type="slidenum">
               <a:rPr lang="en-IN" smtClean="0"/>
               <a:t>10</a:t>
             </a:fld>
@@ -641,7 +641,7 @@
     </p:spTree>
     <p:extLst>
       <p:ext uri="{BB962C8B-B14F-4D97-AF65-F5344CB8AC3E}">
-        <p14:creationId xmlns:p14="http://schemas.microsoft.com/office/powerpoint/2010/main" val="866634024"/>
+        <p14:creationId xmlns:p14="http://schemas.microsoft.com/office/powerpoint/2010/main" val="690376583"/>
       </p:ext>
     </p:extLst>
   </p:cSld>
@@ -718,7 +718,7 @@
           <a:bodyPr/>
           <a:lstStyle/>
           <a:p>
-            <a:fld id="{934E0F31-365A-4FEA-968B-76B74F55F034}" type="slidenum">
+            <a:fld id="{37BF998F-1D90-427D-8AB2-4E508FBD6897}" type="slidenum">
               <a:rPr lang="en-IN" smtClean="0"/>
               <a:t>11</a:t>
             </a:fld>
@@ -729,7 +729,7 @@
     </p:spTree>
     <p:extLst>
       <p:ext uri="{BB962C8B-B14F-4D97-AF65-F5344CB8AC3E}">
-        <p14:creationId xmlns:p14="http://schemas.microsoft.com/office/powerpoint/2010/main" val="1833032259"/>
+        <p14:creationId xmlns:p14="http://schemas.microsoft.com/office/powerpoint/2010/main" val="1207955261"/>
       </p:ext>
     </p:extLst>
   </p:cSld>
@@ -806,7 +806,7 @@
           <a:bodyPr/>
           <a:lstStyle/>
           <a:p>
-            <a:fld id="{934E0F31-365A-4FEA-968B-76B74F55F034}" type="slidenum">
+            <a:fld id="{37BF998F-1D90-427D-8AB2-4E508FBD6897}" type="slidenum">
               <a:rPr lang="en-IN" smtClean="0"/>
               <a:t>12</a:t>
             </a:fld>
@@ -817,7 +817,7 @@
     </p:spTree>
     <p:extLst>
       <p:ext uri="{BB962C8B-B14F-4D97-AF65-F5344CB8AC3E}">
-        <p14:creationId xmlns:p14="http://schemas.microsoft.com/office/powerpoint/2010/main" val="1422000428"/>
+        <p14:creationId xmlns:p14="http://schemas.microsoft.com/office/powerpoint/2010/main" val="3872893741"/>
       </p:ext>
     </p:extLst>
   </p:cSld>
@@ -894,7 +894,7 @@
           <a:bodyPr/>
           <a:lstStyle/>
           <a:p>
-            <a:fld id="{934E0F31-365A-4FEA-968B-76B74F55F034}" type="slidenum">
+            <a:fld id="{37BF998F-1D90-427D-8AB2-4E508FBD6897}" type="slidenum">
               <a:rPr lang="en-IN" smtClean="0"/>
               <a:t>13</a:t>
             </a:fld>
@@ -905,7 +905,7 @@
     </p:spTree>
     <p:extLst>
       <p:ext uri="{BB962C8B-B14F-4D97-AF65-F5344CB8AC3E}">
-        <p14:creationId xmlns:p14="http://schemas.microsoft.com/office/powerpoint/2010/main" val="2491217905"/>
+        <p14:creationId xmlns:p14="http://schemas.microsoft.com/office/powerpoint/2010/main" val="3236615899"/>
       </p:ext>
     </p:extLst>
   </p:cSld>
@@ -982,7 +982,7 @@
           <a:bodyPr/>
           <a:lstStyle/>
           <a:p>
-            <a:fld id="{934E0F31-365A-4FEA-968B-76B74F55F034}" type="slidenum">
+            <a:fld id="{37BF998F-1D90-427D-8AB2-4E508FBD6897}" type="slidenum">
               <a:rPr lang="en-IN" smtClean="0"/>
               <a:t>14</a:t>
             </a:fld>
@@ -993,7 +993,7 @@
     </p:spTree>
     <p:extLst>
       <p:ext uri="{BB962C8B-B14F-4D97-AF65-F5344CB8AC3E}">
-        <p14:creationId xmlns:p14="http://schemas.microsoft.com/office/powerpoint/2010/main" val="2178512906"/>
+        <p14:creationId xmlns:p14="http://schemas.microsoft.com/office/powerpoint/2010/main" val="966308097"/>
       </p:ext>
     </p:extLst>
   </p:cSld>
@@ -1070,7 +1070,7 @@
           <a:bodyPr/>
           <a:lstStyle/>
           <a:p>
-            <a:fld id="{934E0F31-365A-4FEA-968B-76B74F55F034}" type="slidenum">
+            <a:fld id="{37BF998F-1D90-427D-8AB2-4E508FBD6897}" type="slidenum">
               <a:rPr lang="en-IN" smtClean="0"/>
               <a:t>15</a:t>
             </a:fld>
@@ -1081,7 +1081,7 @@
     </p:spTree>
     <p:extLst>
       <p:ext uri="{BB962C8B-B14F-4D97-AF65-F5344CB8AC3E}">
-        <p14:creationId xmlns:p14="http://schemas.microsoft.com/office/powerpoint/2010/main" val="105600643"/>
+        <p14:creationId xmlns:p14="http://schemas.microsoft.com/office/powerpoint/2010/main" val="3895531773"/>
       </p:ext>
     </p:extLst>
   </p:cSld>
@@ -1158,7 +1158,7 @@
           <a:bodyPr/>
           <a:lstStyle/>
           <a:p>
-            <a:fld id="{934E0F31-365A-4FEA-968B-76B74F55F034}" type="slidenum">
+            <a:fld id="{37BF998F-1D90-427D-8AB2-4E508FBD6897}" type="slidenum">
               <a:rPr lang="en-IN" smtClean="0"/>
               <a:t>16</a:t>
             </a:fld>
@@ -1169,7 +1169,7 @@
     </p:spTree>
     <p:extLst>
       <p:ext uri="{BB962C8B-B14F-4D97-AF65-F5344CB8AC3E}">
-        <p14:creationId xmlns:p14="http://schemas.microsoft.com/office/powerpoint/2010/main" val="1171336055"/>
+        <p14:creationId xmlns:p14="http://schemas.microsoft.com/office/powerpoint/2010/main" val="2177513548"/>
       </p:ext>
     </p:extLst>
   </p:cSld>
@@ -1246,7 +1246,7 @@
           <a:bodyPr/>
           <a:lstStyle/>
           <a:p>
-            <a:fld id="{934E0F31-365A-4FEA-968B-76B74F55F034}" type="slidenum">
+            <a:fld id="{37BF998F-1D90-427D-8AB2-4E508FBD6897}" type="slidenum">
               <a:rPr lang="en-IN" smtClean="0"/>
               <a:t>2</a:t>
             </a:fld>
@@ -1257,7 +1257,7 @@
     </p:spTree>
     <p:extLst>
       <p:ext uri="{BB962C8B-B14F-4D97-AF65-F5344CB8AC3E}">
-        <p14:creationId xmlns:p14="http://schemas.microsoft.com/office/powerpoint/2010/main" val="395087188"/>
+        <p14:creationId xmlns:p14="http://schemas.microsoft.com/office/powerpoint/2010/main" val="430174793"/>
       </p:ext>
     </p:extLst>
   </p:cSld>
@@ -1334,7 +1334,7 @@
           <a:bodyPr/>
           <a:lstStyle/>
           <a:p>
-            <a:fld id="{934E0F31-365A-4FEA-968B-76B74F55F034}" type="slidenum">
+            <a:fld id="{37BF998F-1D90-427D-8AB2-4E508FBD6897}" type="slidenum">
               <a:rPr lang="en-IN" smtClean="0"/>
               <a:t>3</a:t>
             </a:fld>
@@ -1345,7 +1345,7 @@
     </p:spTree>
     <p:extLst>
       <p:ext uri="{BB962C8B-B14F-4D97-AF65-F5344CB8AC3E}">
-        <p14:creationId xmlns:p14="http://schemas.microsoft.com/office/powerpoint/2010/main" val="1826402980"/>
+        <p14:creationId xmlns:p14="http://schemas.microsoft.com/office/powerpoint/2010/main" val="734832931"/>
       </p:ext>
     </p:extLst>
   </p:cSld>
@@ -1422,7 +1422,7 @@
           <a:bodyPr/>
           <a:lstStyle/>
           <a:p>
-            <a:fld id="{934E0F31-365A-4FEA-968B-76B74F55F034}" type="slidenum">
+            <a:fld id="{37BF998F-1D90-427D-8AB2-4E508FBD6897}" type="slidenum">
               <a:rPr lang="en-IN" smtClean="0"/>
               <a:t>4</a:t>
             </a:fld>
@@ -1433,7 +1433,7 @@
     </p:spTree>
     <p:extLst>
       <p:ext uri="{BB962C8B-B14F-4D97-AF65-F5344CB8AC3E}">
-        <p14:creationId xmlns:p14="http://schemas.microsoft.com/office/powerpoint/2010/main" val="2199411617"/>
+        <p14:creationId xmlns:p14="http://schemas.microsoft.com/office/powerpoint/2010/main" val="3358629238"/>
       </p:ext>
     </p:extLst>
   </p:cSld>
@@ -1510,7 +1510,7 @@
           <a:bodyPr/>
           <a:lstStyle/>
           <a:p>
-            <a:fld id="{934E0F31-365A-4FEA-968B-76B74F55F034}" type="slidenum">
+            <a:fld id="{37BF998F-1D90-427D-8AB2-4E508FBD6897}" type="slidenum">
               <a:rPr lang="en-IN" smtClean="0"/>
               <a:t>5</a:t>
             </a:fld>
@@ -1521,7 +1521,7 @@
     </p:spTree>
     <p:extLst>
       <p:ext uri="{BB962C8B-B14F-4D97-AF65-F5344CB8AC3E}">
-        <p14:creationId xmlns:p14="http://schemas.microsoft.com/office/powerpoint/2010/main" val="1676332016"/>
+        <p14:creationId xmlns:p14="http://schemas.microsoft.com/office/powerpoint/2010/main" val="4068651146"/>
       </p:ext>
     </p:extLst>
   </p:cSld>
@@ -1598,7 +1598,7 @@
           <a:bodyPr/>
           <a:lstStyle/>
           <a:p>
-            <a:fld id="{934E0F31-365A-4FEA-968B-76B74F55F034}" type="slidenum">
+            <a:fld id="{37BF998F-1D90-427D-8AB2-4E508FBD6897}" type="slidenum">
               <a:rPr lang="en-IN" smtClean="0"/>
               <a:t>6</a:t>
             </a:fld>
@@ -1609,7 +1609,7 @@
     </p:spTree>
     <p:extLst>
       <p:ext uri="{BB962C8B-B14F-4D97-AF65-F5344CB8AC3E}">
-        <p14:creationId xmlns:p14="http://schemas.microsoft.com/office/powerpoint/2010/main" val="3276891441"/>
+        <p14:creationId xmlns:p14="http://schemas.microsoft.com/office/powerpoint/2010/main" val="470906534"/>
       </p:ext>
     </p:extLst>
   </p:cSld>
@@ -1686,7 +1686,7 @@
           <a:bodyPr/>
           <a:lstStyle/>
           <a:p>
-            <a:fld id="{934E0F31-365A-4FEA-968B-76B74F55F034}" type="slidenum">
+            <a:fld id="{37BF998F-1D90-427D-8AB2-4E508FBD6897}" type="slidenum">
               <a:rPr lang="en-IN" smtClean="0"/>
               <a:t>7</a:t>
             </a:fld>
@@ -1697,7 +1697,7 @@
     </p:spTree>
     <p:extLst>
       <p:ext uri="{BB962C8B-B14F-4D97-AF65-F5344CB8AC3E}">
-        <p14:creationId xmlns:p14="http://schemas.microsoft.com/office/powerpoint/2010/main" val="2688697625"/>
+        <p14:creationId xmlns:p14="http://schemas.microsoft.com/office/powerpoint/2010/main" val="1339495662"/>
       </p:ext>
     </p:extLst>
   </p:cSld>
@@ -1774,7 +1774,7 @@
           <a:bodyPr/>
           <a:lstStyle/>
           <a:p>
-            <a:fld id="{934E0F31-365A-4FEA-968B-76B74F55F034}" type="slidenum">
+            <a:fld id="{37BF998F-1D90-427D-8AB2-4E508FBD6897}" type="slidenum">
               <a:rPr lang="en-IN" smtClean="0"/>
               <a:t>8</a:t>
             </a:fld>
@@ -1785,7 +1785,7 @@
     </p:spTree>
     <p:extLst>
       <p:ext uri="{BB962C8B-B14F-4D97-AF65-F5344CB8AC3E}">
-        <p14:creationId xmlns:p14="http://schemas.microsoft.com/office/powerpoint/2010/main" val="2886447352"/>
+        <p14:creationId xmlns:p14="http://schemas.microsoft.com/office/powerpoint/2010/main" val="254243973"/>
       </p:ext>
     </p:extLst>
   </p:cSld>
@@ -1862,7 +1862,7 @@
           <a:bodyPr/>
           <a:lstStyle/>
           <a:p>
-            <a:fld id="{934E0F31-365A-4FEA-968B-76B74F55F034}" type="slidenum">
+            <a:fld id="{37BF998F-1D90-427D-8AB2-4E508FBD6897}" type="slidenum">
               <a:rPr lang="en-IN" smtClean="0"/>
               <a:t>9</a:t>
             </a:fld>
@@ -1873,7 +1873,7 @@
     </p:spTree>
     <p:extLst>
       <p:ext uri="{BB962C8B-B14F-4D97-AF65-F5344CB8AC3E}">
-        <p14:creationId xmlns:p14="http://schemas.microsoft.com/office/powerpoint/2010/main" val="523788481"/>
+        <p14:creationId xmlns:p14="http://schemas.microsoft.com/office/powerpoint/2010/main" val="709105717"/>
       </p:ext>
     </p:extLst>
   </p:cSld>
@@ -1905,7 +1905,7 @@
           <p:cNvPr id="2" name="Title 1">
             <a:extLst>
               <a:ext uri="{FF2B5EF4-FFF2-40B4-BE49-F238E27FC236}">
-                <a16:creationId xmlns:a16="http://schemas.microsoft.com/office/drawing/2014/main" id="{85378D40-9661-583E-AF10-7F610D1CB0CE}"/>
+                <a16:creationId xmlns:a16="http://schemas.microsoft.com/office/drawing/2014/main" id="{1F3D8518-0D12-282F-2289-7F82015D8DFE}"/>
               </a:ext>
             </a:extLst>
           </p:cNvPr>
@@ -1943,7 +1943,7 @@
           <p:cNvPr id="3" name="Subtitle 2">
             <a:extLst>
               <a:ext uri="{FF2B5EF4-FFF2-40B4-BE49-F238E27FC236}">
-                <a16:creationId xmlns:a16="http://schemas.microsoft.com/office/drawing/2014/main" id="{15CBB958-3499-6C40-8DBC-800609043900}"/>
+                <a16:creationId xmlns:a16="http://schemas.microsoft.com/office/drawing/2014/main" id="{6B008C35-6549-C7F1-90E6-F0CAE6E3A3A0}"/>
               </a:ext>
             </a:extLst>
           </p:cNvPr>
@@ -2014,7 +2014,7 @@
           <p:cNvPr id="4" name="Date Placeholder 3">
             <a:extLst>
               <a:ext uri="{FF2B5EF4-FFF2-40B4-BE49-F238E27FC236}">
-                <a16:creationId xmlns:a16="http://schemas.microsoft.com/office/drawing/2014/main" id="{7C274BAA-2ED7-996F-C799-DD58575E2DB0}"/>
+                <a16:creationId xmlns:a16="http://schemas.microsoft.com/office/drawing/2014/main" id="{3C9E370A-981A-CDA3-A23C-2A50D25B2CA1}"/>
               </a:ext>
             </a:extLst>
           </p:cNvPr>
@@ -2030,7 +2030,7 @@
           <a:bodyPr/>
           <a:lstStyle/>
           <a:p>
-            <a:fld id="{DDAEBF46-9B97-4AC3-A0AF-444D94E4545E}" type="datetimeFigureOut">
+            <a:fld id="{CFA8807D-23B5-470F-A350-DF6C7A298D37}" type="datetimeFigureOut">
               <a:rPr lang="en-IN" smtClean="0"/>
               <a:t>19-10-2026</a:t>
             </a:fld>
@@ -2043,7 +2043,7 @@
           <p:cNvPr id="5" name="Footer Placeholder 4">
             <a:extLst>
               <a:ext uri="{FF2B5EF4-FFF2-40B4-BE49-F238E27FC236}">
-                <a16:creationId xmlns:a16="http://schemas.microsoft.com/office/drawing/2014/main" id="{5613BA31-87A2-C3B0-0121-9AA28F6096D2}"/>
+                <a16:creationId xmlns:a16="http://schemas.microsoft.com/office/drawing/2014/main" id="{AE813A50-ACAE-8592-1E35-1DEF50867D9F}"/>
               </a:ext>
             </a:extLst>
           </p:cNvPr>
@@ -2068,7 +2068,7 @@
           <p:cNvPr id="6" name="Slide Number Placeholder 5">
             <a:extLst>
               <a:ext uri="{FF2B5EF4-FFF2-40B4-BE49-F238E27FC236}">
-                <a16:creationId xmlns:a16="http://schemas.microsoft.com/office/drawing/2014/main" id="{64C794F3-688E-8684-ABF0-7A1A19509A33}"/>
+                <a16:creationId xmlns:a16="http://schemas.microsoft.com/office/drawing/2014/main" id="{5BC70A0D-D543-45F9-CBDD-76FF2281C4D9}"/>
               </a:ext>
             </a:extLst>
           </p:cNvPr>
@@ -2084,7 +2084,7 @@
           <a:bodyPr/>
           <a:lstStyle/>
           <a:p>
-            <a:fld id="{174159CA-C179-45FE-86F2-186D70961591}" type="slidenum">
+            <a:fld id="{934BEE5F-DF1C-4A89-BBCC-A9D5D9EBCB77}" type="slidenum">
               <a:rPr lang="en-IN" smtClean="0"/>
               <a:t>‹#›</a:t>
             </a:fld>
@@ -2095,7 +2095,7 @@
     </p:spTree>
     <p:extLst>
       <p:ext uri="{BB962C8B-B14F-4D97-AF65-F5344CB8AC3E}">
-        <p14:creationId xmlns:p14="http://schemas.microsoft.com/office/powerpoint/2010/main" val="3160138518"/>
+        <p14:creationId xmlns:p14="http://schemas.microsoft.com/office/powerpoint/2010/main" val="2603366913"/>
       </p:ext>
     </p:extLst>
   </p:cSld>
@@ -2127,7 +2127,7 @@
           <p:cNvPr id="2" name="Title 1">
             <a:extLst>
               <a:ext uri="{FF2B5EF4-FFF2-40B4-BE49-F238E27FC236}">
-                <a16:creationId xmlns:a16="http://schemas.microsoft.com/office/drawing/2014/main" id="{72B6F813-DC1B-8283-F30A-708E20FB5F58}"/>
+                <a16:creationId xmlns:a16="http://schemas.microsoft.com/office/drawing/2014/main" id="{A2973EF1-8930-DD6D-55BA-8ED664C22701}"/>
               </a:ext>
             </a:extLst>
           </p:cNvPr>
@@ -2156,7 +2156,7 @@
           <p:cNvPr id="3" name="Vertical Text Placeholder 2">
             <a:extLst>
               <a:ext uri="{FF2B5EF4-FFF2-40B4-BE49-F238E27FC236}">
-                <a16:creationId xmlns:a16="http://schemas.microsoft.com/office/drawing/2014/main" id="{5C8F356C-B888-56F2-38AB-67CCFAB938FC}"/>
+                <a16:creationId xmlns:a16="http://schemas.microsoft.com/office/drawing/2014/main" id="{0DB4EE35-C78D-DEA9-383D-7B02A0503712}"/>
               </a:ext>
             </a:extLst>
           </p:cNvPr>
@@ -2214,7 +2214,7 @@
           <p:cNvPr id="4" name="Date Placeholder 3">
             <a:extLst>
               <a:ext uri="{FF2B5EF4-FFF2-40B4-BE49-F238E27FC236}">
-                <a16:creationId xmlns:a16="http://schemas.microsoft.com/office/drawing/2014/main" id="{D46D3EE4-0F5C-D9CD-A286-92219206721A}"/>
+                <a16:creationId xmlns:a16="http://schemas.microsoft.com/office/drawing/2014/main" id="{3CC5DD0B-8D25-CD65-B992-202DDEE24F74}"/>
               </a:ext>
             </a:extLst>
           </p:cNvPr>
@@ -2230,7 +2230,7 @@
           <a:bodyPr/>
           <a:lstStyle/>
           <a:p>
-            <a:fld id="{DDAEBF46-9B97-4AC3-A0AF-444D94E4545E}" type="datetimeFigureOut">
+            <a:fld id="{CFA8807D-23B5-470F-A350-DF6C7A298D37}" type="datetimeFigureOut">
               <a:rPr lang="en-IN" smtClean="0"/>
               <a:t>19-10-2026</a:t>
             </a:fld>
@@ -2243,7 +2243,7 @@
           <p:cNvPr id="5" name="Footer Placeholder 4">
             <a:extLst>
               <a:ext uri="{FF2B5EF4-FFF2-40B4-BE49-F238E27FC236}">
-                <a16:creationId xmlns:a16="http://schemas.microsoft.com/office/drawing/2014/main" id="{58A299BA-FDF6-2DF8-20E4-116DBC38AE07}"/>
+                <a16:creationId xmlns:a16="http://schemas.microsoft.com/office/drawing/2014/main" id="{15B5C077-BA94-330E-5309-07115A5B291D}"/>
               </a:ext>
             </a:extLst>
           </p:cNvPr>
@@ -2268,7 +2268,7 @@
           <p:cNvPr id="6" name="Slide Number Placeholder 5">
             <a:extLst>
               <a:ext uri="{FF2B5EF4-FFF2-40B4-BE49-F238E27FC236}">
-                <a16:creationId xmlns:a16="http://schemas.microsoft.com/office/drawing/2014/main" id="{AD5F83F4-4729-3BE4-AE55-48F5F0EB55B6}"/>
+                <a16:creationId xmlns:a16="http://schemas.microsoft.com/office/drawing/2014/main" id="{8E5EAFDD-AEEB-2DC7-78B3-2EA42C11EB3D}"/>
               </a:ext>
             </a:extLst>
           </p:cNvPr>
@@ -2284,7 +2284,7 @@
           <a:bodyPr/>
           <a:lstStyle/>
           <a:p>
-            <a:fld id="{174159CA-C179-45FE-86F2-186D70961591}" type="slidenum">
+            <a:fld id="{934BEE5F-DF1C-4A89-BBCC-A9D5D9EBCB77}" type="slidenum">
               <a:rPr lang="en-IN" smtClean="0"/>
               <a:t>‹#›</a:t>
             </a:fld>
@@ -2295,7 +2295,7 @@
     </p:spTree>
     <p:extLst>
       <p:ext uri="{BB962C8B-B14F-4D97-AF65-F5344CB8AC3E}">
-        <p14:creationId xmlns:p14="http://schemas.microsoft.com/office/powerpoint/2010/main" val="3275301831"/>
+        <p14:creationId xmlns:p14="http://schemas.microsoft.com/office/powerpoint/2010/main" val="3210822402"/>
       </p:ext>
     </p:extLst>
   </p:cSld>
@@ -2327,7 +2327,7 @@
           <p:cNvPr id="2" name="Vertical Title 1">
             <a:extLst>
               <a:ext uri="{FF2B5EF4-FFF2-40B4-BE49-F238E27FC236}">
-                <a16:creationId xmlns:a16="http://schemas.microsoft.com/office/drawing/2014/main" id="{BE73F166-F08F-A009-70A2-A496B6474DB7}"/>
+                <a16:creationId xmlns:a16="http://schemas.microsoft.com/office/drawing/2014/main" id="{F30B5536-E3C0-661D-367C-214F8948C91E}"/>
               </a:ext>
             </a:extLst>
           </p:cNvPr>
@@ -2361,7 +2361,7 @@
           <p:cNvPr id="3" name="Vertical Text Placeholder 2">
             <a:extLst>
               <a:ext uri="{FF2B5EF4-FFF2-40B4-BE49-F238E27FC236}">
-                <a16:creationId xmlns:a16="http://schemas.microsoft.com/office/drawing/2014/main" id="{B2BA1AB7-CFC4-624A-E8CA-A10CF5F62228}"/>
+                <a16:creationId xmlns:a16="http://schemas.microsoft.com/office/drawing/2014/main" id="{BD065AEF-3527-5BD5-E11B-4AEC7CB07EBA}"/>
               </a:ext>
             </a:extLst>
           </p:cNvPr>
@@ -2424,7 +2424,7 @@
           <p:cNvPr id="4" name="Date Placeholder 3">
             <a:extLst>
               <a:ext uri="{FF2B5EF4-FFF2-40B4-BE49-F238E27FC236}">
-                <a16:creationId xmlns:a16="http://schemas.microsoft.com/office/drawing/2014/main" id="{5980E4E2-8391-46CF-2AD8-ED25C4FC5629}"/>
+                <a16:creationId xmlns:a16="http://schemas.microsoft.com/office/drawing/2014/main" id="{3B8B0EAB-B4D6-5FD6-1331-06298636408B}"/>
               </a:ext>
             </a:extLst>
           </p:cNvPr>
@@ -2440,7 +2440,7 @@
           <a:bodyPr/>
           <a:lstStyle/>
           <a:p>
-            <a:fld id="{DDAEBF46-9B97-4AC3-A0AF-444D94E4545E}" type="datetimeFigureOut">
+            <a:fld id="{CFA8807D-23B5-470F-A350-DF6C7A298D37}" type="datetimeFigureOut">
               <a:rPr lang="en-IN" smtClean="0"/>
               <a:t>19-10-2026</a:t>
             </a:fld>
@@ -2453,7 +2453,7 @@
           <p:cNvPr id="5" name="Footer Placeholder 4">
             <a:extLst>
               <a:ext uri="{FF2B5EF4-FFF2-40B4-BE49-F238E27FC236}">
-                <a16:creationId xmlns:a16="http://schemas.microsoft.com/office/drawing/2014/main" id="{DE23B39E-7882-22C6-49FD-02164FCDE728}"/>
+                <a16:creationId xmlns:a16="http://schemas.microsoft.com/office/drawing/2014/main" id="{048C753A-9847-835B-0177-BDD4FFE2B8B6}"/>
               </a:ext>
             </a:extLst>
           </p:cNvPr>
@@ -2478,7 +2478,7 @@
           <p:cNvPr id="6" name="Slide Number Placeholder 5">
             <a:extLst>
               <a:ext uri="{FF2B5EF4-FFF2-40B4-BE49-F238E27FC236}">
-                <a16:creationId xmlns:a16="http://schemas.microsoft.com/office/drawing/2014/main" id="{06D4CA1B-8F76-868A-6C11-9419B7232D99}"/>
+                <a16:creationId xmlns:a16="http://schemas.microsoft.com/office/drawing/2014/main" id="{ADFDBA45-940D-5AF8-1581-EDFF5F5281E3}"/>
               </a:ext>
             </a:extLst>
           </p:cNvPr>
@@ -2494,7 +2494,7 @@
           <a:bodyPr/>
           <a:lstStyle/>
           <a:p>
-            <a:fld id="{174159CA-C179-45FE-86F2-186D70961591}" type="slidenum">
+            <a:fld id="{934BEE5F-DF1C-4A89-BBCC-A9D5D9EBCB77}" type="slidenum">
               <a:rPr lang="en-IN" smtClean="0"/>
               <a:t>‹#›</a:t>
             </a:fld>
@@ -2505,7 +2505,7 @@
     </p:spTree>
     <p:extLst>
       <p:ext uri="{BB962C8B-B14F-4D97-AF65-F5344CB8AC3E}">
-        <p14:creationId xmlns:p14="http://schemas.microsoft.com/office/powerpoint/2010/main" val="1425051160"/>
+        <p14:creationId xmlns:p14="http://schemas.microsoft.com/office/powerpoint/2010/main" val="4225537345"/>
       </p:ext>
     </p:extLst>
   </p:cSld>
@@ -2537,7 +2537,7 @@
           <p:cNvPr id="2" name="Title 1">
             <a:extLst>
               <a:ext uri="{FF2B5EF4-FFF2-40B4-BE49-F238E27FC236}">
-                <a16:creationId xmlns:a16="http://schemas.microsoft.com/office/drawing/2014/main" id="{C8D82365-72FF-9F0F-E6A4-B02AF185C005}"/>
+                <a16:creationId xmlns:a16="http://schemas.microsoft.com/office/drawing/2014/main" id="{1338052A-A119-A697-6B5B-ED70A727E899}"/>
               </a:ext>
             </a:extLst>
           </p:cNvPr>
@@ -2566,7 +2566,7 @@
           <p:cNvPr id="3" name="Content Placeholder 2">
             <a:extLst>
               <a:ext uri="{FF2B5EF4-FFF2-40B4-BE49-F238E27FC236}">
-                <a16:creationId xmlns:a16="http://schemas.microsoft.com/office/drawing/2014/main" id="{A9DE4717-3B75-ABF0-08E0-6B51327C0A2C}"/>
+                <a16:creationId xmlns:a16="http://schemas.microsoft.com/office/drawing/2014/main" id="{0AF5A2FB-565C-ABA9-5632-64D726C7FDCE}"/>
               </a:ext>
             </a:extLst>
           </p:cNvPr>
@@ -2624,7 +2624,7 @@
           <p:cNvPr id="4" name="Date Placeholder 3">
             <a:extLst>
               <a:ext uri="{FF2B5EF4-FFF2-40B4-BE49-F238E27FC236}">
-                <a16:creationId xmlns:a16="http://schemas.microsoft.com/office/drawing/2014/main" id="{67DEB12C-D0B0-EC56-CF54-2CDBC78AACAA}"/>
+                <a16:creationId xmlns:a16="http://schemas.microsoft.com/office/drawing/2014/main" id="{1404ED12-2DB0-B349-8C1E-5B22BB71D68C}"/>
               </a:ext>
             </a:extLst>
           </p:cNvPr>
@@ -2640,7 +2640,7 @@
           <a:bodyPr/>
           <a:lstStyle/>
           <a:p>
-            <a:fld id="{DDAEBF46-9B97-4AC3-A0AF-444D94E4545E}" type="datetimeFigureOut">
+            <a:fld id="{CFA8807D-23B5-470F-A350-DF6C7A298D37}" type="datetimeFigureOut">
               <a:rPr lang="en-IN" smtClean="0"/>
               <a:t>19-10-2026</a:t>
             </a:fld>
@@ -2653,7 +2653,7 @@
           <p:cNvPr id="5" name="Footer Placeholder 4">
             <a:extLst>
               <a:ext uri="{FF2B5EF4-FFF2-40B4-BE49-F238E27FC236}">
-                <a16:creationId xmlns:a16="http://schemas.microsoft.com/office/drawing/2014/main" id="{40838DBB-1B1E-C3E2-7A0A-0B7E457A3771}"/>
+                <a16:creationId xmlns:a16="http://schemas.microsoft.com/office/drawing/2014/main" id="{E174E2C1-2D86-81A0-DD6B-4B739F08CE20}"/>
               </a:ext>
             </a:extLst>
           </p:cNvPr>
@@ -2678,7 +2678,7 @@
           <p:cNvPr id="6" name="Slide Number Placeholder 5">
             <a:extLst>
               <a:ext uri="{FF2B5EF4-FFF2-40B4-BE49-F238E27FC236}">
-                <a16:creationId xmlns:a16="http://schemas.microsoft.com/office/drawing/2014/main" id="{8D2CF156-5405-668C-125C-8E9E316E742C}"/>
+                <a16:creationId xmlns:a16="http://schemas.microsoft.com/office/drawing/2014/main" id="{F6F959CE-4224-53A2-E6F4-1C2C9A9BEE7F}"/>
               </a:ext>
             </a:extLst>
           </p:cNvPr>
@@ -2694,7 +2694,7 @@
           <a:bodyPr/>
           <a:lstStyle/>
           <a:p>
-            <a:fld id="{174159CA-C179-45FE-86F2-186D70961591}" type="slidenum">
+            <a:fld id="{934BEE5F-DF1C-4A89-BBCC-A9D5D9EBCB77}" type="slidenum">
               <a:rPr lang="en-IN" smtClean="0"/>
               <a:t>‹#›</a:t>
             </a:fld>
@@ -2705,7 +2705,7 @@
     </p:spTree>
     <p:extLst>
       <p:ext uri="{BB962C8B-B14F-4D97-AF65-F5344CB8AC3E}">
-        <p14:creationId xmlns:p14="http://schemas.microsoft.com/office/powerpoint/2010/main" val="3779387966"/>
+        <p14:creationId xmlns:p14="http://schemas.microsoft.com/office/powerpoint/2010/main" val="1191491390"/>
       </p:ext>
     </p:extLst>
   </p:cSld>
@@ -2737,7 +2737,7 @@
           <p:cNvPr id="2" name="Title 1">
             <a:extLst>
               <a:ext uri="{FF2B5EF4-FFF2-40B4-BE49-F238E27FC236}">
-                <a16:creationId xmlns:a16="http://schemas.microsoft.com/office/drawing/2014/main" id="{D3EED1ED-1884-6393-2F71-F0F4FABEBCB4}"/>
+                <a16:creationId xmlns:a16="http://schemas.microsoft.com/office/drawing/2014/main" id="{24FB8D01-BA6A-1798-63F7-1F0A406AE1F2}"/>
               </a:ext>
             </a:extLst>
           </p:cNvPr>
@@ -2775,7 +2775,7 @@
           <p:cNvPr id="3" name="Text Placeholder 2">
             <a:extLst>
               <a:ext uri="{FF2B5EF4-FFF2-40B4-BE49-F238E27FC236}">
-                <a16:creationId xmlns:a16="http://schemas.microsoft.com/office/drawing/2014/main" id="{A53DDF80-9157-1738-D1C2-AADB87157B7A}"/>
+                <a16:creationId xmlns:a16="http://schemas.microsoft.com/office/drawing/2014/main" id="{2E711DA6-78D2-1936-929E-22E345F2361E}"/>
               </a:ext>
             </a:extLst>
           </p:cNvPr>
@@ -2900,7 +2900,7 @@
           <p:cNvPr id="4" name="Date Placeholder 3">
             <a:extLst>
               <a:ext uri="{FF2B5EF4-FFF2-40B4-BE49-F238E27FC236}">
-                <a16:creationId xmlns:a16="http://schemas.microsoft.com/office/drawing/2014/main" id="{1688EC6B-9B12-5E88-3303-48162B3A308B}"/>
+                <a16:creationId xmlns:a16="http://schemas.microsoft.com/office/drawing/2014/main" id="{791C4743-3E57-52BE-E9A8-A6577D4FFD91}"/>
               </a:ext>
             </a:extLst>
           </p:cNvPr>
@@ -2916,7 +2916,7 @@
           <a:bodyPr/>
           <a:lstStyle/>
           <a:p>
-            <a:fld id="{DDAEBF46-9B97-4AC3-A0AF-444D94E4545E}" type="datetimeFigureOut">
+            <a:fld id="{CFA8807D-23B5-470F-A350-DF6C7A298D37}" type="datetimeFigureOut">
               <a:rPr lang="en-IN" smtClean="0"/>
               <a:t>19-10-2026</a:t>
             </a:fld>
@@ -2929,7 +2929,7 @@
           <p:cNvPr id="5" name="Footer Placeholder 4">
             <a:extLst>
               <a:ext uri="{FF2B5EF4-FFF2-40B4-BE49-F238E27FC236}">
-                <a16:creationId xmlns:a16="http://schemas.microsoft.com/office/drawing/2014/main" id="{3F25E26B-CC79-6989-17E9-5EBCE6E070EE}"/>
+                <a16:creationId xmlns:a16="http://schemas.microsoft.com/office/drawing/2014/main" id="{0357955E-661B-BAB5-9D40-5AFA484EEDDA}"/>
               </a:ext>
             </a:extLst>
           </p:cNvPr>
@@ -2954,7 +2954,7 @@
           <p:cNvPr id="6" name="Slide Number Placeholder 5">
             <a:extLst>
               <a:ext uri="{FF2B5EF4-FFF2-40B4-BE49-F238E27FC236}">
-                <a16:creationId xmlns:a16="http://schemas.microsoft.com/office/drawing/2014/main" id="{C873D7C4-8743-5810-EF5C-E9ED6303620E}"/>
+                <a16:creationId xmlns:a16="http://schemas.microsoft.com/office/drawing/2014/main" id="{856916B1-F7D6-9BDF-4E40-7A75EDBE8757}"/>
               </a:ext>
             </a:extLst>
           </p:cNvPr>
@@ -2970,7 +2970,7 @@
           <a:bodyPr/>
           <a:lstStyle/>
           <a:p>
-            <a:fld id="{174159CA-C179-45FE-86F2-186D70961591}" type="slidenum">
+            <a:fld id="{934BEE5F-DF1C-4A89-BBCC-A9D5D9EBCB77}" type="slidenum">
               <a:rPr lang="en-IN" smtClean="0"/>
               <a:t>‹#›</a:t>
             </a:fld>
@@ -2981,7 +2981,7 @@
     </p:spTree>
     <p:extLst>
       <p:ext uri="{BB962C8B-B14F-4D97-AF65-F5344CB8AC3E}">
-        <p14:creationId xmlns:p14="http://schemas.microsoft.com/office/powerpoint/2010/main" val="3090168809"/>
+        <p14:creationId xmlns:p14="http://schemas.microsoft.com/office/powerpoint/2010/main" val="4269770286"/>
       </p:ext>
     </p:extLst>
   </p:cSld>
@@ -3013,7 +3013,7 @@
           <p:cNvPr id="2" name="Title 1">
             <a:extLst>
               <a:ext uri="{FF2B5EF4-FFF2-40B4-BE49-F238E27FC236}">
-                <a16:creationId xmlns:a16="http://schemas.microsoft.com/office/drawing/2014/main" id="{A202F5AF-96F5-74CC-CE6F-81B093FEF4BC}"/>
+                <a16:creationId xmlns:a16="http://schemas.microsoft.com/office/drawing/2014/main" id="{36FFBE4B-5FFD-965A-603B-AA290A0B7A5F}"/>
               </a:ext>
             </a:extLst>
           </p:cNvPr>
@@ -3042,7 +3042,7 @@
           <p:cNvPr id="3" name="Content Placeholder 2">
             <a:extLst>
               <a:ext uri="{FF2B5EF4-FFF2-40B4-BE49-F238E27FC236}">
-                <a16:creationId xmlns:a16="http://schemas.microsoft.com/office/drawing/2014/main" id="{9BD1FBC7-1477-B7FB-F246-6CC0469AC8F2}"/>
+                <a16:creationId xmlns:a16="http://schemas.microsoft.com/office/drawing/2014/main" id="{EE290B0F-5417-091C-D5F2-267F8C01F06E}"/>
               </a:ext>
             </a:extLst>
           </p:cNvPr>
@@ -3105,7 +3105,7 @@
           <p:cNvPr id="4" name="Content Placeholder 3">
             <a:extLst>
               <a:ext uri="{FF2B5EF4-FFF2-40B4-BE49-F238E27FC236}">
-                <a16:creationId xmlns:a16="http://schemas.microsoft.com/office/drawing/2014/main" id="{70A8A3F3-9AD7-3417-8F31-AC92C502DC4B}"/>
+                <a16:creationId xmlns:a16="http://schemas.microsoft.com/office/drawing/2014/main" id="{7C1ACB04-2367-49D4-4460-CBB1FD2AC10E}"/>
               </a:ext>
             </a:extLst>
           </p:cNvPr>
@@ -3168,7 +3168,7 @@
           <p:cNvPr id="5" name="Date Placeholder 4">
             <a:extLst>
               <a:ext uri="{FF2B5EF4-FFF2-40B4-BE49-F238E27FC236}">
-                <a16:creationId xmlns:a16="http://schemas.microsoft.com/office/drawing/2014/main" id="{EEC30507-4205-1B3A-AE2A-2BD5F1DC0515}"/>
+                <a16:creationId xmlns:a16="http://schemas.microsoft.com/office/drawing/2014/main" id="{27A12435-E40E-CCAB-4749-572AF8B77BBE}"/>
               </a:ext>
             </a:extLst>
           </p:cNvPr>
@@ -3184,7 +3184,7 @@
           <a:bodyPr/>
           <a:lstStyle/>
           <a:p>
-            <a:fld id="{DDAEBF46-9B97-4AC3-A0AF-444D94E4545E}" type="datetimeFigureOut">
+            <a:fld id="{CFA8807D-23B5-470F-A350-DF6C7A298D37}" type="datetimeFigureOut">
               <a:rPr lang="en-IN" smtClean="0"/>
               <a:t>19-10-2026</a:t>
             </a:fld>
@@ -3197,7 +3197,7 @@
           <p:cNvPr id="6" name="Footer Placeholder 5">
             <a:extLst>
               <a:ext uri="{FF2B5EF4-FFF2-40B4-BE49-F238E27FC236}">
-                <a16:creationId xmlns:a16="http://schemas.microsoft.com/office/drawing/2014/main" id="{CAF29C3B-207E-2373-261F-383CA33E9AC2}"/>
+                <a16:creationId xmlns:a16="http://schemas.microsoft.com/office/drawing/2014/main" id="{CFB89491-F0C4-BC16-B9C0-EC198441F4DC}"/>
               </a:ext>
             </a:extLst>
           </p:cNvPr>
@@ -3222,7 +3222,7 @@
           <p:cNvPr id="7" name="Slide Number Placeholder 6">
             <a:extLst>
               <a:ext uri="{FF2B5EF4-FFF2-40B4-BE49-F238E27FC236}">
-                <a16:creationId xmlns:a16="http://schemas.microsoft.com/office/drawing/2014/main" id="{AE854A7A-1C94-05BF-0BAC-7F3922B72DAE}"/>
+                <a16:creationId xmlns:a16="http://schemas.microsoft.com/office/drawing/2014/main" id="{26E66FB2-E9C1-F909-8C71-DF11587EB6E5}"/>
               </a:ext>
             </a:extLst>
           </p:cNvPr>
@@ -3238,7 +3238,7 @@
           <a:bodyPr/>
           <a:lstStyle/>
           <a:p>
-            <a:fld id="{174159CA-C179-45FE-86F2-186D70961591}" type="slidenum">
+            <a:fld id="{934BEE5F-DF1C-4A89-BBCC-A9D5D9EBCB77}" type="slidenum">
               <a:rPr lang="en-IN" smtClean="0"/>
               <a:t>‹#›</a:t>
             </a:fld>
@@ -3249,7 +3249,7 @@
     </p:spTree>
     <p:extLst>
       <p:ext uri="{BB962C8B-B14F-4D97-AF65-F5344CB8AC3E}">
-        <p14:creationId xmlns:p14="http://schemas.microsoft.com/office/powerpoint/2010/main" val="2296981858"/>
+        <p14:creationId xmlns:p14="http://schemas.microsoft.com/office/powerpoint/2010/main" val="334907587"/>
       </p:ext>
     </p:extLst>
   </p:cSld>
@@ -3281,7 +3281,7 @@
           <p:cNvPr id="2" name="Title 1">
             <a:extLst>
               <a:ext uri="{FF2B5EF4-FFF2-40B4-BE49-F238E27FC236}">
-                <a16:creationId xmlns:a16="http://schemas.microsoft.com/office/drawing/2014/main" id="{3BC71C4F-AC15-EAFE-F1AB-4AB7D24F30DC}"/>
+                <a16:creationId xmlns:a16="http://schemas.microsoft.com/office/drawing/2014/main" id="{3D6E1683-7B4D-553D-283F-18FA4A99BE0A}"/>
               </a:ext>
             </a:extLst>
           </p:cNvPr>
@@ -3315,7 +3315,7 @@
           <p:cNvPr id="3" name="Text Placeholder 2">
             <a:extLst>
               <a:ext uri="{FF2B5EF4-FFF2-40B4-BE49-F238E27FC236}">
-                <a16:creationId xmlns:a16="http://schemas.microsoft.com/office/drawing/2014/main" id="{0CA2561B-2BE8-DA4F-730A-5A6778E53716}"/>
+                <a16:creationId xmlns:a16="http://schemas.microsoft.com/office/drawing/2014/main" id="{6B5768DC-AFD4-21D4-82B9-EF1E31867410}"/>
               </a:ext>
             </a:extLst>
           </p:cNvPr>
@@ -3386,7 +3386,7 @@
           <p:cNvPr id="4" name="Content Placeholder 3">
             <a:extLst>
               <a:ext uri="{FF2B5EF4-FFF2-40B4-BE49-F238E27FC236}">
-                <a16:creationId xmlns:a16="http://schemas.microsoft.com/office/drawing/2014/main" id="{03B4733C-C103-20BE-8FCB-41C54FE6AA53}"/>
+                <a16:creationId xmlns:a16="http://schemas.microsoft.com/office/drawing/2014/main" id="{094148F8-79DC-80CB-CFE9-DEFC1295A026}"/>
               </a:ext>
             </a:extLst>
           </p:cNvPr>
@@ -3449,7 +3449,7 @@
           <p:cNvPr id="5" name="Text Placeholder 4">
             <a:extLst>
               <a:ext uri="{FF2B5EF4-FFF2-40B4-BE49-F238E27FC236}">
-                <a16:creationId xmlns:a16="http://schemas.microsoft.com/office/drawing/2014/main" id="{C8D9341A-287F-7E71-68AA-657B24C3A32C}"/>
+                <a16:creationId xmlns:a16="http://schemas.microsoft.com/office/drawing/2014/main" id="{23D7E94F-5208-AD5D-C878-FC299148F724}"/>
               </a:ext>
             </a:extLst>
           </p:cNvPr>
@@ -3520,7 +3520,7 @@
           <p:cNvPr id="6" name="Content Placeholder 5">
             <a:extLst>
               <a:ext uri="{FF2B5EF4-FFF2-40B4-BE49-F238E27FC236}">
-                <a16:creationId xmlns:a16="http://schemas.microsoft.com/office/drawing/2014/main" id="{FB94593B-0D23-43A4-6E49-DAC581E49BE4}"/>
+                <a16:creationId xmlns:a16="http://schemas.microsoft.com/office/drawing/2014/main" id="{B1C89C1F-C64B-258E-8CAC-055094BEE51C}"/>
               </a:ext>
             </a:extLst>
           </p:cNvPr>
@@ -3583,7 +3583,7 @@
           <p:cNvPr id="7" name="Date Placeholder 6">
             <a:extLst>
               <a:ext uri="{FF2B5EF4-FFF2-40B4-BE49-F238E27FC236}">
-                <a16:creationId xmlns:a16="http://schemas.microsoft.com/office/drawing/2014/main" id="{53C0F5F9-DF13-090C-053A-2E49E75DABB0}"/>
+                <a16:creationId xmlns:a16="http://schemas.microsoft.com/office/drawing/2014/main" id="{39F4CF4B-7B8B-D0D8-F895-C238B800A869}"/>
               </a:ext>
             </a:extLst>
           </p:cNvPr>
@@ -3599,7 +3599,7 @@
           <a:bodyPr/>
           <a:lstStyle/>
           <a:p>
-            <a:fld id="{DDAEBF46-9B97-4AC3-A0AF-444D94E4545E}" type="datetimeFigureOut">
+            <a:fld id="{CFA8807D-23B5-470F-A350-DF6C7A298D37}" type="datetimeFigureOut">
               <a:rPr lang="en-IN" smtClean="0"/>
               <a:t>19-10-2026</a:t>
             </a:fld>
@@ -3612,7 +3612,7 @@
           <p:cNvPr id="8" name="Footer Placeholder 7">
             <a:extLst>
               <a:ext uri="{FF2B5EF4-FFF2-40B4-BE49-F238E27FC236}">
-                <a16:creationId xmlns:a16="http://schemas.microsoft.com/office/drawing/2014/main" id="{3D4851A9-D20F-AF16-4069-211794ECB4BE}"/>
+                <a16:creationId xmlns:a16="http://schemas.microsoft.com/office/drawing/2014/main" id="{0337533B-5FC2-DF41-4F55-1C4AF68982A5}"/>
               </a:ext>
             </a:extLst>
           </p:cNvPr>
@@ -3637,7 +3637,7 @@
           <p:cNvPr id="9" name="Slide Number Placeholder 8">
             <a:extLst>
               <a:ext uri="{FF2B5EF4-FFF2-40B4-BE49-F238E27FC236}">
-                <a16:creationId xmlns:a16="http://schemas.microsoft.com/office/drawing/2014/main" id="{AC8BC0D2-8234-6828-8F80-E08E913AB3E7}"/>
+                <a16:creationId xmlns:a16="http://schemas.microsoft.com/office/drawing/2014/main" id="{2A357DE3-BAA0-4E19-5A51-38531976B194}"/>
               </a:ext>
             </a:extLst>
           </p:cNvPr>
@@ -3653,7 +3653,7 @@
           <a:bodyPr/>
           <a:lstStyle/>
           <a:p>
-            <a:fld id="{174159CA-C179-45FE-86F2-186D70961591}" type="slidenum">
+            <a:fld id="{934BEE5F-DF1C-4A89-BBCC-A9D5D9EBCB77}" type="slidenum">
               <a:rPr lang="en-IN" smtClean="0"/>
               <a:t>‹#›</a:t>
             </a:fld>
@@ -3664,7 +3664,7 @@
     </p:spTree>
     <p:extLst>
       <p:ext uri="{BB962C8B-B14F-4D97-AF65-F5344CB8AC3E}">
-        <p14:creationId xmlns:p14="http://schemas.microsoft.com/office/powerpoint/2010/main" val="3092111439"/>
+        <p14:creationId xmlns:p14="http://schemas.microsoft.com/office/powerpoint/2010/main" val="3609016246"/>
       </p:ext>
     </p:extLst>
   </p:cSld>
@@ -3696,7 +3696,7 @@
           <p:cNvPr id="2" name="Title 1">
             <a:extLst>
               <a:ext uri="{FF2B5EF4-FFF2-40B4-BE49-F238E27FC236}">
-                <a16:creationId xmlns:a16="http://schemas.microsoft.com/office/drawing/2014/main" id="{D6D79FB5-B504-D9C9-94CF-82C31A3A065D}"/>
+                <a16:creationId xmlns:a16="http://schemas.microsoft.com/office/drawing/2014/main" id="{4CD73FCF-9F85-594C-71B0-151FA260289E}"/>
               </a:ext>
             </a:extLst>
           </p:cNvPr>
@@ -3725,7 +3725,7 @@
           <p:cNvPr id="3" name="Date Placeholder 2">
             <a:extLst>
               <a:ext uri="{FF2B5EF4-FFF2-40B4-BE49-F238E27FC236}">
-                <a16:creationId xmlns:a16="http://schemas.microsoft.com/office/drawing/2014/main" id="{C1998237-B6D8-B0E3-D535-DF8F0B583BA8}"/>
+                <a16:creationId xmlns:a16="http://schemas.microsoft.com/office/drawing/2014/main" id="{BA1E3388-06F5-D963-5258-310CE034E79D}"/>
               </a:ext>
             </a:extLst>
           </p:cNvPr>
@@ -3741,7 +3741,7 @@
           <a:bodyPr/>
           <a:lstStyle/>
           <a:p>
-            <a:fld id="{DDAEBF46-9B97-4AC3-A0AF-444D94E4545E}" type="datetimeFigureOut">
+            <a:fld id="{CFA8807D-23B5-470F-A350-DF6C7A298D37}" type="datetimeFigureOut">
               <a:rPr lang="en-IN" smtClean="0"/>
               <a:t>19-10-2026</a:t>
             </a:fld>
@@ -3754,7 +3754,7 @@
           <p:cNvPr id="4" name="Footer Placeholder 3">
             <a:extLst>
               <a:ext uri="{FF2B5EF4-FFF2-40B4-BE49-F238E27FC236}">
-                <a16:creationId xmlns:a16="http://schemas.microsoft.com/office/drawing/2014/main" id="{FD6A02A9-B13F-7632-0B88-2A3D6D67EEEF}"/>
+                <a16:creationId xmlns:a16="http://schemas.microsoft.com/office/drawing/2014/main" id="{3DB75156-8723-9C47-8EE7-E3C853A571DD}"/>
               </a:ext>
             </a:extLst>
           </p:cNvPr>
@@ -3779,7 +3779,7 @@
           <p:cNvPr id="5" name="Slide Number Placeholder 4">
             <a:extLst>
               <a:ext uri="{FF2B5EF4-FFF2-40B4-BE49-F238E27FC236}">
-                <a16:creationId xmlns:a16="http://schemas.microsoft.com/office/drawing/2014/main" id="{4CD2EE5E-F0B6-D9D8-FE74-F09927787CDF}"/>
+                <a16:creationId xmlns:a16="http://schemas.microsoft.com/office/drawing/2014/main" id="{15EA7568-EAD7-735F-0E9F-8A2DC0F18F4A}"/>
               </a:ext>
             </a:extLst>
           </p:cNvPr>
@@ -3795,7 +3795,7 @@
           <a:bodyPr/>
           <a:lstStyle/>
           <a:p>
-            <a:fld id="{174159CA-C179-45FE-86F2-186D70961591}" type="slidenum">
+            <a:fld id="{934BEE5F-DF1C-4A89-BBCC-A9D5D9EBCB77}" type="slidenum">
               <a:rPr lang="en-IN" smtClean="0"/>
               <a:t>‹#›</a:t>
             </a:fld>
@@ -3806,7 +3806,7 @@
     </p:spTree>
     <p:extLst>
       <p:ext uri="{BB962C8B-B14F-4D97-AF65-F5344CB8AC3E}">
-        <p14:creationId xmlns:p14="http://schemas.microsoft.com/office/powerpoint/2010/main" val="2421413901"/>
+        <p14:creationId xmlns:p14="http://schemas.microsoft.com/office/powerpoint/2010/main" val="3108010882"/>
       </p:ext>
     </p:extLst>
   </p:cSld>
@@ -3838,7 +3838,7 @@
           <p:cNvPr id="2" name="Date Placeholder 1">
             <a:extLst>
               <a:ext uri="{FF2B5EF4-FFF2-40B4-BE49-F238E27FC236}">
-                <a16:creationId xmlns:a16="http://schemas.microsoft.com/office/drawing/2014/main" id="{E4CE79CB-9C7A-B2B0-D530-09ACD050C640}"/>
+                <a16:creationId xmlns:a16="http://schemas.microsoft.com/office/drawing/2014/main" id="{6306354E-663D-FB03-0C92-03CD6BF10026}"/>
               </a:ext>
             </a:extLst>
           </p:cNvPr>
@@ -3854,7 +3854,7 @@
           <a:bodyPr/>
           <a:lstStyle/>
           <a:p>
-            <a:fld id="{DDAEBF46-9B97-4AC3-A0AF-444D94E4545E}" type="datetimeFigureOut">
+            <a:fld id="{CFA8807D-23B5-470F-A350-DF6C7A298D37}" type="datetimeFigureOut">
               <a:rPr lang="en-IN" smtClean="0"/>
               <a:t>19-10-2026</a:t>
             </a:fld>
@@ -3867,7 +3867,7 @@
           <p:cNvPr id="3" name="Footer Placeholder 2">
             <a:extLst>
               <a:ext uri="{FF2B5EF4-FFF2-40B4-BE49-F238E27FC236}">
-                <a16:creationId xmlns:a16="http://schemas.microsoft.com/office/drawing/2014/main" id="{3F3E4261-85CA-7B47-66FC-E4B225DE0951}"/>
+                <a16:creationId xmlns:a16="http://schemas.microsoft.com/office/drawing/2014/main" id="{05DB7F38-0375-009D-3D4F-87475C24DC69}"/>
               </a:ext>
             </a:extLst>
           </p:cNvPr>
@@ -3892,7 +3892,7 @@
           <p:cNvPr id="4" name="Slide Number Placeholder 3">
             <a:extLst>
               <a:ext uri="{FF2B5EF4-FFF2-40B4-BE49-F238E27FC236}">
-                <a16:creationId xmlns:a16="http://schemas.microsoft.com/office/drawing/2014/main" id="{4CB469FA-7B3D-A86B-CF40-89863D7F7341}"/>
+                <a16:creationId xmlns:a16="http://schemas.microsoft.com/office/drawing/2014/main" id="{C1919309-D986-865C-0EF2-EEE5FCF9E556}"/>
               </a:ext>
             </a:extLst>
           </p:cNvPr>
@@ -3908,7 +3908,7 @@
           <a:bodyPr/>
           <a:lstStyle/>
           <a:p>
-            <a:fld id="{174159CA-C179-45FE-86F2-186D70961591}" type="slidenum">
+            <a:fld id="{934BEE5F-DF1C-4A89-BBCC-A9D5D9EBCB77}" type="slidenum">
               <a:rPr lang="en-IN" smtClean="0"/>
               <a:t>‹#›</a:t>
             </a:fld>
@@ -3919,7 +3919,7 @@
     </p:spTree>
     <p:extLst>
       <p:ext uri="{BB962C8B-B14F-4D97-AF65-F5344CB8AC3E}">
-        <p14:creationId xmlns:p14="http://schemas.microsoft.com/office/powerpoint/2010/main" val="2189890881"/>
+        <p14:creationId xmlns:p14="http://schemas.microsoft.com/office/powerpoint/2010/main" val="928004972"/>
       </p:ext>
     </p:extLst>
   </p:cSld>
@@ -3951,7 +3951,7 @@
           <p:cNvPr id="2" name="Title 1">
             <a:extLst>
               <a:ext uri="{FF2B5EF4-FFF2-40B4-BE49-F238E27FC236}">
-                <a16:creationId xmlns:a16="http://schemas.microsoft.com/office/drawing/2014/main" id="{9C784784-F7C6-F78C-20A1-C2ACD7897B0D}"/>
+                <a16:creationId xmlns:a16="http://schemas.microsoft.com/office/drawing/2014/main" id="{2BEE14EB-01C5-55F7-B472-C8C6B382B9A2}"/>
               </a:ext>
             </a:extLst>
           </p:cNvPr>
@@ -3989,7 +3989,7 @@
           <p:cNvPr id="3" name="Content Placeholder 2">
             <a:extLst>
               <a:ext uri="{FF2B5EF4-FFF2-40B4-BE49-F238E27FC236}">
-                <a16:creationId xmlns:a16="http://schemas.microsoft.com/office/drawing/2014/main" id="{461CC8CC-BB5A-83A3-F982-A6A83D0885C4}"/>
+                <a16:creationId xmlns:a16="http://schemas.microsoft.com/office/drawing/2014/main" id="{AD48CC36-212D-8FD8-0F57-87586F74F43E}"/>
               </a:ext>
             </a:extLst>
           </p:cNvPr>
@@ -4080,7 +4080,7 @@
           <p:cNvPr id="4" name="Text Placeholder 3">
             <a:extLst>
               <a:ext uri="{FF2B5EF4-FFF2-40B4-BE49-F238E27FC236}">
-                <a16:creationId xmlns:a16="http://schemas.microsoft.com/office/drawing/2014/main" id="{2DCCF31F-AE3B-AB44-4188-F73222D7CAF3}"/>
+                <a16:creationId xmlns:a16="http://schemas.microsoft.com/office/drawing/2014/main" id="{BF1EC950-0358-CB18-27F9-C0E2FF19CF94}"/>
               </a:ext>
             </a:extLst>
           </p:cNvPr>
@@ -4151,7 +4151,7 @@
           <p:cNvPr id="5" name="Date Placeholder 4">
             <a:extLst>
               <a:ext uri="{FF2B5EF4-FFF2-40B4-BE49-F238E27FC236}">
-                <a16:creationId xmlns:a16="http://schemas.microsoft.com/office/drawing/2014/main" id="{D2D9D01A-2A04-0A27-DF78-5E01C6B88D94}"/>
+                <a16:creationId xmlns:a16="http://schemas.microsoft.com/office/drawing/2014/main" id="{AD57A94A-9BE8-3F9D-4FBF-0C85234DFA25}"/>
               </a:ext>
             </a:extLst>
           </p:cNvPr>
@@ -4167,7 +4167,7 @@
           <a:bodyPr/>
           <a:lstStyle/>
           <a:p>
-            <a:fld id="{DDAEBF46-9B97-4AC3-A0AF-444D94E4545E}" type="datetimeFigureOut">
+            <a:fld id="{CFA8807D-23B5-470F-A350-DF6C7A298D37}" type="datetimeFigureOut">
               <a:rPr lang="en-IN" smtClean="0"/>
               <a:t>19-10-2026</a:t>
             </a:fld>
@@ -4180,7 +4180,7 @@
           <p:cNvPr id="6" name="Footer Placeholder 5">
             <a:extLst>
               <a:ext uri="{FF2B5EF4-FFF2-40B4-BE49-F238E27FC236}">
-                <a16:creationId xmlns:a16="http://schemas.microsoft.com/office/drawing/2014/main" id="{528C9C5B-9952-992F-42A5-1616F0AB6F51}"/>
+                <a16:creationId xmlns:a16="http://schemas.microsoft.com/office/drawing/2014/main" id="{8004D088-9337-6476-2BDF-00183F6C0420}"/>
               </a:ext>
             </a:extLst>
           </p:cNvPr>
@@ -4205,7 +4205,7 @@
           <p:cNvPr id="7" name="Slide Number Placeholder 6">
             <a:extLst>
               <a:ext uri="{FF2B5EF4-FFF2-40B4-BE49-F238E27FC236}">
-                <a16:creationId xmlns:a16="http://schemas.microsoft.com/office/drawing/2014/main" id="{8D372F0E-A98F-1D7A-7B9D-E15EF11FE034}"/>
+                <a16:creationId xmlns:a16="http://schemas.microsoft.com/office/drawing/2014/main" id="{AAA9F8B9-C91D-0E7E-63F7-3DB9373D789C}"/>
               </a:ext>
             </a:extLst>
           </p:cNvPr>
@@ -4221,7 +4221,7 @@
           <a:bodyPr/>
           <a:lstStyle/>
           <a:p>
-            <a:fld id="{174159CA-C179-45FE-86F2-186D70961591}" type="slidenum">
+            <a:fld id="{934BEE5F-DF1C-4A89-BBCC-A9D5D9EBCB77}" type="slidenum">
               <a:rPr lang="en-IN" smtClean="0"/>
               <a:t>‹#›</a:t>
             </a:fld>
@@ -4232,7 +4232,7 @@
     </p:spTree>
     <p:extLst>
       <p:ext uri="{BB962C8B-B14F-4D97-AF65-F5344CB8AC3E}">
-        <p14:creationId xmlns:p14="http://schemas.microsoft.com/office/powerpoint/2010/main" val="88824160"/>
+        <p14:creationId xmlns:p14="http://schemas.microsoft.com/office/powerpoint/2010/main" val="682040366"/>
       </p:ext>
     </p:extLst>
   </p:cSld>
@@ -4264,7 +4264,7 @@
           <p:cNvPr id="2" name="Title 1">
             <a:extLst>
               <a:ext uri="{FF2B5EF4-FFF2-40B4-BE49-F238E27FC236}">
-                <a16:creationId xmlns:a16="http://schemas.microsoft.com/office/drawing/2014/main" id="{E593876E-89AB-A6BC-F810-2CE97F46496E}"/>
+                <a16:creationId xmlns:a16="http://schemas.microsoft.com/office/drawing/2014/main" id="{28FA74DF-AA14-E11E-023B-9428247719FA}"/>
               </a:ext>
             </a:extLst>
           </p:cNvPr>
@@ -4302,7 +4302,7 @@
           <p:cNvPr id="3" name="Picture Placeholder 2">
             <a:extLst>
               <a:ext uri="{FF2B5EF4-FFF2-40B4-BE49-F238E27FC236}">
-                <a16:creationId xmlns:a16="http://schemas.microsoft.com/office/drawing/2014/main" id="{99B0B362-0D6E-5212-768A-1125EB88F314}"/>
+                <a16:creationId xmlns:a16="http://schemas.microsoft.com/office/drawing/2014/main" id="{6A2911CE-14A5-A22B-3432-FC1C7FD3D8A9}"/>
               </a:ext>
             </a:extLst>
           </p:cNvPr>
@@ -4369,7 +4369,7 @@
           <p:cNvPr id="4" name="Text Placeholder 3">
             <a:extLst>
               <a:ext uri="{FF2B5EF4-FFF2-40B4-BE49-F238E27FC236}">
-                <a16:creationId xmlns:a16="http://schemas.microsoft.com/office/drawing/2014/main" id="{9DA25B96-6AF3-A99B-15FA-246AC4E19181}"/>
+                <a16:creationId xmlns:a16="http://schemas.microsoft.com/office/drawing/2014/main" id="{E49019D7-26AF-EFF7-D269-75974CE6C858}"/>
               </a:ext>
             </a:extLst>
           </p:cNvPr>
@@ -4440,7 +4440,7 @@
           <p:cNvPr id="5" name="Date Placeholder 4">
             <a:extLst>
               <a:ext uri="{FF2B5EF4-FFF2-40B4-BE49-F238E27FC236}">
-                <a16:creationId xmlns:a16="http://schemas.microsoft.com/office/drawing/2014/main" id="{59409775-B8F5-1866-D56E-B964406CEBE1}"/>
+                <a16:creationId xmlns:a16="http://schemas.microsoft.com/office/drawing/2014/main" id="{5BDA2F8D-94A7-707D-08EC-0E108634DC6F}"/>
               </a:ext>
             </a:extLst>
           </p:cNvPr>
@@ -4456,7 +4456,7 @@
           <a:bodyPr/>
           <a:lstStyle/>
           <a:p>
-            <a:fld id="{DDAEBF46-9B97-4AC3-A0AF-444D94E4545E}" type="datetimeFigureOut">
+            <a:fld id="{CFA8807D-23B5-470F-A350-DF6C7A298D37}" type="datetimeFigureOut">
               <a:rPr lang="en-IN" smtClean="0"/>
               <a:t>19-10-2026</a:t>
             </a:fld>
@@ -4469,7 +4469,7 @@
           <p:cNvPr id="6" name="Footer Placeholder 5">
             <a:extLst>
               <a:ext uri="{FF2B5EF4-FFF2-40B4-BE49-F238E27FC236}">
-                <a16:creationId xmlns:a16="http://schemas.microsoft.com/office/drawing/2014/main" id="{03CB5122-ECFE-5D50-BE72-CB4B7ABDB665}"/>
+                <a16:creationId xmlns:a16="http://schemas.microsoft.com/office/drawing/2014/main" id="{DA85A6B8-8038-3906-299B-C705F18A5893}"/>
               </a:ext>
             </a:extLst>
           </p:cNvPr>
@@ -4494,7 +4494,7 @@
           <p:cNvPr id="7" name="Slide Number Placeholder 6">
             <a:extLst>
               <a:ext uri="{FF2B5EF4-FFF2-40B4-BE49-F238E27FC236}">
-                <a16:creationId xmlns:a16="http://schemas.microsoft.com/office/drawing/2014/main" id="{444C570F-B8E1-F67A-A5E5-D27E509272FA}"/>
+                <a16:creationId xmlns:a16="http://schemas.microsoft.com/office/drawing/2014/main" id="{DB96EB7B-FAB4-CAD7-A79A-838ED62663FD}"/>
               </a:ext>
             </a:extLst>
           </p:cNvPr>
@@ -4510,7 +4510,7 @@
           <a:bodyPr/>
           <a:lstStyle/>
           <a:p>
-            <a:fld id="{174159CA-C179-45FE-86F2-186D70961591}" type="slidenum">
+            <a:fld id="{934BEE5F-DF1C-4A89-BBCC-A9D5D9EBCB77}" type="slidenum">
               <a:rPr lang="en-IN" smtClean="0"/>
               <a:t>‹#›</a:t>
             </a:fld>
@@ -4521,7 +4521,7 @@
     </p:spTree>
     <p:extLst>
       <p:ext uri="{BB962C8B-B14F-4D97-AF65-F5344CB8AC3E}">
-        <p14:creationId xmlns:p14="http://schemas.microsoft.com/office/powerpoint/2010/main" val="3162236949"/>
+        <p14:creationId xmlns:p14="http://schemas.microsoft.com/office/powerpoint/2010/main" val="674834928"/>
       </p:ext>
     </p:extLst>
   </p:cSld>
@@ -4558,7 +4558,7 @@
           <p:cNvPr id="2" name="Title Placeholder 1">
             <a:extLst>
               <a:ext uri="{FF2B5EF4-FFF2-40B4-BE49-F238E27FC236}">
-                <a16:creationId xmlns:a16="http://schemas.microsoft.com/office/drawing/2014/main" id="{F73F0FA9-6314-1C33-4236-68B1465D3410}"/>
+                <a16:creationId xmlns:a16="http://schemas.microsoft.com/office/drawing/2014/main" id="{B84636D1-AD4F-0790-4E0C-B499AFCEC6C3}"/>
               </a:ext>
             </a:extLst>
           </p:cNvPr>
@@ -4597,7 +4597,7 @@
           <p:cNvPr id="3" name="Text Placeholder 2">
             <a:extLst>
               <a:ext uri="{FF2B5EF4-FFF2-40B4-BE49-F238E27FC236}">
-                <a16:creationId xmlns:a16="http://schemas.microsoft.com/office/drawing/2014/main" id="{553E494C-04E5-D934-FD03-6C7BAB4A4C50}"/>
+                <a16:creationId xmlns:a16="http://schemas.microsoft.com/office/drawing/2014/main" id="{E2331BCE-4EAE-4FF0-3BCC-F0A3B75C15B8}"/>
               </a:ext>
             </a:extLst>
           </p:cNvPr>
@@ -4665,7 +4665,7 @@
           <p:cNvPr id="4" name="Date Placeholder 3">
             <a:extLst>
               <a:ext uri="{FF2B5EF4-FFF2-40B4-BE49-F238E27FC236}">
-                <a16:creationId xmlns:a16="http://schemas.microsoft.com/office/drawing/2014/main" id="{4011260A-AD9F-8D0C-D358-4FCCAF80E841}"/>
+                <a16:creationId xmlns:a16="http://schemas.microsoft.com/office/drawing/2014/main" id="{C800A678-CF3A-8DCD-9ED2-CB0243CC9CB2}"/>
               </a:ext>
             </a:extLst>
           </p:cNvPr>
@@ -4699,7 +4699,7 @@
             </a:lvl1pPr>
           </a:lstStyle>
           <a:p>
-            <a:fld id="{DDAEBF46-9B97-4AC3-A0AF-444D94E4545E}" type="datetimeFigureOut">
+            <a:fld id="{CFA8807D-23B5-470F-A350-DF6C7A298D37}" type="datetimeFigureOut">
               <a:rPr lang="en-IN" smtClean="0"/>
               <a:t>19-10-2026</a:t>
             </a:fld>
@@ -4712,7 +4712,7 @@
           <p:cNvPr id="5" name="Footer Placeholder 4">
             <a:extLst>
               <a:ext uri="{FF2B5EF4-FFF2-40B4-BE49-F238E27FC236}">
-                <a16:creationId xmlns:a16="http://schemas.microsoft.com/office/drawing/2014/main" id="{DCB457B6-92B4-9786-E565-B7B779352C09}"/>
+                <a16:creationId xmlns:a16="http://schemas.microsoft.com/office/drawing/2014/main" id="{5C6680BD-81EF-BA90-90DC-D8F9C5355F42}"/>
               </a:ext>
             </a:extLst>
           </p:cNvPr>
@@ -4755,7 +4755,7 @@
           <p:cNvPr id="6" name="Slide Number Placeholder 5">
             <a:extLst>
               <a:ext uri="{FF2B5EF4-FFF2-40B4-BE49-F238E27FC236}">
-                <a16:creationId xmlns:a16="http://schemas.microsoft.com/office/drawing/2014/main" id="{DDFBC57E-4ABF-095E-99DA-38C209BE83FE}"/>
+                <a16:creationId xmlns:a16="http://schemas.microsoft.com/office/drawing/2014/main" id="{4C2E08B1-7696-7E2C-CCF2-87C3BE6629FB}"/>
               </a:ext>
             </a:extLst>
           </p:cNvPr>
@@ -4789,7 +4789,7 @@
             </a:lvl1pPr>
           </a:lstStyle>
           <a:p>
-            <a:fld id="{174159CA-C179-45FE-86F2-186D70961591}" type="slidenum">
+            <a:fld id="{934BEE5F-DF1C-4A89-BBCC-A9D5D9EBCB77}" type="slidenum">
               <a:rPr lang="en-IN" smtClean="0"/>
               <a:t>‹#›</a:t>
             </a:fld>
@@ -4800,7 +4800,7 @@
     </p:spTree>
     <p:extLst>
       <p:ext uri="{BB962C8B-B14F-4D97-AF65-F5344CB8AC3E}">
-        <p14:creationId xmlns:p14="http://schemas.microsoft.com/office/powerpoint/2010/main" val="719731784"/>
+        <p14:creationId xmlns:p14="http://schemas.microsoft.com/office/powerpoint/2010/main" val="3634179400"/>
       </p:ext>
     </p:extLst>
   </p:cSld>
@@ -5131,7 +5131,7 @@
           <p:cNvPr id="2" name="TextBox 1">
             <a:extLst>
               <a:ext uri="{FF2B5EF4-FFF2-40B4-BE49-F238E27FC236}">
-                <a16:creationId xmlns:a16="http://schemas.microsoft.com/office/drawing/2014/main" id="{A512ED3F-1650-A897-12A0-C0A8E2E2E6CF}"/>
+                <a16:creationId xmlns:a16="http://schemas.microsoft.com/office/drawing/2014/main" id="{407C4733-AA4D-759B-6F6C-62C4F04BEB5C}"/>
               </a:ext>
             </a:extLst>
           </p:cNvPr>
@@ -5176,7 +5176,7 @@
           <p:cNvPr id="3" name="TextBox 2">
             <a:extLst>
               <a:ext uri="{FF2B5EF4-FFF2-40B4-BE49-F238E27FC236}">
-                <a16:creationId xmlns:a16="http://schemas.microsoft.com/office/drawing/2014/main" id="{2E345214-036A-AE64-9C17-03ED3FD53722}"/>
+                <a16:creationId xmlns:a16="http://schemas.microsoft.com/office/drawing/2014/main" id="{335D0336-94BB-868D-644D-210163062735}"/>
               </a:ext>
             </a:extLst>
           </p:cNvPr>
@@ -5222,7 +5222,7 @@
           <p:cNvPr id="4" name="TextBox 3">
             <a:extLst>
               <a:ext uri="{FF2B5EF4-FFF2-40B4-BE49-F238E27FC236}">
-                <a16:creationId xmlns:a16="http://schemas.microsoft.com/office/drawing/2014/main" id="{B83A1794-9817-2255-9460-597E45B095CB}"/>
+                <a16:creationId xmlns:a16="http://schemas.microsoft.com/office/drawing/2014/main" id="{58632CBE-16EC-C551-B78D-1A95732DAEA0}"/>
               </a:ext>
             </a:extLst>
           </p:cNvPr>
@@ -5274,7 +5274,7 @@
           <p:cNvPr id="6" name="Picture 5">
             <a:extLst>
               <a:ext uri="{FF2B5EF4-FFF2-40B4-BE49-F238E27FC236}">
-                <a16:creationId xmlns:a16="http://schemas.microsoft.com/office/drawing/2014/main" id="{9B7D2DD4-32AA-042F-2869-D8FD728BCDDB}"/>
+                <a16:creationId xmlns:a16="http://schemas.microsoft.com/office/drawing/2014/main" id="{B4C8B907-323D-3019-55AE-E0975627B499}"/>
               </a:ext>
             </a:extLst>
           </p:cNvPr>
@@ -5310,7 +5310,7 @@
           <p:cNvPr id="7" name="TextBox 6">
             <a:extLst>
               <a:ext uri="{FF2B5EF4-FFF2-40B4-BE49-F238E27FC236}">
-                <a16:creationId xmlns:a16="http://schemas.microsoft.com/office/drawing/2014/main" id="{2997694D-B5DD-91EB-21CF-DA012080EC4B}"/>
+                <a16:creationId xmlns:a16="http://schemas.microsoft.com/office/drawing/2014/main" id="{EBE2FFE7-6E1D-7E2E-3469-1CCED0098276}"/>
               </a:ext>
             </a:extLst>
           </p:cNvPr>
@@ -5347,7 +5347,7 @@
               </a:rPr>
               <a:t>Hrushikesh Roop Avvari (230249)  /  Voora Rakesh (231174)
 Gokavarapu Manikanta Sri Akshith (230418)
-Lokesh Kumar Moond (230606)  /  Sharath (230303)</a:t>
+Lokesh Kumar Moond (230606)  /  Bollu Sharath chandra (230303)</a:t>
             </a:r>
           </a:p>
         </p:txBody>
@@ -5357,7 +5357,7 @@
           <p:cNvPr id="8" name="TextBox 7">
             <a:extLst>
               <a:ext uri="{FF2B5EF4-FFF2-40B4-BE49-F238E27FC236}">
-                <a16:creationId xmlns:a16="http://schemas.microsoft.com/office/drawing/2014/main" id="{CFDA2127-4BC1-8F03-AF1F-35B42DF38ADB}"/>
+                <a16:creationId xmlns:a16="http://schemas.microsoft.com/office/drawing/2014/main" id="{8027711F-9AB0-F492-76C1-07BF309CC686}"/>
               </a:ext>
             </a:extLst>
           </p:cNvPr>
@@ -5400,7 +5400,7 @@
     </p:spTree>
     <p:extLst>
       <p:ext uri="{BB962C8B-B14F-4D97-AF65-F5344CB8AC3E}">
-        <p14:creationId xmlns:p14="http://schemas.microsoft.com/office/powerpoint/2010/main" val="2838229100"/>
+        <p14:creationId xmlns:p14="http://schemas.microsoft.com/office/powerpoint/2010/main" val="1566570868"/>
       </p:ext>
     </p:extLst>
   </p:cSld>
@@ -5440,7 +5440,7 @@
           <p:cNvPr id="2" name="TextBox 1">
             <a:extLst>
               <a:ext uri="{FF2B5EF4-FFF2-40B4-BE49-F238E27FC236}">
-                <a16:creationId xmlns:a16="http://schemas.microsoft.com/office/drawing/2014/main" id="{A3AE1CED-7637-4EF3-00F6-D76CB8ADF37E}"/>
+                <a16:creationId xmlns:a16="http://schemas.microsoft.com/office/drawing/2014/main" id="{FB4AD9D7-8E71-79A1-60A8-C91925413AD5}"/>
               </a:ext>
             </a:extLst>
           </p:cNvPr>
@@ -5491,7 +5491,7 @@
           <p:cNvPr id="3" name="TextBox 2">
             <a:extLst>
               <a:ext uri="{FF2B5EF4-FFF2-40B4-BE49-F238E27FC236}">
-                <a16:creationId xmlns:a16="http://schemas.microsoft.com/office/drawing/2014/main" id="{3EE48752-3EB9-CEB6-809A-B7A471C94B00}"/>
+                <a16:creationId xmlns:a16="http://schemas.microsoft.com/office/drawing/2014/main" id="{069103D9-AD81-38BF-25F4-5EFD8D975384}"/>
               </a:ext>
             </a:extLst>
           </p:cNvPr>
@@ -5542,7 +5542,7 @@
           <p:cNvPr id="4" name="Table 3">
             <a:extLst>
               <a:ext uri="{FF2B5EF4-FFF2-40B4-BE49-F238E27FC236}">
-                <a16:creationId xmlns:a16="http://schemas.microsoft.com/office/drawing/2014/main" id="{4420A0CF-8166-CE4E-A224-9C7C567ED3D1}"/>
+                <a16:creationId xmlns:a16="http://schemas.microsoft.com/office/drawing/2014/main" id="{FEDE8126-AB7E-FA54-2A8B-855C1496243D}"/>
               </a:ext>
             </a:extLst>
           </p:cNvPr>
@@ -5552,7 +5552,7 @@
           <p:nvPr>
             <p:extLst>
               <p:ext uri="{D42A27DB-BD31-4B8C-83A1-F6EECF244321}">
-                <p14:modId xmlns:p14="http://schemas.microsoft.com/office/powerpoint/2010/main" val="1177215710"/>
+                <p14:modId xmlns:p14="http://schemas.microsoft.com/office/powerpoint/2010/main" val="2037736763"/>
               </p:ext>
             </p:extLst>
           </p:nvPr>
@@ -5571,21 +5571,21 @@
                 <a:gridCol w="3810000">
                   <a:extLst>
                     <a:ext uri="{9D8B030D-6E8A-4147-A177-3AD203B41FA5}">
-                      <a16:colId xmlns:a16="http://schemas.microsoft.com/office/drawing/2014/main" val="1318158259"/>
+                      <a16:colId xmlns:a16="http://schemas.microsoft.com/office/drawing/2014/main" val="2649988353"/>
                     </a:ext>
                   </a:extLst>
                 </a:gridCol>
                 <a:gridCol w="2286000">
                   <a:extLst>
                     <a:ext uri="{9D8B030D-6E8A-4147-A177-3AD203B41FA5}">
-                      <a16:colId xmlns:a16="http://schemas.microsoft.com/office/drawing/2014/main" val="392563919"/>
+                      <a16:colId xmlns:a16="http://schemas.microsoft.com/office/drawing/2014/main" val="1761715499"/>
                     </a:ext>
                   </a:extLst>
                 </a:gridCol>
                 <a:gridCol w="4826000">
                   <a:extLst>
                     <a:ext uri="{9D8B030D-6E8A-4147-A177-3AD203B41FA5}">
-                      <a16:colId xmlns:a16="http://schemas.microsoft.com/office/drawing/2014/main" val="1719317968"/>
+                      <a16:colId xmlns:a16="http://schemas.microsoft.com/office/drawing/2014/main" val="3074253730"/>
                     </a:ext>
                   </a:extLst>
                 </a:gridCol>
@@ -5719,7 +5719,7 @@
                 </a:tc>
                 <a:extLst>
                   <a:ext uri="{0D108BD9-81ED-4DB2-BD59-A6C34878D82A}">
-                    <a16:rowId xmlns:a16="http://schemas.microsoft.com/office/drawing/2014/main" val="2529469606"/>
+                    <a16:rowId xmlns:a16="http://schemas.microsoft.com/office/drawing/2014/main" val="3405473579"/>
                   </a:ext>
                 </a:extLst>
               </a:tr>
@@ -5852,7 +5852,7 @@
                 </a:tc>
                 <a:extLst>
                   <a:ext uri="{0D108BD9-81ED-4DB2-BD59-A6C34878D82A}">
-                    <a16:rowId xmlns:a16="http://schemas.microsoft.com/office/drawing/2014/main" val="2906696692"/>
+                    <a16:rowId xmlns:a16="http://schemas.microsoft.com/office/drawing/2014/main" val="1096819625"/>
                   </a:ext>
                 </a:extLst>
               </a:tr>
@@ -5985,7 +5985,7 @@
                 </a:tc>
                 <a:extLst>
                   <a:ext uri="{0D108BD9-81ED-4DB2-BD59-A6C34878D82A}">
-                    <a16:rowId xmlns:a16="http://schemas.microsoft.com/office/drawing/2014/main" val="3681396691"/>
+                    <a16:rowId xmlns:a16="http://schemas.microsoft.com/office/drawing/2014/main" val="3045006925"/>
                   </a:ext>
                 </a:extLst>
               </a:tr>
@@ -6118,7 +6118,7 @@
                 </a:tc>
                 <a:extLst>
                   <a:ext uri="{0D108BD9-81ED-4DB2-BD59-A6C34878D82A}">
-                    <a16:rowId xmlns:a16="http://schemas.microsoft.com/office/drawing/2014/main" val="2689524873"/>
+                    <a16:rowId xmlns:a16="http://schemas.microsoft.com/office/drawing/2014/main" val="4086029323"/>
                   </a:ext>
                 </a:extLst>
               </a:tr>
@@ -6251,7 +6251,7 @@
                 </a:tc>
                 <a:extLst>
                   <a:ext uri="{0D108BD9-81ED-4DB2-BD59-A6C34878D82A}">
-                    <a16:rowId xmlns:a16="http://schemas.microsoft.com/office/drawing/2014/main" val="1695482550"/>
+                    <a16:rowId xmlns:a16="http://schemas.microsoft.com/office/drawing/2014/main" val="6643461"/>
                   </a:ext>
                 </a:extLst>
               </a:tr>
@@ -6384,7 +6384,7 @@
                 </a:tc>
                 <a:extLst>
                   <a:ext uri="{0D108BD9-81ED-4DB2-BD59-A6C34878D82A}">
-                    <a16:rowId xmlns:a16="http://schemas.microsoft.com/office/drawing/2014/main" val="247883380"/>
+                    <a16:rowId xmlns:a16="http://schemas.microsoft.com/office/drawing/2014/main" val="1876782901"/>
                   </a:ext>
                 </a:extLst>
               </a:tr>
@@ -6397,7 +6397,7 @@
           <p:cNvPr id="5" name="TextBox 4">
             <a:extLst>
               <a:ext uri="{FF2B5EF4-FFF2-40B4-BE49-F238E27FC236}">
-                <a16:creationId xmlns:a16="http://schemas.microsoft.com/office/drawing/2014/main" id="{92C05C1A-C42F-DC43-2209-77475F6894A0}"/>
+                <a16:creationId xmlns:a16="http://schemas.microsoft.com/office/drawing/2014/main" id="{D49EEE81-39F8-FEDE-63A9-65ACC80DCFFA}"/>
               </a:ext>
             </a:extLst>
           </p:cNvPr>
@@ -6448,7 +6448,7 @@
           <p:cNvPr id="6" name="TextBox 5">
             <a:extLst>
               <a:ext uri="{FF2B5EF4-FFF2-40B4-BE49-F238E27FC236}">
-                <a16:creationId xmlns:a16="http://schemas.microsoft.com/office/drawing/2014/main" id="{AA90BDBE-8BE0-EA4C-B8A3-175D64D0BEB0}"/>
+                <a16:creationId xmlns:a16="http://schemas.microsoft.com/office/drawing/2014/main" id="{88EF36A9-2D50-7DE1-E339-8471EA02B10E}"/>
               </a:ext>
             </a:extLst>
           </p:cNvPr>
@@ -6493,7 +6493,7 @@
           <p:cNvPr id="7" name="TextBox 6">
             <a:extLst>
               <a:ext uri="{FF2B5EF4-FFF2-40B4-BE49-F238E27FC236}">
-                <a16:creationId xmlns:a16="http://schemas.microsoft.com/office/drawing/2014/main" id="{D5452298-B9B2-3A6F-6507-6FDF50965A41}"/>
+                <a16:creationId xmlns:a16="http://schemas.microsoft.com/office/drawing/2014/main" id="{347F5C57-9E97-5439-1E80-D0032DF4FFBC}"/>
               </a:ext>
             </a:extLst>
           </p:cNvPr>
@@ -6536,7 +6536,7 @@
     </p:spTree>
     <p:extLst>
       <p:ext uri="{BB962C8B-B14F-4D97-AF65-F5344CB8AC3E}">
-        <p14:creationId xmlns:p14="http://schemas.microsoft.com/office/powerpoint/2010/main" val="3127543949"/>
+        <p14:creationId xmlns:p14="http://schemas.microsoft.com/office/powerpoint/2010/main" val="725490730"/>
       </p:ext>
     </p:extLst>
   </p:cSld>
@@ -6576,7 +6576,7 @@
           <p:cNvPr id="2" name="TextBox 1">
             <a:extLst>
               <a:ext uri="{FF2B5EF4-FFF2-40B4-BE49-F238E27FC236}">
-                <a16:creationId xmlns:a16="http://schemas.microsoft.com/office/drawing/2014/main" id="{DA09D009-5977-94AF-BA06-B19F096B0DBF}"/>
+                <a16:creationId xmlns:a16="http://schemas.microsoft.com/office/drawing/2014/main" id="{B8A51C51-CCDC-7F45-750E-64025DF14F95}"/>
               </a:ext>
             </a:extLst>
           </p:cNvPr>
@@ -6621,7 +6621,7 @@
           <p:cNvPr id="3" name="TextBox 2">
             <a:extLst>
               <a:ext uri="{FF2B5EF4-FFF2-40B4-BE49-F238E27FC236}">
-                <a16:creationId xmlns:a16="http://schemas.microsoft.com/office/drawing/2014/main" id="{1D148D85-53D1-60B1-A09C-C1B7FBCE4459}"/>
+                <a16:creationId xmlns:a16="http://schemas.microsoft.com/office/drawing/2014/main" id="{CEA0BE99-1F89-5735-A9E9-C0E36289DDB0}"/>
               </a:ext>
             </a:extLst>
           </p:cNvPr>
@@ -6672,7 +6672,7 @@
           <p:cNvPr id="4" name="Table 3">
             <a:extLst>
               <a:ext uri="{FF2B5EF4-FFF2-40B4-BE49-F238E27FC236}">
-                <a16:creationId xmlns:a16="http://schemas.microsoft.com/office/drawing/2014/main" id="{87F1EFEF-E5A7-B09B-30C5-AE7CE9ABCEFC}"/>
+                <a16:creationId xmlns:a16="http://schemas.microsoft.com/office/drawing/2014/main" id="{775560BE-3BF2-FFA4-EAC1-0C9AAB751A20}"/>
               </a:ext>
             </a:extLst>
           </p:cNvPr>
@@ -6682,7 +6682,7 @@
           <p:nvPr>
             <p:extLst>
               <p:ext uri="{D42A27DB-BD31-4B8C-83A1-F6EECF244321}">
-                <p14:modId xmlns:p14="http://schemas.microsoft.com/office/powerpoint/2010/main" val="3745530732"/>
+                <p14:modId xmlns:p14="http://schemas.microsoft.com/office/powerpoint/2010/main" val="1942794517"/>
               </p:ext>
             </p:extLst>
           </p:nvPr>
@@ -6701,35 +6701,35 @@
                 <a:gridCol w="3302000">
                   <a:extLst>
                     <a:ext uri="{9D8B030D-6E8A-4147-A177-3AD203B41FA5}">
-                      <a16:colId xmlns:a16="http://schemas.microsoft.com/office/drawing/2014/main" val="1220213133"/>
+                      <a16:colId xmlns:a16="http://schemas.microsoft.com/office/drawing/2014/main" val="2739273257"/>
                     </a:ext>
                   </a:extLst>
                 </a:gridCol>
                 <a:gridCol w="1905000">
                   <a:extLst>
                     <a:ext uri="{9D8B030D-6E8A-4147-A177-3AD203B41FA5}">
-                      <a16:colId xmlns:a16="http://schemas.microsoft.com/office/drawing/2014/main" val="578638584"/>
+                      <a16:colId xmlns:a16="http://schemas.microsoft.com/office/drawing/2014/main" val="65077783"/>
                     </a:ext>
                   </a:extLst>
                 </a:gridCol>
                 <a:gridCol w="1905000">
                   <a:extLst>
                     <a:ext uri="{9D8B030D-6E8A-4147-A177-3AD203B41FA5}">
-                      <a16:colId xmlns:a16="http://schemas.microsoft.com/office/drawing/2014/main" val="2220236956"/>
+                      <a16:colId xmlns:a16="http://schemas.microsoft.com/office/drawing/2014/main" val="941637770"/>
                     </a:ext>
                   </a:extLst>
                 </a:gridCol>
                 <a:gridCol w="1905000">
                   <a:extLst>
                     <a:ext uri="{9D8B030D-6E8A-4147-A177-3AD203B41FA5}">
-                      <a16:colId xmlns:a16="http://schemas.microsoft.com/office/drawing/2014/main" val="3433233931"/>
+                      <a16:colId xmlns:a16="http://schemas.microsoft.com/office/drawing/2014/main" val="1429278253"/>
                     </a:ext>
                   </a:extLst>
                 </a:gridCol>
                 <a:gridCol w="1905000">
                   <a:extLst>
                     <a:ext uri="{9D8B030D-6E8A-4147-A177-3AD203B41FA5}">
-                      <a16:colId xmlns:a16="http://schemas.microsoft.com/office/drawing/2014/main" val="3830974525"/>
+                      <a16:colId xmlns:a16="http://schemas.microsoft.com/office/drawing/2014/main" val="1817886993"/>
                     </a:ext>
                   </a:extLst>
                 </a:gridCol>
@@ -6947,7 +6947,7 @@
                 </a:tc>
                 <a:extLst>
                   <a:ext uri="{0D108BD9-81ED-4DB2-BD59-A6C34878D82A}">
-                    <a16:rowId xmlns:a16="http://schemas.microsoft.com/office/drawing/2014/main" val="3376695512"/>
+                    <a16:rowId xmlns:a16="http://schemas.microsoft.com/office/drawing/2014/main" val="4169113435"/>
                   </a:ext>
                 </a:extLst>
               </a:tr>
@@ -7164,7 +7164,7 @@
                 </a:tc>
                 <a:extLst>
                   <a:ext uri="{0D108BD9-81ED-4DB2-BD59-A6C34878D82A}">
-                    <a16:rowId xmlns:a16="http://schemas.microsoft.com/office/drawing/2014/main" val="2333021820"/>
+                    <a16:rowId xmlns:a16="http://schemas.microsoft.com/office/drawing/2014/main" val="3382521347"/>
                   </a:ext>
                 </a:extLst>
               </a:tr>
@@ -7381,7 +7381,7 @@
                 </a:tc>
                 <a:extLst>
                   <a:ext uri="{0D108BD9-81ED-4DB2-BD59-A6C34878D82A}">
-                    <a16:rowId xmlns:a16="http://schemas.microsoft.com/office/drawing/2014/main" val="1264617560"/>
+                    <a16:rowId xmlns:a16="http://schemas.microsoft.com/office/drawing/2014/main" val="503023023"/>
                   </a:ext>
                 </a:extLst>
               </a:tr>
@@ -7598,7 +7598,7 @@
                 </a:tc>
                 <a:extLst>
                   <a:ext uri="{0D108BD9-81ED-4DB2-BD59-A6C34878D82A}">
-                    <a16:rowId xmlns:a16="http://schemas.microsoft.com/office/drawing/2014/main" val="2531557295"/>
+                    <a16:rowId xmlns:a16="http://schemas.microsoft.com/office/drawing/2014/main" val="2603615563"/>
                   </a:ext>
                 </a:extLst>
               </a:tr>
@@ -7815,7 +7815,7 @@
                 </a:tc>
                 <a:extLst>
                   <a:ext uri="{0D108BD9-81ED-4DB2-BD59-A6C34878D82A}">
-                    <a16:rowId xmlns:a16="http://schemas.microsoft.com/office/drawing/2014/main" val="257310939"/>
+                    <a16:rowId xmlns:a16="http://schemas.microsoft.com/office/drawing/2014/main" val="3258060934"/>
                   </a:ext>
                 </a:extLst>
               </a:tr>
@@ -7828,7 +7828,7 @@
           <p:cNvPr id="5" name="TextBox 4">
             <a:extLst>
               <a:ext uri="{FF2B5EF4-FFF2-40B4-BE49-F238E27FC236}">
-                <a16:creationId xmlns:a16="http://schemas.microsoft.com/office/drawing/2014/main" id="{16D2D64E-9CCF-30C8-6598-3E1BAB74936B}"/>
+                <a16:creationId xmlns:a16="http://schemas.microsoft.com/office/drawing/2014/main" id="{386335B0-56BF-D565-49A8-02DFDCEFF48E}"/>
               </a:ext>
             </a:extLst>
           </p:cNvPr>
@@ -7879,7 +7879,7 @@
           <p:cNvPr id="6" name="TextBox 5">
             <a:extLst>
               <a:ext uri="{FF2B5EF4-FFF2-40B4-BE49-F238E27FC236}">
-                <a16:creationId xmlns:a16="http://schemas.microsoft.com/office/drawing/2014/main" id="{9668968F-6323-816E-8A55-9DF05429715E}"/>
+                <a16:creationId xmlns:a16="http://schemas.microsoft.com/office/drawing/2014/main" id="{33BD448F-1047-9491-D85D-CACD399D9B0C}"/>
               </a:ext>
             </a:extLst>
           </p:cNvPr>
@@ -7924,7 +7924,7 @@
           <p:cNvPr id="7" name="TextBox 6">
             <a:extLst>
               <a:ext uri="{FF2B5EF4-FFF2-40B4-BE49-F238E27FC236}">
-                <a16:creationId xmlns:a16="http://schemas.microsoft.com/office/drawing/2014/main" id="{88C1FD88-2A81-852B-59C4-66CA9DC49E5A}"/>
+                <a16:creationId xmlns:a16="http://schemas.microsoft.com/office/drawing/2014/main" id="{B1F08C2D-5DB3-A175-B4EA-76D8898631E0}"/>
               </a:ext>
             </a:extLst>
           </p:cNvPr>
@@ -7967,7 +7967,7 @@
     </p:spTree>
     <p:extLst>
       <p:ext uri="{BB962C8B-B14F-4D97-AF65-F5344CB8AC3E}">
-        <p14:creationId xmlns:p14="http://schemas.microsoft.com/office/powerpoint/2010/main" val="993026198"/>
+        <p14:creationId xmlns:p14="http://schemas.microsoft.com/office/powerpoint/2010/main" val="926385323"/>
       </p:ext>
     </p:extLst>
   </p:cSld>
@@ -8007,7 +8007,7 @@
           <p:cNvPr id="2" name="TextBox 1">
             <a:extLst>
               <a:ext uri="{FF2B5EF4-FFF2-40B4-BE49-F238E27FC236}">
-                <a16:creationId xmlns:a16="http://schemas.microsoft.com/office/drawing/2014/main" id="{1B89FBD7-82D9-862A-60CC-E8533D8C2D28}"/>
+                <a16:creationId xmlns:a16="http://schemas.microsoft.com/office/drawing/2014/main" id="{DC46EF72-7AE0-7C81-026B-D7C96FE42B67}"/>
               </a:ext>
             </a:extLst>
           </p:cNvPr>
@@ -8058,7 +8058,7 @@
           <p:cNvPr id="3" name="TextBox 2">
             <a:extLst>
               <a:ext uri="{FF2B5EF4-FFF2-40B4-BE49-F238E27FC236}">
-                <a16:creationId xmlns:a16="http://schemas.microsoft.com/office/drawing/2014/main" id="{70ABA883-094B-4DFF-DCC1-C7B7B0E8178A}"/>
+                <a16:creationId xmlns:a16="http://schemas.microsoft.com/office/drawing/2014/main" id="{82CF64F8-62DB-5B14-24E0-1C50C932ED3F}"/>
               </a:ext>
             </a:extLst>
           </p:cNvPr>
@@ -8109,7 +8109,7 @@
           <p:cNvPr id="4" name="TextBox 3">
             <a:extLst>
               <a:ext uri="{FF2B5EF4-FFF2-40B4-BE49-F238E27FC236}">
-                <a16:creationId xmlns:a16="http://schemas.microsoft.com/office/drawing/2014/main" id="{D88F9F1A-AE43-2FC4-1FDD-853FC6890388}"/>
+                <a16:creationId xmlns:a16="http://schemas.microsoft.com/office/drawing/2014/main" id="{DE735362-3608-E572-4C5B-899D0B7BCFC3}"/>
               </a:ext>
             </a:extLst>
           </p:cNvPr>
@@ -8162,7 +8162,7 @@
           <p:cNvPr id="5" name="TextBox 4">
             <a:extLst>
               <a:ext uri="{FF2B5EF4-FFF2-40B4-BE49-F238E27FC236}">
-                <a16:creationId xmlns:a16="http://schemas.microsoft.com/office/drawing/2014/main" id="{79F3F2D7-FC14-DBA3-6A8A-AB778C57ABD9}"/>
+                <a16:creationId xmlns:a16="http://schemas.microsoft.com/office/drawing/2014/main" id="{5AA513A6-EDE9-C456-DA68-1C2BE5388936}"/>
               </a:ext>
             </a:extLst>
           </p:cNvPr>
@@ -8214,7 +8214,7 @@
           <p:cNvPr id="6" name="Table 5">
             <a:extLst>
               <a:ext uri="{FF2B5EF4-FFF2-40B4-BE49-F238E27FC236}">
-                <a16:creationId xmlns:a16="http://schemas.microsoft.com/office/drawing/2014/main" id="{F804803D-F63A-EA2C-353C-3F5904CB55D4}"/>
+                <a16:creationId xmlns:a16="http://schemas.microsoft.com/office/drawing/2014/main" id="{32DCCE35-84CC-4B07-85CD-943E06DCCFDA}"/>
               </a:ext>
             </a:extLst>
           </p:cNvPr>
@@ -8224,7 +8224,7 @@
           <p:nvPr>
             <p:extLst>
               <p:ext uri="{D42A27DB-BD31-4B8C-83A1-F6EECF244321}">
-                <p14:modId xmlns:p14="http://schemas.microsoft.com/office/powerpoint/2010/main" val="372680739"/>
+                <p14:modId xmlns:p14="http://schemas.microsoft.com/office/powerpoint/2010/main" val="2126110360"/>
               </p:ext>
             </p:extLst>
           </p:nvPr>
@@ -8243,21 +8243,21 @@
                 <a:gridCol w="2540000">
                   <a:extLst>
                     <a:ext uri="{9D8B030D-6E8A-4147-A177-3AD203B41FA5}">
-                      <a16:colId xmlns:a16="http://schemas.microsoft.com/office/drawing/2014/main" val="3999907509"/>
+                      <a16:colId xmlns:a16="http://schemas.microsoft.com/office/drawing/2014/main" val="2618060527"/>
                     </a:ext>
                   </a:extLst>
                 </a:gridCol>
                 <a:gridCol w="1397000">
                   <a:extLst>
                     <a:ext uri="{9D8B030D-6E8A-4147-A177-3AD203B41FA5}">
-                      <a16:colId xmlns:a16="http://schemas.microsoft.com/office/drawing/2014/main" val="1963920576"/>
+                      <a16:colId xmlns:a16="http://schemas.microsoft.com/office/drawing/2014/main" val="3664664571"/>
                     </a:ext>
                   </a:extLst>
                 </a:gridCol>
                 <a:gridCol w="1397000">
                   <a:extLst>
                     <a:ext uri="{9D8B030D-6E8A-4147-A177-3AD203B41FA5}">
-                      <a16:colId xmlns:a16="http://schemas.microsoft.com/office/drawing/2014/main" val="1299044863"/>
+                      <a16:colId xmlns:a16="http://schemas.microsoft.com/office/drawing/2014/main" val="1885036282"/>
                     </a:ext>
                   </a:extLst>
                 </a:gridCol>
@@ -8391,7 +8391,7 @@
                 </a:tc>
                 <a:extLst>
                   <a:ext uri="{0D108BD9-81ED-4DB2-BD59-A6C34878D82A}">
-                    <a16:rowId xmlns:a16="http://schemas.microsoft.com/office/drawing/2014/main" val="2430294862"/>
+                    <a16:rowId xmlns:a16="http://schemas.microsoft.com/office/drawing/2014/main" val="424345035"/>
                   </a:ext>
                 </a:extLst>
               </a:tr>
@@ -8524,7 +8524,7 @@
                 </a:tc>
                 <a:extLst>
                   <a:ext uri="{0D108BD9-81ED-4DB2-BD59-A6C34878D82A}">
-                    <a16:rowId xmlns:a16="http://schemas.microsoft.com/office/drawing/2014/main" val="1027262477"/>
+                    <a16:rowId xmlns:a16="http://schemas.microsoft.com/office/drawing/2014/main" val="2068128936"/>
                   </a:ext>
                 </a:extLst>
               </a:tr>
@@ -8657,7 +8657,7 @@
                 </a:tc>
                 <a:extLst>
                   <a:ext uri="{0D108BD9-81ED-4DB2-BD59-A6C34878D82A}">
-                    <a16:rowId xmlns:a16="http://schemas.microsoft.com/office/drawing/2014/main" val="4207949571"/>
+                    <a16:rowId xmlns:a16="http://schemas.microsoft.com/office/drawing/2014/main" val="3330602198"/>
                   </a:ext>
                 </a:extLst>
               </a:tr>
@@ -8670,7 +8670,7 @@
           <p:cNvPr id="7" name="TextBox 6">
             <a:extLst>
               <a:ext uri="{FF2B5EF4-FFF2-40B4-BE49-F238E27FC236}">
-                <a16:creationId xmlns:a16="http://schemas.microsoft.com/office/drawing/2014/main" id="{8499B071-3A07-1399-5D92-D0355502E9E5}"/>
+                <a16:creationId xmlns:a16="http://schemas.microsoft.com/office/drawing/2014/main" id="{ABBAC63F-62D3-9846-5241-EC050CB7BBD4}"/>
               </a:ext>
             </a:extLst>
           </p:cNvPr>
@@ -8721,7 +8721,7 @@
           <p:cNvPr id="8" name="TextBox 7">
             <a:extLst>
               <a:ext uri="{FF2B5EF4-FFF2-40B4-BE49-F238E27FC236}">
-                <a16:creationId xmlns:a16="http://schemas.microsoft.com/office/drawing/2014/main" id="{A72991C2-5068-5692-291E-A94AD3B04B90}"/>
+                <a16:creationId xmlns:a16="http://schemas.microsoft.com/office/drawing/2014/main" id="{50DB733F-04F1-971B-4551-5887A3C877CB}"/>
               </a:ext>
             </a:extLst>
           </p:cNvPr>
@@ -8766,7 +8766,7 @@
           <p:cNvPr id="9" name="TextBox 8">
             <a:extLst>
               <a:ext uri="{FF2B5EF4-FFF2-40B4-BE49-F238E27FC236}">
-                <a16:creationId xmlns:a16="http://schemas.microsoft.com/office/drawing/2014/main" id="{EE440815-7D55-9291-C934-6141E0819D72}"/>
+                <a16:creationId xmlns:a16="http://schemas.microsoft.com/office/drawing/2014/main" id="{A5434A2E-115A-4F04-70FC-E8B062880203}"/>
               </a:ext>
             </a:extLst>
           </p:cNvPr>
@@ -8809,7 +8809,7 @@
     </p:spTree>
     <p:extLst>
       <p:ext uri="{BB962C8B-B14F-4D97-AF65-F5344CB8AC3E}">
-        <p14:creationId xmlns:p14="http://schemas.microsoft.com/office/powerpoint/2010/main" val="2257365528"/>
+        <p14:creationId xmlns:p14="http://schemas.microsoft.com/office/powerpoint/2010/main" val="406171598"/>
       </p:ext>
     </p:extLst>
   </p:cSld>
@@ -8849,7 +8849,7 @@
           <p:cNvPr id="2" name="TextBox 1">
             <a:extLst>
               <a:ext uri="{FF2B5EF4-FFF2-40B4-BE49-F238E27FC236}">
-                <a16:creationId xmlns:a16="http://schemas.microsoft.com/office/drawing/2014/main" id="{2D466AC5-A920-8418-8A47-9BD19594FC24}"/>
+                <a16:creationId xmlns:a16="http://schemas.microsoft.com/office/drawing/2014/main" id="{BF6AA58D-EA17-104E-58A8-9D0ABA27B120}"/>
               </a:ext>
             </a:extLst>
           </p:cNvPr>
@@ -8900,7 +8900,7 @@
           <p:cNvPr id="3" name="TextBox 2">
             <a:extLst>
               <a:ext uri="{FF2B5EF4-FFF2-40B4-BE49-F238E27FC236}">
-                <a16:creationId xmlns:a16="http://schemas.microsoft.com/office/drawing/2014/main" id="{9BD1A495-778F-EBFB-D967-6D7A65F5CFCB}"/>
+                <a16:creationId xmlns:a16="http://schemas.microsoft.com/office/drawing/2014/main" id="{5E01607C-61AE-A275-BB33-94CAFC43B88B}"/>
               </a:ext>
             </a:extLst>
           </p:cNvPr>
@@ -8951,7 +8951,7 @@
           <p:cNvPr id="5" name="Picture 4">
             <a:extLst>
               <a:ext uri="{FF2B5EF4-FFF2-40B4-BE49-F238E27FC236}">
-                <a16:creationId xmlns:a16="http://schemas.microsoft.com/office/drawing/2014/main" id="{001F64E5-EF3F-2CD7-974C-C0F9988C5773}"/>
+                <a16:creationId xmlns:a16="http://schemas.microsoft.com/office/drawing/2014/main" id="{7D681922-B4E8-B6F8-9E2A-1FD7A7FA9975}"/>
               </a:ext>
             </a:extLst>
           </p:cNvPr>
@@ -8987,7 +8987,7 @@
           <p:cNvPr id="6" name="TextBox 5">
             <a:extLst>
               <a:ext uri="{FF2B5EF4-FFF2-40B4-BE49-F238E27FC236}">
-                <a16:creationId xmlns:a16="http://schemas.microsoft.com/office/drawing/2014/main" id="{C0D09CE3-CFC2-4BE3-C5F9-D26747610D46}"/>
+                <a16:creationId xmlns:a16="http://schemas.microsoft.com/office/drawing/2014/main" id="{2BB9E75B-2C25-81DC-4A2D-D2CC81CEFB40}"/>
               </a:ext>
             </a:extLst>
           </p:cNvPr>
@@ -9038,7 +9038,7 @@
           <p:cNvPr id="7" name="TextBox 6">
             <a:extLst>
               <a:ext uri="{FF2B5EF4-FFF2-40B4-BE49-F238E27FC236}">
-                <a16:creationId xmlns:a16="http://schemas.microsoft.com/office/drawing/2014/main" id="{EF5496D2-228E-B235-50C8-654B24FEDFDB}"/>
+                <a16:creationId xmlns:a16="http://schemas.microsoft.com/office/drawing/2014/main" id="{3F40CEB0-8C17-4DC9-B9F5-5C395FB0C93D}"/>
               </a:ext>
             </a:extLst>
           </p:cNvPr>
@@ -9083,7 +9083,7 @@
           <p:cNvPr id="8" name="TextBox 7">
             <a:extLst>
               <a:ext uri="{FF2B5EF4-FFF2-40B4-BE49-F238E27FC236}">
-                <a16:creationId xmlns:a16="http://schemas.microsoft.com/office/drawing/2014/main" id="{FFC0679D-A331-17B2-07E9-C9F8B48536AC}"/>
+                <a16:creationId xmlns:a16="http://schemas.microsoft.com/office/drawing/2014/main" id="{DF5226E7-CD3D-5F43-3E21-FB7A7CC0A3E8}"/>
               </a:ext>
             </a:extLst>
           </p:cNvPr>
@@ -9126,7 +9126,7 @@
     </p:spTree>
     <p:extLst>
       <p:ext uri="{BB962C8B-B14F-4D97-AF65-F5344CB8AC3E}">
-        <p14:creationId xmlns:p14="http://schemas.microsoft.com/office/powerpoint/2010/main" val="3617846772"/>
+        <p14:creationId xmlns:p14="http://schemas.microsoft.com/office/powerpoint/2010/main" val="948567507"/>
       </p:ext>
     </p:extLst>
   </p:cSld>
@@ -9166,7 +9166,7 @@
           <p:cNvPr id="2" name="TextBox 1">
             <a:extLst>
               <a:ext uri="{FF2B5EF4-FFF2-40B4-BE49-F238E27FC236}">
-                <a16:creationId xmlns:a16="http://schemas.microsoft.com/office/drawing/2014/main" id="{C55E80F4-8FED-A408-0A7A-0962FCDD91FE}"/>
+                <a16:creationId xmlns:a16="http://schemas.microsoft.com/office/drawing/2014/main" id="{440715CB-EE41-7DB0-735C-E87B416A909C}"/>
               </a:ext>
             </a:extLst>
           </p:cNvPr>
@@ -9211,7 +9211,7 @@
           <p:cNvPr id="3" name="TextBox 2">
             <a:extLst>
               <a:ext uri="{FF2B5EF4-FFF2-40B4-BE49-F238E27FC236}">
-                <a16:creationId xmlns:a16="http://schemas.microsoft.com/office/drawing/2014/main" id="{55E2395D-5C35-1217-89BA-B2C5EC253A3F}"/>
+                <a16:creationId xmlns:a16="http://schemas.microsoft.com/office/drawing/2014/main" id="{6F240D2A-3764-401D-6563-6219997E1A40}"/>
               </a:ext>
             </a:extLst>
           </p:cNvPr>
@@ -9262,7 +9262,7 @@
           <p:cNvPr id="5" name="Picture 4">
             <a:extLst>
               <a:ext uri="{FF2B5EF4-FFF2-40B4-BE49-F238E27FC236}">
-                <a16:creationId xmlns:a16="http://schemas.microsoft.com/office/drawing/2014/main" id="{0E691191-716D-F694-B8C0-DF927A7A7D74}"/>
+                <a16:creationId xmlns:a16="http://schemas.microsoft.com/office/drawing/2014/main" id="{BC8366F7-1E29-F924-6C3C-7DBFEC30DC0F}"/>
               </a:ext>
             </a:extLst>
           </p:cNvPr>
@@ -9298,7 +9298,7 @@
           <p:cNvPr id="6" name="TextBox 5">
             <a:extLst>
               <a:ext uri="{FF2B5EF4-FFF2-40B4-BE49-F238E27FC236}">
-                <a16:creationId xmlns:a16="http://schemas.microsoft.com/office/drawing/2014/main" id="{1CCF43B4-58DE-F49C-D912-98C2B5C7D03A}"/>
+                <a16:creationId xmlns:a16="http://schemas.microsoft.com/office/drawing/2014/main" id="{8B8A8916-768B-5B5C-85F7-C45D34E3AAEF}"/>
               </a:ext>
             </a:extLst>
           </p:cNvPr>
@@ -9343,7 +9343,7 @@
           <p:cNvPr id="7" name="TextBox 6">
             <a:extLst>
               <a:ext uri="{FF2B5EF4-FFF2-40B4-BE49-F238E27FC236}">
-                <a16:creationId xmlns:a16="http://schemas.microsoft.com/office/drawing/2014/main" id="{B1272838-C23D-A248-A45A-8E506064B8F4}"/>
+                <a16:creationId xmlns:a16="http://schemas.microsoft.com/office/drawing/2014/main" id="{585C88E0-B5D5-AB15-8439-32FAC593B5B3}"/>
               </a:ext>
             </a:extLst>
           </p:cNvPr>
@@ -9386,7 +9386,7 @@
     </p:spTree>
     <p:extLst>
       <p:ext uri="{BB962C8B-B14F-4D97-AF65-F5344CB8AC3E}">
-        <p14:creationId xmlns:p14="http://schemas.microsoft.com/office/powerpoint/2010/main" val="239801929"/>
+        <p14:creationId xmlns:p14="http://schemas.microsoft.com/office/powerpoint/2010/main" val="2330640665"/>
       </p:ext>
     </p:extLst>
   </p:cSld>
@@ -9426,7 +9426,7 @@
           <p:cNvPr id="2" name="TextBox 1">
             <a:extLst>
               <a:ext uri="{FF2B5EF4-FFF2-40B4-BE49-F238E27FC236}">
-                <a16:creationId xmlns:a16="http://schemas.microsoft.com/office/drawing/2014/main" id="{E91EDC7D-0557-179D-5D6E-6882E0C4B96B}"/>
+                <a16:creationId xmlns:a16="http://schemas.microsoft.com/office/drawing/2014/main" id="{0C6729B1-FDD6-9E03-AF34-D9A4D1D75D81}"/>
               </a:ext>
             </a:extLst>
           </p:cNvPr>
@@ -9471,7 +9471,7 @@
           <p:cNvPr id="3" name="TextBox 2">
             <a:extLst>
               <a:ext uri="{FF2B5EF4-FFF2-40B4-BE49-F238E27FC236}">
-                <a16:creationId xmlns:a16="http://schemas.microsoft.com/office/drawing/2014/main" id="{89B8BD77-FE4C-C63B-5F81-A2EA901C1116}"/>
+                <a16:creationId xmlns:a16="http://schemas.microsoft.com/office/drawing/2014/main" id="{66DED1D0-82AD-D174-9225-FA252A9662DF}"/>
               </a:ext>
             </a:extLst>
           </p:cNvPr>
@@ -9522,7 +9522,7 @@
           <p:cNvPr id="4" name="TextBox 3">
             <a:extLst>
               <a:ext uri="{FF2B5EF4-FFF2-40B4-BE49-F238E27FC236}">
-                <a16:creationId xmlns:a16="http://schemas.microsoft.com/office/drawing/2014/main" id="{40B055B8-64AD-CCEF-2C95-44C626270929}"/>
+                <a16:creationId xmlns:a16="http://schemas.microsoft.com/office/drawing/2014/main" id="{AC5A8350-DFD2-14DD-3125-5C012865D225}"/>
               </a:ext>
             </a:extLst>
           </p:cNvPr>
@@ -9567,7 +9567,7 @@
           <p:cNvPr id="5" name="TextBox 4">
             <a:extLst>
               <a:ext uri="{FF2B5EF4-FFF2-40B4-BE49-F238E27FC236}">
-                <a16:creationId xmlns:a16="http://schemas.microsoft.com/office/drawing/2014/main" id="{0F911C7E-6DD9-EC75-1CDC-59E5A17EAE2C}"/>
+                <a16:creationId xmlns:a16="http://schemas.microsoft.com/office/drawing/2014/main" id="{1362987D-A8F0-8EFA-E709-EDFE1CF6AE71}"/>
               </a:ext>
             </a:extLst>
           </p:cNvPr>
@@ -9618,7 +9618,7 @@
           <p:cNvPr id="6" name="TextBox 5">
             <a:extLst>
               <a:ext uri="{FF2B5EF4-FFF2-40B4-BE49-F238E27FC236}">
-                <a16:creationId xmlns:a16="http://schemas.microsoft.com/office/drawing/2014/main" id="{2691A923-0DA8-0E0B-8B20-AA8D469C3C18}"/>
+                <a16:creationId xmlns:a16="http://schemas.microsoft.com/office/drawing/2014/main" id="{38CF0815-B095-C94F-364F-60432AC45E10}"/>
               </a:ext>
             </a:extLst>
           </p:cNvPr>
@@ -9663,7 +9663,7 @@
           <p:cNvPr id="7" name="TextBox 6">
             <a:extLst>
               <a:ext uri="{FF2B5EF4-FFF2-40B4-BE49-F238E27FC236}">
-                <a16:creationId xmlns:a16="http://schemas.microsoft.com/office/drawing/2014/main" id="{9BE67537-7707-5179-3168-070FA6732429}"/>
+                <a16:creationId xmlns:a16="http://schemas.microsoft.com/office/drawing/2014/main" id="{99A02557-20C4-6350-F2D8-3DEC1AD5683F}"/>
               </a:ext>
             </a:extLst>
           </p:cNvPr>
@@ -9715,7 +9715,7 @@
           <p:cNvPr id="8" name="TextBox 7">
             <a:extLst>
               <a:ext uri="{FF2B5EF4-FFF2-40B4-BE49-F238E27FC236}">
-                <a16:creationId xmlns:a16="http://schemas.microsoft.com/office/drawing/2014/main" id="{54BFF95A-20B7-6FEA-0956-9C60BF6CFAC1}"/>
+                <a16:creationId xmlns:a16="http://schemas.microsoft.com/office/drawing/2014/main" id="{5C6EF8CE-F22C-E912-0980-4EE5D6541514}"/>
               </a:ext>
             </a:extLst>
           </p:cNvPr>
@@ -9766,7 +9766,7 @@
           <p:cNvPr id="9" name="TextBox 8">
             <a:extLst>
               <a:ext uri="{FF2B5EF4-FFF2-40B4-BE49-F238E27FC236}">
-                <a16:creationId xmlns:a16="http://schemas.microsoft.com/office/drawing/2014/main" id="{9DAAF8A1-3DEB-C974-0C78-03636FAD1B23}"/>
+                <a16:creationId xmlns:a16="http://schemas.microsoft.com/office/drawing/2014/main" id="{AB936CC4-B587-13E0-6F4A-6143FB24B28B}"/>
               </a:ext>
             </a:extLst>
           </p:cNvPr>
@@ -9811,7 +9811,7 @@
           <p:cNvPr id="10" name="TextBox 9">
             <a:extLst>
               <a:ext uri="{FF2B5EF4-FFF2-40B4-BE49-F238E27FC236}">
-                <a16:creationId xmlns:a16="http://schemas.microsoft.com/office/drawing/2014/main" id="{6EF0211F-24C4-3175-0B04-C9927C831BCA}"/>
+                <a16:creationId xmlns:a16="http://schemas.microsoft.com/office/drawing/2014/main" id="{503803BB-2FEE-D228-A233-E61BCC693051}"/>
               </a:ext>
             </a:extLst>
           </p:cNvPr>
@@ -9854,7 +9854,7 @@
     </p:spTree>
     <p:extLst>
       <p:ext uri="{BB962C8B-B14F-4D97-AF65-F5344CB8AC3E}">
-        <p14:creationId xmlns:p14="http://schemas.microsoft.com/office/powerpoint/2010/main" val="1584205888"/>
+        <p14:creationId xmlns:p14="http://schemas.microsoft.com/office/powerpoint/2010/main" val="1592263174"/>
       </p:ext>
     </p:extLst>
   </p:cSld>
@@ -9894,7 +9894,7 @@
           <p:cNvPr id="2" name="TextBox 1">
             <a:extLst>
               <a:ext uri="{FF2B5EF4-FFF2-40B4-BE49-F238E27FC236}">
-                <a16:creationId xmlns:a16="http://schemas.microsoft.com/office/drawing/2014/main" id="{B3859F40-25A0-7BA2-55FB-6D47A4E54527}"/>
+                <a16:creationId xmlns:a16="http://schemas.microsoft.com/office/drawing/2014/main" id="{AEA9343A-7CF0-AC41-F29D-36BF01DEA0D4}"/>
               </a:ext>
             </a:extLst>
           </p:cNvPr>
@@ -9945,7 +9945,7 @@
           <p:cNvPr id="3" name="TextBox 2">
             <a:extLst>
               <a:ext uri="{FF2B5EF4-FFF2-40B4-BE49-F238E27FC236}">
-                <a16:creationId xmlns:a16="http://schemas.microsoft.com/office/drawing/2014/main" id="{59541F0B-541A-0B8B-AE50-F45F0B236683}"/>
+                <a16:creationId xmlns:a16="http://schemas.microsoft.com/office/drawing/2014/main" id="{41632086-A7B4-A1E2-D911-49264A8C574C}"/>
               </a:ext>
             </a:extLst>
           </p:cNvPr>
@@ -9996,7 +9996,7 @@
           <p:cNvPr id="4" name="TextBox 3">
             <a:extLst>
               <a:ext uri="{FF2B5EF4-FFF2-40B4-BE49-F238E27FC236}">
-                <a16:creationId xmlns:a16="http://schemas.microsoft.com/office/drawing/2014/main" id="{8058FE8E-DA21-ACA6-6496-0F87C1942518}"/>
+                <a16:creationId xmlns:a16="http://schemas.microsoft.com/office/drawing/2014/main" id="{57AC2217-C4F6-84DA-DAE9-D037651F1426}"/>
               </a:ext>
             </a:extLst>
           </p:cNvPr>
@@ -10048,7 +10048,7 @@
           <p:cNvPr id="5" name="Table 4">
             <a:extLst>
               <a:ext uri="{FF2B5EF4-FFF2-40B4-BE49-F238E27FC236}">
-                <a16:creationId xmlns:a16="http://schemas.microsoft.com/office/drawing/2014/main" id="{1704CDCD-81DA-678A-3CF3-A6263EA24AEE}"/>
+                <a16:creationId xmlns:a16="http://schemas.microsoft.com/office/drawing/2014/main" id="{65D46354-1995-CCDA-15B1-1B7D064A9FF9}"/>
               </a:ext>
             </a:extLst>
           </p:cNvPr>
@@ -10058,7 +10058,7 @@
           <p:nvPr>
             <p:extLst>
               <p:ext uri="{D42A27DB-BD31-4B8C-83A1-F6EECF244321}">
-                <p14:modId xmlns:p14="http://schemas.microsoft.com/office/powerpoint/2010/main" val="4287573543"/>
+                <p14:modId xmlns:p14="http://schemas.microsoft.com/office/powerpoint/2010/main" val="4205615836"/>
               </p:ext>
             </p:extLst>
           </p:nvPr>
@@ -10077,21 +10077,21 @@
                 <a:gridCol w="5715000">
                   <a:extLst>
                     <a:ext uri="{9D8B030D-6E8A-4147-A177-3AD203B41FA5}">
-                      <a16:colId xmlns:a16="http://schemas.microsoft.com/office/drawing/2014/main" val="2346158843"/>
+                      <a16:colId xmlns:a16="http://schemas.microsoft.com/office/drawing/2014/main" val="26578484"/>
                     </a:ext>
                   </a:extLst>
                 </a:gridCol>
                 <a:gridCol w="2603500">
                   <a:extLst>
                     <a:ext uri="{9D8B030D-6E8A-4147-A177-3AD203B41FA5}">
-                      <a16:colId xmlns:a16="http://schemas.microsoft.com/office/drawing/2014/main" val="2355496660"/>
+                      <a16:colId xmlns:a16="http://schemas.microsoft.com/office/drawing/2014/main" val="3763827127"/>
                     </a:ext>
                   </a:extLst>
                 </a:gridCol>
                 <a:gridCol w="2603500">
                   <a:extLst>
                     <a:ext uri="{9D8B030D-6E8A-4147-A177-3AD203B41FA5}">
-                      <a16:colId xmlns:a16="http://schemas.microsoft.com/office/drawing/2014/main" val="3189824586"/>
+                      <a16:colId xmlns:a16="http://schemas.microsoft.com/office/drawing/2014/main" val="2920069439"/>
                     </a:ext>
                   </a:extLst>
                 </a:gridCol>
@@ -10225,7 +10225,7 @@
                 </a:tc>
                 <a:extLst>
                   <a:ext uri="{0D108BD9-81ED-4DB2-BD59-A6C34878D82A}">
-                    <a16:rowId xmlns:a16="http://schemas.microsoft.com/office/drawing/2014/main" val="1565506149"/>
+                    <a16:rowId xmlns:a16="http://schemas.microsoft.com/office/drawing/2014/main" val="3951955043"/>
                   </a:ext>
                 </a:extLst>
               </a:tr>
@@ -10358,7 +10358,7 @@
                 </a:tc>
                 <a:extLst>
                   <a:ext uri="{0D108BD9-81ED-4DB2-BD59-A6C34878D82A}">
-                    <a16:rowId xmlns:a16="http://schemas.microsoft.com/office/drawing/2014/main" val="1947812611"/>
+                    <a16:rowId xmlns:a16="http://schemas.microsoft.com/office/drawing/2014/main" val="1388292505"/>
                   </a:ext>
                 </a:extLst>
               </a:tr>
@@ -10491,7 +10491,7 @@
                 </a:tc>
                 <a:extLst>
                   <a:ext uri="{0D108BD9-81ED-4DB2-BD59-A6C34878D82A}">
-                    <a16:rowId xmlns:a16="http://schemas.microsoft.com/office/drawing/2014/main" val="3043222174"/>
+                    <a16:rowId xmlns:a16="http://schemas.microsoft.com/office/drawing/2014/main" val="144200239"/>
                   </a:ext>
                 </a:extLst>
               </a:tr>
@@ -10624,7 +10624,7 @@
                 </a:tc>
                 <a:extLst>
                   <a:ext uri="{0D108BD9-81ED-4DB2-BD59-A6C34878D82A}">
-                    <a16:rowId xmlns:a16="http://schemas.microsoft.com/office/drawing/2014/main" val="1213984595"/>
+                    <a16:rowId xmlns:a16="http://schemas.microsoft.com/office/drawing/2014/main" val="1417143027"/>
                   </a:ext>
                 </a:extLst>
               </a:tr>
@@ -10637,7 +10637,7 @@
           <p:cNvPr id="6" name="TextBox 5">
             <a:extLst>
               <a:ext uri="{FF2B5EF4-FFF2-40B4-BE49-F238E27FC236}">
-                <a16:creationId xmlns:a16="http://schemas.microsoft.com/office/drawing/2014/main" id="{6116F05A-83E9-B9E0-79CE-E60C5758CCA8}"/>
+                <a16:creationId xmlns:a16="http://schemas.microsoft.com/office/drawing/2014/main" id="{50BA3724-9896-73E5-C10D-5765552C0A01}"/>
               </a:ext>
             </a:extLst>
           </p:cNvPr>
@@ -10682,7 +10682,7 @@
           <p:cNvPr id="7" name="TextBox 6">
             <a:extLst>
               <a:ext uri="{FF2B5EF4-FFF2-40B4-BE49-F238E27FC236}">
-                <a16:creationId xmlns:a16="http://schemas.microsoft.com/office/drawing/2014/main" id="{C699471F-7F36-CDC0-0728-8F530CE0691C}"/>
+                <a16:creationId xmlns:a16="http://schemas.microsoft.com/office/drawing/2014/main" id="{C6AF0D13-A488-EDE5-9392-E6CDFD1FF1B6}"/>
               </a:ext>
             </a:extLst>
           </p:cNvPr>
@@ -10725,7 +10725,7 @@
     </p:spTree>
     <p:extLst>
       <p:ext uri="{BB962C8B-B14F-4D97-AF65-F5344CB8AC3E}">
-        <p14:creationId xmlns:p14="http://schemas.microsoft.com/office/powerpoint/2010/main" val="543356652"/>
+        <p14:creationId xmlns:p14="http://schemas.microsoft.com/office/powerpoint/2010/main" val="2661882747"/>
       </p:ext>
     </p:extLst>
   </p:cSld>
@@ -10765,7 +10765,7 @@
           <p:cNvPr id="2" name="TextBox 1">
             <a:extLst>
               <a:ext uri="{FF2B5EF4-FFF2-40B4-BE49-F238E27FC236}">
-                <a16:creationId xmlns:a16="http://schemas.microsoft.com/office/drawing/2014/main" id="{B57A51C8-A676-9450-1AEB-7C7FBA21D0E4}"/>
+                <a16:creationId xmlns:a16="http://schemas.microsoft.com/office/drawing/2014/main" id="{505F1C7C-4AB9-3114-D28D-856FEBD4F3A5}"/>
               </a:ext>
             </a:extLst>
           </p:cNvPr>
@@ -10810,7 +10810,7 @@
           <p:cNvPr id="3" name="TextBox 2">
             <a:extLst>
               <a:ext uri="{FF2B5EF4-FFF2-40B4-BE49-F238E27FC236}">
-                <a16:creationId xmlns:a16="http://schemas.microsoft.com/office/drawing/2014/main" id="{1AF60C53-D3BE-D552-A407-CCE88C8DB843}"/>
+                <a16:creationId xmlns:a16="http://schemas.microsoft.com/office/drawing/2014/main" id="{E2D352CD-AE6B-1798-5F11-515EDB4C3BA7}"/>
               </a:ext>
             </a:extLst>
           </p:cNvPr>
@@ -10861,7 +10861,7 @@
           <p:cNvPr id="4" name="TextBox 3">
             <a:extLst>
               <a:ext uri="{FF2B5EF4-FFF2-40B4-BE49-F238E27FC236}">
-                <a16:creationId xmlns:a16="http://schemas.microsoft.com/office/drawing/2014/main" id="{FAFF5387-5544-5AE4-7401-926049076030}"/>
+                <a16:creationId xmlns:a16="http://schemas.microsoft.com/office/drawing/2014/main" id="{C26ED979-4924-4B1F-619C-2B38CD35A834}"/>
               </a:ext>
             </a:extLst>
           </p:cNvPr>
@@ -10915,7 +10915,7 @@
           <p:cNvPr id="5" name="TextBox 4">
             <a:extLst>
               <a:ext uri="{FF2B5EF4-FFF2-40B4-BE49-F238E27FC236}">
-                <a16:creationId xmlns:a16="http://schemas.microsoft.com/office/drawing/2014/main" id="{A9C05934-E5F8-5E9D-8638-C344753D55A7}"/>
+                <a16:creationId xmlns:a16="http://schemas.microsoft.com/office/drawing/2014/main" id="{77715268-EA15-3A98-54F3-A79709C6273B}"/>
               </a:ext>
             </a:extLst>
           </p:cNvPr>
@@ -10968,7 +10968,7 @@
           <p:cNvPr id="7" name="Picture 6">
             <a:extLst>
               <a:ext uri="{FF2B5EF4-FFF2-40B4-BE49-F238E27FC236}">
-                <a16:creationId xmlns:a16="http://schemas.microsoft.com/office/drawing/2014/main" id="{50ED75BE-89A6-F9F5-FA13-5A74904F7066}"/>
+                <a16:creationId xmlns:a16="http://schemas.microsoft.com/office/drawing/2014/main" id="{4EC2A13A-290C-5016-CA39-A3823D531F90}"/>
               </a:ext>
             </a:extLst>
           </p:cNvPr>
@@ -11004,7 +11004,7 @@
           <p:cNvPr id="8" name="TextBox 7">
             <a:extLst>
               <a:ext uri="{FF2B5EF4-FFF2-40B4-BE49-F238E27FC236}">
-                <a16:creationId xmlns:a16="http://schemas.microsoft.com/office/drawing/2014/main" id="{1B157421-7C28-6654-C521-40FFAABCE1B9}"/>
+                <a16:creationId xmlns:a16="http://schemas.microsoft.com/office/drawing/2014/main" id="{24AC2124-CEE0-1B55-0D41-9BF77C6196A4}"/>
               </a:ext>
             </a:extLst>
           </p:cNvPr>
@@ -11049,7 +11049,7 @@
           <p:cNvPr id="9" name="TextBox 8">
             <a:extLst>
               <a:ext uri="{FF2B5EF4-FFF2-40B4-BE49-F238E27FC236}">
-                <a16:creationId xmlns:a16="http://schemas.microsoft.com/office/drawing/2014/main" id="{C8605736-214A-8AB2-235E-51F21BF487AF}"/>
+                <a16:creationId xmlns:a16="http://schemas.microsoft.com/office/drawing/2014/main" id="{4FD35733-DB57-3D74-3891-7EE9F09BDE74}"/>
               </a:ext>
             </a:extLst>
           </p:cNvPr>
@@ -11092,7 +11092,7 @@
     </p:spTree>
     <p:extLst>
       <p:ext uri="{BB962C8B-B14F-4D97-AF65-F5344CB8AC3E}">
-        <p14:creationId xmlns:p14="http://schemas.microsoft.com/office/powerpoint/2010/main" val="173723156"/>
+        <p14:creationId xmlns:p14="http://schemas.microsoft.com/office/powerpoint/2010/main" val="427640799"/>
       </p:ext>
     </p:extLst>
   </p:cSld>
@@ -11132,7 +11132,7 @@
           <p:cNvPr id="2" name="TextBox 1">
             <a:extLst>
               <a:ext uri="{FF2B5EF4-FFF2-40B4-BE49-F238E27FC236}">
-                <a16:creationId xmlns:a16="http://schemas.microsoft.com/office/drawing/2014/main" id="{4664EBEC-1092-89C7-4793-ADB73A26FA20}"/>
+                <a16:creationId xmlns:a16="http://schemas.microsoft.com/office/drawing/2014/main" id="{C84CC918-79D8-B0D0-2B76-9017D9545E1F}"/>
               </a:ext>
             </a:extLst>
           </p:cNvPr>
@@ -11183,7 +11183,7 @@
           <p:cNvPr id="3" name="TextBox 2">
             <a:extLst>
               <a:ext uri="{FF2B5EF4-FFF2-40B4-BE49-F238E27FC236}">
-                <a16:creationId xmlns:a16="http://schemas.microsoft.com/office/drawing/2014/main" id="{DC6C68E4-CA28-37FA-904E-03A90AB9D511}"/>
+                <a16:creationId xmlns:a16="http://schemas.microsoft.com/office/drawing/2014/main" id="{83CABDAE-18C3-567D-B26A-443A0D45BB58}"/>
               </a:ext>
             </a:extLst>
           </p:cNvPr>
@@ -11234,7 +11234,7 @@
           <p:cNvPr id="4" name="Table 3">
             <a:extLst>
               <a:ext uri="{FF2B5EF4-FFF2-40B4-BE49-F238E27FC236}">
-                <a16:creationId xmlns:a16="http://schemas.microsoft.com/office/drawing/2014/main" id="{584630EB-E21E-BEC7-C92D-EC7810CA206D}"/>
+                <a16:creationId xmlns:a16="http://schemas.microsoft.com/office/drawing/2014/main" id="{7CA4DD9A-65FF-440D-2799-FD50DB8C0F93}"/>
               </a:ext>
             </a:extLst>
           </p:cNvPr>
@@ -11244,7 +11244,7 @@
           <p:nvPr>
             <p:extLst>
               <p:ext uri="{D42A27DB-BD31-4B8C-83A1-F6EECF244321}">
-                <p14:modId xmlns:p14="http://schemas.microsoft.com/office/powerpoint/2010/main" val="2561002737"/>
+                <p14:modId xmlns:p14="http://schemas.microsoft.com/office/powerpoint/2010/main" val="2667902517"/>
               </p:ext>
             </p:extLst>
           </p:nvPr>
@@ -11263,21 +11263,21 @@
                 <a:gridCol w="2921000">
                   <a:extLst>
                     <a:ext uri="{9D8B030D-6E8A-4147-A177-3AD203B41FA5}">
-                      <a16:colId xmlns:a16="http://schemas.microsoft.com/office/drawing/2014/main" val="408300688"/>
+                      <a16:colId xmlns:a16="http://schemas.microsoft.com/office/drawing/2014/main" val="3134815456"/>
                     </a:ext>
                   </a:extLst>
                 </a:gridCol>
                 <a:gridCol w="4191000">
                   <a:extLst>
                     <a:ext uri="{9D8B030D-6E8A-4147-A177-3AD203B41FA5}">
-                      <a16:colId xmlns:a16="http://schemas.microsoft.com/office/drawing/2014/main" val="621236663"/>
+                      <a16:colId xmlns:a16="http://schemas.microsoft.com/office/drawing/2014/main" val="1174950828"/>
                     </a:ext>
                   </a:extLst>
                 </a:gridCol>
                 <a:gridCol w="3810000">
                   <a:extLst>
                     <a:ext uri="{9D8B030D-6E8A-4147-A177-3AD203B41FA5}">
-                      <a16:colId xmlns:a16="http://schemas.microsoft.com/office/drawing/2014/main" val="1125884526"/>
+                      <a16:colId xmlns:a16="http://schemas.microsoft.com/office/drawing/2014/main" val="2241902195"/>
                     </a:ext>
                   </a:extLst>
                 </a:gridCol>
@@ -11411,7 +11411,7 @@
                 </a:tc>
                 <a:extLst>
                   <a:ext uri="{0D108BD9-81ED-4DB2-BD59-A6C34878D82A}">
-                    <a16:rowId xmlns:a16="http://schemas.microsoft.com/office/drawing/2014/main" val="1508988066"/>
+                    <a16:rowId xmlns:a16="http://schemas.microsoft.com/office/drawing/2014/main" val="118433485"/>
                   </a:ext>
                 </a:extLst>
               </a:tr>
@@ -11544,7 +11544,7 @@
                 </a:tc>
                 <a:extLst>
                   <a:ext uri="{0D108BD9-81ED-4DB2-BD59-A6C34878D82A}">
-                    <a16:rowId xmlns:a16="http://schemas.microsoft.com/office/drawing/2014/main" val="3351625309"/>
+                    <a16:rowId xmlns:a16="http://schemas.microsoft.com/office/drawing/2014/main" val="1552429655"/>
                   </a:ext>
                 </a:extLst>
               </a:tr>
@@ -11677,7 +11677,7 @@
                 </a:tc>
                 <a:extLst>
                   <a:ext uri="{0D108BD9-81ED-4DB2-BD59-A6C34878D82A}">
-                    <a16:rowId xmlns:a16="http://schemas.microsoft.com/office/drawing/2014/main" val="2591119937"/>
+                    <a16:rowId xmlns:a16="http://schemas.microsoft.com/office/drawing/2014/main" val="257134937"/>
                   </a:ext>
                 </a:extLst>
               </a:tr>
@@ -11810,7 +11810,7 @@
                 </a:tc>
                 <a:extLst>
                   <a:ext uri="{0D108BD9-81ED-4DB2-BD59-A6C34878D82A}">
-                    <a16:rowId xmlns:a16="http://schemas.microsoft.com/office/drawing/2014/main" val="2715193796"/>
+                    <a16:rowId xmlns:a16="http://schemas.microsoft.com/office/drawing/2014/main" val="2990380411"/>
                   </a:ext>
                 </a:extLst>
               </a:tr>
@@ -11943,7 +11943,7 @@
                 </a:tc>
                 <a:extLst>
                   <a:ext uri="{0D108BD9-81ED-4DB2-BD59-A6C34878D82A}">
-                    <a16:rowId xmlns:a16="http://schemas.microsoft.com/office/drawing/2014/main" val="1366709441"/>
+                    <a16:rowId xmlns:a16="http://schemas.microsoft.com/office/drawing/2014/main" val="3848731280"/>
                   </a:ext>
                 </a:extLst>
               </a:tr>
@@ -11956,7 +11956,7 @@
           <p:cNvPr id="5" name="TextBox 4">
             <a:extLst>
               <a:ext uri="{FF2B5EF4-FFF2-40B4-BE49-F238E27FC236}">
-                <a16:creationId xmlns:a16="http://schemas.microsoft.com/office/drawing/2014/main" id="{6D585153-2F37-0EB8-C5A8-DCB107AE704E}"/>
+                <a16:creationId xmlns:a16="http://schemas.microsoft.com/office/drawing/2014/main" id="{B2F2344D-B9C5-9A96-87BF-F7AF511125BC}"/>
               </a:ext>
             </a:extLst>
           </p:cNvPr>
@@ -12007,7 +12007,7 @@
           <p:cNvPr id="6" name="TextBox 5">
             <a:extLst>
               <a:ext uri="{FF2B5EF4-FFF2-40B4-BE49-F238E27FC236}">
-                <a16:creationId xmlns:a16="http://schemas.microsoft.com/office/drawing/2014/main" id="{43697F08-BEA1-CD88-3872-FE3A38813CAE}"/>
+                <a16:creationId xmlns:a16="http://schemas.microsoft.com/office/drawing/2014/main" id="{DB39AE46-4794-0163-0567-8F249E0D6115}"/>
               </a:ext>
             </a:extLst>
           </p:cNvPr>
@@ -12052,7 +12052,7 @@
           <p:cNvPr id="7" name="TextBox 6">
             <a:extLst>
               <a:ext uri="{FF2B5EF4-FFF2-40B4-BE49-F238E27FC236}">
-                <a16:creationId xmlns:a16="http://schemas.microsoft.com/office/drawing/2014/main" id="{8A65E634-E0E7-3E31-EDCA-96214762C713}"/>
+                <a16:creationId xmlns:a16="http://schemas.microsoft.com/office/drawing/2014/main" id="{BF45746A-5845-3F75-59A6-3BDDD5A40106}"/>
               </a:ext>
             </a:extLst>
           </p:cNvPr>
@@ -12095,7 +12095,7 @@
     </p:spTree>
     <p:extLst>
       <p:ext uri="{BB962C8B-B14F-4D97-AF65-F5344CB8AC3E}">
-        <p14:creationId xmlns:p14="http://schemas.microsoft.com/office/powerpoint/2010/main" val="2757662218"/>
+        <p14:creationId xmlns:p14="http://schemas.microsoft.com/office/powerpoint/2010/main" val="3290382361"/>
       </p:ext>
     </p:extLst>
   </p:cSld>
@@ -12135,7 +12135,7 @@
           <p:cNvPr id="2" name="TextBox 1">
             <a:extLst>
               <a:ext uri="{FF2B5EF4-FFF2-40B4-BE49-F238E27FC236}">
-                <a16:creationId xmlns:a16="http://schemas.microsoft.com/office/drawing/2014/main" id="{A941A79B-45B2-B1EF-30E6-09494665AE0D}"/>
+                <a16:creationId xmlns:a16="http://schemas.microsoft.com/office/drawing/2014/main" id="{BA98EC03-45A6-D50F-50BE-B63A6E9C3D06}"/>
               </a:ext>
             </a:extLst>
           </p:cNvPr>
@@ -12186,7 +12186,7 @@
           <p:cNvPr id="3" name="TextBox 2">
             <a:extLst>
               <a:ext uri="{FF2B5EF4-FFF2-40B4-BE49-F238E27FC236}">
-                <a16:creationId xmlns:a16="http://schemas.microsoft.com/office/drawing/2014/main" id="{92A8D015-FE8D-5C0C-EE4B-7F526AB5D9E9}"/>
+                <a16:creationId xmlns:a16="http://schemas.microsoft.com/office/drawing/2014/main" id="{0B913D2A-0814-DB69-E0CF-46038A942D8A}"/>
               </a:ext>
             </a:extLst>
           </p:cNvPr>
@@ -12237,7 +12237,7 @@
           <p:cNvPr id="4" name="TextBox 3">
             <a:extLst>
               <a:ext uri="{FF2B5EF4-FFF2-40B4-BE49-F238E27FC236}">
-                <a16:creationId xmlns:a16="http://schemas.microsoft.com/office/drawing/2014/main" id="{029C40B4-18EB-F43E-64DE-CA8B623BF865}"/>
+                <a16:creationId xmlns:a16="http://schemas.microsoft.com/office/drawing/2014/main" id="{00F53A3B-BA8C-7C93-CC5D-807290062E2A}"/>
               </a:ext>
             </a:extLst>
           </p:cNvPr>
@@ -12289,7 +12289,7 @@
           <p:cNvPr id="5" name="Table 4">
             <a:extLst>
               <a:ext uri="{FF2B5EF4-FFF2-40B4-BE49-F238E27FC236}">
-                <a16:creationId xmlns:a16="http://schemas.microsoft.com/office/drawing/2014/main" id="{6456D932-A02B-7954-E810-05933208296F}"/>
+                <a16:creationId xmlns:a16="http://schemas.microsoft.com/office/drawing/2014/main" id="{BA2C6DE6-79F8-B0EA-32D8-E2A5915D7B33}"/>
               </a:ext>
             </a:extLst>
           </p:cNvPr>
@@ -12299,7 +12299,7 @@
           <p:nvPr>
             <p:extLst>
               <p:ext uri="{D42A27DB-BD31-4B8C-83A1-F6EECF244321}">
-                <p14:modId xmlns:p14="http://schemas.microsoft.com/office/powerpoint/2010/main" val="1219331328"/>
+                <p14:modId xmlns:p14="http://schemas.microsoft.com/office/powerpoint/2010/main" val="3979582824"/>
               </p:ext>
             </p:extLst>
           </p:nvPr>
@@ -12318,28 +12318,28 @@
                 <a:gridCol w="4064000">
                   <a:extLst>
                     <a:ext uri="{9D8B030D-6E8A-4147-A177-3AD203B41FA5}">
-                      <a16:colId xmlns:a16="http://schemas.microsoft.com/office/drawing/2014/main" val="886453714"/>
+                      <a16:colId xmlns:a16="http://schemas.microsoft.com/office/drawing/2014/main" val="3714643079"/>
                     </a:ext>
                   </a:extLst>
                 </a:gridCol>
                 <a:gridCol w="2286000">
                   <a:extLst>
                     <a:ext uri="{9D8B030D-6E8A-4147-A177-3AD203B41FA5}">
-                      <a16:colId xmlns:a16="http://schemas.microsoft.com/office/drawing/2014/main" val="1463371730"/>
+                      <a16:colId xmlns:a16="http://schemas.microsoft.com/office/drawing/2014/main" val="3477182639"/>
                     </a:ext>
                   </a:extLst>
                 </a:gridCol>
                 <a:gridCol w="2286000">
                   <a:extLst>
                     <a:ext uri="{9D8B030D-6E8A-4147-A177-3AD203B41FA5}">
-                      <a16:colId xmlns:a16="http://schemas.microsoft.com/office/drawing/2014/main" val="290804893"/>
+                      <a16:colId xmlns:a16="http://schemas.microsoft.com/office/drawing/2014/main" val="2123774310"/>
                     </a:ext>
                   </a:extLst>
                 </a:gridCol>
                 <a:gridCol w="2286000">
                   <a:extLst>
                     <a:ext uri="{9D8B030D-6E8A-4147-A177-3AD203B41FA5}">
-                      <a16:colId xmlns:a16="http://schemas.microsoft.com/office/drawing/2014/main" val="935935079"/>
+                      <a16:colId xmlns:a16="http://schemas.microsoft.com/office/drawing/2014/main" val="2306863965"/>
                     </a:ext>
                   </a:extLst>
                 </a:gridCol>
@@ -12515,7 +12515,7 @@
                 </a:tc>
                 <a:extLst>
                   <a:ext uri="{0D108BD9-81ED-4DB2-BD59-A6C34878D82A}">
-                    <a16:rowId xmlns:a16="http://schemas.microsoft.com/office/drawing/2014/main" val="3024712218"/>
+                    <a16:rowId xmlns:a16="http://schemas.microsoft.com/office/drawing/2014/main" val="3218031432"/>
                   </a:ext>
                 </a:extLst>
               </a:tr>
@@ -12690,7 +12690,7 @@
                 </a:tc>
                 <a:extLst>
                   <a:ext uri="{0D108BD9-81ED-4DB2-BD59-A6C34878D82A}">
-                    <a16:rowId xmlns:a16="http://schemas.microsoft.com/office/drawing/2014/main" val="2059798148"/>
+                    <a16:rowId xmlns:a16="http://schemas.microsoft.com/office/drawing/2014/main" val="1070614889"/>
                   </a:ext>
                 </a:extLst>
               </a:tr>
@@ -12865,7 +12865,7 @@
                 </a:tc>
                 <a:extLst>
                   <a:ext uri="{0D108BD9-81ED-4DB2-BD59-A6C34878D82A}">
-                    <a16:rowId xmlns:a16="http://schemas.microsoft.com/office/drawing/2014/main" val="606718861"/>
+                    <a16:rowId xmlns:a16="http://schemas.microsoft.com/office/drawing/2014/main" val="3652924697"/>
                   </a:ext>
                 </a:extLst>
               </a:tr>
@@ -13040,7 +13040,7 @@
                 </a:tc>
                 <a:extLst>
                   <a:ext uri="{0D108BD9-81ED-4DB2-BD59-A6C34878D82A}">
-                    <a16:rowId xmlns:a16="http://schemas.microsoft.com/office/drawing/2014/main" val="2082011026"/>
+                    <a16:rowId xmlns:a16="http://schemas.microsoft.com/office/drawing/2014/main" val="4052454683"/>
                   </a:ext>
                 </a:extLst>
               </a:tr>
@@ -13215,7 +13215,7 @@
                 </a:tc>
                 <a:extLst>
                   <a:ext uri="{0D108BD9-81ED-4DB2-BD59-A6C34878D82A}">
-                    <a16:rowId xmlns:a16="http://schemas.microsoft.com/office/drawing/2014/main" val="1141003386"/>
+                    <a16:rowId xmlns:a16="http://schemas.microsoft.com/office/drawing/2014/main" val="1998977380"/>
                   </a:ext>
                 </a:extLst>
               </a:tr>
@@ -13228,7 +13228,7 @@
           <p:cNvPr id="6" name="TextBox 5">
             <a:extLst>
               <a:ext uri="{FF2B5EF4-FFF2-40B4-BE49-F238E27FC236}">
-                <a16:creationId xmlns:a16="http://schemas.microsoft.com/office/drawing/2014/main" id="{A1AB72BE-A940-EC88-4833-9CA2B8DC4CEA}"/>
+                <a16:creationId xmlns:a16="http://schemas.microsoft.com/office/drawing/2014/main" id="{6F9B2771-5A78-DB5A-520C-493D9628745A}"/>
               </a:ext>
             </a:extLst>
           </p:cNvPr>
@@ -13273,7 +13273,7 @@
           <p:cNvPr id="7" name="TextBox 6">
             <a:extLst>
               <a:ext uri="{FF2B5EF4-FFF2-40B4-BE49-F238E27FC236}">
-                <a16:creationId xmlns:a16="http://schemas.microsoft.com/office/drawing/2014/main" id="{3BFBEBCC-2C2D-98A2-FC3E-56B0A611CFBE}"/>
+                <a16:creationId xmlns:a16="http://schemas.microsoft.com/office/drawing/2014/main" id="{21108568-0165-D60E-CC2F-C8E3F713B47A}"/>
               </a:ext>
             </a:extLst>
           </p:cNvPr>
@@ -13316,7 +13316,7 @@
     </p:spTree>
     <p:extLst>
       <p:ext uri="{BB962C8B-B14F-4D97-AF65-F5344CB8AC3E}">
-        <p14:creationId xmlns:p14="http://schemas.microsoft.com/office/powerpoint/2010/main" val="509101031"/>
+        <p14:creationId xmlns:p14="http://schemas.microsoft.com/office/powerpoint/2010/main" val="3867763941"/>
       </p:ext>
     </p:extLst>
   </p:cSld>
@@ -13356,7 +13356,7 @@
           <p:cNvPr id="2" name="TextBox 1">
             <a:extLst>
               <a:ext uri="{FF2B5EF4-FFF2-40B4-BE49-F238E27FC236}">
-                <a16:creationId xmlns:a16="http://schemas.microsoft.com/office/drawing/2014/main" id="{81D3CB5C-2DB2-D6CC-7503-A5020D35043F}"/>
+                <a16:creationId xmlns:a16="http://schemas.microsoft.com/office/drawing/2014/main" id="{71683F28-FED4-AAFF-2512-03C304A6C9B3}"/>
               </a:ext>
             </a:extLst>
           </p:cNvPr>
@@ -13407,7 +13407,7 @@
           <p:cNvPr id="3" name="TextBox 2">
             <a:extLst>
               <a:ext uri="{FF2B5EF4-FFF2-40B4-BE49-F238E27FC236}">
-                <a16:creationId xmlns:a16="http://schemas.microsoft.com/office/drawing/2014/main" id="{E2DD2BA1-B6D5-1DA2-9A04-A1DA7C1BAEC5}"/>
+                <a16:creationId xmlns:a16="http://schemas.microsoft.com/office/drawing/2014/main" id="{CA8CAF2D-EEDD-6390-B970-3FFA43C72DB3}"/>
               </a:ext>
             </a:extLst>
           </p:cNvPr>
@@ -13458,7 +13458,7 @@
           <p:cNvPr id="4" name="Table 3">
             <a:extLst>
               <a:ext uri="{FF2B5EF4-FFF2-40B4-BE49-F238E27FC236}">
-                <a16:creationId xmlns:a16="http://schemas.microsoft.com/office/drawing/2014/main" id="{E8A126D5-0D50-4A99-1491-8DAD6705FD31}"/>
+                <a16:creationId xmlns:a16="http://schemas.microsoft.com/office/drawing/2014/main" id="{7D640B23-6B8C-1603-7889-0D2448D8FF88}"/>
               </a:ext>
             </a:extLst>
           </p:cNvPr>
@@ -13468,7 +13468,7 @@
           <p:nvPr>
             <p:extLst>
               <p:ext uri="{D42A27DB-BD31-4B8C-83A1-F6EECF244321}">
-                <p14:modId xmlns:p14="http://schemas.microsoft.com/office/powerpoint/2010/main" val="3637985668"/>
+                <p14:modId xmlns:p14="http://schemas.microsoft.com/office/powerpoint/2010/main" val="419998597"/>
               </p:ext>
             </p:extLst>
           </p:nvPr>
@@ -13487,21 +13487,21 @@
                 <a:gridCol w="3810000">
                   <a:extLst>
                     <a:ext uri="{9D8B030D-6E8A-4147-A177-3AD203B41FA5}">
-                      <a16:colId xmlns:a16="http://schemas.microsoft.com/office/drawing/2014/main" val="712449813"/>
+                      <a16:colId xmlns:a16="http://schemas.microsoft.com/office/drawing/2014/main" val="16651699"/>
                     </a:ext>
                   </a:extLst>
                 </a:gridCol>
                 <a:gridCol w="3302000">
                   <a:extLst>
                     <a:ext uri="{9D8B030D-6E8A-4147-A177-3AD203B41FA5}">
-                      <a16:colId xmlns:a16="http://schemas.microsoft.com/office/drawing/2014/main" val="951722510"/>
+                      <a16:colId xmlns:a16="http://schemas.microsoft.com/office/drawing/2014/main" val="1510390071"/>
                     </a:ext>
                   </a:extLst>
                 </a:gridCol>
                 <a:gridCol w="3810000">
                   <a:extLst>
                     <a:ext uri="{9D8B030D-6E8A-4147-A177-3AD203B41FA5}">
-                      <a16:colId xmlns:a16="http://schemas.microsoft.com/office/drawing/2014/main" val="1888829560"/>
+                      <a16:colId xmlns:a16="http://schemas.microsoft.com/office/drawing/2014/main" val="900923165"/>
                     </a:ext>
                   </a:extLst>
                 </a:gridCol>
@@ -13635,7 +13635,7 @@
                 </a:tc>
                 <a:extLst>
                   <a:ext uri="{0D108BD9-81ED-4DB2-BD59-A6C34878D82A}">
-                    <a16:rowId xmlns:a16="http://schemas.microsoft.com/office/drawing/2014/main" val="1620108320"/>
+                    <a16:rowId xmlns:a16="http://schemas.microsoft.com/office/drawing/2014/main" val="3643029211"/>
                   </a:ext>
                 </a:extLst>
               </a:tr>
@@ -13768,7 +13768,7 @@
                 </a:tc>
                 <a:extLst>
                   <a:ext uri="{0D108BD9-81ED-4DB2-BD59-A6C34878D82A}">
-                    <a16:rowId xmlns:a16="http://schemas.microsoft.com/office/drawing/2014/main" val="466921648"/>
+                    <a16:rowId xmlns:a16="http://schemas.microsoft.com/office/drawing/2014/main" val="2656935237"/>
                   </a:ext>
                 </a:extLst>
               </a:tr>
@@ -13907,7 +13907,7 @@
                 </a:tc>
                 <a:extLst>
                   <a:ext uri="{0D108BD9-81ED-4DB2-BD59-A6C34878D82A}">
-                    <a16:rowId xmlns:a16="http://schemas.microsoft.com/office/drawing/2014/main" val="126026058"/>
+                    <a16:rowId xmlns:a16="http://schemas.microsoft.com/office/drawing/2014/main" val="2571405511"/>
                   </a:ext>
                 </a:extLst>
               </a:tr>
@@ -14040,7 +14040,7 @@
                 </a:tc>
                 <a:extLst>
                   <a:ext uri="{0D108BD9-81ED-4DB2-BD59-A6C34878D82A}">
-                    <a16:rowId xmlns:a16="http://schemas.microsoft.com/office/drawing/2014/main" val="431691177"/>
+                    <a16:rowId xmlns:a16="http://schemas.microsoft.com/office/drawing/2014/main" val="1753364743"/>
                   </a:ext>
                 </a:extLst>
               </a:tr>
@@ -14179,7 +14179,7 @@
                 </a:tc>
                 <a:extLst>
                   <a:ext uri="{0D108BD9-81ED-4DB2-BD59-A6C34878D82A}">
-                    <a16:rowId xmlns:a16="http://schemas.microsoft.com/office/drawing/2014/main" val="767539793"/>
+                    <a16:rowId xmlns:a16="http://schemas.microsoft.com/office/drawing/2014/main" val="3172819636"/>
                   </a:ext>
                 </a:extLst>
               </a:tr>
@@ -14192,7 +14192,7 @@
           <p:cNvPr id="5" name="TextBox 4">
             <a:extLst>
               <a:ext uri="{FF2B5EF4-FFF2-40B4-BE49-F238E27FC236}">
-                <a16:creationId xmlns:a16="http://schemas.microsoft.com/office/drawing/2014/main" id="{1275FB98-989E-7A79-3793-0E1C61DBC344}"/>
+                <a16:creationId xmlns:a16="http://schemas.microsoft.com/office/drawing/2014/main" id="{A41F0B5E-C72C-CFBF-4843-67D77EB3EC66}"/>
               </a:ext>
             </a:extLst>
           </p:cNvPr>
@@ -14243,7 +14243,7 @@
           <p:cNvPr id="6" name="TextBox 5">
             <a:extLst>
               <a:ext uri="{FF2B5EF4-FFF2-40B4-BE49-F238E27FC236}">
-                <a16:creationId xmlns:a16="http://schemas.microsoft.com/office/drawing/2014/main" id="{56B8E78C-AB5D-06C3-8585-B1A0D6014367}"/>
+                <a16:creationId xmlns:a16="http://schemas.microsoft.com/office/drawing/2014/main" id="{C756A787-3CA1-C54C-F592-87FF4289EB4C}"/>
               </a:ext>
             </a:extLst>
           </p:cNvPr>
@@ -14288,7 +14288,7 @@
           <p:cNvPr id="7" name="TextBox 6">
             <a:extLst>
               <a:ext uri="{FF2B5EF4-FFF2-40B4-BE49-F238E27FC236}">
-                <a16:creationId xmlns:a16="http://schemas.microsoft.com/office/drawing/2014/main" id="{90188989-4D22-7C83-8E60-6F008B93CF0A}"/>
+                <a16:creationId xmlns:a16="http://schemas.microsoft.com/office/drawing/2014/main" id="{BE14CF39-68B2-3335-C1A7-43757849CF8B}"/>
               </a:ext>
             </a:extLst>
           </p:cNvPr>
@@ -14331,7 +14331,7 @@
     </p:spTree>
     <p:extLst>
       <p:ext uri="{BB962C8B-B14F-4D97-AF65-F5344CB8AC3E}">
-        <p14:creationId xmlns:p14="http://schemas.microsoft.com/office/powerpoint/2010/main" val="4236093407"/>
+        <p14:creationId xmlns:p14="http://schemas.microsoft.com/office/powerpoint/2010/main" val="4203452356"/>
       </p:ext>
     </p:extLst>
   </p:cSld>
@@ -14371,7 +14371,7 @@
           <p:cNvPr id="2" name="TextBox 1">
             <a:extLst>
               <a:ext uri="{FF2B5EF4-FFF2-40B4-BE49-F238E27FC236}">
-                <a16:creationId xmlns:a16="http://schemas.microsoft.com/office/drawing/2014/main" id="{47031FC0-92C2-9B5F-5297-19F293AA7119}"/>
+                <a16:creationId xmlns:a16="http://schemas.microsoft.com/office/drawing/2014/main" id="{8B438954-D374-8E6C-82EA-57C79E09E481}"/>
               </a:ext>
             </a:extLst>
           </p:cNvPr>
@@ -14416,7 +14416,7 @@
           <p:cNvPr id="3" name="TextBox 2">
             <a:extLst>
               <a:ext uri="{FF2B5EF4-FFF2-40B4-BE49-F238E27FC236}">
-                <a16:creationId xmlns:a16="http://schemas.microsoft.com/office/drawing/2014/main" id="{6D96A9B4-C81A-12F2-0E85-1DC103189024}"/>
+                <a16:creationId xmlns:a16="http://schemas.microsoft.com/office/drawing/2014/main" id="{AA399CEC-2CB6-EF84-A9F3-2A7A4824A6B3}"/>
               </a:ext>
             </a:extLst>
           </p:cNvPr>
@@ -14467,7 +14467,7 @@
           <p:cNvPr id="5" name="Picture 4">
             <a:extLst>
               <a:ext uri="{FF2B5EF4-FFF2-40B4-BE49-F238E27FC236}">
-                <a16:creationId xmlns:a16="http://schemas.microsoft.com/office/drawing/2014/main" id="{50D84910-82AF-F8FC-5F68-9565FDC9B38B}"/>
+                <a16:creationId xmlns:a16="http://schemas.microsoft.com/office/drawing/2014/main" id="{20EB9C77-7898-B412-8963-6A7DA5001D2B}"/>
               </a:ext>
             </a:extLst>
           </p:cNvPr>
@@ -14503,7 +14503,7 @@
           <p:cNvPr id="6" name="TextBox 5">
             <a:extLst>
               <a:ext uri="{FF2B5EF4-FFF2-40B4-BE49-F238E27FC236}">
-                <a16:creationId xmlns:a16="http://schemas.microsoft.com/office/drawing/2014/main" id="{1C642973-332D-B4C9-DF2A-C8B7E55A7366}"/>
+                <a16:creationId xmlns:a16="http://schemas.microsoft.com/office/drawing/2014/main" id="{D8B5D059-84EF-057E-110E-992AC6D809B2}"/>
               </a:ext>
             </a:extLst>
           </p:cNvPr>
@@ -14554,7 +14554,7 @@
           <p:cNvPr id="7" name="TextBox 6">
             <a:extLst>
               <a:ext uri="{FF2B5EF4-FFF2-40B4-BE49-F238E27FC236}">
-                <a16:creationId xmlns:a16="http://schemas.microsoft.com/office/drawing/2014/main" id="{604EA817-3C81-5DF6-9990-7479804D4CB3}"/>
+                <a16:creationId xmlns:a16="http://schemas.microsoft.com/office/drawing/2014/main" id="{8EDDF0B7-92A2-56E1-ED96-DA514762214C}"/>
               </a:ext>
             </a:extLst>
           </p:cNvPr>
@@ -14599,7 +14599,7 @@
           <p:cNvPr id="8" name="TextBox 7">
             <a:extLst>
               <a:ext uri="{FF2B5EF4-FFF2-40B4-BE49-F238E27FC236}">
-                <a16:creationId xmlns:a16="http://schemas.microsoft.com/office/drawing/2014/main" id="{86B29DD2-C2F8-1BCC-2E8F-416987682EFC}"/>
+                <a16:creationId xmlns:a16="http://schemas.microsoft.com/office/drawing/2014/main" id="{CC8ABB7A-2AFD-53FC-66F2-57C5C21D30AF}"/>
               </a:ext>
             </a:extLst>
           </p:cNvPr>
@@ -14642,7 +14642,7 @@
     </p:spTree>
     <p:extLst>
       <p:ext uri="{BB962C8B-B14F-4D97-AF65-F5344CB8AC3E}">
-        <p14:creationId xmlns:p14="http://schemas.microsoft.com/office/powerpoint/2010/main" val="2949761323"/>
+        <p14:creationId xmlns:p14="http://schemas.microsoft.com/office/powerpoint/2010/main" val="1215802606"/>
       </p:ext>
     </p:extLst>
   </p:cSld>
@@ -14682,7 +14682,7 @@
           <p:cNvPr id="2" name="TextBox 1">
             <a:extLst>
               <a:ext uri="{FF2B5EF4-FFF2-40B4-BE49-F238E27FC236}">
-                <a16:creationId xmlns:a16="http://schemas.microsoft.com/office/drawing/2014/main" id="{F146BA80-67C9-B403-41B9-FEBFFEDF4DA4}"/>
+                <a16:creationId xmlns:a16="http://schemas.microsoft.com/office/drawing/2014/main" id="{03B33977-86FC-C297-6974-CFE7BF894C6D}"/>
               </a:ext>
             </a:extLst>
           </p:cNvPr>
@@ -14733,7 +14733,7 @@
           <p:cNvPr id="3" name="TextBox 2">
             <a:extLst>
               <a:ext uri="{FF2B5EF4-FFF2-40B4-BE49-F238E27FC236}">
-                <a16:creationId xmlns:a16="http://schemas.microsoft.com/office/drawing/2014/main" id="{DF94234D-D2AF-3510-8A4B-D70A73418EE3}"/>
+                <a16:creationId xmlns:a16="http://schemas.microsoft.com/office/drawing/2014/main" id="{AB183C91-5B71-66D1-5255-6DA37757AA52}"/>
               </a:ext>
             </a:extLst>
           </p:cNvPr>
@@ -14784,7 +14784,7 @@
           <p:cNvPr id="5" name="Picture 4">
             <a:extLst>
               <a:ext uri="{FF2B5EF4-FFF2-40B4-BE49-F238E27FC236}">
-                <a16:creationId xmlns:a16="http://schemas.microsoft.com/office/drawing/2014/main" id="{20881419-538B-8D41-C51B-58CB99C1BFCC}"/>
+                <a16:creationId xmlns:a16="http://schemas.microsoft.com/office/drawing/2014/main" id="{96A2E860-AD91-FB09-1438-77242E73E202}"/>
               </a:ext>
             </a:extLst>
           </p:cNvPr>
@@ -14820,7 +14820,7 @@
           <p:cNvPr id="6" name="Table 5">
             <a:extLst>
               <a:ext uri="{FF2B5EF4-FFF2-40B4-BE49-F238E27FC236}">
-                <a16:creationId xmlns:a16="http://schemas.microsoft.com/office/drawing/2014/main" id="{2C10FF5F-B446-0627-AA02-54195B1ADBB3}"/>
+                <a16:creationId xmlns:a16="http://schemas.microsoft.com/office/drawing/2014/main" id="{FFEC1A12-70FA-9DE9-7E70-B65B8626B640}"/>
               </a:ext>
             </a:extLst>
           </p:cNvPr>
@@ -14830,7 +14830,7 @@
           <p:nvPr>
             <p:extLst>
               <p:ext uri="{D42A27DB-BD31-4B8C-83A1-F6EECF244321}">
-                <p14:modId xmlns:p14="http://schemas.microsoft.com/office/powerpoint/2010/main" val="2180220539"/>
+                <p14:modId xmlns:p14="http://schemas.microsoft.com/office/powerpoint/2010/main" val="3514543653"/>
               </p:ext>
             </p:extLst>
           </p:nvPr>
@@ -14849,14 +14849,14 @@
                 <a:gridCol w="2095500">
                   <a:extLst>
                     <a:ext uri="{9D8B030D-6E8A-4147-A177-3AD203B41FA5}">
-                      <a16:colId xmlns:a16="http://schemas.microsoft.com/office/drawing/2014/main" val="1835909476"/>
+                      <a16:colId xmlns:a16="http://schemas.microsoft.com/office/drawing/2014/main" val="2322973232"/>
                     </a:ext>
                   </a:extLst>
                 </a:gridCol>
                 <a:gridCol w="3683000">
                   <a:extLst>
                     <a:ext uri="{9D8B030D-6E8A-4147-A177-3AD203B41FA5}">
-                      <a16:colId xmlns:a16="http://schemas.microsoft.com/office/drawing/2014/main" val="2386834482"/>
+                      <a16:colId xmlns:a16="http://schemas.microsoft.com/office/drawing/2014/main" val="2709832051"/>
                     </a:ext>
                   </a:extLst>
                 </a:gridCol>
@@ -14948,7 +14948,7 @@
                 </a:tc>
                 <a:extLst>
                   <a:ext uri="{0D108BD9-81ED-4DB2-BD59-A6C34878D82A}">
-                    <a16:rowId xmlns:a16="http://schemas.microsoft.com/office/drawing/2014/main" val="1042222663"/>
+                    <a16:rowId xmlns:a16="http://schemas.microsoft.com/office/drawing/2014/main" val="2076778103"/>
                   </a:ext>
                 </a:extLst>
               </a:tr>
@@ -15039,7 +15039,7 @@
                 </a:tc>
                 <a:extLst>
                   <a:ext uri="{0D108BD9-81ED-4DB2-BD59-A6C34878D82A}">
-                    <a16:rowId xmlns:a16="http://schemas.microsoft.com/office/drawing/2014/main" val="1174358643"/>
+                    <a16:rowId xmlns:a16="http://schemas.microsoft.com/office/drawing/2014/main" val="2672258800"/>
                   </a:ext>
                 </a:extLst>
               </a:tr>
@@ -15130,7 +15130,7 @@
                 </a:tc>
                 <a:extLst>
                   <a:ext uri="{0D108BD9-81ED-4DB2-BD59-A6C34878D82A}">
-                    <a16:rowId xmlns:a16="http://schemas.microsoft.com/office/drawing/2014/main" val="550369042"/>
+                    <a16:rowId xmlns:a16="http://schemas.microsoft.com/office/drawing/2014/main" val="431767679"/>
                   </a:ext>
                 </a:extLst>
               </a:tr>
@@ -15227,7 +15227,7 @@
                 </a:tc>
                 <a:extLst>
                   <a:ext uri="{0D108BD9-81ED-4DB2-BD59-A6C34878D82A}">
-                    <a16:rowId xmlns:a16="http://schemas.microsoft.com/office/drawing/2014/main" val="564642736"/>
+                    <a16:rowId xmlns:a16="http://schemas.microsoft.com/office/drawing/2014/main" val="895981161"/>
                   </a:ext>
                 </a:extLst>
               </a:tr>
@@ -15318,7 +15318,7 @@
                 </a:tc>
                 <a:extLst>
                   <a:ext uri="{0D108BD9-81ED-4DB2-BD59-A6C34878D82A}">
-                    <a16:rowId xmlns:a16="http://schemas.microsoft.com/office/drawing/2014/main" val="4007471541"/>
+                    <a16:rowId xmlns:a16="http://schemas.microsoft.com/office/drawing/2014/main" val="1484753629"/>
                   </a:ext>
                 </a:extLst>
               </a:tr>
@@ -15415,7 +15415,7 @@
                 </a:tc>
                 <a:extLst>
                   <a:ext uri="{0D108BD9-81ED-4DB2-BD59-A6C34878D82A}">
-                    <a16:rowId xmlns:a16="http://schemas.microsoft.com/office/drawing/2014/main" val="1100197873"/>
+                    <a16:rowId xmlns:a16="http://schemas.microsoft.com/office/drawing/2014/main" val="802850315"/>
                   </a:ext>
                 </a:extLst>
               </a:tr>
@@ -15428,7 +15428,7 @@
           <p:cNvPr id="7" name="TextBox 6">
             <a:extLst>
               <a:ext uri="{FF2B5EF4-FFF2-40B4-BE49-F238E27FC236}">
-                <a16:creationId xmlns:a16="http://schemas.microsoft.com/office/drawing/2014/main" id="{014D3635-14E1-0FAE-8798-265559B9949B}"/>
+                <a16:creationId xmlns:a16="http://schemas.microsoft.com/office/drawing/2014/main" id="{11D47714-9A39-4C47-9D56-20CF25B589AE}"/>
               </a:ext>
             </a:extLst>
           </p:cNvPr>
@@ -15479,7 +15479,7 @@
           <p:cNvPr id="8" name="TextBox 7">
             <a:extLst>
               <a:ext uri="{FF2B5EF4-FFF2-40B4-BE49-F238E27FC236}">
-                <a16:creationId xmlns:a16="http://schemas.microsoft.com/office/drawing/2014/main" id="{9D925CA3-E4A7-CD9D-606A-CB33A8C799F6}"/>
+                <a16:creationId xmlns:a16="http://schemas.microsoft.com/office/drawing/2014/main" id="{9CDC6331-5A4D-8687-FF66-7FEC8BC7CA09}"/>
               </a:ext>
             </a:extLst>
           </p:cNvPr>
@@ -15524,7 +15524,7 @@
           <p:cNvPr id="9" name="TextBox 8">
             <a:extLst>
               <a:ext uri="{FF2B5EF4-FFF2-40B4-BE49-F238E27FC236}">
-                <a16:creationId xmlns:a16="http://schemas.microsoft.com/office/drawing/2014/main" id="{1787F6E5-F335-1E24-1D82-BA109A2E32AD}"/>
+                <a16:creationId xmlns:a16="http://schemas.microsoft.com/office/drawing/2014/main" id="{67E6E872-7584-42BA-1969-62713D6FDD3D}"/>
               </a:ext>
             </a:extLst>
           </p:cNvPr>
@@ -15567,7 +15567,7 @@
     </p:spTree>
     <p:extLst>
       <p:ext uri="{BB962C8B-B14F-4D97-AF65-F5344CB8AC3E}">
-        <p14:creationId xmlns:p14="http://schemas.microsoft.com/office/powerpoint/2010/main" val="674186113"/>
+        <p14:creationId xmlns:p14="http://schemas.microsoft.com/office/powerpoint/2010/main" val="4094274428"/>
       </p:ext>
     </p:extLst>
   </p:cSld>
@@ -15607,7 +15607,7 @@
           <p:cNvPr id="2" name="TextBox 1">
             <a:extLst>
               <a:ext uri="{FF2B5EF4-FFF2-40B4-BE49-F238E27FC236}">
-                <a16:creationId xmlns:a16="http://schemas.microsoft.com/office/drawing/2014/main" id="{B757166E-FAF1-F18F-C2C5-D9D7824D0CB2}"/>
+                <a16:creationId xmlns:a16="http://schemas.microsoft.com/office/drawing/2014/main" id="{9AAA906C-D57C-FB9D-98C8-9C5C2FB8AD2E}"/>
               </a:ext>
             </a:extLst>
           </p:cNvPr>
@@ -15658,7 +15658,7 @@
           <p:cNvPr id="3" name="TextBox 2">
             <a:extLst>
               <a:ext uri="{FF2B5EF4-FFF2-40B4-BE49-F238E27FC236}">
-                <a16:creationId xmlns:a16="http://schemas.microsoft.com/office/drawing/2014/main" id="{F39BE7F8-9B97-F6FC-D73C-77723E17C295}"/>
+                <a16:creationId xmlns:a16="http://schemas.microsoft.com/office/drawing/2014/main" id="{A4C198BB-E7EC-9154-EBEE-590E18A61514}"/>
               </a:ext>
             </a:extLst>
           </p:cNvPr>
@@ -15709,7 +15709,7 @@
           <p:cNvPr id="4" name="TextBox 3">
             <a:extLst>
               <a:ext uri="{FF2B5EF4-FFF2-40B4-BE49-F238E27FC236}">
-                <a16:creationId xmlns:a16="http://schemas.microsoft.com/office/drawing/2014/main" id="{940A8781-9E69-6C02-F391-D7DB94AFD438}"/>
+                <a16:creationId xmlns:a16="http://schemas.microsoft.com/office/drawing/2014/main" id="{4295B0A4-5C74-758F-9698-353E9274D8F0}"/>
               </a:ext>
             </a:extLst>
           </p:cNvPr>
@@ -15761,7 +15761,7 @@
           <p:cNvPr id="5" name="Table 4">
             <a:extLst>
               <a:ext uri="{FF2B5EF4-FFF2-40B4-BE49-F238E27FC236}">
-                <a16:creationId xmlns:a16="http://schemas.microsoft.com/office/drawing/2014/main" id="{777A143D-4857-3CED-9EDA-C34D4724D00D}"/>
+                <a16:creationId xmlns:a16="http://schemas.microsoft.com/office/drawing/2014/main" id="{57925E37-E44B-2893-DD61-81BC0739CAB6}"/>
               </a:ext>
             </a:extLst>
           </p:cNvPr>
@@ -15771,7 +15771,7 @@
           <p:nvPr>
             <p:extLst>
               <p:ext uri="{D42A27DB-BD31-4B8C-83A1-F6EECF244321}">
-                <p14:modId xmlns:p14="http://schemas.microsoft.com/office/powerpoint/2010/main" val="973656349"/>
+                <p14:modId xmlns:p14="http://schemas.microsoft.com/office/powerpoint/2010/main" val="2645606805"/>
               </p:ext>
             </p:extLst>
           </p:nvPr>
@@ -15790,21 +15790,21 @@
                 <a:gridCol w="3810000">
                   <a:extLst>
                     <a:ext uri="{9D8B030D-6E8A-4147-A177-3AD203B41FA5}">
-                      <a16:colId xmlns:a16="http://schemas.microsoft.com/office/drawing/2014/main" val="1367436227"/>
+                      <a16:colId xmlns:a16="http://schemas.microsoft.com/office/drawing/2014/main" val="3304361364"/>
                     </a:ext>
                   </a:extLst>
                 </a:gridCol>
                 <a:gridCol w="4572000">
                   <a:extLst>
                     <a:ext uri="{9D8B030D-6E8A-4147-A177-3AD203B41FA5}">
-                      <a16:colId xmlns:a16="http://schemas.microsoft.com/office/drawing/2014/main" val="2543235757"/>
+                      <a16:colId xmlns:a16="http://schemas.microsoft.com/office/drawing/2014/main" val="410694315"/>
                     </a:ext>
                   </a:extLst>
                 </a:gridCol>
                 <a:gridCol w="2540000">
                   <a:extLst>
                     <a:ext uri="{9D8B030D-6E8A-4147-A177-3AD203B41FA5}">
-                      <a16:colId xmlns:a16="http://schemas.microsoft.com/office/drawing/2014/main" val="4121217250"/>
+                      <a16:colId xmlns:a16="http://schemas.microsoft.com/office/drawing/2014/main" val="1859349803"/>
                     </a:ext>
                   </a:extLst>
                 </a:gridCol>
@@ -15938,7 +15938,7 @@
                 </a:tc>
                 <a:extLst>
                   <a:ext uri="{0D108BD9-81ED-4DB2-BD59-A6C34878D82A}">
-                    <a16:rowId xmlns:a16="http://schemas.microsoft.com/office/drawing/2014/main" val="3086867157"/>
+                    <a16:rowId xmlns:a16="http://schemas.microsoft.com/office/drawing/2014/main" val="4227138705"/>
                   </a:ext>
                 </a:extLst>
               </a:tr>
@@ -16071,7 +16071,7 @@
                 </a:tc>
                 <a:extLst>
                   <a:ext uri="{0D108BD9-81ED-4DB2-BD59-A6C34878D82A}">
-                    <a16:rowId xmlns:a16="http://schemas.microsoft.com/office/drawing/2014/main" val="3949444652"/>
+                    <a16:rowId xmlns:a16="http://schemas.microsoft.com/office/drawing/2014/main" val="1430032645"/>
                   </a:ext>
                 </a:extLst>
               </a:tr>
@@ -16204,7 +16204,7 @@
                 </a:tc>
                 <a:extLst>
                   <a:ext uri="{0D108BD9-81ED-4DB2-BD59-A6C34878D82A}">
-                    <a16:rowId xmlns:a16="http://schemas.microsoft.com/office/drawing/2014/main" val="514384930"/>
+                    <a16:rowId xmlns:a16="http://schemas.microsoft.com/office/drawing/2014/main" val="4258313058"/>
                   </a:ext>
                 </a:extLst>
               </a:tr>
@@ -16337,7 +16337,7 @@
                 </a:tc>
                 <a:extLst>
                   <a:ext uri="{0D108BD9-81ED-4DB2-BD59-A6C34878D82A}">
-                    <a16:rowId xmlns:a16="http://schemas.microsoft.com/office/drawing/2014/main" val="3178105032"/>
+                    <a16:rowId xmlns:a16="http://schemas.microsoft.com/office/drawing/2014/main" val="28864441"/>
                   </a:ext>
                 </a:extLst>
               </a:tr>
@@ -16470,7 +16470,7 @@
                 </a:tc>
                 <a:extLst>
                   <a:ext uri="{0D108BD9-81ED-4DB2-BD59-A6C34878D82A}">
-                    <a16:rowId xmlns:a16="http://schemas.microsoft.com/office/drawing/2014/main" val="2996618080"/>
+                    <a16:rowId xmlns:a16="http://schemas.microsoft.com/office/drawing/2014/main" val="2949334616"/>
                   </a:ext>
                 </a:extLst>
               </a:tr>
@@ -16483,7 +16483,7 @@
           <p:cNvPr id="6" name="TextBox 5">
             <a:extLst>
               <a:ext uri="{FF2B5EF4-FFF2-40B4-BE49-F238E27FC236}">
-                <a16:creationId xmlns:a16="http://schemas.microsoft.com/office/drawing/2014/main" id="{3003F5CC-F7FE-7A69-DBB9-C203550A2B36}"/>
+                <a16:creationId xmlns:a16="http://schemas.microsoft.com/office/drawing/2014/main" id="{23230B7E-27AF-D5EB-44D4-B199D086251D}"/>
               </a:ext>
             </a:extLst>
           </p:cNvPr>
@@ -16528,7 +16528,7 @@
           <p:cNvPr id="7" name="TextBox 6">
             <a:extLst>
               <a:ext uri="{FF2B5EF4-FFF2-40B4-BE49-F238E27FC236}">
-                <a16:creationId xmlns:a16="http://schemas.microsoft.com/office/drawing/2014/main" id="{5C1F75AC-743E-E911-CA9D-0603C665F5D4}"/>
+                <a16:creationId xmlns:a16="http://schemas.microsoft.com/office/drawing/2014/main" id="{76900C8B-1292-08B6-BF7D-FBCAD9CEB608}"/>
               </a:ext>
             </a:extLst>
           </p:cNvPr>
@@ -16571,7 +16571,7 @@
     </p:spTree>
     <p:extLst>
       <p:ext uri="{BB962C8B-B14F-4D97-AF65-F5344CB8AC3E}">
-        <p14:creationId xmlns:p14="http://schemas.microsoft.com/office/powerpoint/2010/main" val="1628352625"/>
+        <p14:creationId xmlns:p14="http://schemas.microsoft.com/office/powerpoint/2010/main" val="2702726541"/>
       </p:ext>
     </p:extLst>
   </p:cSld>
@@ -16611,7 +16611,7 @@
           <p:cNvPr id="2" name="TextBox 1">
             <a:extLst>
               <a:ext uri="{FF2B5EF4-FFF2-40B4-BE49-F238E27FC236}">
-                <a16:creationId xmlns:a16="http://schemas.microsoft.com/office/drawing/2014/main" id="{3CEBBBB1-D908-6978-6DAB-CFB195E16130}"/>
+                <a16:creationId xmlns:a16="http://schemas.microsoft.com/office/drawing/2014/main" id="{267F16DC-E9A8-B583-0594-20534728AA84}"/>
               </a:ext>
             </a:extLst>
           </p:cNvPr>
@@ -16656,7 +16656,7 @@
           <p:cNvPr id="3" name="TextBox 2">
             <a:extLst>
               <a:ext uri="{FF2B5EF4-FFF2-40B4-BE49-F238E27FC236}">
-                <a16:creationId xmlns:a16="http://schemas.microsoft.com/office/drawing/2014/main" id="{0384101A-3B0A-E005-21F2-A32A23BD12C3}"/>
+                <a16:creationId xmlns:a16="http://schemas.microsoft.com/office/drawing/2014/main" id="{477D7371-2124-813E-6C93-DF86E6823E16}"/>
               </a:ext>
             </a:extLst>
           </p:cNvPr>
@@ -16707,7 +16707,7 @@
           <p:cNvPr id="4" name="Table 3">
             <a:extLst>
               <a:ext uri="{FF2B5EF4-FFF2-40B4-BE49-F238E27FC236}">
-                <a16:creationId xmlns:a16="http://schemas.microsoft.com/office/drawing/2014/main" id="{839EF2DC-4849-8EB8-41FB-5CC08BE4C7BB}"/>
+                <a16:creationId xmlns:a16="http://schemas.microsoft.com/office/drawing/2014/main" id="{B508A277-545E-17A1-C5C0-5D37E204B9BD}"/>
               </a:ext>
             </a:extLst>
           </p:cNvPr>
@@ -16717,7 +16717,7 @@
           <p:nvPr>
             <p:extLst>
               <p:ext uri="{D42A27DB-BD31-4B8C-83A1-F6EECF244321}">
-                <p14:modId xmlns:p14="http://schemas.microsoft.com/office/powerpoint/2010/main" val="3939285875"/>
+                <p14:modId xmlns:p14="http://schemas.microsoft.com/office/powerpoint/2010/main" val="2390203610"/>
               </p:ext>
             </p:extLst>
           </p:nvPr>
@@ -16736,35 +16736,35 @@
                 <a:gridCol w="3810000">
                   <a:extLst>
                     <a:ext uri="{9D8B030D-6E8A-4147-A177-3AD203B41FA5}">
-                      <a16:colId xmlns:a16="http://schemas.microsoft.com/office/drawing/2014/main" val="2802902501"/>
+                      <a16:colId xmlns:a16="http://schemas.microsoft.com/office/drawing/2014/main" val="1403984627"/>
                     </a:ext>
                   </a:extLst>
                 </a:gridCol>
                 <a:gridCol w="1016000">
                   <a:extLst>
                     <a:ext uri="{9D8B030D-6E8A-4147-A177-3AD203B41FA5}">
-                      <a16:colId xmlns:a16="http://schemas.microsoft.com/office/drawing/2014/main" val="2474154842"/>
+                      <a16:colId xmlns:a16="http://schemas.microsoft.com/office/drawing/2014/main" val="431130825"/>
                     </a:ext>
                   </a:extLst>
                 </a:gridCol>
                 <a:gridCol w="2032000">
                   <a:extLst>
                     <a:ext uri="{9D8B030D-6E8A-4147-A177-3AD203B41FA5}">
-                      <a16:colId xmlns:a16="http://schemas.microsoft.com/office/drawing/2014/main" val="3157022336"/>
+                      <a16:colId xmlns:a16="http://schemas.microsoft.com/office/drawing/2014/main" val="123444724"/>
                     </a:ext>
                   </a:extLst>
                 </a:gridCol>
                 <a:gridCol w="2032000">
                   <a:extLst>
                     <a:ext uri="{9D8B030D-6E8A-4147-A177-3AD203B41FA5}">
-                      <a16:colId xmlns:a16="http://schemas.microsoft.com/office/drawing/2014/main" val="3387723779"/>
+                      <a16:colId xmlns:a16="http://schemas.microsoft.com/office/drawing/2014/main" val="416654287"/>
                     </a:ext>
                   </a:extLst>
                 </a:gridCol>
                 <a:gridCol w="2032000">
                   <a:extLst>
                     <a:ext uri="{9D8B030D-6E8A-4147-A177-3AD203B41FA5}">
-                      <a16:colId xmlns:a16="http://schemas.microsoft.com/office/drawing/2014/main" val="462388645"/>
+                      <a16:colId xmlns:a16="http://schemas.microsoft.com/office/drawing/2014/main" val="2836748067"/>
                     </a:ext>
                   </a:extLst>
                 </a:gridCol>
@@ -16982,7 +16982,7 @@
                 </a:tc>
                 <a:extLst>
                   <a:ext uri="{0D108BD9-81ED-4DB2-BD59-A6C34878D82A}">
-                    <a16:rowId xmlns:a16="http://schemas.microsoft.com/office/drawing/2014/main" val="2668157392"/>
+                    <a16:rowId xmlns:a16="http://schemas.microsoft.com/office/drawing/2014/main" val="2302773172"/>
                   </a:ext>
                 </a:extLst>
               </a:tr>
@@ -17199,7 +17199,7 @@
                 </a:tc>
                 <a:extLst>
                   <a:ext uri="{0D108BD9-81ED-4DB2-BD59-A6C34878D82A}">
-                    <a16:rowId xmlns:a16="http://schemas.microsoft.com/office/drawing/2014/main" val="2033613068"/>
+                    <a16:rowId xmlns:a16="http://schemas.microsoft.com/office/drawing/2014/main" val="826111151"/>
                   </a:ext>
                 </a:extLst>
               </a:tr>
@@ -17416,7 +17416,7 @@
                 </a:tc>
                 <a:extLst>
                   <a:ext uri="{0D108BD9-81ED-4DB2-BD59-A6C34878D82A}">
-                    <a16:rowId xmlns:a16="http://schemas.microsoft.com/office/drawing/2014/main" val="862856242"/>
+                    <a16:rowId xmlns:a16="http://schemas.microsoft.com/office/drawing/2014/main" val="407550352"/>
                   </a:ext>
                 </a:extLst>
               </a:tr>
@@ -17633,7 +17633,7 @@
                 </a:tc>
                 <a:extLst>
                   <a:ext uri="{0D108BD9-81ED-4DB2-BD59-A6C34878D82A}">
-                    <a16:rowId xmlns:a16="http://schemas.microsoft.com/office/drawing/2014/main" val="701161998"/>
+                    <a16:rowId xmlns:a16="http://schemas.microsoft.com/office/drawing/2014/main" val="510581478"/>
                   </a:ext>
                 </a:extLst>
               </a:tr>
@@ -17850,7 +17850,7 @@
                 </a:tc>
                 <a:extLst>
                   <a:ext uri="{0D108BD9-81ED-4DB2-BD59-A6C34878D82A}">
-                    <a16:rowId xmlns:a16="http://schemas.microsoft.com/office/drawing/2014/main" val="1503710281"/>
+                    <a16:rowId xmlns:a16="http://schemas.microsoft.com/office/drawing/2014/main" val="1336223254"/>
                   </a:ext>
                 </a:extLst>
               </a:tr>
@@ -18067,7 +18067,7 @@
                 </a:tc>
                 <a:extLst>
                   <a:ext uri="{0D108BD9-81ED-4DB2-BD59-A6C34878D82A}">
-                    <a16:rowId xmlns:a16="http://schemas.microsoft.com/office/drawing/2014/main" val="71782302"/>
+                    <a16:rowId xmlns:a16="http://schemas.microsoft.com/office/drawing/2014/main" val="3429864367"/>
                   </a:ext>
                 </a:extLst>
               </a:tr>
@@ -18080,7 +18080,7 @@
           <p:cNvPr id="5" name="TextBox 4">
             <a:extLst>
               <a:ext uri="{FF2B5EF4-FFF2-40B4-BE49-F238E27FC236}">
-                <a16:creationId xmlns:a16="http://schemas.microsoft.com/office/drawing/2014/main" id="{6FAD10B0-1FBB-21D2-79FB-A060440A3E6D}"/>
+                <a16:creationId xmlns:a16="http://schemas.microsoft.com/office/drawing/2014/main" id="{2898D917-2511-1486-E907-98233E8BA860}"/>
               </a:ext>
             </a:extLst>
           </p:cNvPr>
@@ -18131,7 +18131,7 @@
           <p:cNvPr id="6" name="TextBox 5">
             <a:extLst>
               <a:ext uri="{FF2B5EF4-FFF2-40B4-BE49-F238E27FC236}">
-                <a16:creationId xmlns:a16="http://schemas.microsoft.com/office/drawing/2014/main" id="{BFF7A516-2D02-D2F8-DFE2-1E156D12C1C8}"/>
+                <a16:creationId xmlns:a16="http://schemas.microsoft.com/office/drawing/2014/main" id="{AC7826E2-B5EC-6632-FBA0-796D04871956}"/>
               </a:ext>
             </a:extLst>
           </p:cNvPr>
@@ -18176,7 +18176,7 @@
           <p:cNvPr id="7" name="TextBox 6">
             <a:extLst>
               <a:ext uri="{FF2B5EF4-FFF2-40B4-BE49-F238E27FC236}">
-                <a16:creationId xmlns:a16="http://schemas.microsoft.com/office/drawing/2014/main" id="{41F58AD5-C6CA-3647-2797-7CAB30692BC2}"/>
+                <a16:creationId xmlns:a16="http://schemas.microsoft.com/office/drawing/2014/main" id="{8F5E7923-F7CF-5407-C272-CBEEC8E3F4BF}"/>
               </a:ext>
             </a:extLst>
           </p:cNvPr>
@@ -18219,7 +18219,7 @@
     </p:spTree>
     <p:extLst>
       <p:ext uri="{BB962C8B-B14F-4D97-AF65-F5344CB8AC3E}">
-        <p14:creationId xmlns:p14="http://schemas.microsoft.com/office/powerpoint/2010/main" val="462564666"/>
+        <p14:creationId xmlns:p14="http://schemas.microsoft.com/office/powerpoint/2010/main" val="2556659909"/>
       </p:ext>
     </p:extLst>
   </p:cSld>

</xml_diff>

<commit_message>
Update report, experiments and demo examples
</commit_message>
<xml_diff>
--- a/output/presentation/CricketShot_Presentation.pptx
+++ b/output/presentation/CricketShot_Presentation.pptx
@@ -205,7 +205,7 @@
             </a:lvl1pPr>
           </a:lstStyle>
           <a:p>
-            <a:fld id="{7A8255CF-EF48-4FE2-9F24-AFB83501EFF9}" type="datetimeFigureOut">
+            <a:fld id="{0A0CB448-8CD0-43B2-873A-FF1FC171ACA2}" type="datetimeFigureOut">
               <a:rPr lang="en-IN" smtClean="0"/>
               <a:t>19-10-2026</a:t>
             </a:fld>
@@ -364,7 +364,7 @@
             </a:lvl1pPr>
           </a:lstStyle>
           <a:p>
-            <a:fld id="{37BF998F-1D90-427D-8AB2-4E508FBD6897}" type="slidenum">
+            <a:fld id="{CB6D05BF-3823-4251-85D6-8F40948E3712}" type="slidenum">
               <a:rPr lang="en-IN" smtClean="0"/>
               <a:t>‹#›</a:t>
             </a:fld>
@@ -375,7 +375,7 @@
     </p:spTree>
     <p:extLst>
       <p:ext uri="{BB962C8B-B14F-4D97-AF65-F5344CB8AC3E}">
-        <p14:creationId xmlns:p14="http://schemas.microsoft.com/office/powerpoint/2010/main" val="1902088556"/>
+        <p14:creationId xmlns:p14="http://schemas.microsoft.com/office/powerpoint/2010/main" val="2249882167"/>
       </p:ext>
     </p:extLst>
   </p:cSld>
@@ -542,7 +542,7 @@
           <a:bodyPr/>
           <a:lstStyle/>
           <a:p>
-            <a:fld id="{37BF998F-1D90-427D-8AB2-4E508FBD6897}" type="slidenum">
+            <a:fld id="{CB6D05BF-3823-4251-85D6-8F40948E3712}" type="slidenum">
               <a:rPr lang="en-IN" smtClean="0"/>
               <a:t>1</a:t>
             </a:fld>
@@ -553,7 +553,7 @@
     </p:spTree>
     <p:extLst>
       <p:ext uri="{BB962C8B-B14F-4D97-AF65-F5344CB8AC3E}">
-        <p14:creationId xmlns:p14="http://schemas.microsoft.com/office/powerpoint/2010/main" val="3431530483"/>
+        <p14:creationId xmlns:p14="http://schemas.microsoft.com/office/powerpoint/2010/main" val="117299915"/>
       </p:ext>
     </p:extLst>
   </p:cSld>
@@ -609,7 +609,7 @@
           <a:p>
             <a:r>
               <a:rPr lang="en-US"/>
-              <a:t>Draw groups with replacement and keep all images within each drawn group. Reuse draws between methods for paired differences. Statistics are image-weighted in each resample. Intervals omit training/split variability and unknown match correlation. They are not a hypothesis-test certificate of equality. Contrast 619/945, concatenation 616/945. Data and calculations: scripts/analyze_revision.py.</a:t>
+              <a:t>This descriptive analysis uses unchanged saved test predictions. Cases are first IDs in gain/loss categories, selected after evaluation. image_00696: label drive; global drive, crop pull, concat pull, contrast drive. image_00017: label drive; global drive, crop glance/flick, concat drive, contrast glance/flick. Agreement subsets do not identify a causal mechanism or validate a new selection rule. For uncertainty, resample the 70 visual groups, retaining all their images, in 2000 paired draws with seed17; image-weighted statistics. The interval omits training/split variability and unknown match correlation. Complete individual-method intervals remain in report and results/revision/comparison.json; case evidence is in view_diagnostics.json.</a:t>
             </a:r>
             <a:endParaRPr lang="en-IN"/>
           </a:p>
@@ -630,7 +630,7 @@
           <a:bodyPr/>
           <a:lstStyle/>
           <a:p>
-            <a:fld id="{37BF998F-1D90-427D-8AB2-4E508FBD6897}" type="slidenum">
+            <a:fld id="{CB6D05BF-3823-4251-85D6-8F40948E3712}" type="slidenum">
               <a:rPr lang="en-IN" smtClean="0"/>
               <a:t>10</a:t>
             </a:fld>
@@ -641,7 +641,7 @@
     </p:spTree>
     <p:extLst>
       <p:ext uri="{BB962C8B-B14F-4D97-AF65-F5344CB8AC3E}">
-        <p14:creationId xmlns:p14="http://schemas.microsoft.com/office/powerpoint/2010/main" val="690376583"/>
+        <p14:creationId xmlns:p14="http://schemas.microsoft.com/office/powerpoint/2010/main" val="1800606735"/>
       </p:ext>
     </p:extLst>
   </p:cSld>
@@ -718,7 +718,7 @@
           <a:bodyPr/>
           <a:lstStyle/>
           <a:p>
-            <a:fld id="{37BF998F-1D90-427D-8AB2-4E508FBD6897}" type="slidenum">
+            <a:fld id="{CB6D05BF-3823-4251-85D6-8F40948E3712}" type="slidenum">
               <a:rPr lang="en-IN" smtClean="0"/>
               <a:t>11</a:t>
             </a:fld>
@@ -729,7 +729,7 @@
     </p:spTree>
     <p:extLst>
       <p:ext uri="{BB962C8B-B14F-4D97-AF65-F5344CB8AC3E}">
-        <p14:creationId xmlns:p14="http://schemas.microsoft.com/office/powerpoint/2010/main" val="1207955261"/>
+        <p14:creationId xmlns:p14="http://schemas.microsoft.com/office/powerpoint/2010/main" val="2926563933"/>
       </p:ext>
     </p:extLst>
   </p:cSld>
@@ -785,7 +785,7 @@
           <a:p>
             <a:r>
               <a:rPr lang="en-US"/>
-              <a:t>NLL and ECE worsen; do not say calibration improved. ECE uses ten equal-width confidence bins. The same validation set selected C, temperature and threshold. The gate needs global/crop/contrast agreement; the heads are correlated. HOG scores are unscaled and do not affect review. Sources: https://proceedings.mlr.press/v70/guo17a.html ; https://arxiv.org/abs/1705.08500 .</a:t>
+              <a:t>NLL and ECE worsen. ECE uses ten equal-width confidence bins. The same validation set selected C, temperature and threshold; the 90% validation target did not transfer to test. The gate needs global/crop/contrast agreement; the heads are correlated. It accepts557/945 with433 correct. Its measured benefit over confidence alone is tiny. Retain it as visible triage for conflicting views; diagnostic heads use the same two encoder outputs, adding no encoder pass. HOG scores are unscaled and do not affect review. Sources: https://proceedings.mlr.press/v70/guo17a.html ; https://arxiv.org/abs/1705.08500 .</a:t>
             </a:r>
             <a:endParaRPr lang="en-IN"/>
           </a:p>
@@ -806,7 +806,7 @@
           <a:bodyPr/>
           <a:lstStyle/>
           <a:p>
-            <a:fld id="{37BF998F-1D90-427D-8AB2-4E508FBD6897}" type="slidenum">
+            <a:fld id="{CB6D05BF-3823-4251-85D6-8F40948E3712}" type="slidenum">
               <a:rPr lang="en-IN" smtClean="0"/>
               <a:t>12</a:t>
             </a:fld>
@@ -817,7 +817,7 @@
     </p:spTree>
     <p:extLst>
       <p:ext uri="{BB962C8B-B14F-4D97-AF65-F5344CB8AC3E}">
-        <p14:creationId xmlns:p14="http://schemas.microsoft.com/office/powerpoint/2010/main" val="3872893741"/>
+        <p14:creationId xmlns:p14="http://schemas.microsoft.com/office/powerpoint/2010/main" val="1865189731"/>
       </p:ext>
     </p:extLst>
   </p:cSld>
@@ -894,7 +894,7 @@
           <a:bodyPr/>
           <a:lstStyle/>
           <a:p>
-            <a:fld id="{37BF998F-1D90-427D-8AB2-4E508FBD6897}" type="slidenum">
+            <a:fld id="{CB6D05BF-3823-4251-85D6-8F40948E3712}" type="slidenum">
               <a:rPr lang="en-IN" smtClean="0"/>
               <a:t>13</a:t>
             </a:fld>
@@ -905,7 +905,7 @@
     </p:spTree>
     <p:extLst>
       <p:ext uri="{BB962C8B-B14F-4D97-AF65-F5344CB8AC3E}">
-        <p14:creationId xmlns:p14="http://schemas.microsoft.com/office/powerpoint/2010/main" val="3236615899"/>
+        <p14:creationId xmlns:p14="http://schemas.microsoft.com/office/powerpoint/2010/main" val="3628834908"/>
       </p:ext>
     </p:extLst>
   </p:cSld>
@@ -961,7 +961,7 @@
           <a:p>
             <a:r>
               <a:rPr lang="en-US"/>
-              <a:t>Run setup.bat on a fresh machine, then run_demo.bat. Default URL http://127.0.0.1:6040. Revision verification may use 6060 to avoid another local service. Show success image_00210, confident error image_04199 and disagreement image_00014. Selected examples are honestly labeled. JSON preserves temperature-scaled score semantics. Screenshot must come from the revised running app, not a mockup.</a:t>
+              <a:t>Run setup.bat on a fresh machine, then run_demo.bat. Install and rehearse before going offline. Default URL http://127.0.0.1:6040. Five shipped JPEG illustrations cover all four successful class labels plus confident error image_04199. The full local package also has original disagreement image_00014; public clones can restore it optionally. Fresh scores are computed from actual input files; JPEG inputs may differ from original benchmark pixels. All examples were selected after evaluation. Show actual views and HOG, then export JSON. Screenshot source is the running app.</a:t>
             </a:r>
             <a:endParaRPr lang="en-IN"/>
           </a:p>
@@ -982,7 +982,7 @@
           <a:bodyPr/>
           <a:lstStyle/>
           <a:p>
-            <a:fld id="{37BF998F-1D90-427D-8AB2-4E508FBD6897}" type="slidenum">
+            <a:fld id="{CB6D05BF-3823-4251-85D6-8F40948E3712}" type="slidenum">
               <a:rPr lang="en-IN" smtClean="0"/>
               <a:t>14</a:t>
             </a:fld>
@@ -993,7 +993,7 @@
     </p:spTree>
     <p:extLst>
       <p:ext uri="{BB962C8B-B14F-4D97-AF65-F5344CB8AC3E}">
-        <p14:creationId xmlns:p14="http://schemas.microsoft.com/office/powerpoint/2010/main" val="966308097"/>
+        <p14:creationId xmlns:p14="http://schemas.microsoft.com/office/powerpoint/2010/main" val="3278748687"/>
       </p:ext>
     </p:extLst>
   </p:cSld>
@@ -1049,7 +1049,7 @@
           <a:p>
             <a:r>
               <a:rPr lang="en-US"/>
-              <a:t>Novelty remains a weakness, not a promise of marks. Do not claim a new architecture, detector or state-of-the-art result. Mention unknown upstream license, possible missed copies and unverified labels. Course mapping and viva guide contain actual page references and a tensor-shape trace. Team identities and the real repository URL are on the cover.</a:t>
+              <a:t>The implemented contribution is the controlled comparison and inspectable integration of two-view absolute differences and diagnostic agreement. Components are established; HOG itself is not new. The measured gain is uncertain, so do not claim a new architecture, detector or state-of-the-art result. The audit also corrects an optimistic initial result, and calibration fails to transfer. Mention possible missed copies and unverified labels. Course mapping and viva guide contain page references and a measured trace. Team identities and repository URL are on the cover.</a:t>
             </a:r>
             <a:endParaRPr lang="en-IN"/>
           </a:p>
@@ -1070,7 +1070,7 @@
           <a:bodyPr/>
           <a:lstStyle/>
           <a:p>
-            <a:fld id="{37BF998F-1D90-427D-8AB2-4E508FBD6897}" type="slidenum">
+            <a:fld id="{CB6D05BF-3823-4251-85D6-8F40948E3712}" type="slidenum">
               <a:rPr lang="en-IN" smtClean="0"/>
               <a:t>15</a:t>
             </a:fld>
@@ -1081,7 +1081,7 @@
     </p:spTree>
     <p:extLst>
       <p:ext uri="{BB962C8B-B14F-4D97-AF65-F5344CB8AC3E}">
-        <p14:creationId xmlns:p14="http://schemas.microsoft.com/office/powerpoint/2010/main" val="3895531773"/>
+        <p14:creationId xmlns:p14="http://schemas.microsoft.com/office/powerpoint/2010/main" val="1485376136"/>
       </p:ext>
     </p:extLst>
   </p:cSld>
@@ -1158,7 +1158,7 @@
           <a:bodyPr/>
           <a:lstStyle/>
           <a:p>
-            <a:fld id="{37BF998F-1D90-427D-8AB2-4E508FBD6897}" type="slidenum">
+            <a:fld id="{CB6D05BF-3823-4251-85D6-8F40948E3712}" type="slidenum">
               <a:rPr lang="en-IN" smtClean="0"/>
               <a:t>16</a:t>
             </a:fld>
@@ -1169,7 +1169,7 @@
     </p:spTree>
     <p:extLst>
       <p:ext uri="{BB962C8B-B14F-4D97-AF65-F5344CB8AC3E}">
-        <p14:creationId xmlns:p14="http://schemas.microsoft.com/office/powerpoint/2010/main" val="2177513548"/>
+        <p14:creationId xmlns:p14="http://schemas.microsoft.com/office/powerpoint/2010/main" val="3125352997"/>
       </p:ext>
     </p:extLst>
   </p:cSld>
@@ -1246,7 +1246,7 @@
           <a:bodyPr/>
           <a:lstStyle/>
           <a:p>
-            <a:fld id="{37BF998F-1D90-427D-8AB2-4E508FBD6897}" type="slidenum">
+            <a:fld id="{CB6D05BF-3823-4251-85D6-8F40948E3712}" type="slidenum">
               <a:rPr lang="en-IN" smtClean="0"/>
               <a:t>2</a:t>
             </a:fld>
@@ -1257,7 +1257,7 @@
     </p:spTree>
     <p:extLst>
       <p:ext uri="{BB962C8B-B14F-4D97-AF65-F5344CB8AC3E}">
-        <p14:creationId xmlns:p14="http://schemas.microsoft.com/office/powerpoint/2010/main" val="430174793"/>
+        <p14:creationId xmlns:p14="http://schemas.microsoft.com/office/powerpoint/2010/main" val="1510356705"/>
       </p:ext>
     </p:extLst>
   </p:cSld>
@@ -1312,10 +1312,9 @@
           <a:lstStyle/>
           <a:p>
             <a:r>
-              <a:rPr lang="en-US"/>
-              <a:t>Lecture 8 part 2 page 9 distinguishes local/global features; our crop is a regional descriptor, not a keypoint. Lecture 14 part 2 pp 2-3 and 27 cover extractor/classifier and softmax. MobileNetV2 is our architecture choice, not claimed taught by name. Sources: https://lear.inrialpes.fr/people/triggs/pubs/Dalal-cvpr05.pdf ; https://arxiv.org/abs/1801.04381 ; https://github.com/AtanuCSE/CricketShotDetection ; https://arxiv.org/abs/2510.09187 . Do not compare published percentages across datasets.</a:t>
+              <a:rPr lang="en-IN"/>
+              <a:t>Sen et al.: CricShotClassify, Sensors 21(8), 2846 (2021), https://www.mdpi.com/1424-8220/21/8/2846 . CNN frame features and GRU, including frozen and partly fine-tuned VGG16 variants. Kang: https://arxiv.org/abs/2510.09187 , a preprint comparing sequence models and proposing EfficientNet-B0 with bidirectional GRU and temporal attention. No code or datasets from either paper were imported. KUCricShot authors' repository https://github.com/AtanuCSE/CricketShotDetection describes a separate four-shot, 1278-example dataset, also unused. Lecture 8 part 2 p9 distinguishes local/global features. Lecture 14 part 2 pp2-3 and 27 covers extractor/classifier and softmax. We implement an image comparison, not a new backbone or a priority claim.</a:t>
             </a:r>
-            <a:endParaRPr lang="en-IN"/>
           </a:p>
         </p:txBody>
       </p:sp>
@@ -1334,7 +1333,7 @@
           <a:bodyPr/>
           <a:lstStyle/>
           <a:p>
-            <a:fld id="{37BF998F-1D90-427D-8AB2-4E508FBD6897}" type="slidenum">
+            <a:fld id="{CB6D05BF-3823-4251-85D6-8F40948E3712}" type="slidenum">
               <a:rPr lang="en-IN" smtClean="0"/>
               <a:t>3</a:t>
             </a:fld>
@@ -1345,7 +1344,7 @@
     </p:spTree>
     <p:extLst>
       <p:ext uri="{BB962C8B-B14F-4D97-AF65-F5344CB8AC3E}">
-        <p14:creationId xmlns:p14="http://schemas.microsoft.com/office/powerpoint/2010/main" val="734832931"/>
+        <p14:creationId xmlns:p14="http://schemas.microsoft.com/office/powerpoint/2010/main" val="2884638227"/>
       </p:ext>
     </p:extLst>
   </p:cSld>
@@ -1422,7 +1421,7 @@
           <a:bodyPr/>
           <a:lstStyle/>
           <a:p>
-            <a:fld id="{37BF998F-1D90-427D-8AB2-4E508FBD6897}" type="slidenum">
+            <a:fld id="{CB6D05BF-3823-4251-85D6-8F40948E3712}" type="slidenum">
               <a:rPr lang="en-IN" smtClean="0"/>
               <a:t>4</a:t>
             </a:fld>
@@ -1433,7 +1432,7 @@
     </p:spTree>
     <p:extLst>
       <p:ext uri="{BB962C8B-B14F-4D97-AF65-F5344CB8AC3E}">
-        <p14:creationId xmlns:p14="http://schemas.microsoft.com/office/powerpoint/2010/main" val="3358629238"/>
+        <p14:creationId xmlns:p14="http://schemas.microsoft.com/office/powerpoint/2010/main" val="4069658076"/>
       </p:ext>
     </p:extLst>
   </p:cSld>
@@ -1510,7 +1509,7 @@
           <a:bodyPr/>
           <a:lstStyle/>
           <a:p>
-            <a:fld id="{37BF998F-1D90-427D-8AB2-4E508FBD6897}" type="slidenum">
+            <a:fld id="{CB6D05BF-3823-4251-85D6-8F40948E3712}" type="slidenum">
               <a:rPr lang="en-IN" smtClean="0"/>
               <a:t>5</a:t>
             </a:fld>
@@ -1521,7 +1520,7 @@
     </p:spTree>
     <p:extLst>
       <p:ext uri="{BB962C8B-B14F-4D97-AF65-F5344CB8AC3E}">
-        <p14:creationId xmlns:p14="http://schemas.microsoft.com/office/powerpoint/2010/main" val="4068651146"/>
+        <p14:creationId xmlns:p14="http://schemas.microsoft.com/office/powerpoint/2010/main" val="2785798324"/>
       </p:ext>
     </p:extLst>
   </p:cSld>
@@ -1577,7 +1576,7 @@
           <a:p>
             <a:r>
               <a:rPr lang="en-US"/>
-              <a:t>Explain the two branches. HOG and CNN global inputs have identical aspect-preserving 224 square geometry. CNN has two view passes; its global, crop and fused heads share features. HOG uses luminance, unsigned gradients, cells, blocks and per-image normalization. No StandardScaler or PCA learns from test. Source: actual implemented pipeline; lecture mapping in docs/course_mapping.md.</a:t>
+              <a:t>Explain the two branches. HOG and CNN global inputs have identical aspect-preserving 224 square geometry. The fixed crop reduces some background without training a detector, but can miss an off-center batter. Keeping the global view preserves a second source of context, although square center fitting also removes peripheral pixels. MobileNetV2 is an efficient ImageNet backbone selected for CPU use; freezing limits cricket fitting to small heads on only 221 training groups. This is design reasoning, not proof that freezing or this model is optimal. CNN has two view passes; its heads share features. Source: actual implemented pipeline, https://arxiv.org/abs/1801.04381 , and docs/course_mapping.md.</a:t>
             </a:r>
             <a:endParaRPr lang="en-IN"/>
           </a:p>
@@ -1598,7 +1597,7 @@
           <a:bodyPr/>
           <a:lstStyle/>
           <a:p>
-            <a:fld id="{37BF998F-1D90-427D-8AB2-4E508FBD6897}" type="slidenum">
+            <a:fld id="{CB6D05BF-3823-4251-85D6-8F40948E3712}" type="slidenum">
               <a:rPr lang="en-IN" smtClean="0"/>
               <a:t>6</a:t>
             </a:fld>
@@ -1609,7 +1608,7 @@
     </p:spTree>
     <p:extLst>
       <p:ext uri="{BB962C8B-B14F-4D97-AF65-F5344CB8AC3E}">
-        <p14:creationId xmlns:p14="http://schemas.microsoft.com/office/powerpoint/2010/main" val="470906534"/>
+        <p14:creationId xmlns:p14="http://schemas.microsoft.com/office/powerpoint/2010/main" val="1378751336"/>
       </p:ext>
     </p:extLst>
   </p:cSld>
@@ -1686,7 +1685,7 @@
           <a:bodyPr/>
           <a:lstStyle/>
           <a:p>
-            <a:fld id="{37BF998F-1D90-427D-8AB2-4E508FBD6897}" type="slidenum">
+            <a:fld id="{CB6D05BF-3823-4251-85D6-8F40948E3712}" type="slidenum">
               <a:rPr lang="en-IN" smtClean="0"/>
               <a:t>7</a:t>
             </a:fld>
@@ -1697,7 +1696,7 @@
     </p:spTree>
     <p:extLst>
       <p:ext uri="{BB962C8B-B14F-4D97-AF65-F5344CB8AC3E}">
-        <p14:creationId xmlns:p14="http://schemas.microsoft.com/office/powerpoint/2010/main" val="1339495662"/>
+        <p14:creationId xmlns:p14="http://schemas.microsoft.com/office/powerpoint/2010/main" val="2713292730"/>
       </p:ext>
     </p:extLst>
   </p:cSld>
@@ -1753,7 +1752,7 @@
           <a:p>
             <a:r>
               <a:rPr lang="en-US"/>
-              <a:t>Both vectors are normalized before joining; the joined descriptor is normalized again. Contrast W has (4,3840) shape plus four biases. It learns weighted multiclass cross-entropy with L2 regularization. No bat-motion interpretation is assigned to feature coordinates. Actual inputs are displayed in the demo. MobileNetV2: https://arxiv.org/abs/1801.04381 ; ONNX weights: https://github.com/onnx/models .</a:t>
+              <a:t>Both vectors are L2-normalized before joining so their raw magnitudes do not set the relative block scale; the joined descriptor is normalized again. Equal norm does not imply equal usefulness. No normalization ablation was conducted. A linear head on concatenation can compute signed u-v but cannot generally compute abs(u-v); the explicit block supplies this nonlinear relation. This is the motivation to test, not proof of improvement. Contrast W has (4,3840) shape plus four biases, 15364 stored parameters, trained with weighted multiclass cross-entropy and L2 regularization. No bat-motion interpretation is assigned to coordinates. MobileNetV2: https://arxiv.org/abs/1801.04381 ; weights: https://github.com/onnx/models .</a:t>
             </a:r>
             <a:endParaRPr lang="en-IN"/>
           </a:p>
@@ -1774,7 +1773,7 @@
           <a:bodyPr/>
           <a:lstStyle/>
           <a:p>
-            <a:fld id="{37BF998F-1D90-427D-8AB2-4E508FBD6897}" type="slidenum">
+            <a:fld id="{CB6D05BF-3823-4251-85D6-8F40948E3712}" type="slidenum">
               <a:rPr lang="en-IN" smtClean="0"/>
               <a:t>8</a:t>
             </a:fld>
@@ -1785,7 +1784,7 @@
     </p:spTree>
     <p:extLst>
       <p:ext uri="{BB962C8B-B14F-4D97-AF65-F5344CB8AC3E}">
-        <p14:creationId xmlns:p14="http://schemas.microsoft.com/office/powerpoint/2010/main" val="254243973"/>
+        <p14:creationId xmlns:p14="http://schemas.microsoft.com/office/powerpoint/2010/main" val="3950751163"/>
       </p:ext>
     </p:extLst>
   </p:cSld>
@@ -1862,7 +1861,7 @@
           <a:bodyPr/>
           <a:lstStyle/>
           <a:p>
-            <a:fld id="{37BF998F-1D90-427D-8AB2-4E508FBD6897}" type="slidenum">
+            <a:fld id="{CB6D05BF-3823-4251-85D6-8F40948E3712}" type="slidenum">
               <a:rPr lang="en-IN" smtClean="0"/>
               <a:t>9</a:t>
             </a:fld>
@@ -1873,7 +1872,7 @@
     </p:spTree>
     <p:extLst>
       <p:ext uri="{BB962C8B-B14F-4D97-AF65-F5344CB8AC3E}">
-        <p14:creationId xmlns:p14="http://schemas.microsoft.com/office/powerpoint/2010/main" val="709105717"/>
+        <p14:creationId xmlns:p14="http://schemas.microsoft.com/office/powerpoint/2010/main" val="3181840052"/>
       </p:ext>
     </p:extLst>
   </p:cSld>
@@ -1905,7 +1904,7 @@
           <p:cNvPr id="2" name="Title 1">
             <a:extLst>
               <a:ext uri="{FF2B5EF4-FFF2-40B4-BE49-F238E27FC236}">
-                <a16:creationId xmlns:a16="http://schemas.microsoft.com/office/drawing/2014/main" id="{1F3D8518-0D12-282F-2289-7F82015D8DFE}"/>
+                <a16:creationId xmlns:a16="http://schemas.microsoft.com/office/drawing/2014/main" id="{716E1839-1072-7A4C-2D15-0E56DE762A91}"/>
               </a:ext>
             </a:extLst>
           </p:cNvPr>
@@ -1943,7 +1942,7 @@
           <p:cNvPr id="3" name="Subtitle 2">
             <a:extLst>
               <a:ext uri="{FF2B5EF4-FFF2-40B4-BE49-F238E27FC236}">
-                <a16:creationId xmlns:a16="http://schemas.microsoft.com/office/drawing/2014/main" id="{6B008C35-6549-C7F1-90E6-F0CAE6E3A3A0}"/>
+                <a16:creationId xmlns:a16="http://schemas.microsoft.com/office/drawing/2014/main" id="{958C9CD2-5793-CADE-5BDF-0EDDF318D910}"/>
               </a:ext>
             </a:extLst>
           </p:cNvPr>
@@ -2014,7 +2013,7 @@
           <p:cNvPr id="4" name="Date Placeholder 3">
             <a:extLst>
               <a:ext uri="{FF2B5EF4-FFF2-40B4-BE49-F238E27FC236}">
-                <a16:creationId xmlns:a16="http://schemas.microsoft.com/office/drawing/2014/main" id="{3C9E370A-981A-CDA3-A23C-2A50D25B2CA1}"/>
+                <a16:creationId xmlns:a16="http://schemas.microsoft.com/office/drawing/2014/main" id="{C7409789-81F8-7D59-1CD6-7CD2ECEBF96E}"/>
               </a:ext>
             </a:extLst>
           </p:cNvPr>
@@ -2030,7 +2029,7 @@
           <a:bodyPr/>
           <a:lstStyle/>
           <a:p>
-            <a:fld id="{CFA8807D-23B5-470F-A350-DF6C7A298D37}" type="datetimeFigureOut">
+            <a:fld id="{DDF74FE0-EBC5-4AB9-800B-A335A3F14358}" type="datetimeFigureOut">
               <a:rPr lang="en-IN" smtClean="0"/>
               <a:t>19-10-2026</a:t>
             </a:fld>
@@ -2043,7 +2042,7 @@
           <p:cNvPr id="5" name="Footer Placeholder 4">
             <a:extLst>
               <a:ext uri="{FF2B5EF4-FFF2-40B4-BE49-F238E27FC236}">
-                <a16:creationId xmlns:a16="http://schemas.microsoft.com/office/drawing/2014/main" id="{AE813A50-ACAE-8592-1E35-1DEF50867D9F}"/>
+                <a16:creationId xmlns:a16="http://schemas.microsoft.com/office/drawing/2014/main" id="{3CB5837B-90B8-A97E-536A-216B57C0542B}"/>
               </a:ext>
             </a:extLst>
           </p:cNvPr>
@@ -2068,7 +2067,7 @@
           <p:cNvPr id="6" name="Slide Number Placeholder 5">
             <a:extLst>
               <a:ext uri="{FF2B5EF4-FFF2-40B4-BE49-F238E27FC236}">
-                <a16:creationId xmlns:a16="http://schemas.microsoft.com/office/drawing/2014/main" id="{5BC70A0D-D543-45F9-CBDD-76FF2281C4D9}"/>
+                <a16:creationId xmlns:a16="http://schemas.microsoft.com/office/drawing/2014/main" id="{DBFC46DF-0B84-5467-E423-E5C925875079}"/>
               </a:ext>
             </a:extLst>
           </p:cNvPr>
@@ -2084,7 +2083,7 @@
           <a:bodyPr/>
           <a:lstStyle/>
           <a:p>
-            <a:fld id="{934BEE5F-DF1C-4A89-BBCC-A9D5D9EBCB77}" type="slidenum">
+            <a:fld id="{937938ED-2178-43B3-9AAE-1648119C4B05}" type="slidenum">
               <a:rPr lang="en-IN" smtClean="0"/>
               <a:t>‹#›</a:t>
             </a:fld>
@@ -2095,7 +2094,7 @@
     </p:spTree>
     <p:extLst>
       <p:ext uri="{BB962C8B-B14F-4D97-AF65-F5344CB8AC3E}">
-        <p14:creationId xmlns:p14="http://schemas.microsoft.com/office/powerpoint/2010/main" val="2603366913"/>
+        <p14:creationId xmlns:p14="http://schemas.microsoft.com/office/powerpoint/2010/main" val="875530539"/>
       </p:ext>
     </p:extLst>
   </p:cSld>
@@ -2127,7 +2126,7 @@
           <p:cNvPr id="2" name="Title 1">
             <a:extLst>
               <a:ext uri="{FF2B5EF4-FFF2-40B4-BE49-F238E27FC236}">
-                <a16:creationId xmlns:a16="http://schemas.microsoft.com/office/drawing/2014/main" id="{A2973EF1-8930-DD6D-55BA-8ED664C22701}"/>
+                <a16:creationId xmlns:a16="http://schemas.microsoft.com/office/drawing/2014/main" id="{197D6B74-C42C-BB25-F993-BD1D904CA05C}"/>
               </a:ext>
             </a:extLst>
           </p:cNvPr>
@@ -2156,7 +2155,7 @@
           <p:cNvPr id="3" name="Vertical Text Placeholder 2">
             <a:extLst>
               <a:ext uri="{FF2B5EF4-FFF2-40B4-BE49-F238E27FC236}">
-                <a16:creationId xmlns:a16="http://schemas.microsoft.com/office/drawing/2014/main" id="{0DB4EE35-C78D-DEA9-383D-7B02A0503712}"/>
+                <a16:creationId xmlns:a16="http://schemas.microsoft.com/office/drawing/2014/main" id="{1E102F80-0842-95B4-CA98-9821D94A7709}"/>
               </a:ext>
             </a:extLst>
           </p:cNvPr>
@@ -2214,7 +2213,7 @@
           <p:cNvPr id="4" name="Date Placeholder 3">
             <a:extLst>
               <a:ext uri="{FF2B5EF4-FFF2-40B4-BE49-F238E27FC236}">
-                <a16:creationId xmlns:a16="http://schemas.microsoft.com/office/drawing/2014/main" id="{3CC5DD0B-8D25-CD65-B992-202DDEE24F74}"/>
+                <a16:creationId xmlns:a16="http://schemas.microsoft.com/office/drawing/2014/main" id="{1497F151-1563-24F4-C39C-B7BC57FCD608}"/>
               </a:ext>
             </a:extLst>
           </p:cNvPr>
@@ -2230,7 +2229,7 @@
           <a:bodyPr/>
           <a:lstStyle/>
           <a:p>
-            <a:fld id="{CFA8807D-23B5-470F-A350-DF6C7A298D37}" type="datetimeFigureOut">
+            <a:fld id="{DDF74FE0-EBC5-4AB9-800B-A335A3F14358}" type="datetimeFigureOut">
               <a:rPr lang="en-IN" smtClean="0"/>
               <a:t>19-10-2026</a:t>
             </a:fld>
@@ -2243,7 +2242,7 @@
           <p:cNvPr id="5" name="Footer Placeholder 4">
             <a:extLst>
               <a:ext uri="{FF2B5EF4-FFF2-40B4-BE49-F238E27FC236}">
-                <a16:creationId xmlns:a16="http://schemas.microsoft.com/office/drawing/2014/main" id="{15B5C077-BA94-330E-5309-07115A5B291D}"/>
+                <a16:creationId xmlns:a16="http://schemas.microsoft.com/office/drawing/2014/main" id="{B55E07A8-D1AB-FCDB-35F5-17583AF1DA31}"/>
               </a:ext>
             </a:extLst>
           </p:cNvPr>
@@ -2268,7 +2267,7 @@
           <p:cNvPr id="6" name="Slide Number Placeholder 5">
             <a:extLst>
               <a:ext uri="{FF2B5EF4-FFF2-40B4-BE49-F238E27FC236}">
-                <a16:creationId xmlns:a16="http://schemas.microsoft.com/office/drawing/2014/main" id="{8E5EAFDD-AEEB-2DC7-78B3-2EA42C11EB3D}"/>
+                <a16:creationId xmlns:a16="http://schemas.microsoft.com/office/drawing/2014/main" id="{5AB74005-DA92-1D87-3E46-56465DE42343}"/>
               </a:ext>
             </a:extLst>
           </p:cNvPr>
@@ -2284,7 +2283,7 @@
           <a:bodyPr/>
           <a:lstStyle/>
           <a:p>
-            <a:fld id="{934BEE5F-DF1C-4A89-BBCC-A9D5D9EBCB77}" type="slidenum">
+            <a:fld id="{937938ED-2178-43B3-9AAE-1648119C4B05}" type="slidenum">
               <a:rPr lang="en-IN" smtClean="0"/>
               <a:t>‹#›</a:t>
             </a:fld>
@@ -2295,7 +2294,7 @@
     </p:spTree>
     <p:extLst>
       <p:ext uri="{BB962C8B-B14F-4D97-AF65-F5344CB8AC3E}">
-        <p14:creationId xmlns:p14="http://schemas.microsoft.com/office/powerpoint/2010/main" val="3210822402"/>
+        <p14:creationId xmlns:p14="http://schemas.microsoft.com/office/powerpoint/2010/main" val="638435247"/>
       </p:ext>
     </p:extLst>
   </p:cSld>
@@ -2327,7 +2326,7 @@
           <p:cNvPr id="2" name="Vertical Title 1">
             <a:extLst>
               <a:ext uri="{FF2B5EF4-FFF2-40B4-BE49-F238E27FC236}">
-                <a16:creationId xmlns:a16="http://schemas.microsoft.com/office/drawing/2014/main" id="{F30B5536-E3C0-661D-367C-214F8948C91E}"/>
+                <a16:creationId xmlns:a16="http://schemas.microsoft.com/office/drawing/2014/main" id="{AC75DA39-A18A-257C-FAB1-89C072B15CB1}"/>
               </a:ext>
             </a:extLst>
           </p:cNvPr>
@@ -2361,7 +2360,7 @@
           <p:cNvPr id="3" name="Vertical Text Placeholder 2">
             <a:extLst>
               <a:ext uri="{FF2B5EF4-FFF2-40B4-BE49-F238E27FC236}">
-                <a16:creationId xmlns:a16="http://schemas.microsoft.com/office/drawing/2014/main" id="{BD065AEF-3527-5BD5-E11B-4AEC7CB07EBA}"/>
+                <a16:creationId xmlns:a16="http://schemas.microsoft.com/office/drawing/2014/main" id="{F1AEA553-26FB-E4C0-48A2-ADE4BBE19DD3}"/>
               </a:ext>
             </a:extLst>
           </p:cNvPr>
@@ -2424,7 +2423,7 @@
           <p:cNvPr id="4" name="Date Placeholder 3">
             <a:extLst>
               <a:ext uri="{FF2B5EF4-FFF2-40B4-BE49-F238E27FC236}">
-                <a16:creationId xmlns:a16="http://schemas.microsoft.com/office/drawing/2014/main" id="{3B8B0EAB-B4D6-5FD6-1331-06298636408B}"/>
+                <a16:creationId xmlns:a16="http://schemas.microsoft.com/office/drawing/2014/main" id="{E913954C-CFFF-6F6E-EFFC-078CF6808632}"/>
               </a:ext>
             </a:extLst>
           </p:cNvPr>
@@ -2440,7 +2439,7 @@
           <a:bodyPr/>
           <a:lstStyle/>
           <a:p>
-            <a:fld id="{CFA8807D-23B5-470F-A350-DF6C7A298D37}" type="datetimeFigureOut">
+            <a:fld id="{DDF74FE0-EBC5-4AB9-800B-A335A3F14358}" type="datetimeFigureOut">
               <a:rPr lang="en-IN" smtClean="0"/>
               <a:t>19-10-2026</a:t>
             </a:fld>
@@ -2453,7 +2452,7 @@
           <p:cNvPr id="5" name="Footer Placeholder 4">
             <a:extLst>
               <a:ext uri="{FF2B5EF4-FFF2-40B4-BE49-F238E27FC236}">
-                <a16:creationId xmlns:a16="http://schemas.microsoft.com/office/drawing/2014/main" id="{048C753A-9847-835B-0177-BDD4FFE2B8B6}"/>
+                <a16:creationId xmlns:a16="http://schemas.microsoft.com/office/drawing/2014/main" id="{F5C86339-98F0-7C36-60A3-999CEBE3FF6B}"/>
               </a:ext>
             </a:extLst>
           </p:cNvPr>
@@ -2478,7 +2477,7 @@
           <p:cNvPr id="6" name="Slide Number Placeholder 5">
             <a:extLst>
               <a:ext uri="{FF2B5EF4-FFF2-40B4-BE49-F238E27FC236}">
-                <a16:creationId xmlns:a16="http://schemas.microsoft.com/office/drawing/2014/main" id="{ADFDBA45-940D-5AF8-1581-EDFF5F5281E3}"/>
+                <a16:creationId xmlns:a16="http://schemas.microsoft.com/office/drawing/2014/main" id="{1359C2F5-1633-4372-5881-C9AA6C02A969}"/>
               </a:ext>
             </a:extLst>
           </p:cNvPr>
@@ -2494,7 +2493,7 @@
           <a:bodyPr/>
           <a:lstStyle/>
           <a:p>
-            <a:fld id="{934BEE5F-DF1C-4A89-BBCC-A9D5D9EBCB77}" type="slidenum">
+            <a:fld id="{937938ED-2178-43B3-9AAE-1648119C4B05}" type="slidenum">
               <a:rPr lang="en-IN" smtClean="0"/>
               <a:t>‹#›</a:t>
             </a:fld>
@@ -2505,7 +2504,7 @@
     </p:spTree>
     <p:extLst>
       <p:ext uri="{BB962C8B-B14F-4D97-AF65-F5344CB8AC3E}">
-        <p14:creationId xmlns:p14="http://schemas.microsoft.com/office/powerpoint/2010/main" val="4225537345"/>
+        <p14:creationId xmlns:p14="http://schemas.microsoft.com/office/powerpoint/2010/main" val="2139768494"/>
       </p:ext>
     </p:extLst>
   </p:cSld>
@@ -2537,7 +2536,7 @@
           <p:cNvPr id="2" name="Title 1">
             <a:extLst>
               <a:ext uri="{FF2B5EF4-FFF2-40B4-BE49-F238E27FC236}">
-                <a16:creationId xmlns:a16="http://schemas.microsoft.com/office/drawing/2014/main" id="{1338052A-A119-A697-6B5B-ED70A727E899}"/>
+                <a16:creationId xmlns:a16="http://schemas.microsoft.com/office/drawing/2014/main" id="{C546E4BA-E18C-F385-6FA9-05CCC4581F4D}"/>
               </a:ext>
             </a:extLst>
           </p:cNvPr>
@@ -2566,7 +2565,7 @@
           <p:cNvPr id="3" name="Content Placeholder 2">
             <a:extLst>
               <a:ext uri="{FF2B5EF4-FFF2-40B4-BE49-F238E27FC236}">
-                <a16:creationId xmlns:a16="http://schemas.microsoft.com/office/drawing/2014/main" id="{0AF5A2FB-565C-ABA9-5632-64D726C7FDCE}"/>
+                <a16:creationId xmlns:a16="http://schemas.microsoft.com/office/drawing/2014/main" id="{59374049-31BC-9B20-9CC9-B0DED08E7DB6}"/>
               </a:ext>
             </a:extLst>
           </p:cNvPr>
@@ -2624,7 +2623,7 @@
           <p:cNvPr id="4" name="Date Placeholder 3">
             <a:extLst>
               <a:ext uri="{FF2B5EF4-FFF2-40B4-BE49-F238E27FC236}">
-                <a16:creationId xmlns:a16="http://schemas.microsoft.com/office/drawing/2014/main" id="{1404ED12-2DB0-B349-8C1E-5B22BB71D68C}"/>
+                <a16:creationId xmlns:a16="http://schemas.microsoft.com/office/drawing/2014/main" id="{C70D595A-B3A4-B8C5-2AA7-EB25B2F0747B}"/>
               </a:ext>
             </a:extLst>
           </p:cNvPr>
@@ -2640,7 +2639,7 @@
           <a:bodyPr/>
           <a:lstStyle/>
           <a:p>
-            <a:fld id="{CFA8807D-23B5-470F-A350-DF6C7A298D37}" type="datetimeFigureOut">
+            <a:fld id="{DDF74FE0-EBC5-4AB9-800B-A335A3F14358}" type="datetimeFigureOut">
               <a:rPr lang="en-IN" smtClean="0"/>
               <a:t>19-10-2026</a:t>
             </a:fld>
@@ -2653,7 +2652,7 @@
           <p:cNvPr id="5" name="Footer Placeholder 4">
             <a:extLst>
               <a:ext uri="{FF2B5EF4-FFF2-40B4-BE49-F238E27FC236}">
-                <a16:creationId xmlns:a16="http://schemas.microsoft.com/office/drawing/2014/main" id="{E174E2C1-2D86-81A0-DD6B-4B739F08CE20}"/>
+                <a16:creationId xmlns:a16="http://schemas.microsoft.com/office/drawing/2014/main" id="{84D3E644-AFA2-B637-4119-4C938D31322F}"/>
               </a:ext>
             </a:extLst>
           </p:cNvPr>
@@ -2678,7 +2677,7 @@
           <p:cNvPr id="6" name="Slide Number Placeholder 5">
             <a:extLst>
               <a:ext uri="{FF2B5EF4-FFF2-40B4-BE49-F238E27FC236}">
-                <a16:creationId xmlns:a16="http://schemas.microsoft.com/office/drawing/2014/main" id="{F6F959CE-4224-53A2-E6F4-1C2C9A9BEE7F}"/>
+                <a16:creationId xmlns:a16="http://schemas.microsoft.com/office/drawing/2014/main" id="{8C673581-0ECE-F0B1-A568-2489AFD3CAAE}"/>
               </a:ext>
             </a:extLst>
           </p:cNvPr>
@@ -2694,7 +2693,7 @@
           <a:bodyPr/>
           <a:lstStyle/>
           <a:p>
-            <a:fld id="{934BEE5F-DF1C-4A89-BBCC-A9D5D9EBCB77}" type="slidenum">
+            <a:fld id="{937938ED-2178-43B3-9AAE-1648119C4B05}" type="slidenum">
               <a:rPr lang="en-IN" smtClean="0"/>
               <a:t>‹#›</a:t>
             </a:fld>
@@ -2705,7 +2704,7 @@
     </p:spTree>
     <p:extLst>
       <p:ext uri="{BB962C8B-B14F-4D97-AF65-F5344CB8AC3E}">
-        <p14:creationId xmlns:p14="http://schemas.microsoft.com/office/powerpoint/2010/main" val="1191491390"/>
+        <p14:creationId xmlns:p14="http://schemas.microsoft.com/office/powerpoint/2010/main" val="2935971010"/>
       </p:ext>
     </p:extLst>
   </p:cSld>
@@ -2737,7 +2736,7 @@
           <p:cNvPr id="2" name="Title 1">
             <a:extLst>
               <a:ext uri="{FF2B5EF4-FFF2-40B4-BE49-F238E27FC236}">
-                <a16:creationId xmlns:a16="http://schemas.microsoft.com/office/drawing/2014/main" id="{24FB8D01-BA6A-1798-63F7-1F0A406AE1F2}"/>
+                <a16:creationId xmlns:a16="http://schemas.microsoft.com/office/drawing/2014/main" id="{7BDD5B24-70B0-E62B-77F8-1ED20A996A75}"/>
               </a:ext>
             </a:extLst>
           </p:cNvPr>
@@ -2775,7 +2774,7 @@
           <p:cNvPr id="3" name="Text Placeholder 2">
             <a:extLst>
               <a:ext uri="{FF2B5EF4-FFF2-40B4-BE49-F238E27FC236}">
-                <a16:creationId xmlns:a16="http://schemas.microsoft.com/office/drawing/2014/main" id="{2E711DA6-78D2-1936-929E-22E345F2361E}"/>
+                <a16:creationId xmlns:a16="http://schemas.microsoft.com/office/drawing/2014/main" id="{46111E76-6FDF-1E45-BD50-BF45A6DD96F7}"/>
               </a:ext>
             </a:extLst>
           </p:cNvPr>
@@ -2900,7 +2899,7 @@
           <p:cNvPr id="4" name="Date Placeholder 3">
             <a:extLst>
               <a:ext uri="{FF2B5EF4-FFF2-40B4-BE49-F238E27FC236}">
-                <a16:creationId xmlns:a16="http://schemas.microsoft.com/office/drawing/2014/main" id="{791C4743-3E57-52BE-E9A8-A6577D4FFD91}"/>
+                <a16:creationId xmlns:a16="http://schemas.microsoft.com/office/drawing/2014/main" id="{A8D4240D-854D-28C5-F473-1CB104CD1230}"/>
               </a:ext>
             </a:extLst>
           </p:cNvPr>
@@ -2916,7 +2915,7 @@
           <a:bodyPr/>
           <a:lstStyle/>
           <a:p>
-            <a:fld id="{CFA8807D-23B5-470F-A350-DF6C7A298D37}" type="datetimeFigureOut">
+            <a:fld id="{DDF74FE0-EBC5-4AB9-800B-A335A3F14358}" type="datetimeFigureOut">
               <a:rPr lang="en-IN" smtClean="0"/>
               <a:t>19-10-2026</a:t>
             </a:fld>
@@ -2929,7 +2928,7 @@
           <p:cNvPr id="5" name="Footer Placeholder 4">
             <a:extLst>
               <a:ext uri="{FF2B5EF4-FFF2-40B4-BE49-F238E27FC236}">
-                <a16:creationId xmlns:a16="http://schemas.microsoft.com/office/drawing/2014/main" id="{0357955E-661B-BAB5-9D40-5AFA484EEDDA}"/>
+                <a16:creationId xmlns:a16="http://schemas.microsoft.com/office/drawing/2014/main" id="{47F1E4DD-26A2-6215-D336-3FE193C0357E}"/>
               </a:ext>
             </a:extLst>
           </p:cNvPr>
@@ -2954,7 +2953,7 @@
           <p:cNvPr id="6" name="Slide Number Placeholder 5">
             <a:extLst>
               <a:ext uri="{FF2B5EF4-FFF2-40B4-BE49-F238E27FC236}">
-                <a16:creationId xmlns:a16="http://schemas.microsoft.com/office/drawing/2014/main" id="{856916B1-F7D6-9BDF-4E40-7A75EDBE8757}"/>
+                <a16:creationId xmlns:a16="http://schemas.microsoft.com/office/drawing/2014/main" id="{6ECC9CA8-1873-7F27-C009-628D7A4DC97D}"/>
               </a:ext>
             </a:extLst>
           </p:cNvPr>
@@ -2970,7 +2969,7 @@
           <a:bodyPr/>
           <a:lstStyle/>
           <a:p>
-            <a:fld id="{934BEE5F-DF1C-4A89-BBCC-A9D5D9EBCB77}" type="slidenum">
+            <a:fld id="{937938ED-2178-43B3-9AAE-1648119C4B05}" type="slidenum">
               <a:rPr lang="en-IN" smtClean="0"/>
               <a:t>‹#›</a:t>
             </a:fld>
@@ -2981,7 +2980,7 @@
     </p:spTree>
     <p:extLst>
       <p:ext uri="{BB962C8B-B14F-4D97-AF65-F5344CB8AC3E}">
-        <p14:creationId xmlns:p14="http://schemas.microsoft.com/office/powerpoint/2010/main" val="4269770286"/>
+        <p14:creationId xmlns:p14="http://schemas.microsoft.com/office/powerpoint/2010/main" val="419232040"/>
       </p:ext>
     </p:extLst>
   </p:cSld>
@@ -3013,7 +3012,7 @@
           <p:cNvPr id="2" name="Title 1">
             <a:extLst>
               <a:ext uri="{FF2B5EF4-FFF2-40B4-BE49-F238E27FC236}">
-                <a16:creationId xmlns:a16="http://schemas.microsoft.com/office/drawing/2014/main" id="{36FFBE4B-5FFD-965A-603B-AA290A0B7A5F}"/>
+                <a16:creationId xmlns:a16="http://schemas.microsoft.com/office/drawing/2014/main" id="{9B83FB1A-5C36-F56A-3280-05D03E966616}"/>
               </a:ext>
             </a:extLst>
           </p:cNvPr>
@@ -3042,7 +3041,7 @@
           <p:cNvPr id="3" name="Content Placeholder 2">
             <a:extLst>
               <a:ext uri="{FF2B5EF4-FFF2-40B4-BE49-F238E27FC236}">
-                <a16:creationId xmlns:a16="http://schemas.microsoft.com/office/drawing/2014/main" id="{EE290B0F-5417-091C-D5F2-267F8C01F06E}"/>
+                <a16:creationId xmlns:a16="http://schemas.microsoft.com/office/drawing/2014/main" id="{39397153-FAF2-C048-2150-C094CB46595D}"/>
               </a:ext>
             </a:extLst>
           </p:cNvPr>
@@ -3105,7 +3104,7 @@
           <p:cNvPr id="4" name="Content Placeholder 3">
             <a:extLst>
               <a:ext uri="{FF2B5EF4-FFF2-40B4-BE49-F238E27FC236}">
-                <a16:creationId xmlns:a16="http://schemas.microsoft.com/office/drawing/2014/main" id="{7C1ACB04-2367-49D4-4460-CBB1FD2AC10E}"/>
+                <a16:creationId xmlns:a16="http://schemas.microsoft.com/office/drawing/2014/main" id="{E89D5A36-93C7-1274-60BE-960883F3BB1E}"/>
               </a:ext>
             </a:extLst>
           </p:cNvPr>
@@ -3168,7 +3167,7 @@
           <p:cNvPr id="5" name="Date Placeholder 4">
             <a:extLst>
               <a:ext uri="{FF2B5EF4-FFF2-40B4-BE49-F238E27FC236}">
-                <a16:creationId xmlns:a16="http://schemas.microsoft.com/office/drawing/2014/main" id="{27A12435-E40E-CCAB-4749-572AF8B77BBE}"/>
+                <a16:creationId xmlns:a16="http://schemas.microsoft.com/office/drawing/2014/main" id="{1FD054BA-7E9F-18CF-35DC-5740185E8B6C}"/>
               </a:ext>
             </a:extLst>
           </p:cNvPr>
@@ -3184,7 +3183,7 @@
           <a:bodyPr/>
           <a:lstStyle/>
           <a:p>
-            <a:fld id="{CFA8807D-23B5-470F-A350-DF6C7A298D37}" type="datetimeFigureOut">
+            <a:fld id="{DDF74FE0-EBC5-4AB9-800B-A335A3F14358}" type="datetimeFigureOut">
               <a:rPr lang="en-IN" smtClean="0"/>
               <a:t>19-10-2026</a:t>
             </a:fld>
@@ -3197,7 +3196,7 @@
           <p:cNvPr id="6" name="Footer Placeholder 5">
             <a:extLst>
               <a:ext uri="{FF2B5EF4-FFF2-40B4-BE49-F238E27FC236}">
-                <a16:creationId xmlns:a16="http://schemas.microsoft.com/office/drawing/2014/main" id="{CFB89491-F0C4-BC16-B9C0-EC198441F4DC}"/>
+                <a16:creationId xmlns:a16="http://schemas.microsoft.com/office/drawing/2014/main" id="{83741CB5-1DF8-6133-8367-DBD600E9682E}"/>
               </a:ext>
             </a:extLst>
           </p:cNvPr>
@@ -3222,7 +3221,7 @@
           <p:cNvPr id="7" name="Slide Number Placeholder 6">
             <a:extLst>
               <a:ext uri="{FF2B5EF4-FFF2-40B4-BE49-F238E27FC236}">
-                <a16:creationId xmlns:a16="http://schemas.microsoft.com/office/drawing/2014/main" id="{26E66FB2-E9C1-F909-8C71-DF11587EB6E5}"/>
+                <a16:creationId xmlns:a16="http://schemas.microsoft.com/office/drawing/2014/main" id="{691044BB-D95A-5721-CC29-1152D9B34110}"/>
               </a:ext>
             </a:extLst>
           </p:cNvPr>
@@ -3238,7 +3237,7 @@
           <a:bodyPr/>
           <a:lstStyle/>
           <a:p>
-            <a:fld id="{934BEE5F-DF1C-4A89-BBCC-A9D5D9EBCB77}" type="slidenum">
+            <a:fld id="{937938ED-2178-43B3-9AAE-1648119C4B05}" type="slidenum">
               <a:rPr lang="en-IN" smtClean="0"/>
               <a:t>‹#›</a:t>
             </a:fld>
@@ -3249,7 +3248,7 @@
     </p:spTree>
     <p:extLst>
       <p:ext uri="{BB962C8B-B14F-4D97-AF65-F5344CB8AC3E}">
-        <p14:creationId xmlns:p14="http://schemas.microsoft.com/office/powerpoint/2010/main" val="334907587"/>
+        <p14:creationId xmlns:p14="http://schemas.microsoft.com/office/powerpoint/2010/main" val="3761249564"/>
       </p:ext>
     </p:extLst>
   </p:cSld>
@@ -3281,7 +3280,7 @@
           <p:cNvPr id="2" name="Title 1">
             <a:extLst>
               <a:ext uri="{FF2B5EF4-FFF2-40B4-BE49-F238E27FC236}">
-                <a16:creationId xmlns:a16="http://schemas.microsoft.com/office/drawing/2014/main" id="{3D6E1683-7B4D-553D-283F-18FA4A99BE0A}"/>
+                <a16:creationId xmlns:a16="http://schemas.microsoft.com/office/drawing/2014/main" id="{5332D856-4E70-D7A6-B7A8-D0A1491F86A0}"/>
               </a:ext>
             </a:extLst>
           </p:cNvPr>
@@ -3315,7 +3314,7 @@
           <p:cNvPr id="3" name="Text Placeholder 2">
             <a:extLst>
               <a:ext uri="{FF2B5EF4-FFF2-40B4-BE49-F238E27FC236}">
-                <a16:creationId xmlns:a16="http://schemas.microsoft.com/office/drawing/2014/main" id="{6B5768DC-AFD4-21D4-82B9-EF1E31867410}"/>
+                <a16:creationId xmlns:a16="http://schemas.microsoft.com/office/drawing/2014/main" id="{A1ED72D7-1537-C151-6661-F4C47FC83DAD}"/>
               </a:ext>
             </a:extLst>
           </p:cNvPr>
@@ -3386,7 +3385,7 @@
           <p:cNvPr id="4" name="Content Placeholder 3">
             <a:extLst>
               <a:ext uri="{FF2B5EF4-FFF2-40B4-BE49-F238E27FC236}">
-                <a16:creationId xmlns:a16="http://schemas.microsoft.com/office/drawing/2014/main" id="{094148F8-79DC-80CB-CFE9-DEFC1295A026}"/>
+                <a16:creationId xmlns:a16="http://schemas.microsoft.com/office/drawing/2014/main" id="{926F7022-DBE2-4700-D0EC-65E922AF0BB1}"/>
               </a:ext>
             </a:extLst>
           </p:cNvPr>
@@ -3449,7 +3448,7 @@
           <p:cNvPr id="5" name="Text Placeholder 4">
             <a:extLst>
               <a:ext uri="{FF2B5EF4-FFF2-40B4-BE49-F238E27FC236}">
-                <a16:creationId xmlns:a16="http://schemas.microsoft.com/office/drawing/2014/main" id="{23D7E94F-5208-AD5D-C878-FC299148F724}"/>
+                <a16:creationId xmlns:a16="http://schemas.microsoft.com/office/drawing/2014/main" id="{7A9BE0F4-083D-B399-6B9C-99D005D8A1F7}"/>
               </a:ext>
             </a:extLst>
           </p:cNvPr>
@@ -3520,7 +3519,7 @@
           <p:cNvPr id="6" name="Content Placeholder 5">
             <a:extLst>
               <a:ext uri="{FF2B5EF4-FFF2-40B4-BE49-F238E27FC236}">
-                <a16:creationId xmlns:a16="http://schemas.microsoft.com/office/drawing/2014/main" id="{B1C89C1F-C64B-258E-8CAC-055094BEE51C}"/>
+                <a16:creationId xmlns:a16="http://schemas.microsoft.com/office/drawing/2014/main" id="{AEDDB603-514C-9943-714B-4A00058D414D}"/>
               </a:ext>
             </a:extLst>
           </p:cNvPr>
@@ -3583,7 +3582,7 @@
           <p:cNvPr id="7" name="Date Placeholder 6">
             <a:extLst>
               <a:ext uri="{FF2B5EF4-FFF2-40B4-BE49-F238E27FC236}">
-                <a16:creationId xmlns:a16="http://schemas.microsoft.com/office/drawing/2014/main" id="{39F4CF4B-7B8B-D0D8-F895-C238B800A869}"/>
+                <a16:creationId xmlns:a16="http://schemas.microsoft.com/office/drawing/2014/main" id="{4F279CAF-656E-7442-8FAC-111B1EC7C478}"/>
               </a:ext>
             </a:extLst>
           </p:cNvPr>
@@ -3599,7 +3598,7 @@
           <a:bodyPr/>
           <a:lstStyle/>
           <a:p>
-            <a:fld id="{CFA8807D-23B5-470F-A350-DF6C7A298D37}" type="datetimeFigureOut">
+            <a:fld id="{DDF74FE0-EBC5-4AB9-800B-A335A3F14358}" type="datetimeFigureOut">
               <a:rPr lang="en-IN" smtClean="0"/>
               <a:t>19-10-2026</a:t>
             </a:fld>
@@ -3612,7 +3611,7 @@
           <p:cNvPr id="8" name="Footer Placeholder 7">
             <a:extLst>
               <a:ext uri="{FF2B5EF4-FFF2-40B4-BE49-F238E27FC236}">
-                <a16:creationId xmlns:a16="http://schemas.microsoft.com/office/drawing/2014/main" id="{0337533B-5FC2-DF41-4F55-1C4AF68982A5}"/>
+                <a16:creationId xmlns:a16="http://schemas.microsoft.com/office/drawing/2014/main" id="{17AC5EE4-8A79-B4EC-C29D-A077EA258042}"/>
               </a:ext>
             </a:extLst>
           </p:cNvPr>
@@ -3637,7 +3636,7 @@
           <p:cNvPr id="9" name="Slide Number Placeholder 8">
             <a:extLst>
               <a:ext uri="{FF2B5EF4-FFF2-40B4-BE49-F238E27FC236}">
-                <a16:creationId xmlns:a16="http://schemas.microsoft.com/office/drawing/2014/main" id="{2A357DE3-BAA0-4E19-5A51-38531976B194}"/>
+                <a16:creationId xmlns:a16="http://schemas.microsoft.com/office/drawing/2014/main" id="{DCAF8873-4FD6-DBCD-51F8-B0CB069C9755}"/>
               </a:ext>
             </a:extLst>
           </p:cNvPr>
@@ -3653,7 +3652,7 @@
           <a:bodyPr/>
           <a:lstStyle/>
           <a:p>
-            <a:fld id="{934BEE5F-DF1C-4A89-BBCC-A9D5D9EBCB77}" type="slidenum">
+            <a:fld id="{937938ED-2178-43B3-9AAE-1648119C4B05}" type="slidenum">
               <a:rPr lang="en-IN" smtClean="0"/>
               <a:t>‹#›</a:t>
             </a:fld>
@@ -3664,7 +3663,7 @@
     </p:spTree>
     <p:extLst>
       <p:ext uri="{BB962C8B-B14F-4D97-AF65-F5344CB8AC3E}">
-        <p14:creationId xmlns:p14="http://schemas.microsoft.com/office/powerpoint/2010/main" val="3609016246"/>
+        <p14:creationId xmlns:p14="http://schemas.microsoft.com/office/powerpoint/2010/main" val="4212934535"/>
       </p:ext>
     </p:extLst>
   </p:cSld>
@@ -3696,7 +3695,7 @@
           <p:cNvPr id="2" name="Title 1">
             <a:extLst>
               <a:ext uri="{FF2B5EF4-FFF2-40B4-BE49-F238E27FC236}">
-                <a16:creationId xmlns:a16="http://schemas.microsoft.com/office/drawing/2014/main" id="{4CD73FCF-9F85-594C-71B0-151FA260289E}"/>
+                <a16:creationId xmlns:a16="http://schemas.microsoft.com/office/drawing/2014/main" id="{C3F2EB36-9AA5-4E32-525C-9BC8F998E0FB}"/>
               </a:ext>
             </a:extLst>
           </p:cNvPr>
@@ -3725,7 +3724,7 @@
           <p:cNvPr id="3" name="Date Placeholder 2">
             <a:extLst>
               <a:ext uri="{FF2B5EF4-FFF2-40B4-BE49-F238E27FC236}">
-                <a16:creationId xmlns:a16="http://schemas.microsoft.com/office/drawing/2014/main" id="{BA1E3388-06F5-D963-5258-310CE034E79D}"/>
+                <a16:creationId xmlns:a16="http://schemas.microsoft.com/office/drawing/2014/main" id="{7793E4B8-9D2E-0387-88BE-41905B369BB3}"/>
               </a:ext>
             </a:extLst>
           </p:cNvPr>
@@ -3741,7 +3740,7 @@
           <a:bodyPr/>
           <a:lstStyle/>
           <a:p>
-            <a:fld id="{CFA8807D-23B5-470F-A350-DF6C7A298D37}" type="datetimeFigureOut">
+            <a:fld id="{DDF74FE0-EBC5-4AB9-800B-A335A3F14358}" type="datetimeFigureOut">
               <a:rPr lang="en-IN" smtClean="0"/>
               <a:t>19-10-2026</a:t>
             </a:fld>
@@ -3754,7 +3753,7 @@
           <p:cNvPr id="4" name="Footer Placeholder 3">
             <a:extLst>
               <a:ext uri="{FF2B5EF4-FFF2-40B4-BE49-F238E27FC236}">
-                <a16:creationId xmlns:a16="http://schemas.microsoft.com/office/drawing/2014/main" id="{3DB75156-8723-9C47-8EE7-E3C853A571DD}"/>
+                <a16:creationId xmlns:a16="http://schemas.microsoft.com/office/drawing/2014/main" id="{F4F92089-0110-EA24-78B2-ED1589208531}"/>
               </a:ext>
             </a:extLst>
           </p:cNvPr>
@@ -3779,7 +3778,7 @@
           <p:cNvPr id="5" name="Slide Number Placeholder 4">
             <a:extLst>
               <a:ext uri="{FF2B5EF4-FFF2-40B4-BE49-F238E27FC236}">
-                <a16:creationId xmlns:a16="http://schemas.microsoft.com/office/drawing/2014/main" id="{15EA7568-EAD7-735F-0E9F-8A2DC0F18F4A}"/>
+                <a16:creationId xmlns:a16="http://schemas.microsoft.com/office/drawing/2014/main" id="{5084F1AA-3F7D-243F-149D-7874AB6C7DF8}"/>
               </a:ext>
             </a:extLst>
           </p:cNvPr>
@@ -3795,7 +3794,7 @@
           <a:bodyPr/>
           <a:lstStyle/>
           <a:p>
-            <a:fld id="{934BEE5F-DF1C-4A89-BBCC-A9D5D9EBCB77}" type="slidenum">
+            <a:fld id="{937938ED-2178-43B3-9AAE-1648119C4B05}" type="slidenum">
               <a:rPr lang="en-IN" smtClean="0"/>
               <a:t>‹#›</a:t>
             </a:fld>
@@ -3806,7 +3805,7 @@
     </p:spTree>
     <p:extLst>
       <p:ext uri="{BB962C8B-B14F-4D97-AF65-F5344CB8AC3E}">
-        <p14:creationId xmlns:p14="http://schemas.microsoft.com/office/powerpoint/2010/main" val="3108010882"/>
+        <p14:creationId xmlns:p14="http://schemas.microsoft.com/office/powerpoint/2010/main" val="1447700378"/>
       </p:ext>
     </p:extLst>
   </p:cSld>
@@ -3838,7 +3837,7 @@
           <p:cNvPr id="2" name="Date Placeholder 1">
             <a:extLst>
               <a:ext uri="{FF2B5EF4-FFF2-40B4-BE49-F238E27FC236}">
-                <a16:creationId xmlns:a16="http://schemas.microsoft.com/office/drawing/2014/main" id="{6306354E-663D-FB03-0C92-03CD6BF10026}"/>
+                <a16:creationId xmlns:a16="http://schemas.microsoft.com/office/drawing/2014/main" id="{9136E848-83C7-8824-3787-BA012C0C1EEA}"/>
               </a:ext>
             </a:extLst>
           </p:cNvPr>
@@ -3854,7 +3853,7 @@
           <a:bodyPr/>
           <a:lstStyle/>
           <a:p>
-            <a:fld id="{CFA8807D-23B5-470F-A350-DF6C7A298D37}" type="datetimeFigureOut">
+            <a:fld id="{DDF74FE0-EBC5-4AB9-800B-A335A3F14358}" type="datetimeFigureOut">
               <a:rPr lang="en-IN" smtClean="0"/>
               <a:t>19-10-2026</a:t>
             </a:fld>
@@ -3867,7 +3866,7 @@
           <p:cNvPr id="3" name="Footer Placeholder 2">
             <a:extLst>
               <a:ext uri="{FF2B5EF4-FFF2-40B4-BE49-F238E27FC236}">
-                <a16:creationId xmlns:a16="http://schemas.microsoft.com/office/drawing/2014/main" id="{05DB7F38-0375-009D-3D4F-87475C24DC69}"/>
+                <a16:creationId xmlns:a16="http://schemas.microsoft.com/office/drawing/2014/main" id="{EF2598AE-3ECB-A026-C5BA-8485B15A4896}"/>
               </a:ext>
             </a:extLst>
           </p:cNvPr>
@@ -3892,7 +3891,7 @@
           <p:cNvPr id="4" name="Slide Number Placeholder 3">
             <a:extLst>
               <a:ext uri="{FF2B5EF4-FFF2-40B4-BE49-F238E27FC236}">
-                <a16:creationId xmlns:a16="http://schemas.microsoft.com/office/drawing/2014/main" id="{C1919309-D986-865C-0EF2-EEE5FCF9E556}"/>
+                <a16:creationId xmlns:a16="http://schemas.microsoft.com/office/drawing/2014/main" id="{E6D6FB99-65E0-5A40-BFC0-1BBB89FE8E20}"/>
               </a:ext>
             </a:extLst>
           </p:cNvPr>
@@ -3908,7 +3907,7 @@
           <a:bodyPr/>
           <a:lstStyle/>
           <a:p>
-            <a:fld id="{934BEE5F-DF1C-4A89-BBCC-A9D5D9EBCB77}" type="slidenum">
+            <a:fld id="{937938ED-2178-43B3-9AAE-1648119C4B05}" type="slidenum">
               <a:rPr lang="en-IN" smtClean="0"/>
               <a:t>‹#›</a:t>
             </a:fld>
@@ -3919,7 +3918,7 @@
     </p:spTree>
     <p:extLst>
       <p:ext uri="{BB962C8B-B14F-4D97-AF65-F5344CB8AC3E}">
-        <p14:creationId xmlns:p14="http://schemas.microsoft.com/office/powerpoint/2010/main" val="928004972"/>
+        <p14:creationId xmlns:p14="http://schemas.microsoft.com/office/powerpoint/2010/main" val="3663843266"/>
       </p:ext>
     </p:extLst>
   </p:cSld>
@@ -3951,7 +3950,7 @@
           <p:cNvPr id="2" name="Title 1">
             <a:extLst>
               <a:ext uri="{FF2B5EF4-FFF2-40B4-BE49-F238E27FC236}">
-                <a16:creationId xmlns:a16="http://schemas.microsoft.com/office/drawing/2014/main" id="{2BEE14EB-01C5-55F7-B472-C8C6B382B9A2}"/>
+                <a16:creationId xmlns:a16="http://schemas.microsoft.com/office/drawing/2014/main" id="{C3DDFAC1-8FF1-6E12-9287-26821641BD73}"/>
               </a:ext>
             </a:extLst>
           </p:cNvPr>
@@ -3989,7 +3988,7 @@
           <p:cNvPr id="3" name="Content Placeholder 2">
             <a:extLst>
               <a:ext uri="{FF2B5EF4-FFF2-40B4-BE49-F238E27FC236}">
-                <a16:creationId xmlns:a16="http://schemas.microsoft.com/office/drawing/2014/main" id="{AD48CC36-212D-8FD8-0F57-87586F74F43E}"/>
+                <a16:creationId xmlns:a16="http://schemas.microsoft.com/office/drawing/2014/main" id="{4CB339A6-0CE1-C3C8-1D53-41638E42DCD4}"/>
               </a:ext>
             </a:extLst>
           </p:cNvPr>
@@ -4080,7 +4079,7 @@
           <p:cNvPr id="4" name="Text Placeholder 3">
             <a:extLst>
               <a:ext uri="{FF2B5EF4-FFF2-40B4-BE49-F238E27FC236}">
-                <a16:creationId xmlns:a16="http://schemas.microsoft.com/office/drawing/2014/main" id="{BF1EC950-0358-CB18-27F9-C0E2FF19CF94}"/>
+                <a16:creationId xmlns:a16="http://schemas.microsoft.com/office/drawing/2014/main" id="{DFF9F2B1-FE21-907F-2BBA-26250902752E}"/>
               </a:ext>
             </a:extLst>
           </p:cNvPr>
@@ -4151,7 +4150,7 @@
           <p:cNvPr id="5" name="Date Placeholder 4">
             <a:extLst>
               <a:ext uri="{FF2B5EF4-FFF2-40B4-BE49-F238E27FC236}">
-                <a16:creationId xmlns:a16="http://schemas.microsoft.com/office/drawing/2014/main" id="{AD57A94A-9BE8-3F9D-4FBF-0C85234DFA25}"/>
+                <a16:creationId xmlns:a16="http://schemas.microsoft.com/office/drawing/2014/main" id="{12385E95-8A70-DED0-4A2E-3F27278ACFC9}"/>
               </a:ext>
             </a:extLst>
           </p:cNvPr>
@@ -4167,7 +4166,7 @@
           <a:bodyPr/>
           <a:lstStyle/>
           <a:p>
-            <a:fld id="{CFA8807D-23B5-470F-A350-DF6C7A298D37}" type="datetimeFigureOut">
+            <a:fld id="{DDF74FE0-EBC5-4AB9-800B-A335A3F14358}" type="datetimeFigureOut">
               <a:rPr lang="en-IN" smtClean="0"/>
               <a:t>19-10-2026</a:t>
             </a:fld>
@@ -4180,7 +4179,7 @@
           <p:cNvPr id="6" name="Footer Placeholder 5">
             <a:extLst>
               <a:ext uri="{FF2B5EF4-FFF2-40B4-BE49-F238E27FC236}">
-                <a16:creationId xmlns:a16="http://schemas.microsoft.com/office/drawing/2014/main" id="{8004D088-9337-6476-2BDF-00183F6C0420}"/>
+                <a16:creationId xmlns:a16="http://schemas.microsoft.com/office/drawing/2014/main" id="{02FBCBB6-0787-B8B4-40CC-50524AB64320}"/>
               </a:ext>
             </a:extLst>
           </p:cNvPr>
@@ -4205,7 +4204,7 @@
           <p:cNvPr id="7" name="Slide Number Placeholder 6">
             <a:extLst>
               <a:ext uri="{FF2B5EF4-FFF2-40B4-BE49-F238E27FC236}">
-                <a16:creationId xmlns:a16="http://schemas.microsoft.com/office/drawing/2014/main" id="{AAA9F8B9-C91D-0E7E-63F7-3DB9373D789C}"/>
+                <a16:creationId xmlns:a16="http://schemas.microsoft.com/office/drawing/2014/main" id="{D7AE41E5-BD29-497F-9AE2-DF77513B4C95}"/>
               </a:ext>
             </a:extLst>
           </p:cNvPr>
@@ -4221,7 +4220,7 @@
           <a:bodyPr/>
           <a:lstStyle/>
           <a:p>
-            <a:fld id="{934BEE5F-DF1C-4A89-BBCC-A9D5D9EBCB77}" type="slidenum">
+            <a:fld id="{937938ED-2178-43B3-9AAE-1648119C4B05}" type="slidenum">
               <a:rPr lang="en-IN" smtClean="0"/>
               <a:t>‹#›</a:t>
             </a:fld>
@@ -4232,7 +4231,7 @@
     </p:spTree>
     <p:extLst>
       <p:ext uri="{BB962C8B-B14F-4D97-AF65-F5344CB8AC3E}">
-        <p14:creationId xmlns:p14="http://schemas.microsoft.com/office/powerpoint/2010/main" val="682040366"/>
+        <p14:creationId xmlns:p14="http://schemas.microsoft.com/office/powerpoint/2010/main" val="750196848"/>
       </p:ext>
     </p:extLst>
   </p:cSld>
@@ -4264,7 +4263,7 @@
           <p:cNvPr id="2" name="Title 1">
             <a:extLst>
               <a:ext uri="{FF2B5EF4-FFF2-40B4-BE49-F238E27FC236}">
-                <a16:creationId xmlns:a16="http://schemas.microsoft.com/office/drawing/2014/main" id="{28FA74DF-AA14-E11E-023B-9428247719FA}"/>
+                <a16:creationId xmlns:a16="http://schemas.microsoft.com/office/drawing/2014/main" id="{76B1844E-6807-0DC0-5F5F-DFA4493F629A}"/>
               </a:ext>
             </a:extLst>
           </p:cNvPr>
@@ -4302,7 +4301,7 @@
           <p:cNvPr id="3" name="Picture Placeholder 2">
             <a:extLst>
               <a:ext uri="{FF2B5EF4-FFF2-40B4-BE49-F238E27FC236}">
-                <a16:creationId xmlns:a16="http://schemas.microsoft.com/office/drawing/2014/main" id="{6A2911CE-14A5-A22B-3432-FC1C7FD3D8A9}"/>
+                <a16:creationId xmlns:a16="http://schemas.microsoft.com/office/drawing/2014/main" id="{26335A1E-405F-5FF7-801A-87F5204EE284}"/>
               </a:ext>
             </a:extLst>
           </p:cNvPr>
@@ -4369,7 +4368,7 @@
           <p:cNvPr id="4" name="Text Placeholder 3">
             <a:extLst>
               <a:ext uri="{FF2B5EF4-FFF2-40B4-BE49-F238E27FC236}">
-                <a16:creationId xmlns:a16="http://schemas.microsoft.com/office/drawing/2014/main" id="{E49019D7-26AF-EFF7-D269-75974CE6C858}"/>
+                <a16:creationId xmlns:a16="http://schemas.microsoft.com/office/drawing/2014/main" id="{98934909-4665-7513-8C7B-DADF28F6094B}"/>
               </a:ext>
             </a:extLst>
           </p:cNvPr>
@@ -4440,7 +4439,7 @@
           <p:cNvPr id="5" name="Date Placeholder 4">
             <a:extLst>
               <a:ext uri="{FF2B5EF4-FFF2-40B4-BE49-F238E27FC236}">
-                <a16:creationId xmlns:a16="http://schemas.microsoft.com/office/drawing/2014/main" id="{5BDA2F8D-94A7-707D-08EC-0E108634DC6F}"/>
+                <a16:creationId xmlns:a16="http://schemas.microsoft.com/office/drawing/2014/main" id="{528AED3E-95FB-F3EE-0D85-83423F738A18}"/>
               </a:ext>
             </a:extLst>
           </p:cNvPr>
@@ -4456,7 +4455,7 @@
           <a:bodyPr/>
           <a:lstStyle/>
           <a:p>
-            <a:fld id="{CFA8807D-23B5-470F-A350-DF6C7A298D37}" type="datetimeFigureOut">
+            <a:fld id="{DDF74FE0-EBC5-4AB9-800B-A335A3F14358}" type="datetimeFigureOut">
               <a:rPr lang="en-IN" smtClean="0"/>
               <a:t>19-10-2026</a:t>
             </a:fld>
@@ -4469,7 +4468,7 @@
           <p:cNvPr id="6" name="Footer Placeholder 5">
             <a:extLst>
               <a:ext uri="{FF2B5EF4-FFF2-40B4-BE49-F238E27FC236}">
-                <a16:creationId xmlns:a16="http://schemas.microsoft.com/office/drawing/2014/main" id="{DA85A6B8-8038-3906-299B-C705F18A5893}"/>
+                <a16:creationId xmlns:a16="http://schemas.microsoft.com/office/drawing/2014/main" id="{097210E7-43AF-25AC-35E8-2EA04B64262C}"/>
               </a:ext>
             </a:extLst>
           </p:cNvPr>
@@ -4494,7 +4493,7 @@
           <p:cNvPr id="7" name="Slide Number Placeholder 6">
             <a:extLst>
               <a:ext uri="{FF2B5EF4-FFF2-40B4-BE49-F238E27FC236}">
-                <a16:creationId xmlns:a16="http://schemas.microsoft.com/office/drawing/2014/main" id="{DB96EB7B-FAB4-CAD7-A79A-838ED62663FD}"/>
+                <a16:creationId xmlns:a16="http://schemas.microsoft.com/office/drawing/2014/main" id="{F2A07760-7CB4-F427-3B98-A1FC6CEB8954}"/>
               </a:ext>
             </a:extLst>
           </p:cNvPr>
@@ -4510,7 +4509,7 @@
           <a:bodyPr/>
           <a:lstStyle/>
           <a:p>
-            <a:fld id="{934BEE5F-DF1C-4A89-BBCC-A9D5D9EBCB77}" type="slidenum">
+            <a:fld id="{937938ED-2178-43B3-9AAE-1648119C4B05}" type="slidenum">
               <a:rPr lang="en-IN" smtClean="0"/>
               <a:t>‹#›</a:t>
             </a:fld>
@@ -4521,7 +4520,7 @@
     </p:spTree>
     <p:extLst>
       <p:ext uri="{BB962C8B-B14F-4D97-AF65-F5344CB8AC3E}">
-        <p14:creationId xmlns:p14="http://schemas.microsoft.com/office/powerpoint/2010/main" val="674834928"/>
+        <p14:creationId xmlns:p14="http://schemas.microsoft.com/office/powerpoint/2010/main" val="2596804219"/>
       </p:ext>
     </p:extLst>
   </p:cSld>
@@ -4558,7 +4557,7 @@
           <p:cNvPr id="2" name="Title Placeholder 1">
             <a:extLst>
               <a:ext uri="{FF2B5EF4-FFF2-40B4-BE49-F238E27FC236}">
-                <a16:creationId xmlns:a16="http://schemas.microsoft.com/office/drawing/2014/main" id="{B84636D1-AD4F-0790-4E0C-B499AFCEC6C3}"/>
+                <a16:creationId xmlns:a16="http://schemas.microsoft.com/office/drawing/2014/main" id="{F8755496-C3F6-EC84-C90D-24DDCD3B75A5}"/>
               </a:ext>
             </a:extLst>
           </p:cNvPr>
@@ -4597,7 +4596,7 @@
           <p:cNvPr id="3" name="Text Placeholder 2">
             <a:extLst>
               <a:ext uri="{FF2B5EF4-FFF2-40B4-BE49-F238E27FC236}">
-                <a16:creationId xmlns:a16="http://schemas.microsoft.com/office/drawing/2014/main" id="{E2331BCE-4EAE-4FF0-3BCC-F0A3B75C15B8}"/>
+                <a16:creationId xmlns:a16="http://schemas.microsoft.com/office/drawing/2014/main" id="{C70B77BE-6685-7309-6733-90B70D460DEC}"/>
               </a:ext>
             </a:extLst>
           </p:cNvPr>
@@ -4665,7 +4664,7 @@
           <p:cNvPr id="4" name="Date Placeholder 3">
             <a:extLst>
               <a:ext uri="{FF2B5EF4-FFF2-40B4-BE49-F238E27FC236}">
-                <a16:creationId xmlns:a16="http://schemas.microsoft.com/office/drawing/2014/main" id="{C800A678-CF3A-8DCD-9ED2-CB0243CC9CB2}"/>
+                <a16:creationId xmlns:a16="http://schemas.microsoft.com/office/drawing/2014/main" id="{788A17BD-55F8-AA8F-E794-60DEB4F638D9}"/>
               </a:ext>
             </a:extLst>
           </p:cNvPr>
@@ -4699,7 +4698,7 @@
             </a:lvl1pPr>
           </a:lstStyle>
           <a:p>
-            <a:fld id="{CFA8807D-23B5-470F-A350-DF6C7A298D37}" type="datetimeFigureOut">
+            <a:fld id="{DDF74FE0-EBC5-4AB9-800B-A335A3F14358}" type="datetimeFigureOut">
               <a:rPr lang="en-IN" smtClean="0"/>
               <a:t>19-10-2026</a:t>
             </a:fld>
@@ -4712,7 +4711,7 @@
           <p:cNvPr id="5" name="Footer Placeholder 4">
             <a:extLst>
               <a:ext uri="{FF2B5EF4-FFF2-40B4-BE49-F238E27FC236}">
-                <a16:creationId xmlns:a16="http://schemas.microsoft.com/office/drawing/2014/main" id="{5C6680BD-81EF-BA90-90DC-D8F9C5355F42}"/>
+                <a16:creationId xmlns:a16="http://schemas.microsoft.com/office/drawing/2014/main" id="{EE2F4C87-7EB0-2068-9617-B7B3A9C43335}"/>
               </a:ext>
             </a:extLst>
           </p:cNvPr>
@@ -4755,7 +4754,7 @@
           <p:cNvPr id="6" name="Slide Number Placeholder 5">
             <a:extLst>
               <a:ext uri="{FF2B5EF4-FFF2-40B4-BE49-F238E27FC236}">
-                <a16:creationId xmlns:a16="http://schemas.microsoft.com/office/drawing/2014/main" id="{4C2E08B1-7696-7E2C-CCF2-87C3BE6629FB}"/>
+                <a16:creationId xmlns:a16="http://schemas.microsoft.com/office/drawing/2014/main" id="{D508284D-AA35-D54C-6D60-B47373BCE903}"/>
               </a:ext>
             </a:extLst>
           </p:cNvPr>
@@ -4789,7 +4788,7 @@
             </a:lvl1pPr>
           </a:lstStyle>
           <a:p>
-            <a:fld id="{934BEE5F-DF1C-4A89-BBCC-A9D5D9EBCB77}" type="slidenum">
+            <a:fld id="{937938ED-2178-43B3-9AAE-1648119C4B05}" type="slidenum">
               <a:rPr lang="en-IN" smtClean="0"/>
               <a:t>‹#›</a:t>
             </a:fld>
@@ -4800,7 +4799,7 @@
     </p:spTree>
     <p:extLst>
       <p:ext uri="{BB962C8B-B14F-4D97-AF65-F5344CB8AC3E}">
-        <p14:creationId xmlns:p14="http://schemas.microsoft.com/office/powerpoint/2010/main" val="3634179400"/>
+        <p14:creationId xmlns:p14="http://schemas.microsoft.com/office/powerpoint/2010/main" val="3866621658"/>
       </p:ext>
     </p:extLst>
   </p:cSld>
@@ -5131,7 +5130,7 @@
           <p:cNvPr id="2" name="TextBox 1">
             <a:extLst>
               <a:ext uri="{FF2B5EF4-FFF2-40B4-BE49-F238E27FC236}">
-                <a16:creationId xmlns:a16="http://schemas.microsoft.com/office/drawing/2014/main" id="{407C4733-AA4D-759B-6F6C-62C4F04BEB5C}"/>
+                <a16:creationId xmlns:a16="http://schemas.microsoft.com/office/drawing/2014/main" id="{729CD704-1229-AEBB-CD0B-BF095760F9D4}"/>
               </a:ext>
             </a:extLst>
           </p:cNvPr>
@@ -5176,7 +5175,7 @@
           <p:cNvPr id="3" name="TextBox 2">
             <a:extLst>
               <a:ext uri="{FF2B5EF4-FFF2-40B4-BE49-F238E27FC236}">
-                <a16:creationId xmlns:a16="http://schemas.microsoft.com/office/drawing/2014/main" id="{335D0336-94BB-868D-644D-210163062735}"/>
+                <a16:creationId xmlns:a16="http://schemas.microsoft.com/office/drawing/2014/main" id="{5A45F18B-61E9-0A96-059C-DFECECAEF07B}"/>
               </a:ext>
             </a:extLst>
           </p:cNvPr>
@@ -5222,7 +5221,7 @@
           <p:cNvPr id="4" name="TextBox 3">
             <a:extLst>
               <a:ext uri="{FF2B5EF4-FFF2-40B4-BE49-F238E27FC236}">
-                <a16:creationId xmlns:a16="http://schemas.microsoft.com/office/drawing/2014/main" id="{58632CBE-16EC-C551-B78D-1A95732DAEA0}"/>
+                <a16:creationId xmlns:a16="http://schemas.microsoft.com/office/drawing/2014/main" id="{C746DE91-3620-0AD8-EEF9-74CD01893F48}"/>
               </a:ext>
             </a:extLst>
           </p:cNvPr>
@@ -5274,7 +5273,7 @@
           <p:cNvPr id="6" name="Picture 5">
             <a:extLst>
               <a:ext uri="{FF2B5EF4-FFF2-40B4-BE49-F238E27FC236}">
-                <a16:creationId xmlns:a16="http://schemas.microsoft.com/office/drawing/2014/main" id="{B4C8B907-323D-3019-55AE-E0975627B499}"/>
+                <a16:creationId xmlns:a16="http://schemas.microsoft.com/office/drawing/2014/main" id="{85E74406-9F7F-535D-20E6-EE7DD43EBB9C}"/>
               </a:ext>
             </a:extLst>
           </p:cNvPr>
@@ -5310,7 +5309,7 @@
           <p:cNvPr id="7" name="TextBox 6">
             <a:extLst>
               <a:ext uri="{FF2B5EF4-FFF2-40B4-BE49-F238E27FC236}">
-                <a16:creationId xmlns:a16="http://schemas.microsoft.com/office/drawing/2014/main" id="{EBE2FFE7-6E1D-7E2E-3469-1CCED0098276}"/>
+                <a16:creationId xmlns:a16="http://schemas.microsoft.com/office/drawing/2014/main" id="{1DBB3ED9-50FE-B727-25F6-15EA65EBBB03}"/>
               </a:ext>
             </a:extLst>
           </p:cNvPr>
@@ -5357,7 +5356,7 @@
           <p:cNvPr id="8" name="TextBox 7">
             <a:extLst>
               <a:ext uri="{FF2B5EF4-FFF2-40B4-BE49-F238E27FC236}">
-                <a16:creationId xmlns:a16="http://schemas.microsoft.com/office/drawing/2014/main" id="{8027711F-9AB0-F492-76C1-07BF309CC686}"/>
+                <a16:creationId xmlns:a16="http://schemas.microsoft.com/office/drawing/2014/main" id="{B7BAE007-3F78-CB78-7A6E-3384BFE0574D}"/>
               </a:ext>
             </a:extLst>
           </p:cNvPr>
@@ -5400,7 +5399,7 @@
     </p:spTree>
     <p:extLst>
       <p:ext uri="{BB962C8B-B14F-4D97-AF65-F5344CB8AC3E}">
-        <p14:creationId xmlns:p14="http://schemas.microsoft.com/office/powerpoint/2010/main" val="1566570868"/>
+        <p14:creationId xmlns:p14="http://schemas.microsoft.com/office/powerpoint/2010/main" val="60809029"/>
       </p:ext>
     </p:extLst>
   </p:cSld>
@@ -5440,7 +5439,7 @@
           <p:cNvPr id="2" name="TextBox 1">
             <a:extLst>
               <a:ext uri="{FF2B5EF4-FFF2-40B4-BE49-F238E27FC236}">
-                <a16:creationId xmlns:a16="http://schemas.microsoft.com/office/drawing/2014/main" id="{FB4AD9D7-8E71-79A1-60A8-C91925413AD5}"/>
+                <a16:creationId xmlns:a16="http://schemas.microsoft.com/office/drawing/2014/main" id="{5AFC735A-4FBE-2606-8A32-ED6425752295}"/>
               </a:ext>
             </a:extLst>
           </p:cNvPr>
@@ -5469,20 +5468,14 @@
               </a:spcAft>
             </a:pPr>
             <a:r>
-              <a:rPr lang="en-US" sz="3200" b="1">
+              <a:rPr lang="en-IN" sz="3200" b="1">
                 <a:solidFill>
                   <a:srgbClr val="20382A"/>
                 </a:solidFill>
                 <a:latin typeface="Arial" panose="020B0604020202020204" pitchFamily="34" charset="0"/>
               </a:rPr>
-              <a:t>Uncertainty comes from 70 visual groups</a:t>
+              <a:t>Where contrast changes decisions</a:t>
             </a:r>
-            <a:endParaRPr lang="en-IN" sz="3200" b="1">
-              <a:solidFill>
-                <a:srgbClr val="20382A"/>
-              </a:solidFill>
-              <a:latin typeface="Arial" panose="020B0604020202020204" pitchFamily="34" charset="0"/>
-            </a:endParaRPr>
           </a:p>
         </p:txBody>
       </p:sp>
@@ -5491,7 +5484,7 @@
           <p:cNvPr id="3" name="TextBox 2">
             <a:extLst>
               <a:ext uri="{FF2B5EF4-FFF2-40B4-BE49-F238E27FC236}">
-                <a16:creationId xmlns:a16="http://schemas.microsoft.com/office/drawing/2014/main" id="{069103D9-AD81-38BF-25F4-5EFD8D975384}"/>
+                <a16:creationId xmlns:a16="http://schemas.microsoft.com/office/drawing/2014/main" id="{38A509CC-B27B-5C8D-6344-F9FA4799FD47}"/>
               </a:ext>
             </a:extLst>
           </p:cNvPr>
@@ -5526,7 +5519,7 @@
                 </a:solidFill>
                 <a:latin typeface="Arial" panose="020B0604020202020204" pitchFamily="34" charset="0"/>
               </a:rPr>
-              <a:t>Whole-group bootstrap, 2,000 paired draws, fixed model and split</a:t>
+              <a:t>17 concatenation errors corrected, but 14 correct decisions lost</a:t>
             </a:r>
             <a:endParaRPr lang="en-IN" sz="1500">
               <a:solidFill>
@@ -5537,12 +5530,64 @@
           </a:p>
         </p:txBody>
       </p:sp>
+      <p:sp>
+        <p:nvSpPr>
+          <p:cNvPr id="4" name="TextBox 3">
+            <a:extLst>
+              <a:ext uri="{FF2B5EF4-FFF2-40B4-BE49-F238E27FC236}">
+                <a16:creationId xmlns:a16="http://schemas.microsoft.com/office/drawing/2014/main" id="{2DD2C4B0-6BBF-D3A6-E95E-F93FD04CF4F7}"/>
+              </a:ext>
+            </a:extLst>
+          </p:cNvPr>
+          <p:cNvSpPr txBox="1"/>
+          <p:nvPr/>
+        </p:nvSpPr>
+        <p:spPr>
+          <a:xfrm>
+            <a:off x="635000" y="4952999"/>
+            <a:ext cx="10795000" cy="698500"/>
+          </a:xfrm>
+          <a:prstGeom prst="rect">
+            <a:avLst/>
+          </a:prstGeom>
+          <a:noFill/>
+        </p:spPr>
+        <p:txBody>
+          <a:bodyPr vert="horz" wrap="square" lIns="0" tIns="0" rIns="0" bIns="0" rtlCol="0">
+            <a:noAutofit/>
+          </a:bodyPr>
+          <a:lstStyle/>
+          <a:p>
+            <a:pPr>
+              <a:spcAft>
+                <a:spcPts val="800"/>
+              </a:spcAft>
+            </a:pPr>
+            <a:r>
+              <a:rPr lang="en-US">
+                <a:solidFill>
+                  <a:srgbClr val="20382A"/>
+                </a:solidFill>
+                <a:latin typeface="Arial" panose="020B0604020202020204" pitchFamily="34" charset="0"/>
+              </a:rPr>
+              <a:t>Selected examples: drive image_00696 is corrected;
+drive image_00017 changes from correct to incorrect.</a:t>
+            </a:r>
+            <a:endParaRPr lang="en-IN">
+              <a:solidFill>
+                <a:srgbClr val="20382A"/>
+              </a:solidFill>
+              <a:latin typeface="Arial" panose="020B0604020202020204" pitchFamily="34" charset="0"/>
+            </a:endParaRPr>
+          </a:p>
+        </p:txBody>
+      </p:sp>
       <p:graphicFrame>
         <p:nvGraphicFramePr>
-          <p:cNvPr id="4" name="Table 3">
+          <p:cNvPr id="5" name="Table 4">
             <a:extLst>
               <a:ext uri="{FF2B5EF4-FFF2-40B4-BE49-F238E27FC236}">
-                <a16:creationId xmlns:a16="http://schemas.microsoft.com/office/drawing/2014/main" id="{FEDE8126-AB7E-FA54-2A8B-855C1496243D}"/>
+                <a16:creationId xmlns:a16="http://schemas.microsoft.com/office/drawing/2014/main" id="{6E131E8E-AD7B-9095-4DE7-FD5550397641}"/>
               </a:ext>
             </a:extLst>
           </p:cNvPr>
@@ -5552,14 +5597,14 @@
           <p:nvPr>
             <p:extLst>
               <p:ext uri="{D42A27DB-BD31-4B8C-83A1-F6EECF244321}">
-                <p14:modId xmlns:p14="http://schemas.microsoft.com/office/powerpoint/2010/main" val="2037736763"/>
+                <p14:modId xmlns:p14="http://schemas.microsoft.com/office/powerpoint/2010/main" val="4106356954"/>
               </p:ext>
             </p:extLst>
           </p:nvPr>
         </p:nvGraphicFramePr>
         <p:xfrm>
           <a:off x="635000" y="1905000"/>
-          <a:ext cx="10922000" cy="3111500"/>
+          <a:ext cx="10922000" cy="2857500"/>
         </p:xfrm>
         <a:graphic>
           <a:graphicData uri="http://schemas.openxmlformats.org/drawingml/2006/table">
@@ -5568,42 +5613,49 @@
                 <a:tableStyleId>{5C22544A-7EE6-4342-B048-85BDC9FD1C3A}</a:tableStyleId>
               </a:tblPr>
               <a:tblGrid>
-                <a:gridCol w="3810000">
+                <a:gridCol w="4064000">
                   <a:extLst>
                     <a:ext uri="{9D8B030D-6E8A-4147-A177-3AD203B41FA5}">
-                      <a16:colId xmlns:a16="http://schemas.microsoft.com/office/drawing/2014/main" val="2649988353"/>
+                      <a16:colId xmlns:a16="http://schemas.microsoft.com/office/drawing/2014/main" val="942351640"/>
                     </a:ext>
                   </a:extLst>
                 </a:gridCol>
-                <a:gridCol w="2286000">
+                <a:gridCol w="1524000">
                   <a:extLst>
                     <a:ext uri="{9D8B030D-6E8A-4147-A177-3AD203B41FA5}">
-                      <a16:colId xmlns:a16="http://schemas.microsoft.com/office/drawing/2014/main" val="1761715499"/>
+                      <a16:colId xmlns:a16="http://schemas.microsoft.com/office/drawing/2014/main" val="3131021289"/>
                     </a:ext>
                   </a:extLst>
                 </a:gridCol>
-                <a:gridCol w="4826000">
+                <a:gridCol w="2667000">
                   <a:extLst>
                     <a:ext uri="{9D8B030D-6E8A-4147-A177-3AD203B41FA5}">
-                      <a16:colId xmlns:a16="http://schemas.microsoft.com/office/drawing/2014/main" val="3074253730"/>
+                      <a16:colId xmlns:a16="http://schemas.microsoft.com/office/drawing/2014/main" val="2012984853"/>
+                    </a:ext>
+                  </a:extLst>
+                </a:gridCol>
+                <a:gridCol w="2667000">
+                  <a:extLst>
+                    <a:ext uri="{9D8B030D-6E8A-4147-A177-3AD203B41FA5}">
+                      <a16:colId xmlns:a16="http://schemas.microsoft.com/office/drawing/2014/main" val="3809571636"/>
                     </a:ext>
                   </a:extLst>
                 </a:gridCol>
               </a:tblGrid>
-              <a:tr h="518583">
+              <a:tr h="714375">
                 <a:tc>
                   <a:txBody>
                     <a:bodyPr/>
                     <a:lstStyle/>
                     <a:p>
                       <a:r>
-                        <a:rPr lang="en-IN" sz="1700" b="1">
+                        <a:rPr lang="en-IN" sz="1800" b="1">
                           <a:solidFill>
                             <a:srgbClr val="FFFFFF"/>
                           </a:solidFill>
                           <a:latin typeface="Arial" panose="020B0604020202020204" pitchFamily="34" charset="0"/>
                         </a:rPr>
-                        <a:t>Feature</a:t>
+                        <a:t>Post-hoc subset</a:t>
                       </a:r>
                     </a:p>
                   </a:txBody>
@@ -5639,13 +5691,13 @@
                     <a:lstStyle/>
                     <a:p>
                       <a:r>
-                        <a:rPr lang="en-IN" sz="1700" b="1">
+                        <a:rPr lang="en-IN" sz="1800" b="1">
                           <a:solidFill>
                             <a:srgbClr val="FFFFFF"/>
                           </a:solidFill>
                           <a:latin typeface="Arial" panose="020B0604020202020204" pitchFamily="34" charset="0"/>
                         </a:rPr>
-                        <a:t>Accuracy</a:t>
+                        <a:t>Images</a:t>
                       </a:r>
                     </a:p>
                   </a:txBody>
@@ -5681,13 +5733,55 @@
                     <a:lstStyle/>
                     <a:p>
                       <a:r>
-                        <a:rPr lang="en-IN" sz="1700" b="1">
+                        <a:rPr lang="en-IN" sz="1800" b="1">
                           <a:solidFill>
                             <a:srgbClr val="FFFFFF"/>
                           </a:solidFill>
                           <a:latin typeface="Arial" panose="020B0604020202020204" pitchFamily="34" charset="0"/>
                         </a:rPr>
-                        <a:t>Conditional 95% interval</a:t>
+                        <a:t>Concat. correct</a:t>
+                      </a:r>
+                    </a:p>
+                  </a:txBody>
+                  <a:tcPr marL="114300" marR="76200" marT="63500" marB="50800" anchor="ctr">
+                    <a:lnL w="6350" cmpd="sng">
+                      <a:solidFill>
+                        <a:srgbClr val="D8DFD0"/>
+                      </a:solidFill>
+                    </a:lnL>
+                    <a:lnR w="6350" cmpd="sng">
+                      <a:solidFill>
+                        <a:srgbClr val="D8DFD0"/>
+                      </a:solidFill>
+                    </a:lnR>
+                    <a:lnT w="6350" cmpd="sng">
+                      <a:solidFill>
+                        <a:srgbClr val="D8DFD0"/>
+                      </a:solidFill>
+                    </a:lnT>
+                    <a:lnB w="6350" cmpd="sng">
+                      <a:solidFill>
+                        <a:srgbClr val="D8DFD0"/>
+                      </a:solidFill>
+                    </a:lnB>
+                    <a:solidFill>
+                      <a:srgbClr val="20382A"/>
+                    </a:solidFill>
+                  </a:tcPr>
+                </a:tc>
+                <a:tc>
+                  <a:txBody>
+                    <a:bodyPr/>
+                    <a:lstStyle/>
+                    <a:p>
+                      <a:r>
+                        <a:rPr lang="en-IN" sz="1800" b="1">
+                          <a:solidFill>
+                            <a:srgbClr val="FFFFFF"/>
+                          </a:solidFill>
+                          <a:latin typeface="Arial" panose="020B0604020202020204" pitchFamily="34" charset="0"/>
+                        </a:rPr>
+                        <a:t>Contrast correct</a:t>
                       </a:r>
                     </a:p>
                   </a:txBody>
@@ -5719,24 +5813,24 @@
                 </a:tc>
                 <a:extLst>
                   <a:ext uri="{0D108BD9-81ED-4DB2-BD59-A6C34878D82A}">
-                    <a16:rowId xmlns:a16="http://schemas.microsoft.com/office/drawing/2014/main" val="3405473579"/>
+                    <a16:rowId xmlns:a16="http://schemas.microsoft.com/office/drawing/2014/main" val="482410368"/>
                   </a:ext>
                 </a:extLst>
               </a:tr>
-              <a:tr h="518583">
+              <a:tr h="714375">
                 <a:tc>
                   <a:txBody>
                     <a:bodyPr/>
                     <a:lstStyle/>
                     <a:p>
                       <a:r>
-                        <a:rPr lang="en-IN" sz="1700" b="0">
+                        <a:rPr lang="en-IN" sz="1800" b="0">
                           <a:solidFill>
                             <a:srgbClr val="20382A"/>
                           </a:solidFill>
                           <a:latin typeface="Arial" panose="020B0604020202020204" pitchFamily="34" charset="0"/>
                         </a:rPr>
-                        <a:t>HOG</a:t>
+                        <a:t>Global / crop agree</a:t>
                       </a:r>
                     </a:p>
                   </a:txBody>
@@ -5772,13 +5866,13 @@
                     <a:lstStyle/>
                     <a:p>
                       <a:r>
-                        <a:rPr lang="en-IN" sz="1700" b="0">
+                        <a:rPr lang="en-IN" sz="1800" b="0">
                           <a:solidFill>
                             <a:srgbClr val="20382A"/>
                           </a:solidFill>
                           <a:latin typeface="Arial" panose="020B0604020202020204" pitchFamily="34" charset="0"/>
                         </a:rPr>
-                        <a:t>35.3%</a:t>
+                        <a:t>713</a:t>
                       </a:r>
                     </a:p>
                   </a:txBody>
@@ -5814,13 +5908,55 @@
                     <a:lstStyle/>
                     <a:p>
                       <a:r>
-                        <a:rPr lang="en-IN" sz="1700" b="0">
+                        <a:rPr lang="en-IN" sz="1800" b="0">
                           <a:solidFill>
                             <a:srgbClr val="20382A"/>
                           </a:solidFill>
                           <a:latin typeface="Arial" panose="020B0604020202020204" pitchFamily="34" charset="0"/>
                         </a:rPr>
-                        <a:t>25.9 to 48.1%</a:t>
+                        <a:t>499</a:t>
+                      </a:r>
+                    </a:p>
+                  </a:txBody>
+                  <a:tcPr marL="114300" marR="76200" marT="63500" marB="50800" anchor="ctr">
+                    <a:lnL w="6350" cmpd="sng">
+                      <a:solidFill>
+                        <a:srgbClr val="D8DFD0"/>
+                      </a:solidFill>
+                    </a:lnL>
+                    <a:lnR w="6350" cmpd="sng">
+                      <a:solidFill>
+                        <a:srgbClr val="D8DFD0"/>
+                      </a:solidFill>
+                    </a:lnR>
+                    <a:lnT w="6350" cmpd="sng">
+                      <a:solidFill>
+                        <a:srgbClr val="D8DFD0"/>
+                      </a:solidFill>
+                    </a:lnT>
+                    <a:lnB w="6350" cmpd="sng">
+                      <a:solidFill>
+                        <a:srgbClr val="D8DFD0"/>
+                      </a:solidFill>
+                    </a:lnB>
+                    <a:solidFill>
+                      <a:srgbClr val="FFFFFF"/>
+                    </a:solidFill>
+                  </a:tcPr>
+                </a:tc>
+                <a:tc>
+                  <a:txBody>
+                    <a:bodyPr/>
+                    <a:lstStyle/>
+                    <a:p>
+                      <a:r>
+                        <a:rPr lang="en-IN" sz="1800" b="0">
+                          <a:solidFill>
+                            <a:srgbClr val="20382A"/>
+                          </a:solidFill>
+                          <a:latin typeface="Arial" panose="020B0604020202020204" pitchFamily="34" charset="0"/>
+                        </a:rPr>
+                        <a:t>499</a:t>
                       </a:r>
                     </a:p>
                   </a:txBody>
@@ -5852,24 +5988,24 @@
                 </a:tc>
                 <a:extLst>
                   <a:ext uri="{0D108BD9-81ED-4DB2-BD59-A6C34878D82A}">
-                    <a16:rowId xmlns:a16="http://schemas.microsoft.com/office/drawing/2014/main" val="1096819625"/>
+                    <a16:rowId xmlns:a16="http://schemas.microsoft.com/office/drawing/2014/main" val="3692162954"/>
                   </a:ext>
                 </a:extLst>
               </a:tr>
-              <a:tr h="518583">
+              <a:tr h="714375">
                 <a:tc>
                   <a:txBody>
                     <a:bodyPr/>
                     <a:lstStyle/>
                     <a:p>
                       <a:r>
-                        <a:rPr lang="en-IN" sz="1700" b="0">
+                        <a:rPr lang="en-IN" sz="1800" b="0">
                           <a:solidFill>
                             <a:srgbClr val="20382A"/>
                           </a:solidFill>
                           <a:latin typeface="Arial" panose="020B0604020202020204" pitchFamily="34" charset="0"/>
                         </a:rPr>
-                        <a:t>CNN global</a:t>
+                        <a:t>Global / crop disagree</a:t>
                       </a:r>
                     </a:p>
                   </a:txBody>
@@ -5905,13 +6041,13 @@
                     <a:lstStyle/>
                     <a:p>
                       <a:r>
-                        <a:rPr lang="en-IN" sz="1700" b="0">
+                        <a:rPr lang="en-IN" sz="1800" b="0">
                           <a:solidFill>
                             <a:srgbClr val="20382A"/>
                           </a:solidFill>
                           <a:latin typeface="Arial" panose="020B0604020202020204" pitchFamily="34" charset="0"/>
                         </a:rPr>
-                        <a:t>63.0%</a:t>
+                        <a:t>232</a:t>
                       </a:r>
                     </a:p>
                   </a:txBody>
@@ -5947,13 +6083,55 @@
                     <a:lstStyle/>
                     <a:p>
                       <a:r>
-                        <a:rPr lang="en-IN" sz="1700" b="0">
+                        <a:rPr lang="en-IN" sz="1800" b="0">
                           <a:solidFill>
                             <a:srgbClr val="20382A"/>
                           </a:solidFill>
                           <a:latin typeface="Arial" panose="020B0604020202020204" pitchFamily="34" charset="0"/>
                         </a:rPr>
-                        <a:t>49.5 to 74.2%</a:t>
+                        <a:t>117</a:t>
+                      </a:r>
+                    </a:p>
+                  </a:txBody>
+                  <a:tcPr marL="114300" marR="76200" marT="63500" marB="50800" anchor="ctr">
+                    <a:lnL w="6350" cmpd="sng">
+                      <a:solidFill>
+                        <a:srgbClr val="D8DFD0"/>
+                      </a:solidFill>
+                    </a:lnL>
+                    <a:lnR w="6350" cmpd="sng">
+                      <a:solidFill>
+                        <a:srgbClr val="D8DFD0"/>
+                      </a:solidFill>
+                    </a:lnR>
+                    <a:lnT w="6350" cmpd="sng">
+                      <a:solidFill>
+                        <a:srgbClr val="D8DFD0"/>
+                      </a:solidFill>
+                    </a:lnT>
+                    <a:lnB w="6350" cmpd="sng">
+                      <a:solidFill>
+                        <a:srgbClr val="D8DFD0"/>
+                      </a:solidFill>
+                    </a:lnB>
+                    <a:solidFill>
+                      <a:srgbClr val="EEF2E7"/>
+                    </a:solidFill>
+                  </a:tcPr>
+                </a:tc>
+                <a:tc>
+                  <a:txBody>
+                    <a:bodyPr/>
+                    <a:lstStyle/>
+                    <a:p>
+                      <a:r>
+                        <a:rPr lang="en-IN" sz="1800" b="0">
+                          <a:solidFill>
+                            <a:srgbClr val="20382A"/>
+                          </a:solidFill>
+                          <a:latin typeface="Arial" panose="020B0604020202020204" pitchFamily="34" charset="0"/>
+                        </a:rPr>
+                        <a:t>120</a:t>
                       </a:r>
                     </a:p>
                   </a:txBody>
@@ -5985,24 +6163,24 @@
                 </a:tc>
                 <a:extLst>
                   <a:ext uri="{0D108BD9-81ED-4DB2-BD59-A6C34878D82A}">
-                    <a16:rowId xmlns:a16="http://schemas.microsoft.com/office/drawing/2014/main" val="3045006925"/>
+                    <a16:rowId xmlns:a16="http://schemas.microsoft.com/office/drawing/2014/main" val="2706094569"/>
                   </a:ext>
                 </a:extLst>
               </a:tr>
-              <a:tr h="518583">
+              <a:tr h="714375">
                 <a:tc>
                   <a:txBody>
                     <a:bodyPr/>
                     <a:lstStyle/>
                     <a:p>
                       <a:r>
-                        <a:rPr lang="en-IN" sz="1700" b="0">
+                        <a:rPr lang="en-IN" sz="1800" b="0">
                           <a:solidFill>
                             <a:srgbClr val="20382A"/>
                           </a:solidFill>
                           <a:latin typeface="Arial" panose="020B0604020202020204" pitchFamily="34" charset="0"/>
                         </a:rPr>
-                        <a:t>CNN crop</a:t>
+                        <a:t>All test images</a:t>
                       </a:r>
                     </a:p>
                   </a:txBody>
@@ -6038,13 +6216,13 @@
                     <a:lstStyle/>
                     <a:p>
                       <a:r>
-                        <a:rPr lang="en-IN" sz="1700" b="0">
+                        <a:rPr lang="en-IN" sz="1800" b="0">
                           <a:solidFill>
                             <a:srgbClr val="20382A"/>
                           </a:solidFill>
                           <a:latin typeface="Arial" panose="020B0604020202020204" pitchFamily="34" charset="0"/>
                         </a:rPr>
-                        <a:t>62.4%</a:t>
+                        <a:t>945</a:t>
                       </a:r>
                     </a:p>
                   </a:txBody>
@@ -6080,195 +6258,13 @@
                     <a:lstStyle/>
                     <a:p>
                       <a:r>
-                        <a:rPr lang="en-IN" sz="1700" b="0">
+                        <a:rPr lang="en-IN" sz="1800" b="0">
                           <a:solidFill>
                             <a:srgbClr val="20382A"/>
                           </a:solidFill>
                           <a:latin typeface="Arial" panose="020B0604020202020204" pitchFamily="34" charset="0"/>
                         </a:rPr>
-                        <a:t>45.3 to 76.7%</a:t>
-                      </a:r>
-                    </a:p>
-                  </a:txBody>
-                  <a:tcPr marL="114300" marR="76200" marT="63500" marB="50800" anchor="ctr">
-                    <a:lnL w="6350" cmpd="sng">
-                      <a:solidFill>
-                        <a:srgbClr val="D8DFD0"/>
-                      </a:solidFill>
-                    </a:lnL>
-                    <a:lnR w="6350" cmpd="sng">
-                      <a:solidFill>
-                        <a:srgbClr val="D8DFD0"/>
-                      </a:solidFill>
-                    </a:lnR>
-                    <a:lnT w="6350" cmpd="sng">
-                      <a:solidFill>
-                        <a:srgbClr val="D8DFD0"/>
-                      </a:solidFill>
-                    </a:lnT>
-                    <a:lnB w="6350" cmpd="sng">
-                      <a:solidFill>
-                        <a:srgbClr val="D8DFD0"/>
-                      </a:solidFill>
-                    </a:lnB>
-                    <a:solidFill>
-                      <a:srgbClr val="FFFFFF"/>
-                    </a:solidFill>
-                  </a:tcPr>
-                </a:tc>
-                <a:extLst>
-                  <a:ext uri="{0D108BD9-81ED-4DB2-BD59-A6C34878D82A}">
-                    <a16:rowId xmlns:a16="http://schemas.microsoft.com/office/drawing/2014/main" val="4086029323"/>
-                  </a:ext>
-                </a:extLst>
-              </a:tr>
-              <a:tr h="518583">
-                <a:tc>
-                  <a:txBody>
-                    <a:bodyPr/>
-                    <a:lstStyle/>
-                    <a:p>
-                      <a:r>
-                        <a:rPr lang="en-IN" sz="1700" b="0">
-                          <a:solidFill>
-                            <a:srgbClr val="20382A"/>
-                          </a:solidFill>
-                          <a:latin typeface="Arial" panose="020B0604020202020204" pitchFamily="34" charset="0"/>
-                        </a:rPr>
-                        <a:t>Concatenation</a:t>
-                      </a:r>
-                    </a:p>
-                  </a:txBody>
-                  <a:tcPr marL="114300" marR="76200" marT="63500" marB="50800" anchor="ctr">
-                    <a:lnL w="6350" cmpd="sng">
-                      <a:solidFill>
-                        <a:srgbClr val="D8DFD0"/>
-                      </a:solidFill>
-                    </a:lnL>
-                    <a:lnR w="6350" cmpd="sng">
-                      <a:solidFill>
-                        <a:srgbClr val="D8DFD0"/>
-                      </a:solidFill>
-                    </a:lnR>
-                    <a:lnT w="6350" cmpd="sng">
-                      <a:solidFill>
-                        <a:srgbClr val="D8DFD0"/>
-                      </a:solidFill>
-                    </a:lnT>
-                    <a:lnB w="6350" cmpd="sng">
-                      <a:solidFill>
-                        <a:srgbClr val="D8DFD0"/>
-                      </a:solidFill>
-                    </a:lnB>
-                    <a:solidFill>
-                      <a:srgbClr val="EEF2E7"/>
-                    </a:solidFill>
-                  </a:tcPr>
-                </a:tc>
-                <a:tc>
-                  <a:txBody>
-                    <a:bodyPr/>
-                    <a:lstStyle/>
-                    <a:p>
-                      <a:r>
-                        <a:rPr lang="en-IN" sz="1700" b="0">
-                          <a:solidFill>
-                            <a:srgbClr val="20382A"/>
-                          </a:solidFill>
-                          <a:latin typeface="Arial" panose="020B0604020202020204" pitchFamily="34" charset="0"/>
-                        </a:rPr>
-                        <a:t>65.2%</a:t>
-                      </a:r>
-                    </a:p>
-                  </a:txBody>
-                  <a:tcPr marL="114300" marR="76200" marT="63500" marB="50800" anchor="ctr">
-                    <a:lnL w="6350" cmpd="sng">
-                      <a:solidFill>
-                        <a:srgbClr val="D8DFD0"/>
-                      </a:solidFill>
-                    </a:lnL>
-                    <a:lnR w="6350" cmpd="sng">
-                      <a:solidFill>
-                        <a:srgbClr val="D8DFD0"/>
-                      </a:solidFill>
-                    </a:lnR>
-                    <a:lnT w="6350" cmpd="sng">
-                      <a:solidFill>
-                        <a:srgbClr val="D8DFD0"/>
-                      </a:solidFill>
-                    </a:lnT>
-                    <a:lnB w="6350" cmpd="sng">
-                      <a:solidFill>
-                        <a:srgbClr val="D8DFD0"/>
-                      </a:solidFill>
-                    </a:lnB>
-                    <a:solidFill>
-                      <a:srgbClr val="EEF2E7"/>
-                    </a:solidFill>
-                  </a:tcPr>
-                </a:tc>
-                <a:tc>
-                  <a:txBody>
-                    <a:bodyPr/>
-                    <a:lstStyle/>
-                    <a:p>
-                      <a:r>
-                        <a:rPr lang="en-IN" sz="1700" b="0">
-                          <a:solidFill>
-                            <a:srgbClr val="20382A"/>
-                          </a:solidFill>
-                          <a:latin typeface="Arial" panose="020B0604020202020204" pitchFamily="34" charset="0"/>
-                        </a:rPr>
-                        <a:t>48.9 to 77.9%</a:t>
-                      </a:r>
-                    </a:p>
-                  </a:txBody>
-                  <a:tcPr marL="114300" marR="76200" marT="63500" marB="50800" anchor="ctr">
-                    <a:lnL w="6350" cmpd="sng">
-                      <a:solidFill>
-                        <a:srgbClr val="D8DFD0"/>
-                      </a:solidFill>
-                    </a:lnL>
-                    <a:lnR w="6350" cmpd="sng">
-                      <a:solidFill>
-                        <a:srgbClr val="D8DFD0"/>
-                      </a:solidFill>
-                    </a:lnR>
-                    <a:lnT w="6350" cmpd="sng">
-                      <a:solidFill>
-                        <a:srgbClr val="D8DFD0"/>
-                      </a:solidFill>
-                    </a:lnT>
-                    <a:lnB w="6350" cmpd="sng">
-                      <a:solidFill>
-                        <a:srgbClr val="D8DFD0"/>
-                      </a:solidFill>
-                    </a:lnB>
-                    <a:solidFill>
-                      <a:srgbClr val="EEF2E7"/>
-                    </a:solidFill>
-                  </a:tcPr>
-                </a:tc>
-                <a:extLst>
-                  <a:ext uri="{0D108BD9-81ED-4DB2-BD59-A6C34878D82A}">
-                    <a16:rowId xmlns:a16="http://schemas.microsoft.com/office/drawing/2014/main" val="6643461"/>
-                  </a:ext>
-                </a:extLst>
-              </a:tr>
-              <a:tr h="518583">
-                <a:tc>
-                  <a:txBody>
-                    <a:bodyPr/>
-                    <a:lstStyle/>
-                    <a:p>
-                      <a:r>
-                        <a:rPr lang="en-IN" sz="1700" b="0">
-                          <a:solidFill>
-                            <a:srgbClr val="20382A"/>
-                          </a:solidFill>
-                          <a:latin typeface="Arial" panose="020B0604020202020204" pitchFamily="34" charset="0"/>
-                        </a:rPr>
-                        <a:t>Contrast</a:t>
+                        <a:t>616</a:t>
                       </a:r>
                     </a:p>
                   </a:txBody>
@@ -6304,55 +6300,13 @@
                     <a:lstStyle/>
                     <a:p>
                       <a:r>
-                        <a:rPr lang="en-IN" sz="1700" b="0">
+                        <a:rPr lang="en-IN" sz="1800" b="0">
                           <a:solidFill>
                             <a:srgbClr val="20382A"/>
                           </a:solidFill>
                           <a:latin typeface="Arial" panose="020B0604020202020204" pitchFamily="34" charset="0"/>
                         </a:rPr>
-                        <a:t>65.5%</a:t>
-                      </a:r>
-                    </a:p>
-                  </a:txBody>
-                  <a:tcPr marL="114300" marR="76200" marT="63500" marB="50800" anchor="ctr">
-                    <a:lnL w="6350" cmpd="sng">
-                      <a:solidFill>
-                        <a:srgbClr val="D8DFD0"/>
-                      </a:solidFill>
-                    </a:lnL>
-                    <a:lnR w="6350" cmpd="sng">
-                      <a:solidFill>
-                        <a:srgbClr val="D8DFD0"/>
-                      </a:solidFill>
-                    </a:lnR>
-                    <a:lnT w="6350" cmpd="sng">
-                      <a:solidFill>
-                        <a:srgbClr val="D8DFD0"/>
-                      </a:solidFill>
-                    </a:lnT>
-                    <a:lnB w="6350" cmpd="sng">
-                      <a:solidFill>
-                        <a:srgbClr val="D8DFD0"/>
-                      </a:solidFill>
-                    </a:lnB>
-                    <a:solidFill>
-                      <a:srgbClr val="FFFFFF"/>
-                    </a:solidFill>
-                  </a:tcPr>
-                </a:tc>
-                <a:tc>
-                  <a:txBody>
-                    <a:bodyPr/>
-                    <a:lstStyle/>
-                    <a:p>
-                      <a:r>
-                        <a:rPr lang="en-IN" sz="1700" b="0">
-                          <a:solidFill>
-                            <a:srgbClr val="20382A"/>
-                          </a:solidFill>
-                          <a:latin typeface="Arial" panose="020B0604020202020204" pitchFamily="34" charset="0"/>
-                        </a:rPr>
-                        <a:t>49.9 to 77.6%</a:t>
+                        <a:t>619</a:t>
                       </a:r>
                     </a:p>
                   </a:txBody>
@@ -6384,7 +6338,7 @@
                 </a:tc>
                 <a:extLst>
                   <a:ext uri="{0D108BD9-81ED-4DB2-BD59-A6C34878D82A}">
-                    <a16:rowId xmlns:a16="http://schemas.microsoft.com/office/drawing/2014/main" val="1876782901"/>
+                    <a16:rowId xmlns:a16="http://schemas.microsoft.com/office/drawing/2014/main" val="4008685344"/>
                   </a:ext>
                 </a:extLst>
               </a:tr>
@@ -6394,10 +6348,10 @@
       </p:graphicFrame>
       <p:sp>
         <p:nvSpPr>
-          <p:cNvPr id="5" name="TextBox 4">
+          <p:cNvPr id="6" name="TextBox 5">
             <a:extLst>
               <a:ext uri="{FF2B5EF4-FFF2-40B4-BE49-F238E27FC236}">
-                <a16:creationId xmlns:a16="http://schemas.microsoft.com/office/drawing/2014/main" id="{D49EEE81-39F8-FEDE-63A9-65ACC80DCFFA}"/>
+                <a16:creationId xmlns:a16="http://schemas.microsoft.com/office/drawing/2014/main" id="{B17446E6-BF90-88A9-0179-D0329016279A}"/>
               </a:ext>
             </a:extLst>
           </p:cNvPr>
@@ -6432,7 +6386,7 @@
                 </a:solidFill>
                 <a:latin typeface="Arial" panose="020B0604020202020204" pitchFamily="34" charset="0"/>
               </a:rPr>
-              <a:t>Contrast minus concatenation: +0.32 points; interval -1.46 to +2.38. No clear advantage.</a:t>
+              <a:t>Paired group interval: -1.46 to +2.38 points. A reliable gain is not established.</a:t>
             </a:r>
             <a:endParaRPr lang="en-IN" sz="1600">
               <a:solidFill>
@@ -6445,10 +6399,10 @@
       </p:sp>
       <p:sp>
         <p:nvSpPr>
-          <p:cNvPr id="6" name="TextBox 5">
+          <p:cNvPr id="7" name="TextBox 6">
             <a:extLst>
               <a:ext uri="{FF2B5EF4-FFF2-40B4-BE49-F238E27FC236}">
-                <a16:creationId xmlns:a16="http://schemas.microsoft.com/office/drawing/2014/main" id="{88EF36A9-2D50-7DE1-E339-8471EA02B10E}"/>
+                <a16:creationId xmlns:a16="http://schemas.microsoft.com/office/drawing/2014/main" id="{632B2B50-C543-4818-711B-7B66228A660A}"/>
               </a:ext>
             </a:extLst>
           </p:cNvPr>
@@ -6490,10 +6444,10 @@
       </p:sp>
       <p:sp>
         <p:nvSpPr>
-          <p:cNvPr id="7" name="TextBox 6">
+          <p:cNvPr id="8" name="TextBox 7">
             <a:extLst>
               <a:ext uri="{FF2B5EF4-FFF2-40B4-BE49-F238E27FC236}">
-                <a16:creationId xmlns:a16="http://schemas.microsoft.com/office/drawing/2014/main" id="{347F5C57-9E97-5439-1E80-D0032DF4FFBC}"/>
+                <a16:creationId xmlns:a16="http://schemas.microsoft.com/office/drawing/2014/main" id="{A9D46563-8159-ADCC-E300-E56D019E635E}"/>
               </a:ext>
             </a:extLst>
           </p:cNvPr>
@@ -6536,7 +6490,7 @@
     </p:spTree>
     <p:extLst>
       <p:ext uri="{BB962C8B-B14F-4D97-AF65-F5344CB8AC3E}">
-        <p14:creationId xmlns:p14="http://schemas.microsoft.com/office/powerpoint/2010/main" val="725490730"/>
+        <p14:creationId xmlns:p14="http://schemas.microsoft.com/office/powerpoint/2010/main" val="2075331251"/>
       </p:ext>
     </p:extLst>
   </p:cSld>
@@ -6576,7 +6530,7 @@
           <p:cNvPr id="2" name="TextBox 1">
             <a:extLst>
               <a:ext uri="{FF2B5EF4-FFF2-40B4-BE49-F238E27FC236}">
-                <a16:creationId xmlns:a16="http://schemas.microsoft.com/office/drawing/2014/main" id="{B8A51C51-CCDC-7F45-750E-64025DF14F95}"/>
+                <a16:creationId xmlns:a16="http://schemas.microsoft.com/office/drawing/2014/main" id="{5DB52067-7CCD-7FBA-E31E-DA005B4F3124}"/>
               </a:ext>
             </a:extLst>
           </p:cNvPr>
@@ -6621,7 +6575,7 @@
           <p:cNvPr id="3" name="TextBox 2">
             <a:extLst>
               <a:ext uri="{FF2B5EF4-FFF2-40B4-BE49-F238E27FC236}">
-                <a16:creationId xmlns:a16="http://schemas.microsoft.com/office/drawing/2014/main" id="{CEA0BE99-1F89-5735-A9E9-C0E36289DDB0}"/>
+                <a16:creationId xmlns:a16="http://schemas.microsoft.com/office/drawing/2014/main" id="{D1D58F2D-FEB3-B9B9-2619-C36B285C03D0}"/>
               </a:ext>
             </a:extLst>
           </p:cNvPr>
@@ -6672,7 +6626,7 @@
           <p:cNvPr id="4" name="Table 3">
             <a:extLst>
               <a:ext uri="{FF2B5EF4-FFF2-40B4-BE49-F238E27FC236}">
-                <a16:creationId xmlns:a16="http://schemas.microsoft.com/office/drawing/2014/main" id="{775560BE-3BF2-FFA4-EAC1-0C9AAB751A20}"/>
+                <a16:creationId xmlns:a16="http://schemas.microsoft.com/office/drawing/2014/main" id="{8092B2EC-4FC7-6AD1-E7CA-AEE15E4248C1}"/>
               </a:ext>
             </a:extLst>
           </p:cNvPr>
@@ -6682,7 +6636,7 @@
           <p:nvPr>
             <p:extLst>
               <p:ext uri="{D42A27DB-BD31-4B8C-83A1-F6EECF244321}">
-                <p14:modId xmlns:p14="http://schemas.microsoft.com/office/powerpoint/2010/main" val="1942794517"/>
+                <p14:modId xmlns:p14="http://schemas.microsoft.com/office/powerpoint/2010/main" val="2084035532"/>
               </p:ext>
             </p:extLst>
           </p:nvPr>
@@ -6701,35 +6655,35 @@
                 <a:gridCol w="3302000">
                   <a:extLst>
                     <a:ext uri="{9D8B030D-6E8A-4147-A177-3AD203B41FA5}">
-                      <a16:colId xmlns:a16="http://schemas.microsoft.com/office/drawing/2014/main" val="2739273257"/>
+                      <a16:colId xmlns:a16="http://schemas.microsoft.com/office/drawing/2014/main" val="505685940"/>
                     </a:ext>
                   </a:extLst>
                 </a:gridCol>
                 <a:gridCol w="1905000">
                   <a:extLst>
                     <a:ext uri="{9D8B030D-6E8A-4147-A177-3AD203B41FA5}">
-                      <a16:colId xmlns:a16="http://schemas.microsoft.com/office/drawing/2014/main" val="65077783"/>
+                      <a16:colId xmlns:a16="http://schemas.microsoft.com/office/drawing/2014/main" val="2875457233"/>
                     </a:ext>
                   </a:extLst>
                 </a:gridCol>
                 <a:gridCol w="1905000">
                   <a:extLst>
                     <a:ext uri="{9D8B030D-6E8A-4147-A177-3AD203B41FA5}">
-                      <a16:colId xmlns:a16="http://schemas.microsoft.com/office/drawing/2014/main" val="941637770"/>
+                      <a16:colId xmlns:a16="http://schemas.microsoft.com/office/drawing/2014/main" val="12305160"/>
                     </a:ext>
                   </a:extLst>
                 </a:gridCol>
                 <a:gridCol w="1905000">
                   <a:extLst>
                     <a:ext uri="{9D8B030D-6E8A-4147-A177-3AD203B41FA5}">
-                      <a16:colId xmlns:a16="http://schemas.microsoft.com/office/drawing/2014/main" val="1429278253"/>
+                      <a16:colId xmlns:a16="http://schemas.microsoft.com/office/drawing/2014/main" val="2517738048"/>
                     </a:ext>
                   </a:extLst>
                 </a:gridCol>
                 <a:gridCol w="1905000">
                   <a:extLst>
                     <a:ext uri="{9D8B030D-6E8A-4147-A177-3AD203B41FA5}">
-                      <a16:colId xmlns:a16="http://schemas.microsoft.com/office/drawing/2014/main" val="1817886993"/>
+                      <a16:colId xmlns:a16="http://schemas.microsoft.com/office/drawing/2014/main" val="4292797885"/>
                     </a:ext>
                   </a:extLst>
                 </a:gridCol>
@@ -6947,7 +6901,7 @@
                 </a:tc>
                 <a:extLst>
                   <a:ext uri="{0D108BD9-81ED-4DB2-BD59-A6C34878D82A}">
-                    <a16:rowId xmlns:a16="http://schemas.microsoft.com/office/drawing/2014/main" val="4169113435"/>
+                    <a16:rowId xmlns:a16="http://schemas.microsoft.com/office/drawing/2014/main" val="615875965"/>
                   </a:ext>
                 </a:extLst>
               </a:tr>
@@ -7164,7 +7118,7 @@
                 </a:tc>
                 <a:extLst>
                   <a:ext uri="{0D108BD9-81ED-4DB2-BD59-A6C34878D82A}">
-                    <a16:rowId xmlns:a16="http://schemas.microsoft.com/office/drawing/2014/main" val="3382521347"/>
+                    <a16:rowId xmlns:a16="http://schemas.microsoft.com/office/drawing/2014/main" val="3360513813"/>
                   </a:ext>
                 </a:extLst>
               </a:tr>
@@ -7381,7 +7335,7 @@
                 </a:tc>
                 <a:extLst>
                   <a:ext uri="{0D108BD9-81ED-4DB2-BD59-A6C34878D82A}">
-                    <a16:rowId xmlns:a16="http://schemas.microsoft.com/office/drawing/2014/main" val="503023023"/>
+                    <a16:rowId xmlns:a16="http://schemas.microsoft.com/office/drawing/2014/main" val="4029551806"/>
                   </a:ext>
                 </a:extLst>
               </a:tr>
@@ -7598,7 +7552,7 @@
                 </a:tc>
                 <a:extLst>
                   <a:ext uri="{0D108BD9-81ED-4DB2-BD59-A6C34878D82A}">
-                    <a16:rowId xmlns:a16="http://schemas.microsoft.com/office/drawing/2014/main" val="2603615563"/>
+                    <a16:rowId xmlns:a16="http://schemas.microsoft.com/office/drawing/2014/main" val="1453545393"/>
                   </a:ext>
                 </a:extLst>
               </a:tr>
@@ -7815,7 +7769,7 @@
                 </a:tc>
                 <a:extLst>
                   <a:ext uri="{0D108BD9-81ED-4DB2-BD59-A6C34878D82A}">
-                    <a16:rowId xmlns:a16="http://schemas.microsoft.com/office/drawing/2014/main" val="3258060934"/>
+                    <a16:rowId xmlns:a16="http://schemas.microsoft.com/office/drawing/2014/main" val="3623195443"/>
                   </a:ext>
                 </a:extLst>
               </a:tr>
@@ -7828,7 +7782,7 @@
           <p:cNvPr id="5" name="TextBox 4">
             <a:extLst>
               <a:ext uri="{FF2B5EF4-FFF2-40B4-BE49-F238E27FC236}">
-                <a16:creationId xmlns:a16="http://schemas.microsoft.com/office/drawing/2014/main" id="{386335B0-56BF-D565-49A8-02DFDCEFF48E}"/>
+                <a16:creationId xmlns:a16="http://schemas.microsoft.com/office/drawing/2014/main" id="{03FAC8D3-749D-BA85-32CE-E2136B2EB22D}"/>
               </a:ext>
             </a:extLst>
           </p:cNvPr>
@@ -7879,7 +7833,7 @@
           <p:cNvPr id="6" name="TextBox 5">
             <a:extLst>
               <a:ext uri="{FF2B5EF4-FFF2-40B4-BE49-F238E27FC236}">
-                <a16:creationId xmlns:a16="http://schemas.microsoft.com/office/drawing/2014/main" id="{33BD448F-1047-9491-D85D-CACD399D9B0C}"/>
+                <a16:creationId xmlns:a16="http://schemas.microsoft.com/office/drawing/2014/main" id="{0B6899BD-3994-087C-D841-87594CEF31E3}"/>
               </a:ext>
             </a:extLst>
           </p:cNvPr>
@@ -7924,7 +7878,7 @@
           <p:cNvPr id="7" name="TextBox 6">
             <a:extLst>
               <a:ext uri="{FF2B5EF4-FFF2-40B4-BE49-F238E27FC236}">
-                <a16:creationId xmlns:a16="http://schemas.microsoft.com/office/drawing/2014/main" id="{B1F08C2D-5DB3-A175-B4EA-76D8898631E0}"/>
+                <a16:creationId xmlns:a16="http://schemas.microsoft.com/office/drawing/2014/main" id="{E9606B1E-8A42-324B-A863-7DCFD671C319}"/>
               </a:ext>
             </a:extLst>
           </p:cNvPr>
@@ -7967,7 +7921,7 @@
     </p:spTree>
     <p:extLst>
       <p:ext uri="{BB962C8B-B14F-4D97-AF65-F5344CB8AC3E}">
-        <p14:creationId xmlns:p14="http://schemas.microsoft.com/office/powerpoint/2010/main" val="926385323"/>
+        <p14:creationId xmlns:p14="http://schemas.microsoft.com/office/powerpoint/2010/main" val="1602161767"/>
       </p:ext>
     </p:extLst>
   </p:cSld>
@@ -8007,7 +7961,7 @@
           <p:cNvPr id="2" name="TextBox 1">
             <a:extLst>
               <a:ext uri="{FF2B5EF4-FFF2-40B4-BE49-F238E27FC236}">
-                <a16:creationId xmlns:a16="http://schemas.microsoft.com/office/drawing/2014/main" id="{DC46EF72-7AE0-7C81-026B-D7C96FE42B67}"/>
+                <a16:creationId xmlns:a16="http://schemas.microsoft.com/office/drawing/2014/main" id="{74784183-0EBA-EF83-D6D7-31C8AC8E5541}"/>
               </a:ext>
             </a:extLst>
           </p:cNvPr>
@@ -8058,7 +8012,7 @@
           <p:cNvPr id="3" name="TextBox 2">
             <a:extLst>
               <a:ext uri="{FF2B5EF4-FFF2-40B4-BE49-F238E27FC236}">
-                <a16:creationId xmlns:a16="http://schemas.microsoft.com/office/drawing/2014/main" id="{82CF64F8-62DB-5B14-24E0-1C50C932ED3F}"/>
+                <a16:creationId xmlns:a16="http://schemas.microsoft.com/office/drawing/2014/main" id="{ADDFDC27-1B53-BA66-10D7-CD97038D0953}"/>
               </a:ext>
             </a:extLst>
           </p:cNvPr>
@@ -8109,7 +8063,7 @@
           <p:cNvPr id="4" name="TextBox 3">
             <a:extLst>
               <a:ext uri="{FF2B5EF4-FFF2-40B4-BE49-F238E27FC236}">
-                <a16:creationId xmlns:a16="http://schemas.microsoft.com/office/drawing/2014/main" id="{DE735362-3608-E572-4C5B-899D0B7BCFC3}"/>
+                <a16:creationId xmlns:a16="http://schemas.microsoft.com/office/drawing/2014/main" id="{50CE65C1-2569-1742-EE12-CF24070597A7}"/>
               </a:ext>
             </a:extLst>
           </p:cNvPr>
@@ -8118,8 +8072,8 @@
         </p:nvSpPr>
         <p:spPr>
           <a:xfrm>
-            <a:off x="6477000" y="2095499"/>
-            <a:ext cx="5080000" cy="1905000"/>
+            <a:off x="6477000" y="1968499"/>
+            <a:ext cx="5080000" cy="2286000"/>
           </a:xfrm>
           <a:prstGeom prst="rect">
             <a:avLst/>
@@ -8138,17 +8092,18 @@
               </a:spcAft>
             </a:pPr>
             <a:r>
-              <a:rPr lang="en-US" sz="2500" b="1">
+              <a:rPr lang="en-US" sz="2200" b="1">
                 <a:solidFill>
                   <a:srgbClr val="20382A"/>
                 </a:solidFill>
                 <a:latin typeface="Arial" panose="020B0604020202020204" pitchFamily="34" charset="0"/>
               </a:rPr>
-              <a:t>557 / 945 accepted
-433 accepted predictions correct
+              <a:t>Confidence alone
+62.2% coverage / 77.6% accuracy
+With agreement
 58.9% coverage / 77.7% accuracy</a:t>
             </a:r>
-            <a:endParaRPr lang="en-IN" sz="2500" b="1">
+            <a:endParaRPr lang="en-IN" sz="2200" b="1">
               <a:solidFill>
                 <a:srgbClr val="20382A"/>
               </a:solidFill>
@@ -8162,7 +8117,7 @@
           <p:cNvPr id="5" name="TextBox 4">
             <a:extLst>
               <a:ext uri="{FF2B5EF4-FFF2-40B4-BE49-F238E27FC236}">
-                <a16:creationId xmlns:a16="http://schemas.microsoft.com/office/drawing/2014/main" id="{5AA513A6-EDE9-C456-DA68-1C2BE5388936}"/>
+                <a16:creationId xmlns:a16="http://schemas.microsoft.com/office/drawing/2014/main" id="{BD825728-46F2-A4FF-72F3-13F6C427FEBB}"/>
               </a:ext>
             </a:extLst>
           </p:cNvPr>
@@ -8197,8 +8152,8 @@
                 </a:solidFill>
                 <a:latin typeface="Arial" panose="020B0604020202020204" pitchFamily="34" charset="0"/>
               </a:rPr>
-              <a:t>Keep T = 0.802 and threshold = 0.70 unchanged.
-The 90% validation target did not transfer to test.</a:t>
+              <a:t>Agreement rejects more images for negligible accuracy benefit.
+Keep T = 0.802 and threshold = 0.70 unchanged.</a:t>
             </a:r>
             <a:endParaRPr lang="en-IN" sz="2000">
               <a:solidFill>
@@ -8214,7 +8169,7 @@
           <p:cNvPr id="6" name="Table 5">
             <a:extLst>
               <a:ext uri="{FF2B5EF4-FFF2-40B4-BE49-F238E27FC236}">
-                <a16:creationId xmlns:a16="http://schemas.microsoft.com/office/drawing/2014/main" id="{32DCCE35-84CC-4B07-85CD-943E06DCCFDA}"/>
+                <a16:creationId xmlns:a16="http://schemas.microsoft.com/office/drawing/2014/main" id="{DCF0D178-77D6-2751-0385-37E3870F0614}"/>
               </a:ext>
             </a:extLst>
           </p:cNvPr>
@@ -8224,7 +8179,7 @@
           <p:nvPr>
             <p:extLst>
               <p:ext uri="{D42A27DB-BD31-4B8C-83A1-F6EECF244321}">
-                <p14:modId xmlns:p14="http://schemas.microsoft.com/office/powerpoint/2010/main" val="2126110360"/>
+                <p14:modId xmlns:p14="http://schemas.microsoft.com/office/powerpoint/2010/main" val="3851198020"/>
               </p:ext>
             </p:extLst>
           </p:nvPr>
@@ -8243,21 +8198,21 @@
                 <a:gridCol w="2540000">
                   <a:extLst>
                     <a:ext uri="{9D8B030D-6E8A-4147-A177-3AD203B41FA5}">
-                      <a16:colId xmlns:a16="http://schemas.microsoft.com/office/drawing/2014/main" val="2618060527"/>
+                      <a16:colId xmlns:a16="http://schemas.microsoft.com/office/drawing/2014/main" val="4083259485"/>
                     </a:ext>
                   </a:extLst>
                 </a:gridCol>
                 <a:gridCol w="1397000">
                   <a:extLst>
                     <a:ext uri="{9D8B030D-6E8A-4147-A177-3AD203B41FA5}">
-                      <a16:colId xmlns:a16="http://schemas.microsoft.com/office/drawing/2014/main" val="3664664571"/>
+                      <a16:colId xmlns:a16="http://schemas.microsoft.com/office/drawing/2014/main" val="2604777657"/>
                     </a:ext>
                   </a:extLst>
                 </a:gridCol>
                 <a:gridCol w="1397000">
                   <a:extLst>
                     <a:ext uri="{9D8B030D-6E8A-4147-A177-3AD203B41FA5}">
-                      <a16:colId xmlns:a16="http://schemas.microsoft.com/office/drawing/2014/main" val="1885036282"/>
+                      <a16:colId xmlns:a16="http://schemas.microsoft.com/office/drawing/2014/main" val="4278163778"/>
                     </a:ext>
                   </a:extLst>
                 </a:gridCol>
@@ -8391,7 +8346,7 @@
                 </a:tc>
                 <a:extLst>
                   <a:ext uri="{0D108BD9-81ED-4DB2-BD59-A6C34878D82A}">
-                    <a16:rowId xmlns:a16="http://schemas.microsoft.com/office/drawing/2014/main" val="424345035"/>
+                    <a16:rowId xmlns:a16="http://schemas.microsoft.com/office/drawing/2014/main" val="4197451786"/>
                   </a:ext>
                 </a:extLst>
               </a:tr>
@@ -8524,7 +8479,7 @@
                 </a:tc>
                 <a:extLst>
                   <a:ext uri="{0D108BD9-81ED-4DB2-BD59-A6C34878D82A}">
-                    <a16:rowId xmlns:a16="http://schemas.microsoft.com/office/drawing/2014/main" val="2068128936"/>
+                    <a16:rowId xmlns:a16="http://schemas.microsoft.com/office/drawing/2014/main" val="1407413560"/>
                   </a:ext>
                 </a:extLst>
               </a:tr>
@@ -8657,7 +8612,7 @@
                 </a:tc>
                 <a:extLst>
                   <a:ext uri="{0D108BD9-81ED-4DB2-BD59-A6C34878D82A}">
-                    <a16:rowId xmlns:a16="http://schemas.microsoft.com/office/drawing/2014/main" val="3330602198"/>
+                    <a16:rowId xmlns:a16="http://schemas.microsoft.com/office/drawing/2014/main" val="646978135"/>
                   </a:ext>
                 </a:extLst>
               </a:tr>
@@ -8670,7 +8625,7 @@
           <p:cNvPr id="7" name="TextBox 6">
             <a:extLst>
               <a:ext uri="{FF2B5EF4-FFF2-40B4-BE49-F238E27FC236}">
-                <a16:creationId xmlns:a16="http://schemas.microsoft.com/office/drawing/2014/main" id="{ABBAC63F-62D3-9846-5241-EC050CB7BBD4}"/>
+                <a16:creationId xmlns:a16="http://schemas.microsoft.com/office/drawing/2014/main" id="{4047BFC7-22ED-6016-89BE-F28D78369A78}"/>
               </a:ext>
             </a:extLst>
           </p:cNvPr>
@@ -8721,7 +8676,7 @@
           <p:cNvPr id="8" name="TextBox 7">
             <a:extLst>
               <a:ext uri="{FF2B5EF4-FFF2-40B4-BE49-F238E27FC236}">
-                <a16:creationId xmlns:a16="http://schemas.microsoft.com/office/drawing/2014/main" id="{50DB733F-04F1-971B-4551-5887A3C877CB}"/>
+                <a16:creationId xmlns:a16="http://schemas.microsoft.com/office/drawing/2014/main" id="{AFC8FFA2-07E6-3C94-98F3-E25BDB908D1C}"/>
               </a:ext>
             </a:extLst>
           </p:cNvPr>
@@ -8766,7 +8721,7 @@
           <p:cNvPr id="9" name="TextBox 8">
             <a:extLst>
               <a:ext uri="{FF2B5EF4-FFF2-40B4-BE49-F238E27FC236}">
-                <a16:creationId xmlns:a16="http://schemas.microsoft.com/office/drawing/2014/main" id="{A5434A2E-115A-4F04-70FC-E8B062880203}"/>
+                <a16:creationId xmlns:a16="http://schemas.microsoft.com/office/drawing/2014/main" id="{9D024A44-7FCF-F1D8-83D6-B0B6AF135A90}"/>
               </a:ext>
             </a:extLst>
           </p:cNvPr>
@@ -8809,7 +8764,7 @@
     </p:spTree>
     <p:extLst>
       <p:ext uri="{BB962C8B-B14F-4D97-AF65-F5344CB8AC3E}">
-        <p14:creationId xmlns:p14="http://schemas.microsoft.com/office/powerpoint/2010/main" val="406171598"/>
+        <p14:creationId xmlns:p14="http://schemas.microsoft.com/office/powerpoint/2010/main" val="4142419670"/>
       </p:ext>
     </p:extLst>
   </p:cSld>
@@ -8849,7 +8804,7 @@
           <p:cNvPr id="2" name="TextBox 1">
             <a:extLst>
               <a:ext uri="{FF2B5EF4-FFF2-40B4-BE49-F238E27FC236}">
-                <a16:creationId xmlns:a16="http://schemas.microsoft.com/office/drawing/2014/main" id="{BF6AA58D-EA17-104E-58A8-9D0ABA27B120}"/>
+                <a16:creationId xmlns:a16="http://schemas.microsoft.com/office/drawing/2014/main" id="{6F2E402F-788C-177D-DD1A-6E53A9983AB6}"/>
               </a:ext>
             </a:extLst>
           </p:cNvPr>
@@ -8900,7 +8855,7 @@
           <p:cNvPr id="3" name="TextBox 2">
             <a:extLst>
               <a:ext uri="{FF2B5EF4-FFF2-40B4-BE49-F238E27FC236}">
-                <a16:creationId xmlns:a16="http://schemas.microsoft.com/office/drawing/2014/main" id="{5E01607C-61AE-A275-BB33-94CAFC43B88B}"/>
+                <a16:creationId xmlns:a16="http://schemas.microsoft.com/office/drawing/2014/main" id="{3E6C5B41-E91C-40E5-35E9-0D56919086D1}"/>
               </a:ext>
             </a:extLst>
           </p:cNvPr>
@@ -8951,7 +8906,7 @@
           <p:cNvPr id="5" name="Picture 4">
             <a:extLst>
               <a:ext uri="{FF2B5EF4-FFF2-40B4-BE49-F238E27FC236}">
-                <a16:creationId xmlns:a16="http://schemas.microsoft.com/office/drawing/2014/main" id="{7D681922-B4E8-B6F8-9E2A-1FD7A7FA9975}"/>
+                <a16:creationId xmlns:a16="http://schemas.microsoft.com/office/drawing/2014/main" id="{33C2030B-463D-33B4-2EE4-6D74086009B3}"/>
               </a:ext>
             </a:extLst>
           </p:cNvPr>
@@ -8987,7 +8942,7 @@
           <p:cNvPr id="6" name="TextBox 5">
             <a:extLst>
               <a:ext uri="{FF2B5EF4-FFF2-40B4-BE49-F238E27FC236}">
-                <a16:creationId xmlns:a16="http://schemas.microsoft.com/office/drawing/2014/main" id="{2BB9E75B-2C25-81DC-4A2D-D2CC81CEFB40}"/>
+                <a16:creationId xmlns:a16="http://schemas.microsoft.com/office/drawing/2014/main" id="{5E14F40B-108A-C2DB-0183-0014FF688967}"/>
               </a:ext>
             </a:extLst>
           </p:cNvPr>
@@ -9038,7 +8993,7 @@
           <p:cNvPr id="7" name="TextBox 6">
             <a:extLst>
               <a:ext uri="{FF2B5EF4-FFF2-40B4-BE49-F238E27FC236}">
-                <a16:creationId xmlns:a16="http://schemas.microsoft.com/office/drawing/2014/main" id="{3F40CEB0-8C17-4DC9-B9F5-5C395FB0C93D}"/>
+                <a16:creationId xmlns:a16="http://schemas.microsoft.com/office/drawing/2014/main" id="{9A30C9A4-60D8-48AC-3BFE-9A6BF332EBCD}"/>
               </a:ext>
             </a:extLst>
           </p:cNvPr>
@@ -9083,7 +9038,7 @@
           <p:cNvPr id="8" name="TextBox 7">
             <a:extLst>
               <a:ext uri="{FF2B5EF4-FFF2-40B4-BE49-F238E27FC236}">
-                <a16:creationId xmlns:a16="http://schemas.microsoft.com/office/drawing/2014/main" id="{DF5226E7-CD3D-5F43-3E21-FB7A7CC0A3E8}"/>
+                <a16:creationId xmlns:a16="http://schemas.microsoft.com/office/drawing/2014/main" id="{81C2B6A7-4AE8-F1F8-EA12-AC4BA114751D}"/>
               </a:ext>
             </a:extLst>
           </p:cNvPr>
@@ -9126,7 +9081,7 @@
     </p:spTree>
     <p:extLst>
       <p:ext uri="{BB962C8B-B14F-4D97-AF65-F5344CB8AC3E}">
-        <p14:creationId xmlns:p14="http://schemas.microsoft.com/office/powerpoint/2010/main" val="948567507"/>
+        <p14:creationId xmlns:p14="http://schemas.microsoft.com/office/powerpoint/2010/main" val="2921581798"/>
       </p:ext>
     </p:extLst>
   </p:cSld>
@@ -9166,7 +9121,7 @@
           <p:cNvPr id="2" name="TextBox 1">
             <a:extLst>
               <a:ext uri="{FF2B5EF4-FFF2-40B4-BE49-F238E27FC236}">
-                <a16:creationId xmlns:a16="http://schemas.microsoft.com/office/drawing/2014/main" id="{440715CB-EE41-7DB0-735C-E87B416A909C}"/>
+                <a16:creationId xmlns:a16="http://schemas.microsoft.com/office/drawing/2014/main" id="{78FD4821-6AEB-BBB1-BBB7-395E3B0EAC73}"/>
               </a:ext>
             </a:extLst>
           </p:cNvPr>
@@ -9211,7 +9166,7 @@
           <p:cNvPr id="3" name="TextBox 2">
             <a:extLst>
               <a:ext uri="{FF2B5EF4-FFF2-40B4-BE49-F238E27FC236}">
-                <a16:creationId xmlns:a16="http://schemas.microsoft.com/office/drawing/2014/main" id="{6F240D2A-3764-401D-6563-6219997E1A40}"/>
+                <a16:creationId xmlns:a16="http://schemas.microsoft.com/office/drawing/2014/main" id="{F5F242B6-6AC7-7DFF-154F-34B6F5182110}"/>
               </a:ext>
             </a:extLst>
           </p:cNvPr>
@@ -9262,7 +9217,7 @@
           <p:cNvPr id="5" name="Picture 4">
             <a:extLst>
               <a:ext uri="{FF2B5EF4-FFF2-40B4-BE49-F238E27FC236}">
-                <a16:creationId xmlns:a16="http://schemas.microsoft.com/office/drawing/2014/main" id="{BC8366F7-1E29-F924-6C3C-7DBFEC30DC0F}"/>
+                <a16:creationId xmlns:a16="http://schemas.microsoft.com/office/drawing/2014/main" id="{2C451886-180E-E11B-D55E-84FDF83086B0}"/>
               </a:ext>
             </a:extLst>
           </p:cNvPr>
@@ -9285,8 +9240,8 @@
         </p:blipFill>
         <p:spPr>
           <a:xfrm>
-            <a:off x="1725706" y="1714500"/>
-            <a:ext cx="8740588" cy="4127500"/>
+            <a:off x="1509889" y="1714500"/>
+            <a:ext cx="9172222" cy="4127500"/>
           </a:xfrm>
           <a:prstGeom prst="rect">
             <a:avLst/>
@@ -9298,7 +9253,7 @@
           <p:cNvPr id="6" name="TextBox 5">
             <a:extLst>
               <a:ext uri="{FF2B5EF4-FFF2-40B4-BE49-F238E27FC236}">
-                <a16:creationId xmlns:a16="http://schemas.microsoft.com/office/drawing/2014/main" id="{8B8A8916-768B-5B5C-85F7-C45D34E3AAEF}"/>
+                <a16:creationId xmlns:a16="http://schemas.microsoft.com/office/drawing/2014/main" id="{1F826171-4730-F2D7-F782-42A41A222B61}"/>
               </a:ext>
             </a:extLst>
           </p:cNvPr>
@@ -9343,7 +9298,7 @@
           <p:cNvPr id="7" name="TextBox 6">
             <a:extLst>
               <a:ext uri="{FF2B5EF4-FFF2-40B4-BE49-F238E27FC236}">
-                <a16:creationId xmlns:a16="http://schemas.microsoft.com/office/drawing/2014/main" id="{585C88E0-B5D5-AB15-8439-32FAC593B5B3}"/>
+                <a16:creationId xmlns:a16="http://schemas.microsoft.com/office/drawing/2014/main" id="{30D698A3-3B30-B677-3C74-B3FE874BA7A8}"/>
               </a:ext>
             </a:extLst>
           </p:cNvPr>
@@ -9386,7 +9341,7 @@
     </p:spTree>
     <p:extLst>
       <p:ext uri="{BB962C8B-B14F-4D97-AF65-F5344CB8AC3E}">
-        <p14:creationId xmlns:p14="http://schemas.microsoft.com/office/powerpoint/2010/main" val="2330640665"/>
+        <p14:creationId xmlns:p14="http://schemas.microsoft.com/office/powerpoint/2010/main" val="2301701190"/>
       </p:ext>
     </p:extLst>
   </p:cSld>
@@ -9426,7 +9381,7 @@
           <p:cNvPr id="2" name="TextBox 1">
             <a:extLst>
               <a:ext uri="{FF2B5EF4-FFF2-40B4-BE49-F238E27FC236}">
-                <a16:creationId xmlns:a16="http://schemas.microsoft.com/office/drawing/2014/main" id="{0C6729B1-FDD6-9E03-AF34-D9A4D1D75D81}"/>
+                <a16:creationId xmlns:a16="http://schemas.microsoft.com/office/drawing/2014/main" id="{1B6C508C-1A08-18AA-4F2E-E145E495D6CE}"/>
               </a:ext>
             </a:extLst>
           </p:cNvPr>
@@ -9471,7 +9426,7 @@
           <p:cNvPr id="3" name="TextBox 2">
             <a:extLst>
               <a:ext uri="{FF2B5EF4-FFF2-40B4-BE49-F238E27FC236}">
-                <a16:creationId xmlns:a16="http://schemas.microsoft.com/office/drawing/2014/main" id="{66DED1D0-82AD-D174-9225-FA252A9662DF}"/>
+                <a16:creationId xmlns:a16="http://schemas.microsoft.com/office/drawing/2014/main" id="{32A29767-2F1D-4776-1449-12F6012203D7}"/>
               </a:ext>
             </a:extLst>
           </p:cNvPr>
@@ -9522,7 +9477,7 @@
           <p:cNvPr id="4" name="TextBox 3">
             <a:extLst>
               <a:ext uri="{FF2B5EF4-FFF2-40B4-BE49-F238E27FC236}">
-                <a16:creationId xmlns:a16="http://schemas.microsoft.com/office/drawing/2014/main" id="{AC5A8350-DFD2-14DD-3125-5C012865D225}"/>
+                <a16:creationId xmlns:a16="http://schemas.microsoft.com/office/drawing/2014/main" id="{E4D2DDD1-E796-0A4D-F852-FD8481D66D85}"/>
               </a:ext>
             </a:extLst>
           </p:cNvPr>
@@ -9567,7 +9522,7 @@
           <p:cNvPr id="5" name="TextBox 4">
             <a:extLst>
               <a:ext uri="{FF2B5EF4-FFF2-40B4-BE49-F238E27FC236}">
-                <a16:creationId xmlns:a16="http://schemas.microsoft.com/office/drawing/2014/main" id="{1362987D-A8F0-8EFA-E709-EDFE1CF6AE71}"/>
+                <a16:creationId xmlns:a16="http://schemas.microsoft.com/office/drawing/2014/main" id="{EF4CB36F-39BC-5AB2-2C78-793A5DF728DC}"/>
               </a:ext>
             </a:extLst>
           </p:cNvPr>
@@ -9618,7 +9573,7 @@
           <p:cNvPr id="6" name="TextBox 5">
             <a:extLst>
               <a:ext uri="{FF2B5EF4-FFF2-40B4-BE49-F238E27FC236}">
-                <a16:creationId xmlns:a16="http://schemas.microsoft.com/office/drawing/2014/main" id="{38CF0815-B095-C94F-364F-60432AC45E10}"/>
+                <a16:creationId xmlns:a16="http://schemas.microsoft.com/office/drawing/2014/main" id="{6C65F6A9-F98A-33FE-CEA3-A81BED7C4E3A}"/>
               </a:ext>
             </a:extLst>
           </p:cNvPr>
@@ -9653,7 +9608,7 @@
                 </a:solidFill>
                 <a:latin typeface="Arial" panose="020B0604020202020204" pitchFamily="34" charset="0"/>
               </a:rPr>
-              <a:t>Limited extension</a:t>
+              <a:t>Implemented extension and evidence</a:t>
             </a:r>
           </a:p>
         </p:txBody>
@@ -9663,7 +9618,7 @@
           <p:cNvPr id="7" name="TextBox 6">
             <a:extLst>
               <a:ext uri="{FF2B5EF4-FFF2-40B4-BE49-F238E27FC236}">
-                <a16:creationId xmlns:a16="http://schemas.microsoft.com/office/drawing/2014/main" id="{99A02557-20C4-6350-F2D8-3DEC1AD5683F}"/>
+                <a16:creationId xmlns:a16="http://schemas.microsoft.com/office/drawing/2014/main" id="{F364155C-3E1D-AECE-4449-64D33C278D5B}"/>
               </a:ext>
             </a:extLst>
           </p:cNvPr>
@@ -9698,8 +9653,8 @@
                 </a:solidFill>
                 <a:latin typeface="Arial" panose="020B0604020202020204" pitchFamily="34" charset="0"/>
               </a:rPr>
-              <a:t>Contrast gains three test images; uncertainty spans no gain.
-The audit corrects optimism, and calibration fails to transfer.</a:t>
+              <a:t>Explicit spatial-view difference, tested against concatenation.
+17 decisions gained and 14 lost, with no reliable advantage.</a:t>
             </a:r>
             <a:endParaRPr lang="en-IN" sz="2100">
               <a:solidFill>
@@ -9715,7 +9670,7 @@
           <p:cNvPr id="8" name="TextBox 7">
             <a:extLst>
               <a:ext uri="{FF2B5EF4-FFF2-40B4-BE49-F238E27FC236}">
-                <a16:creationId xmlns:a16="http://schemas.microsoft.com/office/drawing/2014/main" id="{5C6EF8CE-F22C-E912-0980-4EE5D6541514}"/>
+                <a16:creationId xmlns:a16="http://schemas.microsoft.com/office/drawing/2014/main" id="{4E96263D-58D9-9B7F-DFDF-08243ABE0364}"/>
               </a:ext>
             </a:extLst>
           </p:cNvPr>
@@ -9766,7 +9721,7 @@
           <p:cNvPr id="9" name="TextBox 8">
             <a:extLst>
               <a:ext uri="{FF2B5EF4-FFF2-40B4-BE49-F238E27FC236}">
-                <a16:creationId xmlns:a16="http://schemas.microsoft.com/office/drawing/2014/main" id="{AB936CC4-B587-13E0-6F4A-6143FB24B28B}"/>
+                <a16:creationId xmlns:a16="http://schemas.microsoft.com/office/drawing/2014/main" id="{B5568FF6-CD7B-CBED-F139-1E9B305F8384}"/>
               </a:ext>
             </a:extLst>
           </p:cNvPr>
@@ -9811,7 +9766,7 @@
           <p:cNvPr id="10" name="TextBox 9">
             <a:extLst>
               <a:ext uri="{FF2B5EF4-FFF2-40B4-BE49-F238E27FC236}">
-                <a16:creationId xmlns:a16="http://schemas.microsoft.com/office/drawing/2014/main" id="{503803BB-2FEE-D228-A233-E61BCC693051}"/>
+                <a16:creationId xmlns:a16="http://schemas.microsoft.com/office/drawing/2014/main" id="{1616F366-AC7F-DF17-2817-16BEAE057A35}"/>
               </a:ext>
             </a:extLst>
           </p:cNvPr>
@@ -9854,7 +9809,7 @@
     </p:spTree>
     <p:extLst>
       <p:ext uri="{BB962C8B-B14F-4D97-AF65-F5344CB8AC3E}">
-        <p14:creationId xmlns:p14="http://schemas.microsoft.com/office/powerpoint/2010/main" val="1592263174"/>
+        <p14:creationId xmlns:p14="http://schemas.microsoft.com/office/powerpoint/2010/main" val="2627644674"/>
       </p:ext>
     </p:extLst>
   </p:cSld>
@@ -9894,7 +9849,7 @@
           <p:cNvPr id="2" name="TextBox 1">
             <a:extLst>
               <a:ext uri="{FF2B5EF4-FFF2-40B4-BE49-F238E27FC236}">
-                <a16:creationId xmlns:a16="http://schemas.microsoft.com/office/drawing/2014/main" id="{AEA9343A-7CF0-AC41-F29D-36BF01DEA0D4}"/>
+                <a16:creationId xmlns:a16="http://schemas.microsoft.com/office/drawing/2014/main" id="{8B689E3D-9D27-3993-6C68-EA2768A436E8}"/>
               </a:ext>
             </a:extLst>
           </p:cNvPr>
@@ -9945,7 +9900,7 @@
           <p:cNvPr id="3" name="TextBox 2">
             <a:extLst>
               <a:ext uri="{FF2B5EF4-FFF2-40B4-BE49-F238E27FC236}">
-                <a16:creationId xmlns:a16="http://schemas.microsoft.com/office/drawing/2014/main" id="{41632086-A7B4-A1E2-D911-49264A8C574C}"/>
+                <a16:creationId xmlns:a16="http://schemas.microsoft.com/office/drawing/2014/main" id="{4EB4B66E-6C03-F341-CA4F-3DC0E0209087}"/>
               </a:ext>
             </a:extLst>
           </p:cNvPr>
@@ -9996,7 +9951,7 @@
           <p:cNvPr id="4" name="TextBox 3">
             <a:extLst>
               <a:ext uri="{FF2B5EF4-FFF2-40B4-BE49-F238E27FC236}">
-                <a16:creationId xmlns:a16="http://schemas.microsoft.com/office/drawing/2014/main" id="{57AC2217-C4F6-84DA-DAE9-D037651F1426}"/>
+                <a16:creationId xmlns:a16="http://schemas.microsoft.com/office/drawing/2014/main" id="{55436288-FDD5-BD95-559F-7E6B3607FCAF}"/>
               </a:ext>
             </a:extLst>
           </p:cNvPr>
@@ -10048,7 +10003,7 @@
           <p:cNvPr id="5" name="Table 4">
             <a:extLst>
               <a:ext uri="{FF2B5EF4-FFF2-40B4-BE49-F238E27FC236}">
-                <a16:creationId xmlns:a16="http://schemas.microsoft.com/office/drawing/2014/main" id="{65D46354-1995-CCDA-15B1-1B7D064A9FF9}"/>
+                <a16:creationId xmlns:a16="http://schemas.microsoft.com/office/drawing/2014/main" id="{FCC879BD-36CA-BF78-C412-FFD45A4BE4E8}"/>
               </a:ext>
             </a:extLst>
           </p:cNvPr>
@@ -10058,7 +10013,7 @@
           <p:nvPr>
             <p:extLst>
               <p:ext uri="{D42A27DB-BD31-4B8C-83A1-F6EECF244321}">
-                <p14:modId xmlns:p14="http://schemas.microsoft.com/office/powerpoint/2010/main" val="4205615836"/>
+                <p14:modId xmlns:p14="http://schemas.microsoft.com/office/powerpoint/2010/main" val="3387001524"/>
               </p:ext>
             </p:extLst>
           </p:nvPr>
@@ -10077,21 +10032,21 @@
                 <a:gridCol w="5715000">
                   <a:extLst>
                     <a:ext uri="{9D8B030D-6E8A-4147-A177-3AD203B41FA5}">
-                      <a16:colId xmlns:a16="http://schemas.microsoft.com/office/drawing/2014/main" val="26578484"/>
+                      <a16:colId xmlns:a16="http://schemas.microsoft.com/office/drawing/2014/main" val="948693385"/>
                     </a:ext>
                   </a:extLst>
                 </a:gridCol>
                 <a:gridCol w="2603500">
                   <a:extLst>
                     <a:ext uri="{9D8B030D-6E8A-4147-A177-3AD203B41FA5}">
-                      <a16:colId xmlns:a16="http://schemas.microsoft.com/office/drawing/2014/main" val="3763827127"/>
+                      <a16:colId xmlns:a16="http://schemas.microsoft.com/office/drawing/2014/main" val="3169428359"/>
                     </a:ext>
                   </a:extLst>
                 </a:gridCol>
                 <a:gridCol w="2603500">
                   <a:extLst>
                     <a:ext uri="{9D8B030D-6E8A-4147-A177-3AD203B41FA5}">
-                      <a16:colId xmlns:a16="http://schemas.microsoft.com/office/drawing/2014/main" val="2920069439"/>
+                      <a16:colId xmlns:a16="http://schemas.microsoft.com/office/drawing/2014/main" val="4931970"/>
                     </a:ext>
                   </a:extLst>
                 </a:gridCol>
@@ -10225,7 +10180,7 @@
                 </a:tc>
                 <a:extLst>
                   <a:ext uri="{0D108BD9-81ED-4DB2-BD59-A6C34878D82A}">
-                    <a16:rowId xmlns:a16="http://schemas.microsoft.com/office/drawing/2014/main" val="3951955043"/>
+                    <a16:rowId xmlns:a16="http://schemas.microsoft.com/office/drawing/2014/main" val="3584294335"/>
                   </a:ext>
                 </a:extLst>
               </a:tr>
@@ -10358,7 +10313,7 @@
                 </a:tc>
                 <a:extLst>
                   <a:ext uri="{0D108BD9-81ED-4DB2-BD59-A6C34878D82A}">
-                    <a16:rowId xmlns:a16="http://schemas.microsoft.com/office/drawing/2014/main" val="1388292505"/>
+                    <a16:rowId xmlns:a16="http://schemas.microsoft.com/office/drawing/2014/main" val="1349346348"/>
                   </a:ext>
                 </a:extLst>
               </a:tr>
@@ -10491,7 +10446,7 @@
                 </a:tc>
                 <a:extLst>
                   <a:ext uri="{0D108BD9-81ED-4DB2-BD59-A6C34878D82A}">
-                    <a16:rowId xmlns:a16="http://schemas.microsoft.com/office/drawing/2014/main" val="144200239"/>
+                    <a16:rowId xmlns:a16="http://schemas.microsoft.com/office/drawing/2014/main" val="2364236726"/>
                   </a:ext>
                 </a:extLst>
               </a:tr>
@@ -10624,7 +10579,7 @@
                 </a:tc>
                 <a:extLst>
                   <a:ext uri="{0D108BD9-81ED-4DB2-BD59-A6C34878D82A}">
-                    <a16:rowId xmlns:a16="http://schemas.microsoft.com/office/drawing/2014/main" val="1417143027"/>
+                    <a16:rowId xmlns:a16="http://schemas.microsoft.com/office/drawing/2014/main" val="2329282436"/>
                   </a:ext>
                 </a:extLst>
               </a:tr>
@@ -10637,7 +10592,7 @@
           <p:cNvPr id="6" name="TextBox 5">
             <a:extLst>
               <a:ext uri="{FF2B5EF4-FFF2-40B4-BE49-F238E27FC236}">
-                <a16:creationId xmlns:a16="http://schemas.microsoft.com/office/drawing/2014/main" id="{50BA3724-9896-73E5-C10D-5765552C0A01}"/>
+                <a16:creationId xmlns:a16="http://schemas.microsoft.com/office/drawing/2014/main" id="{9C3F29F0-5C82-1EF9-51F3-737936AF38EE}"/>
               </a:ext>
             </a:extLst>
           </p:cNvPr>
@@ -10682,7 +10637,7 @@
           <p:cNvPr id="7" name="TextBox 6">
             <a:extLst>
               <a:ext uri="{FF2B5EF4-FFF2-40B4-BE49-F238E27FC236}">
-                <a16:creationId xmlns:a16="http://schemas.microsoft.com/office/drawing/2014/main" id="{C6AF0D13-A488-EDE5-9392-E6CDFD1FF1B6}"/>
+                <a16:creationId xmlns:a16="http://schemas.microsoft.com/office/drawing/2014/main" id="{5B9B2B93-F585-3BCD-7DC6-A2B4C5BAE9B2}"/>
               </a:ext>
             </a:extLst>
           </p:cNvPr>
@@ -10725,7 +10680,7 @@
     </p:spTree>
     <p:extLst>
       <p:ext uri="{BB962C8B-B14F-4D97-AF65-F5344CB8AC3E}">
-        <p14:creationId xmlns:p14="http://schemas.microsoft.com/office/powerpoint/2010/main" val="2661882747"/>
+        <p14:creationId xmlns:p14="http://schemas.microsoft.com/office/powerpoint/2010/main" val="2884471481"/>
       </p:ext>
     </p:extLst>
   </p:cSld>
@@ -10765,7 +10720,7 @@
           <p:cNvPr id="2" name="TextBox 1">
             <a:extLst>
               <a:ext uri="{FF2B5EF4-FFF2-40B4-BE49-F238E27FC236}">
-                <a16:creationId xmlns:a16="http://schemas.microsoft.com/office/drawing/2014/main" id="{505F1C7C-4AB9-3114-D28D-856FEBD4F3A5}"/>
+                <a16:creationId xmlns:a16="http://schemas.microsoft.com/office/drawing/2014/main" id="{081C9969-90C9-A0E8-CE99-A3192A99888D}"/>
               </a:ext>
             </a:extLst>
           </p:cNvPr>
@@ -10810,7 +10765,7 @@
           <p:cNvPr id="3" name="TextBox 2">
             <a:extLst>
               <a:ext uri="{FF2B5EF4-FFF2-40B4-BE49-F238E27FC236}">
-                <a16:creationId xmlns:a16="http://schemas.microsoft.com/office/drawing/2014/main" id="{E2D352CD-AE6B-1798-5F11-515EDB4C3BA7}"/>
+                <a16:creationId xmlns:a16="http://schemas.microsoft.com/office/drawing/2014/main" id="{67D0545A-F5C5-0460-AAB1-F9D54E500394}"/>
               </a:ext>
             </a:extLst>
           </p:cNvPr>
@@ -10861,7 +10816,7 @@
           <p:cNvPr id="4" name="TextBox 3">
             <a:extLst>
               <a:ext uri="{FF2B5EF4-FFF2-40B4-BE49-F238E27FC236}">
-                <a16:creationId xmlns:a16="http://schemas.microsoft.com/office/drawing/2014/main" id="{C26ED979-4924-4B1F-619C-2B38CD35A834}"/>
+                <a16:creationId xmlns:a16="http://schemas.microsoft.com/office/drawing/2014/main" id="{C78D9CFE-5FF4-A058-AE8D-698058481DD6}"/>
               </a:ext>
             </a:extLst>
           </p:cNvPr>
@@ -10915,7 +10870,7 @@
           <p:cNvPr id="5" name="TextBox 4">
             <a:extLst>
               <a:ext uri="{FF2B5EF4-FFF2-40B4-BE49-F238E27FC236}">
-                <a16:creationId xmlns:a16="http://schemas.microsoft.com/office/drawing/2014/main" id="{77715268-EA15-3A98-54F3-A79709C6273B}"/>
+                <a16:creationId xmlns:a16="http://schemas.microsoft.com/office/drawing/2014/main" id="{A6188B30-24C6-7DF4-67A7-8E2B0D17881D}"/>
               </a:ext>
             </a:extLst>
           </p:cNvPr>
@@ -10968,7 +10923,7 @@
           <p:cNvPr id="7" name="Picture 6">
             <a:extLst>
               <a:ext uri="{FF2B5EF4-FFF2-40B4-BE49-F238E27FC236}">
-                <a16:creationId xmlns:a16="http://schemas.microsoft.com/office/drawing/2014/main" id="{4EC2A13A-290C-5016-CA39-A3823D531F90}"/>
+                <a16:creationId xmlns:a16="http://schemas.microsoft.com/office/drawing/2014/main" id="{740969B3-2C15-BC58-54B9-F93EAF889637}"/>
               </a:ext>
             </a:extLst>
           </p:cNvPr>
@@ -11004,7 +10959,7 @@
           <p:cNvPr id="8" name="TextBox 7">
             <a:extLst>
               <a:ext uri="{FF2B5EF4-FFF2-40B4-BE49-F238E27FC236}">
-                <a16:creationId xmlns:a16="http://schemas.microsoft.com/office/drawing/2014/main" id="{24AC2124-CEE0-1B55-0D41-9BF77C6196A4}"/>
+                <a16:creationId xmlns:a16="http://schemas.microsoft.com/office/drawing/2014/main" id="{B8BEDB02-B1B0-F341-FCC9-118632C1A12B}"/>
               </a:ext>
             </a:extLst>
           </p:cNvPr>
@@ -11049,7 +11004,7 @@
           <p:cNvPr id="9" name="TextBox 8">
             <a:extLst>
               <a:ext uri="{FF2B5EF4-FFF2-40B4-BE49-F238E27FC236}">
-                <a16:creationId xmlns:a16="http://schemas.microsoft.com/office/drawing/2014/main" id="{4FD35733-DB57-3D74-3891-7EE9F09BDE74}"/>
+                <a16:creationId xmlns:a16="http://schemas.microsoft.com/office/drawing/2014/main" id="{C7C5ABA1-02E3-F223-603B-71E3B89AA021}"/>
               </a:ext>
             </a:extLst>
           </p:cNvPr>
@@ -11092,7 +11047,7 @@
     </p:spTree>
     <p:extLst>
       <p:ext uri="{BB962C8B-B14F-4D97-AF65-F5344CB8AC3E}">
-        <p14:creationId xmlns:p14="http://schemas.microsoft.com/office/powerpoint/2010/main" val="427640799"/>
+        <p14:creationId xmlns:p14="http://schemas.microsoft.com/office/powerpoint/2010/main" val="3995080891"/>
       </p:ext>
     </p:extLst>
   </p:cSld>
@@ -11132,7 +11087,7 @@
           <p:cNvPr id="2" name="TextBox 1">
             <a:extLst>
               <a:ext uri="{FF2B5EF4-FFF2-40B4-BE49-F238E27FC236}">
-                <a16:creationId xmlns:a16="http://schemas.microsoft.com/office/drawing/2014/main" id="{C84CC918-79D8-B0D0-2B76-9017D9545E1F}"/>
+                <a16:creationId xmlns:a16="http://schemas.microsoft.com/office/drawing/2014/main" id="{7093CBB9-74B9-1BAB-530C-C775061E361B}"/>
               </a:ext>
             </a:extLst>
           </p:cNvPr>
@@ -11161,20 +11116,14 @@
               </a:spcAft>
             </a:pPr>
             <a:r>
-              <a:rPr lang="en-US" sz="3200" b="1">
+              <a:rPr lang="en-IN" sz="3200" b="1">
                 <a:solidFill>
                   <a:srgbClr val="20382A"/>
                 </a:solidFill>
                 <a:latin typeface="Arial" panose="020B0604020202020204" pitchFamily="34" charset="0"/>
               </a:rPr>
-              <a:t>Course foundation and prior work</a:t>
+              <a:t>Previous cricket-recognition methods</a:t>
             </a:r>
-            <a:endParaRPr lang="en-IN" sz="3200" b="1">
-              <a:solidFill>
-                <a:srgbClr val="20382A"/>
-              </a:solidFill>
-              <a:latin typeface="Arial" panose="020B0604020202020204" pitchFamily="34" charset="0"/>
-            </a:endParaRPr>
           </a:p>
         </p:txBody>
       </p:sp>
@@ -11183,7 +11132,7 @@
           <p:cNvPr id="3" name="TextBox 2">
             <a:extLst>
               <a:ext uri="{FF2B5EF4-FFF2-40B4-BE49-F238E27FC236}">
-                <a16:creationId xmlns:a16="http://schemas.microsoft.com/office/drawing/2014/main" id="{83CABDAE-18C3-567D-B26A-443A0D45BB58}"/>
+                <a16:creationId xmlns:a16="http://schemas.microsoft.com/office/drawing/2014/main" id="{73F8022A-EF72-265E-7CEF-65122C11DFD7}"/>
               </a:ext>
             </a:extLst>
           </p:cNvPr>
@@ -11218,7 +11167,7 @@
                 </a:solidFill>
                 <a:latin typeface="Arial" panose="020B0604020202020204" pitchFamily="34" charset="0"/>
               </a:rPr>
-              <a:t>Use established feature extraction, then test one modest extension</a:t>
+              <a:t>Video sequence studies provide context for our narrower image task</a:t>
             </a:r>
             <a:endParaRPr lang="en-IN" sz="1500">
               <a:solidFill>
@@ -11229,12 +11178,57 @@
           </a:p>
         </p:txBody>
       </p:sp>
+      <p:sp>
+        <p:nvSpPr>
+          <p:cNvPr id="4" name="TextBox 3">
+            <a:extLst>
+              <a:ext uri="{FF2B5EF4-FFF2-40B4-BE49-F238E27FC236}">
+                <a16:creationId xmlns:a16="http://schemas.microsoft.com/office/drawing/2014/main" id="{FFB22E3B-DF31-7E04-0946-8D32DE33BAB8}"/>
+              </a:ext>
+            </a:extLst>
+          </p:cNvPr>
+          <p:cNvSpPr txBox="1"/>
+          <p:nvPr/>
+        </p:nvSpPr>
+        <p:spPr>
+          <a:xfrm>
+            <a:off x="635000" y="5168899"/>
+            <a:ext cx="10795000" cy="406400"/>
+          </a:xfrm>
+          <a:prstGeom prst="rect">
+            <a:avLst/>
+          </a:prstGeom>
+          <a:noFill/>
+        </p:spPr>
+        <p:txBody>
+          <a:bodyPr vert="horz" wrap="square" lIns="0" tIns="0" rIns="0" bIns="0" rtlCol="0">
+            <a:noAutofit/>
+          </a:bodyPr>
+          <a:lstStyle/>
+          <a:p>
+            <a:pPr>
+              <a:spcAft>
+                <a:spcPts val="800"/>
+              </a:spcAft>
+            </a:pPr>
+            <a:r>
+              <a:rPr lang="en-IN">
+                <a:solidFill>
+                  <a:srgbClr val="20382A"/>
+                </a:solidFill>
+                <a:latin typeface="Arial" panose="020B0604020202020204" pitchFamily="34" charset="0"/>
+              </a:rPr>
+              <a:t>Course links: HOG (Lecture 10) and frozen features / classification (Lecture 15).</a:t>
+            </a:r>
+          </a:p>
+        </p:txBody>
+      </p:sp>
       <p:graphicFrame>
         <p:nvGraphicFramePr>
-          <p:cNvPr id="4" name="Table 3">
+          <p:cNvPr id="5" name="Table 4">
             <a:extLst>
               <a:ext uri="{FF2B5EF4-FFF2-40B4-BE49-F238E27FC236}">
-                <a16:creationId xmlns:a16="http://schemas.microsoft.com/office/drawing/2014/main" id="{7CA4DD9A-65FF-440D-2799-FD50DB8C0F93}"/>
+                <a16:creationId xmlns:a16="http://schemas.microsoft.com/office/drawing/2014/main" id="{2B09F4F2-37E5-3E05-49A7-756880028B1F}"/>
               </a:ext>
             </a:extLst>
           </p:cNvPr>
@@ -11244,14 +11238,14 @@
           <p:nvPr>
             <p:extLst>
               <p:ext uri="{D42A27DB-BD31-4B8C-83A1-F6EECF244321}">
-                <p14:modId xmlns:p14="http://schemas.microsoft.com/office/powerpoint/2010/main" val="2667902517"/>
+                <p14:modId xmlns:p14="http://schemas.microsoft.com/office/powerpoint/2010/main" val="1430504644"/>
               </p:ext>
             </p:extLst>
           </p:nvPr>
         </p:nvGraphicFramePr>
         <p:xfrm>
           <a:off x="635000" y="1905000"/>
-          <a:ext cx="10922000" cy="3238500"/>
+          <a:ext cx="10922000" cy="2984500"/>
         </p:xfrm>
         <a:graphic>
           <a:graphicData uri="http://schemas.openxmlformats.org/drawingml/2006/table">
@@ -11260,42 +11254,42 @@
                 <a:tableStyleId>{5C22544A-7EE6-4342-B048-85BDC9FD1C3A}</a:tableStyleId>
               </a:tblPr>
               <a:tblGrid>
-                <a:gridCol w="2921000">
+                <a:gridCol w="2603500">
                   <a:extLst>
                     <a:ext uri="{9D8B030D-6E8A-4147-A177-3AD203B41FA5}">
-                      <a16:colId xmlns:a16="http://schemas.microsoft.com/office/drawing/2014/main" val="3134815456"/>
+                      <a16:colId xmlns:a16="http://schemas.microsoft.com/office/drawing/2014/main" val="3950320502"/>
                     </a:ext>
                   </a:extLst>
                 </a:gridCol>
                 <a:gridCol w="4191000">
                   <a:extLst>
                     <a:ext uri="{9D8B030D-6E8A-4147-A177-3AD203B41FA5}">
-                      <a16:colId xmlns:a16="http://schemas.microsoft.com/office/drawing/2014/main" val="1174950828"/>
+                      <a16:colId xmlns:a16="http://schemas.microsoft.com/office/drawing/2014/main" val="868020415"/>
                     </a:ext>
                   </a:extLst>
                 </a:gridCol>
-                <a:gridCol w="3810000">
+                <a:gridCol w="4127500">
                   <a:extLst>
                     <a:ext uri="{9D8B030D-6E8A-4147-A177-3AD203B41FA5}">
-                      <a16:colId xmlns:a16="http://schemas.microsoft.com/office/drawing/2014/main" val="2241902195"/>
+                      <a16:colId xmlns:a16="http://schemas.microsoft.com/office/drawing/2014/main" val="1316956723"/>
                     </a:ext>
                   </a:extLst>
                 </a:gridCol>
               </a:tblGrid>
-              <a:tr h="647700">
+              <a:tr h="994833">
                 <a:tc>
                   <a:txBody>
                     <a:bodyPr/>
                     <a:lstStyle/>
                     <a:p>
                       <a:r>
-                        <a:rPr lang="en-IN" sz="1600" b="1">
+                        <a:rPr lang="en-IN" sz="1700" b="1">
                           <a:solidFill>
                             <a:srgbClr val="FFFFFF"/>
                           </a:solidFill>
                           <a:latin typeface="Arial" panose="020B0604020202020204" pitchFamily="34" charset="0"/>
                         </a:rPr>
-                        <a:t>Foundation</a:t>
+                        <a:t>Study</a:t>
                       </a:r>
                     </a:p>
                   </a:txBody>
@@ -11331,13 +11325,13 @@
                     <a:lstStyle/>
                     <a:p>
                       <a:r>
-                        <a:rPr lang="en-IN" sz="1600" b="1">
+                        <a:rPr lang="en-IN" sz="1700" b="1">
                           <a:solidFill>
                             <a:srgbClr val="FFFFFF"/>
                           </a:solidFill>
                           <a:latin typeface="Arial" panose="020B0604020202020204" pitchFamily="34" charset="0"/>
                         </a:rPr>
-                        <a:t>Source</a:t>
+                        <a:t>Input and main method</a:t>
                       </a:r>
                     </a:p>
                   </a:txBody>
@@ -11373,13 +11367,13 @@
                     <a:lstStyle/>
                     <a:p>
                       <a:r>
-                        <a:rPr lang="en-IN" sz="1600" b="1">
+                        <a:rPr lang="en-IN" sz="1700" b="1">
                           <a:solidFill>
                             <a:srgbClr val="FFFFFF"/>
                           </a:solidFill>
                           <a:latin typeface="Arial" panose="020B0604020202020204" pitchFamily="34" charset="0"/>
                         </a:rPr>
-                        <a:t>Our use</a:t>
+                        <a:t>Difference in this project</a:t>
                       </a:r>
                     </a:p>
                   </a:txBody>
@@ -11411,24 +11405,24 @@
                 </a:tc>
                 <a:extLst>
                   <a:ext uri="{0D108BD9-81ED-4DB2-BD59-A6C34878D82A}">
-                    <a16:rowId xmlns:a16="http://schemas.microsoft.com/office/drawing/2014/main" val="118433485"/>
+                    <a16:rowId xmlns:a16="http://schemas.microsoft.com/office/drawing/2014/main" val="196126918"/>
                   </a:ext>
                 </a:extLst>
               </a:tr>
-              <a:tr h="647700">
+              <a:tr h="994833">
                 <a:tc>
                   <a:txBody>
                     <a:bodyPr/>
                     <a:lstStyle/>
                     <a:p>
                       <a:r>
-                        <a:rPr lang="en-IN" sz="1600" b="0">
+                        <a:rPr lang="en-IN" sz="1700" b="0">
                           <a:solidFill>
                             <a:srgbClr val="20382A"/>
                           </a:solidFill>
                           <a:latin typeface="Arial" panose="020B0604020202020204" pitchFamily="34" charset="0"/>
                         </a:rPr>
-                        <a:t>Gradient histograms</a:t>
+                        <a:t>Sen et al. (2021)</a:t>
                       </a:r>
                     </a:p>
                   </a:txBody>
@@ -11464,14 +11458,21 @@
                     <a:lstStyle/>
                     <a:p>
                       <a:r>
-                        <a:rPr lang="en-IN" sz="1600" b="0">
+                        <a:rPr lang="en-US" sz="1700" b="0">
                           <a:solidFill>
                             <a:srgbClr val="20382A"/>
                           </a:solidFill>
                           <a:latin typeface="Arial" panose="020B0604020202020204" pitchFamily="34" charset="0"/>
                         </a:rPr>
-                        <a:t>Lecture 10; Dalal / Triggs (2005)</a:t>
+                        <a:t>Ten-class video
+CNN / VGG16 features + GRU</a:t>
                       </a:r>
+                      <a:endParaRPr lang="en-IN" sz="1700" b="0">
+                        <a:solidFill>
+                          <a:srgbClr val="20382A"/>
+                        </a:solidFill>
+                        <a:latin typeface="Arial" panose="020B0604020202020204" pitchFamily="34" charset="0"/>
+                      </a:endParaRPr>
                     </a:p>
                   </a:txBody>
                   <a:tcPr marL="114300" marR="76200" marT="63500" marB="50800" anchor="ctr">
@@ -11506,14 +11507,21 @@
                     <a:lstStyle/>
                     <a:p>
                       <a:r>
-                        <a:rPr lang="en-IN" sz="1600" b="0">
+                        <a:rPr lang="en-US" sz="1700" b="0">
                           <a:solidFill>
                             <a:srgbClr val="20382A"/>
                           </a:solidFill>
                           <a:latin typeface="Arial" panose="020B0604020202020204" pitchFamily="34" charset="0"/>
                         </a:rPr>
-                        <a:t>Explicit HOG baseline</a:t>
+                        <a:t>One image, four labels
+Frozen MobileNetV2 + linear heads</a:t>
                       </a:r>
+                      <a:endParaRPr lang="en-IN" sz="1700" b="0">
+                        <a:solidFill>
+                          <a:srgbClr val="20382A"/>
+                        </a:solidFill>
+                        <a:latin typeface="Arial" panose="020B0604020202020204" pitchFamily="34" charset="0"/>
+                      </a:endParaRPr>
                     </a:p>
                   </a:txBody>
                   <a:tcPr marL="114300" marR="76200" marT="63500" marB="50800" anchor="ctr">
@@ -11544,24 +11552,24 @@
                 </a:tc>
                 <a:extLst>
                   <a:ext uri="{0D108BD9-81ED-4DB2-BD59-A6C34878D82A}">
-                    <a16:rowId xmlns:a16="http://schemas.microsoft.com/office/drawing/2014/main" val="1552429655"/>
+                    <a16:rowId xmlns:a16="http://schemas.microsoft.com/office/drawing/2014/main" val="2717118345"/>
                   </a:ext>
                 </a:extLst>
               </a:tr>
-              <a:tr h="647700">
+              <a:tr h="994833">
                 <a:tc>
                   <a:txBody>
                     <a:bodyPr/>
                     <a:lstStyle/>
                     <a:p>
                       <a:r>
-                        <a:rPr lang="en-IN" sz="1600" b="0">
+                        <a:rPr lang="en-IN" sz="1700" b="0">
                           <a:solidFill>
                             <a:srgbClr val="20382A"/>
                           </a:solidFill>
                           <a:latin typeface="Arial" panose="020B0604020202020204" pitchFamily="34" charset="0"/>
                         </a:rPr>
-                        <a:t>Frozen pretrained features</a:t>
+                        <a:t>Kang (2025 preprint)</a:t>
                       </a:r>
                     </a:p>
                   </a:txBody>
@@ -11597,14 +11605,22 @@
                     <a:lstStyle/>
                     <a:p>
                       <a:r>
-                        <a:rPr lang="en-IN" sz="1600" b="0">
+                        <a:rPr lang="en-US" sz="1700" b="0">
                           <a:solidFill>
                             <a:srgbClr val="20382A"/>
                           </a:solidFill>
                           <a:latin typeface="Arial" panose="020B0604020202020204" pitchFamily="34" charset="0"/>
                         </a:rPr>
-                        <a:t>Lecture 15, pp. 11-14</a:t>
+                        <a:t>Ten-class video
+EfficientNet-B0 + bidirectional GRU
+and temporal attention</a:t>
                       </a:r>
+                      <a:endParaRPr lang="en-IN" sz="1700" b="0">
+                        <a:solidFill>
+                          <a:srgbClr val="20382A"/>
+                        </a:solidFill>
+                        <a:latin typeface="Arial" panose="020B0604020202020204" pitchFamily="34" charset="0"/>
+                      </a:endParaRPr>
                     </a:p>
                   </a:txBody>
                   <a:tcPr marL="114300" marR="76200" marT="63500" marB="50800" anchor="ctr">
@@ -11639,14 +11655,22 @@
                     <a:lstStyle/>
                     <a:p>
                       <a:r>
-                        <a:rPr lang="en-IN" sz="1600" b="0">
+                        <a:rPr lang="en-US" sz="1700" b="0">
                           <a:solidFill>
                             <a:srgbClr val="20382A"/>
                           </a:solidFill>
                           <a:latin typeface="Arial" panose="020B0604020202020204" pitchFamily="34" charset="0"/>
                         </a:rPr>
-                        <a:t>MobileNetV2 + linear classifier</a:t>
+                        <a:t>Two spatial views
+Explicit abs-difference ablation
+No temporal sequence model</a:t>
                       </a:r>
+                      <a:endParaRPr lang="en-IN" sz="1700" b="0">
+                        <a:solidFill>
+                          <a:srgbClr val="20382A"/>
+                        </a:solidFill>
+                        <a:latin typeface="Arial" panose="020B0604020202020204" pitchFamily="34" charset="0"/>
+                      </a:endParaRPr>
                     </a:p>
                   </a:txBody>
                   <a:tcPr marL="114300" marR="76200" marT="63500" marB="50800" anchor="ctr">
@@ -11677,273 +11701,7 @@
                 </a:tc>
                 <a:extLst>
                   <a:ext uri="{0D108BD9-81ED-4DB2-BD59-A6C34878D82A}">
-                    <a16:rowId xmlns:a16="http://schemas.microsoft.com/office/drawing/2014/main" val="257134937"/>
-                  </a:ext>
-                </a:extLst>
-              </a:tr>
-              <a:tr h="647700">
-                <a:tc>
-                  <a:txBody>
-                    <a:bodyPr/>
-                    <a:lstStyle/>
-                    <a:p>
-                      <a:r>
-                        <a:rPr lang="en-IN" sz="1600" b="0">
-                          <a:solidFill>
-                            <a:srgbClr val="20382A"/>
-                          </a:solidFill>
-                          <a:latin typeface="Arial" panose="020B0604020202020204" pitchFamily="34" charset="0"/>
-                        </a:rPr>
-                        <a:t>Cricket recognition</a:t>
-                      </a:r>
-                    </a:p>
-                  </a:txBody>
-                  <a:tcPr marL="114300" marR="76200" marT="63500" marB="50800" anchor="ctr">
-                    <a:lnL w="6350" cmpd="sng">
-                      <a:solidFill>
-                        <a:srgbClr val="D8DFD0"/>
-                      </a:solidFill>
-                    </a:lnL>
-                    <a:lnR w="6350" cmpd="sng">
-                      <a:solidFill>
-                        <a:srgbClr val="D8DFD0"/>
-                      </a:solidFill>
-                    </a:lnR>
-                    <a:lnT w="6350" cmpd="sng">
-                      <a:solidFill>
-                        <a:srgbClr val="D8DFD0"/>
-                      </a:solidFill>
-                    </a:lnT>
-                    <a:lnB w="6350" cmpd="sng">
-                      <a:solidFill>
-                        <a:srgbClr val="D8DFD0"/>
-                      </a:solidFill>
-                    </a:lnB>
-                    <a:solidFill>
-                      <a:srgbClr val="FFFFFF"/>
-                    </a:solidFill>
-                  </a:tcPr>
-                </a:tc>
-                <a:tc>
-                  <a:txBody>
-                    <a:bodyPr/>
-                    <a:lstStyle/>
-                    <a:p>
-                      <a:r>
-                        <a:rPr lang="en-IN" sz="1600" b="0">
-                          <a:solidFill>
-                            <a:srgbClr val="20382A"/>
-                          </a:solidFill>
-                          <a:latin typeface="Arial" panose="020B0604020202020204" pitchFamily="34" charset="0"/>
-                        </a:rPr>
-                        <a:t>KUCricShot (2023); Kang (2025)</a:t>
-                      </a:r>
-                    </a:p>
-                  </a:txBody>
-                  <a:tcPr marL="114300" marR="76200" marT="63500" marB="50800" anchor="ctr">
-                    <a:lnL w="6350" cmpd="sng">
-                      <a:solidFill>
-                        <a:srgbClr val="D8DFD0"/>
-                      </a:solidFill>
-                    </a:lnL>
-                    <a:lnR w="6350" cmpd="sng">
-                      <a:solidFill>
-                        <a:srgbClr val="D8DFD0"/>
-                      </a:solidFill>
-                    </a:lnR>
-                    <a:lnT w="6350" cmpd="sng">
-                      <a:solidFill>
-                        <a:srgbClr val="D8DFD0"/>
-                      </a:solidFill>
-                    </a:lnT>
-                    <a:lnB w="6350" cmpd="sng">
-                      <a:solidFill>
-                        <a:srgbClr val="D8DFD0"/>
-                      </a:solidFill>
-                    </a:lnB>
-                    <a:solidFill>
-                      <a:srgbClr val="FFFFFF"/>
-                    </a:solidFill>
-                  </a:tcPr>
-                </a:tc>
-                <a:tc>
-                  <a:txBody>
-                    <a:bodyPr/>
-                    <a:lstStyle/>
-                    <a:p>
-                      <a:r>
-                        <a:rPr lang="en-IN" sz="1600" b="0">
-                          <a:solidFill>
-                            <a:srgbClr val="20382A"/>
-                          </a:solidFill>
-                          <a:latin typeface="Arial" panose="020B0604020202020204" pitchFamily="34" charset="0"/>
-                        </a:rPr>
-                        <a:t>Prior task studies; different data</a:t>
-                      </a:r>
-                    </a:p>
-                  </a:txBody>
-                  <a:tcPr marL="114300" marR="76200" marT="63500" marB="50800" anchor="ctr">
-                    <a:lnL w="6350" cmpd="sng">
-                      <a:solidFill>
-                        <a:srgbClr val="D8DFD0"/>
-                      </a:solidFill>
-                    </a:lnL>
-                    <a:lnR w="6350" cmpd="sng">
-                      <a:solidFill>
-                        <a:srgbClr val="D8DFD0"/>
-                      </a:solidFill>
-                    </a:lnR>
-                    <a:lnT w="6350" cmpd="sng">
-                      <a:solidFill>
-                        <a:srgbClr val="D8DFD0"/>
-                      </a:solidFill>
-                    </a:lnT>
-                    <a:lnB w="6350" cmpd="sng">
-                      <a:solidFill>
-                        <a:srgbClr val="D8DFD0"/>
-                      </a:solidFill>
-                    </a:lnB>
-                    <a:solidFill>
-                      <a:srgbClr val="FFFFFF"/>
-                    </a:solidFill>
-                  </a:tcPr>
-                </a:tc>
-                <a:extLst>
-                  <a:ext uri="{0D108BD9-81ED-4DB2-BD59-A6C34878D82A}">
-                    <a16:rowId xmlns:a16="http://schemas.microsoft.com/office/drawing/2014/main" val="2990380411"/>
-                  </a:ext>
-                </a:extLst>
-              </a:tr>
-              <a:tr h="647700">
-                <a:tc>
-                  <a:txBody>
-                    <a:bodyPr/>
-                    <a:lstStyle/>
-                    <a:p>
-                      <a:r>
-                        <a:rPr lang="en-IN" sz="1600" b="0">
-                          <a:solidFill>
-                            <a:srgbClr val="20382A"/>
-                          </a:solidFill>
-                          <a:latin typeface="Arial" panose="020B0604020202020204" pitchFamily="34" charset="0"/>
-                        </a:rPr>
-                        <a:t>Two-view difference</a:t>
-                      </a:r>
-                    </a:p>
-                  </a:txBody>
-                  <a:tcPr marL="114300" marR="76200" marT="63500" marB="50800" anchor="ctr">
-                    <a:lnL w="6350" cmpd="sng">
-                      <a:solidFill>
-                        <a:srgbClr val="D8DFD0"/>
-                      </a:solidFill>
-                    </a:lnL>
-                    <a:lnR w="6350" cmpd="sng">
-                      <a:solidFill>
-                        <a:srgbClr val="D8DFD0"/>
-                      </a:solidFill>
-                    </a:lnR>
-                    <a:lnT w="6350" cmpd="sng">
-                      <a:solidFill>
-                        <a:srgbClr val="D8DFD0"/>
-                      </a:solidFill>
-                    </a:lnT>
-                    <a:lnB w="6350" cmpd="sng">
-                      <a:solidFill>
-                        <a:srgbClr val="D8DFD0"/>
-                      </a:solidFill>
-                    </a:lnB>
-                    <a:solidFill>
-                      <a:srgbClr val="EEF2E7"/>
-                    </a:solidFill>
-                  </a:tcPr>
-                </a:tc>
-                <a:tc>
-                  <a:txBody>
-                    <a:bodyPr/>
-                    <a:lstStyle/>
-                    <a:p>
-                      <a:r>
-                        <a:rPr lang="en-IN" sz="1600" b="0">
-                          <a:solidFill>
-                            <a:srgbClr val="20382A"/>
-                          </a:solidFill>
-                          <a:latin typeface="Arial" panose="020B0604020202020204" pitchFamily="34" charset="0"/>
-                        </a:rPr>
-                        <a:t>Course implementation</a:t>
-                      </a:r>
-                    </a:p>
-                  </a:txBody>
-                  <a:tcPr marL="114300" marR="76200" marT="63500" marB="50800" anchor="ctr">
-                    <a:lnL w="6350" cmpd="sng">
-                      <a:solidFill>
-                        <a:srgbClr val="D8DFD0"/>
-                      </a:solidFill>
-                    </a:lnL>
-                    <a:lnR w="6350" cmpd="sng">
-                      <a:solidFill>
-                        <a:srgbClr val="D8DFD0"/>
-                      </a:solidFill>
-                    </a:lnR>
-                    <a:lnT w="6350" cmpd="sng">
-                      <a:solidFill>
-                        <a:srgbClr val="D8DFD0"/>
-                      </a:solidFill>
-                    </a:lnT>
-                    <a:lnB w="6350" cmpd="sng">
-                      <a:solidFill>
-                        <a:srgbClr val="D8DFD0"/>
-                      </a:solidFill>
-                    </a:lnB>
-                    <a:solidFill>
-                      <a:srgbClr val="EEF2E7"/>
-                    </a:solidFill>
-                  </a:tcPr>
-                </a:tc>
-                <a:tc>
-                  <a:txBody>
-                    <a:bodyPr/>
-                    <a:lstStyle/>
-                    <a:p>
-                      <a:r>
-                        <a:rPr lang="en-IN" sz="1600" b="0">
-                          <a:solidFill>
-                            <a:srgbClr val="20382A"/>
-                          </a:solidFill>
-                          <a:latin typeface="Arial" panose="020B0604020202020204" pitchFamily="34" charset="0"/>
-                        </a:rPr>
-                        <a:t>Compare with simple concatenation</a:t>
-                      </a:r>
-                    </a:p>
-                  </a:txBody>
-                  <a:tcPr marL="114300" marR="76200" marT="63500" marB="50800" anchor="ctr">
-                    <a:lnL w="6350" cmpd="sng">
-                      <a:solidFill>
-                        <a:srgbClr val="D8DFD0"/>
-                      </a:solidFill>
-                    </a:lnL>
-                    <a:lnR w="6350" cmpd="sng">
-                      <a:solidFill>
-                        <a:srgbClr val="D8DFD0"/>
-                      </a:solidFill>
-                    </a:lnR>
-                    <a:lnT w="6350" cmpd="sng">
-                      <a:solidFill>
-                        <a:srgbClr val="D8DFD0"/>
-                      </a:solidFill>
-                    </a:lnT>
-                    <a:lnB w="6350" cmpd="sng">
-                      <a:solidFill>
-                        <a:srgbClr val="D8DFD0"/>
-                      </a:solidFill>
-                    </a:lnB>
-                    <a:solidFill>
-                      <a:srgbClr val="EEF2E7"/>
-                    </a:solidFill>
-                  </a:tcPr>
-                </a:tc>
-                <a:extLst>
-                  <a:ext uri="{0D108BD9-81ED-4DB2-BD59-A6C34878D82A}">
-                    <a16:rowId xmlns:a16="http://schemas.microsoft.com/office/drawing/2014/main" val="3848731280"/>
+                    <a16:rowId xmlns:a16="http://schemas.microsoft.com/office/drawing/2014/main" val="1426222621"/>
                   </a:ext>
                 </a:extLst>
               </a:tr>
@@ -11953,10 +11711,10 @@
       </p:graphicFrame>
       <p:sp>
         <p:nvSpPr>
-          <p:cNvPr id="5" name="TextBox 4">
+          <p:cNvPr id="6" name="TextBox 5">
             <a:extLst>
               <a:ext uri="{FF2B5EF4-FFF2-40B4-BE49-F238E27FC236}">
-                <a16:creationId xmlns:a16="http://schemas.microsoft.com/office/drawing/2014/main" id="{B2F2344D-B9C5-9A96-87BF-F7AF511125BC}"/>
+                <a16:creationId xmlns:a16="http://schemas.microsoft.com/office/drawing/2014/main" id="{0B93C31F-9EB9-4D4D-ED08-080EC5838F36}"/>
               </a:ext>
             </a:extLst>
           </p:cNvPr>
@@ -11991,7 +11749,7 @@
                 </a:solidFill>
                 <a:latin typeface="Arial" panose="020B0604020202020204" pitchFamily="34" charset="0"/>
               </a:rPr>
-              <a:t>No claim of a new backbone or an unprecedented combination. Novelty remains limited.</a:t>
+              <a:t>Different data, labels and splits prevent direct comparison of published percentages.</a:t>
             </a:r>
             <a:endParaRPr lang="en-IN" sz="1600">
               <a:solidFill>
@@ -12004,10 +11762,10 @@
       </p:sp>
       <p:sp>
         <p:nvSpPr>
-          <p:cNvPr id="6" name="TextBox 5">
+          <p:cNvPr id="7" name="TextBox 6">
             <a:extLst>
               <a:ext uri="{FF2B5EF4-FFF2-40B4-BE49-F238E27FC236}">
-                <a16:creationId xmlns:a16="http://schemas.microsoft.com/office/drawing/2014/main" id="{DB39AE46-4794-0163-0567-8F249E0D6115}"/>
+                <a16:creationId xmlns:a16="http://schemas.microsoft.com/office/drawing/2014/main" id="{70FD8DF0-AD51-E4B0-79A7-D1C933228F8D}"/>
               </a:ext>
             </a:extLst>
           </p:cNvPr>
@@ -12049,10 +11807,10 @@
       </p:sp>
       <p:sp>
         <p:nvSpPr>
-          <p:cNvPr id="7" name="TextBox 6">
+          <p:cNvPr id="8" name="TextBox 7">
             <a:extLst>
               <a:ext uri="{FF2B5EF4-FFF2-40B4-BE49-F238E27FC236}">
-                <a16:creationId xmlns:a16="http://schemas.microsoft.com/office/drawing/2014/main" id="{BF45746A-5845-3F75-59A6-3BDDD5A40106}"/>
+                <a16:creationId xmlns:a16="http://schemas.microsoft.com/office/drawing/2014/main" id="{B32CFBB0-4ACE-CE32-A41B-C2DFF826E323}"/>
               </a:ext>
             </a:extLst>
           </p:cNvPr>
@@ -12095,7 +11853,7 @@
     </p:spTree>
     <p:extLst>
       <p:ext uri="{BB962C8B-B14F-4D97-AF65-F5344CB8AC3E}">
-        <p14:creationId xmlns:p14="http://schemas.microsoft.com/office/powerpoint/2010/main" val="3290382361"/>
+        <p14:creationId xmlns:p14="http://schemas.microsoft.com/office/powerpoint/2010/main" val="2024908939"/>
       </p:ext>
     </p:extLst>
   </p:cSld>
@@ -12135,7 +11893,7 @@
           <p:cNvPr id="2" name="TextBox 1">
             <a:extLst>
               <a:ext uri="{FF2B5EF4-FFF2-40B4-BE49-F238E27FC236}">
-                <a16:creationId xmlns:a16="http://schemas.microsoft.com/office/drawing/2014/main" id="{BA98EC03-45A6-D50F-50BE-B63A6E9C3D06}"/>
+                <a16:creationId xmlns:a16="http://schemas.microsoft.com/office/drawing/2014/main" id="{C3A92D6F-119C-8F4E-3E69-91BD59B3A1E5}"/>
               </a:ext>
             </a:extLst>
           </p:cNvPr>
@@ -12186,7 +11944,7 @@
           <p:cNvPr id="3" name="TextBox 2">
             <a:extLst>
               <a:ext uri="{FF2B5EF4-FFF2-40B4-BE49-F238E27FC236}">
-                <a16:creationId xmlns:a16="http://schemas.microsoft.com/office/drawing/2014/main" id="{0B913D2A-0814-DB69-E0CF-46038A942D8A}"/>
+                <a16:creationId xmlns:a16="http://schemas.microsoft.com/office/drawing/2014/main" id="{E6CF889F-4D4B-70C1-8D3C-DB9F0A25CBDB}"/>
               </a:ext>
             </a:extLst>
           </p:cNvPr>
@@ -12237,7 +11995,7 @@
           <p:cNvPr id="4" name="TextBox 3">
             <a:extLst>
               <a:ext uri="{FF2B5EF4-FFF2-40B4-BE49-F238E27FC236}">
-                <a16:creationId xmlns:a16="http://schemas.microsoft.com/office/drawing/2014/main" id="{00F53A3B-BA8C-7C93-CC5D-807290062E2A}"/>
+                <a16:creationId xmlns:a16="http://schemas.microsoft.com/office/drawing/2014/main" id="{3CF15159-C9F0-BD56-5DF8-EFFC42C4CFE3}"/>
               </a:ext>
             </a:extLst>
           </p:cNvPr>
@@ -12289,7 +12047,7 @@
           <p:cNvPr id="5" name="Table 4">
             <a:extLst>
               <a:ext uri="{FF2B5EF4-FFF2-40B4-BE49-F238E27FC236}">
-                <a16:creationId xmlns:a16="http://schemas.microsoft.com/office/drawing/2014/main" id="{BA2C6DE6-79F8-B0EA-32D8-E2A5915D7B33}"/>
+                <a16:creationId xmlns:a16="http://schemas.microsoft.com/office/drawing/2014/main" id="{E06D0556-379B-3F23-4710-06B22B8DA2EC}"/>
               </a:ext>
             </a:extLst>
           </p:cNvPr>
@@ -12299,7 +12057,7 @@
           <p:nvPr>
             <p:extLst>
               <p:ext uri="{D42A27DB-BD31-4B8C-83A1-F6EECF244321}">
-                <p14:modId xmlns:p14="http://schemas.microsoft.com/office/powerpoint/2010/main" val="3979582824"/>
+                <p14:modId xmlns:p14="http://schemas.microsoft.com/office/powerpoint/2010/main" val="3747710869"/>
               </p:ext>
             </p:extLst>
           </p:nvPr>
@@ -12318,28 +12076,28 @@
                 <a:gridCol w="4064000">
                   <a:extLst>
                     <a:ext uri="{9D8B030D-6E8A-4147-A177-3AD203B41FA5}">
-                      <a16:colId xmlns:a16="http://schemas.microsoft.com/office/drawing/2014/main" val="3714643079"/>
+                      <a16:colId xmlns:a16="http://schemas.microsoft.com/office/drawing/2014/main" val="4240250660"/>
                     </a:ext>
                   </a:extLst>
                 </a:gridCol>
                 <a:gridCol w="2286000">
                   <a:extLst>
                     <a:ext uri="{9D8B030D-6E8A-4147-A177-3AD203B41FA5}">
-                      <a16:colId xmlns:a16="http://schemas.microsoft.com/office/drawing/2014/main" val="3477182639"/>
+                      <a16:colId xmlns:a16="http://schemas.microsoft.com/office/drawing/2014/main" val="3280819196"/>
                     </a:ext>
                   </a:extLst>
                 </a:gridCol>
                 <a:gridCol w="2286000">
                   <a:extLst>
                     <a:ext uri="{9D8B030D-6E8A-4147-A177-3AD203B41FA5}">
-                      <a16:colId xmlns:a16="http://schemas.microsoft.com/office/drawing/2014/main" val="2123774310"/>
+                      <a16:colId xmlns:a16="http://schemas.microsoft.com/office/drawing/2014/main" val="3455703620"/>
                     </a:ext>
                   </a:extLst>
                 </a:gridCol>
                 <a:gridCol w="2286000">
                   <a:extLst>
                     <a:ext uri="{9D8B030D-6E8A-4147-A177-3AD203B41FA5}">
-                      <a16:colId xmlns:a16="http://schemas.microsoft.com/office/drawing/2014/main" val="2306863965"/>
+                      <a16:colId xmlns:a16="http://schemas.microsoft.com/office/drawing/2014/main" val="936531746"/>
                     </a:ext>
                   </a:extLst>
                 </a:gridCol>
@@ -12515,7 +12273,7 @@
                 </a:tc>
                 <a:extLst>
                   <a:ext uri="{0D108BD9-81ED-4DB2-BD59-A6C34878D82A}">
-                    <a16:rowId xmlns:a16="http://schemas.microsoft.com/office/drawing/2014/main" val="3218031432"/>
+                    <a16:rowId xmlns:a16="http://schemas.microsoft.com/office/drawing/2014/main" val="1304179206"/>
                   </a:ext>
                 </a:extLst>
               </a:tr>
@@ -12690,7 +12448,7 @@
                 </a:tc>
                 <a:extLst>
                   <a:ext uri="{0D108BD9-81ED-4DB2-BD59-A6C34878D82A}">
-                    <a16:rowId xmlns:a16="http://schemas.microsoft.com/office/drawing/2014/main" val="1070614889"/>
+                    <a16:rowId xmlns:a16="http://schemas.microsoft.com/office/drawing/2014/main" val="1468912456"/>
                   </a:ext>
                 </a:extLst>
               </a:tr>
@@ -12865,7 +12623,7 @@
                 </a:tc>
                 <a:extLst>
                   <a:ext uri="{0D108BD9-81ED-4DB2-BD59-A6C34878D82A}">
-                    <a16:rowId xmlns:a16="http://schemas.microsoft.com/office/drawing/2014/main" val="3652924697"/>
+                    <a16:rowId xmlns:a16="http://schemas.microsoft.com/office/drawing/2014/main" val="1551063131"/>
                   </a:ext>
                 </a:extLst>
               </a:tr>
@@ -13040,7 +12798,7 @@
                 </a:tc>
                 <a:extLst>
                   <a:ext uri="{0D108BD9-81ED-4DB2-BD59-A6C34878D82A}">
-                    <a16:rowId xmlns:a16="http://schemas.microsoft.com/office/drawing/2014/main" val="4052454683"/>
+                    <a16:rowId xmlns:a16="http://schemas.microsoft.com/office/drawing/2014/main" val="1347555616"/>
                   </a:ext>
                 </a:extLst>
               </a:tr>
@@ -13215,7 +12973,7 @@
                 </a:tc>
                 <a:extLst>
                   <a:ext uri="{0D108BD9-81ED-4DB2-BD59-A6C34878D82A}">
-                    <a16:rowId xmlns:a16="http://schemas.microsoft.com/office/drawing/2014/main" val="1998977380"/>
+                    <a16:rowId xmlns:a16="http://schemas.microsoft.com/office/drawing/2014/main" val="1768019722"/>
                   </a:ext>
                 </a:extLst>
               </a:tr>
@@ -13228,7 +12986,7 @@
           <p:cNvPr id="6" name="TextBox 5">
             <a:extLst>
               <a:ext uri="{FF2B5EF4-FFF2-40B4-BE49-F238E27FC236}">
-                <a16:creationId xmlns:a16="http://schemas.microsoft.com/office/drawing/2014/main" id="{6F9B2771-5A78-DB5A-520C-493D9628745A}"/>
+                <a16:creationId xmlns:a16="http://schemas.microsoft.com/office/drawing/2014/main" id="{5474F76D-4812-6AE5-088E-1876BA9831F7}"/>
               </a:ext>
             </a:extLst>
           </p:cNvPr>
@@ -13273,7 +13031,7 @@
           <p:cNvPr id="7" name="TextBox 6">
             <a:extLst>
               <a:ext uri="{FF2B5EF4-FFF2-40B4-BE49-F238E27FC236}">
-                <a16:creationId xmlns:a16="http://schemas.microsoft.com/office/drawing/2014/main" id="{21108568-0165-D60E-CC2F-C8E3F713B47A}"/>
+                <a16:creationId xmlns:a16="http://schemas.microsoft.com/office/drawing/2014/main" id="{9EC6AFBC-F7C6-BB9D-E9B1-E70991310DA9}"/>
               </a:ext>
             </a:extLst>
           </p:cNvPr>
@@ -13316,7 +13074,7 @@
     </p:spTree>
     <p:extLst>
       <p:ext uri="{BB962C8B-B14F-4D97-AF65-F5344CB8AC3E}">
-        <p14:creationId xmlns:p14="http://schemas.microsoft.com/office/powerpoint/2010/main" val="3867763941"/>
+        <p14:creationId xmlns:p14="http://schemas.microsoft.com/office/powerpoint/2010/main" val="3146023693"/>
       </p:ext>
     </p:extLst>
   </p:cSld>
@@ -13356,7 +13114,7 @@
           <p:cNvPr id="2" name="TextBox 1">
             <a:extLst>
               <a:ext uri="{FF2B5EF4-FFF2-40B4-BE49-F238E27FC236}">
-                <a16:creationId xmlns:a16="http://schemas.microsoft.com/office/drawing/2014/main" id="{71683F28-FED4-AAFF-2512-03C304A6C9B3}"/>
+                <a16:creationId xmlns:a16="http://schemas.microsoft.com/office/drawing/2014/main" id="{2B5F9FD1-865E-518F-73F4-105B2F7ECCE0}"/>
               </a:ext>
             </a:extLst>
           </p:cNvPr>
@@ -13407,7 +13165,7 @@
           <p:cNvPr id="3" name="TextBox 2">
             <a:extLst>
               <a:ext uri="{FF2B5EF4-FFF2-40B4-BE49-F238E27FC236}">
-                <a16:creationId xmlns:a16="http://schemas.microsoft.com/office/drawing/2014/main" id="{CA8CAF2D-EEDD-6390-B970-3FFA43C72DB3}"/>
+                <a16:creationId xmlns:a16="http://schemas.microsoft.com/office/drawing/2014/main" id="{8BE4C6D6-5FDD-995D-0643-7D6BAE3ED292}"/>
               </a:ext>
             </a:extLst>
           </p:cNvPr>
@@ -13458,7 +13216,7 @@
           <p:cNvPr id="4" name="Table 3">
             <a:extLst>
               <a:ext uri="{FF2B5EF4-FFF2-40B4-BE49-F238E27FC236}">
-                <a16:creationId xmlns:a16="http://schemas.microsoft.com/office/drawing/2014/main" id="{7D640B23-6B8C-1603-7889-0D2448D8FF88}"/>
+                <a16:creationId xmlns:a16="http://schemas.microsoft.com/office/drawing/2014/main" id="{C86929ED-79A9-4D58-C762-D19E510A255E}"/>
               </a:ext>
             </a:extLst>
           </p:cNvPr>
@@ -13468,7 +13226,7 @@
           <p:nvPr>
             <p:extLst>
               <p:ext uri="{D42A27DB-BD31-4B8C-83A1-F6EECF244321}">
-                <p14:modId xmlns:p14="http://schemas.microsoft.com/office/powerpoint/2010/main" val="419998597"/>
+                <p14:modId xmlns:p14="http://schemas.microsoft.com/office/powerpoint/2010/main" val="1256962775"/>
               </p:ext>
             </p:extLst>
           </p:nvPr>
@@ -13487,21 +13245,21 @@
                 <a:gridCol w="3810000">
                   <a:extLst>
                     <a:ext uri="{9D8B030D-6E8A-4147-A177-3AD203B41FA5}">
-                      <a16:colId xmlns:a16="http://schemas.microsoft.com/office/drawing/2014/main" val="16651699"/>
+                      <a16:colId xmlns:a16="http://schemas.microsoft.com/office/drawing/2014/main" val="2326982087"/>
                     </a:ext>
                   </a:extLst>
                 </a:gridCol>
                 <a:gridCol w="3302000">
                   <a:extLst>
                     <a:ext uri="{9D8B030D-6E8A-4147-A177-3AD203B41FA5}">
-                      <a16:colId xmlns:a16="http://schemas.microsoft.com/office/drawing/2014/main" val="1510390071"/>
+                      <a16:colId xmlns:a16="http://schemas.microsoft.com/office/drawing/2014/main" val="3515128273"/>
                     </a:ext>
                   </a:extLst>
                 </a:gridCol>
                 <a:gridCol w="3810000">
                   <a:extLst>
                     <a:ext uri="{9D8B030D-6E8A-4147-A177-3AD203B41FA5}">
-                      <a16:colId xmlns:a16="http://schemas.microsoft.com/office/drawing/2014/main" val="900923165"/>
+                      <a16:colId xmlns:a16="http://schemas.microsoft.com/office/drawing/2014/main" val="3019342547"/>
                     </a:ext>
                   </a:extLst>
                 </a:gridCol>
@@ -13635,7 +13393,7 @@
                 </a:tc>
                 <a:extLst>
                   <a:ext uri="{0D108BD9-81ED-4DB2-BD59-A6C34878D82A}">
-                    <a16:rowId xmlns:a16="http://schemas.microsoft.com/office/drawing/2014/main" val="3643029211"/>
+                    <a16:rowId xmlns:a16="http://schemas.microsoft.com/office/drawing/2014/main" val="3137844428"/>
                   </a:ext>
                 </a:extLst>
               </a:tr>
@@ -13768,7 +13526,7 @@
                 </a:tc>
                 <a:extLst>
                   <a:ext uri="{0D108BD9-81ED-4DB2-BD59-A6C34878D82A}">
-                    <a16:rowId xmlns:a16="http://schemas.microsoft.com/office/drawing/2014/main" val="2656935237"/>
+                    <a16:rowId xmlns:a16="http://schemas.microsoft.com/office/drawing/2014/main" val="512638069"/>
                   </a:ext>
                 </a:extLst>
               </a:tr>
@@ -13907,7 +13665,7 @@
                 </a:tc>
                 <a:extLst>
                   <a:ext uri="{0D108BD9-81ED-4DB2-BD59-A6C34878D82A}">
-                    <a16:rowId xmlns:a16="http://schemas.microsoft.com/office/drawing/2014/main" val="2571405511"/>
+                    <a16:rowId xmlns:a16="http://schemas.microsoft.com/office/drawing/2014/main" val="3989803062"/>
                   </a:ext>
                 </a:extLst>
               </a:tr>
@@ -14040,7 +13798,7 @@
                 </a:tc>
                 <a:extLst>
                   <a:ext uri="{0D108BD9-81ED-4DB2-BD59-A6C34878D82A}">
-                    <a16:rowId xmlns:a16="http://schemas.microsoft.com/office/drawing/2014/main" val="1753364743"/>
+                    <a16:rowId xmlns:a16="http://schemas.microsoft.com/office/drawing/2014/main" val="1638595399"/>
                   </a:ext>
                 </a:extLst>
               </a:tr>
@@ -14179,7 +13937,7 @@
                 </a:tc>
                 <a:extLst>
                   <a:ext uri="{0D108BD9-81ED-4DB2-BD59-A6C34878D82A}">
-                    <a16:rowId xmlns:a16="http://schemas.microsoft.com/office/drawing/2014/main" val="3172819636"/>
+                    <a16:rowId xmlns:a16="http://schemas.microsoft.com/office/drawing/2014/main" val="2247959618"/>
                   </a:ext>
                 </a:extLst>
               </a:tr>
@@ -14192,7 +13950,7 @@
           <p:cNvPr id="5" name="TextBox 4">
             <a:extLst>
               <a:ext uri="{FF2B5EF4-FFF2-40B4-BE49-F238E27FC236}">
-                <a16:creationId xmlns:a16="http://schemas.microsoft.com/office/drawing/2014/main" id="{A41F0B5E-C72C-CFBF-4843-67D77EB3EC66}"/>
+                <a16:creationId xmlns:a16="http://schemas.microsoft.com/office/drawing/2014/main" id="{851F107E-C93F-6FA8-8795-36A7B67BE928}"/>
               </a:ext>
             </a:extLst>
           </p:cNvPr>
@@ -14243,7 +14001,7 @@
           <p:cNvPr id="6" name="TextBox 5">
             <a:extLst>
               <a:ext uri="{FF2B5EF4-FFF2-40B4-BE49-F238E27FC236}">
-                <a16:creationId xmlns:a16="http://schemas.microsoft.com/office/drawing/2014/main" id="{C756A787-3CA1-C54C-F592-87FF4289EB4C}"/>
+                <a16:creationId xmlns:a16="http://schemas.microsoft.com/office/drawing/2014/main" id="{DA25196B-9EB0-6717-ACD3-2F1FA357151D}"/>
               </a:ext>
             </a:extLst>
           </p:cNvPr>
@@ -14288,7 +14046,7 @@
           <p:cNvPr id="7" name="TextBox 6">
             <a:extLst>
               <a:ext uri="{FF2B5EF4-FFF2-40B4-BE49-F238E27FC236}">
-                <a16:creationId xmlns:a16="http://schemas.microsoft.com/office/drawing/2014/main" id="{BE14CF39-68B2-3335-C1A7-43757849CF8B}"/>
+                <a16:creationId xmlns:a16="http://schemas.microsoft.com/office/drawing/2014/main" id="{713AF0BE-BB33-D985-36B0-C389A49425F6}"/>
               </a:ext>
             </a:extLst>
           </p:cNvPr>
@@ -14331,7 +14089,7 @@
     </p:spTree>
     <p:extLst>
       <p:ext uri="{BB962C8B-B14F-4D97-AF65-F5344CB8AC3E}">
-        <p14:creationId xmlns:p14="http://schemas.microsoft.com/office/powerpoint/2010/main" val="4203452356"/>
+        <p14:creationId xmlns:p14="http://schemas.microsoft.com/office/powerpoint/2010/main" val="3241774398"/>
       </p:ext>
     </p:extLst>
   </p:cSld>
@@ -14371,7 +14129,7 @@
           <p:cNvPr id="2" name="TextBox 1">
             <a:extLst>
               <a:ext uri="{FF2B5EF4-FFF2-40B4-BE49-F238E27FC236}">
-                <a16:creationId xmlns:a16="http://schemas.microsoft.com/office/drawing/2014/main" id="{8B438954-D374-8E6C-82EA-57C79E09E481}"/>
+                <a16:creationId xmlns:a16="http://schemas.microsoft.com/office/drawing/2014/main" id="{B1177534-9845-7A6D-79A7-CA3E25702C91}"/>
               </a:ext>
             </a:extLst>
           </p:cNvPr>
@@ -14416,7 +14174,7 @@
           <p:cNvPr id="3" name="TextBox 2">
             <a:extLst>
               <a:ext uri="{FF2B5EF4-FFF2-40B4-BE49-F238E27FC236}">
-                <a16:creationId xmlns:a16="http://schemas.microsoft.com/office/drawing/2014/main" id="{AA399CEC-2CB6-EF84-A9F3-2A7A4824A6B3}"/>
+                <a16:creationId xmlns:a16="http://schemas.microsoft.com/office/drawing/2014/main" id="{E01C27BC-C535-449B-FB1A-083ED58598E2}"/>
               </a:ext>
             </a:extLst>
           </p:cNvPr>
@@ -14467,7 +14225,7 @@
           <p:cNvPr id="5" name="Picture 4">
             <a:extLst>
               <a:ext uri="{FF2B5EF4-FFF2-40B4-BE49-F238E27FC236}">
-                <a16:creationId xmlns:a16="http://schemas.microsoft.com/office/drawing/2014/main" id="{20EB9C77-7898-B412-8963-6A7DA5001D2B}"/>
+                <a16:creationId xmlns:a16="http://schemas.microsoft.com/office/drawing/2014/main" id="{2D021BDF-5B64-50C1-5430-C63F6058CEAA}"/>
               </a:ext>
             </a:extLst>
           </p:cNvPr>
@@ -14503,7 +14261,7 @@
           <p:cNvPr id="6" name="TextBox 5">
             <a:extLst>
               <a:ext uri="{FF2B5EF4-FFF2-40B4-BE49-F238E27FC236}">
-                <a16:creationId xmlns:a16="http://schemas.microsoft.com/office/drawing/2014/main" id="{D8B5D059-84EF-057E-110E-992AC6D809B2}"/>
+                <a16:creationId xmlns:a16="http://schemas.microsoft.com/office/drawing/2014/main" id="{AFBB1E70-C412-6146-5090-026236A3F3A2}"/>
               </a:ext>
             </a:extLst>
           </p:cNvPr>
@@ -14538,7 +14296,7 @@
                 </a:solidFill>
                 <a:latin typeface="Arial" panose="020B0604020202020204" pitchFamily="34" charset="0"/>
               </a:rPr>
-              <a:t>The fixed crop is a regional view. It does not detect or segment the batter.</a:t>
+              <a:t>Central crop assumes a centered batter. It can remove the bat or useful scene context.</a:t>
             </a:r>
             <a:endParaRPr lang="en-IN" sz="1600">
               <a:solidFill>
@@ -14554,7 +14312,7 @@
           <p:cNvPr id="7" name="TextBox 6">
             <a:extLst>
               <a:ext uri="{FF2B5EF4-FFF2-40B4-BE49-F238E27FC236}">
-                <a16:creationId xmlns:a16="http://schemas.microsoft.com/office/drawing/2014/main" id="{8EDDF0B7-92A2-56E1-ED96-DA514762214C}"/>
+                <a16:creationId xmlns:a16="http://schemas.microsoft.com/office/drawing/2014/main" id="{90B352BD-8303-4FEA-4838-7F030976896B}"/>
               </a:ext>
             </a:extLst>
           </p:cNvPr>
@@ -14599,7 +14357,7 @@
           <p:cNvPr id="8" name="TextBox 7">
             <a:extLst>
               <a:ext uri="{FF2B5EF4-FFF2-40B4-BE49-F238E27FC236}">
-                <a16:creationId xmlns:a16="http://schemas.microsoft.com/office/drawing/2014/main" id="{CC8ABB7A-2AFD-53FC-66F2-57C5C21D30AF}"/>
+                <a16:creationId xmlns:a16="http://schemas.microsoft.com/office/drawing/2014/main" id="{352FD84C-AC3A-F553-CDE1-29785ADB4E48}"/>
               </a:ext>
             </a:extLst>
           </p:cNvPr>
@@ -14642,7 +14400,7 @@
     </p:spTree>
     <p:extLst>
       <p:ext uri="{BB962C8B-B14F-4D97-AF65-F5344CB8AC3E}">
-        <p14:creationId xmlns:p14="http://schemas.microsoft.com/office/powerpoint/2010/main" val="1215802606"/>
+        <p14:creationId xmlns:p14="http://schemas.microsoft.com/office/powerpoint/2010/main" val="2730475874"/>
       </p:ext>
     </p:extLst>
   </p:cSld>
@@ -14682,7 +14440,7 @@
           <p:cNvPr id="2" name="TextBox 1">
             <a:extLst>
               <a:ext uri="{FF2B5EF4-FFF2-40B4-BE49-F238E27FC236}">
-                <a16:creationId xmlns:a16="http://schemas.microsoft.com/office/drawing/2014/main" id="{03B33977-86FC-C297-6974-CFE7BF894C6D}"/>
+                <a16:creationId xmlns:a16="http://schemas.microsoft.com/office/drawing/2014/main" id="{89E67D05-A244-FDB6-F2F2-680F37107249}"/>
               </a:ext>
             </a:extLst>
           </p:cNvPr>
@@ -14733,7 +14491,7 @@
           <p:cNvPr id="3" name="TextBox 2">
             <a:extLst>
               <a:ext uri="{FF2B5EF4-FFF2-40B4-BE49-F238E27FC236}">
-                <a16:creationId xmlns:a16="http://schemas.microsoft.com/office/drawing/2014/main" id="{AB183C91-5B71-66D1-5255-6DA37757AA52}"/>
+                <a16:creationId xmlns:a16="http://schemas.microsoft.com/office/drawing/2014/main" id="{B2B3F2C9-FFC0-3CB8-CC19-B537CE5B5ED5}"/>
               </a:ext>
             </a:extLst>
           </p:cNvPr>
@@ -14784,7 +14542,7 @@
           <p:cNvPr id="5" name="Picture 4">
             <a:extLst>
               <a:ext uri="{FF2B5EF4-FFF2-40B4-BE49-F238E27FC236}">
-                <a16:creationId xmlns:a16="http://schemas.microsoft.com/office/drawing/2014/main" id="{96A2E860-AD91-FB09-1438-77242E73E202}"/>
+                <a16:creationId xmlns:a16="http://schemas.microsoft.com/office/drawing/2014/main" id="{DCB5A3EB-109B-9FA3-7545-0F82E55D6A5B}"/>
               </a:ext>
             </a:extLst>
           </p:cNvPr>
@@ -14820,7 +14578,7 @@
           <p:cNvPr id="6" name="Table 5">
             <a:extLst>
               <a:ext uri="{FF2B5EF4-FFF2-40B4-BE49-F238E27FC236}">
-                <a16:creationId xmlns:a16="http://schemas.microsoft.com/office/drawing/2014/main" id="{FFEC1A12-70FA-9DE9-7E70-B65B8626B640}"/>
+                <a16:creationId xmlns:a16="http://schemas.microsoft.com/office/drawing/2014/main" id="{C204978F-1231-0D03-9A28-1503B190830A}"/>
               </a:ext>
             </a:extLst>
           </p:cNvPr>
@@ -14830,7 +14588,7 @@
           <p:nvPr>
             <p:extLst>
               <p:ext uri="{D42A27DB-BD31-4B8C-83A1-F6EECF244321}">
-                <p14:modId xmlns:p14="http://schemas.microsoft.com/office/powerpoint/2010/main" val="3514543653"/>
+                <p14:modId xmlns:p14="http://schemas.microsoft.com/office/powerpoint/2010/main" val="2810868110"/>
               </p:ext>
             </p:extLst>
           </p:nvPr>
@@ -14849,14 +14607,14 @@
                 <a:gridCol w="2095500">
                   <a:extLst>
                     <a:ext uri="{9D8B030D-6E8A-4147-A177-3AD203B41FA5}">
-                      <a16:colId xmlns:a16="http://schemas.microsoft.com/office/drawing/2014/main" val="2322973232"/>
+                      <a16:colId xmlns:a16="http://schemas.microsoft.com/office/drawing/2014/main" val="3757413207"/>
                     </a:ext>
                   </a:extLst>
                 </a:gridCol>
                 <a:gridCol w="3683000">
                   <a:extLst>
                     <a:ext uri="{9D8B030D-6E8A-4147-A177-3AD203B41FA5}">
-                      <a16:colId xmlns:a16="http://schemas.microsoft.com/office/drawing/2014/main" val="2709832051"/>
+                      <a16:colId xmlns:a16="http://schemas.microsoft.com/office/drawing/2014/main" val="2775934503"/>
                     </a:ext>
                   </a:extLst>
                 </a:gridCol>
@@ -14948,7 +14706,7 @@
                 </a:tc>
                 <a:extLst>
                   <a:ext uri="{0D108BD9-81ED-4DB2-BD59-A6C34878D82A}">
-                    <a16:rowId xmlns:a16="http://schemas.microsoft.com/office/drawing/2014/main" val="2076778103"/>
+                    <a16:rowId xmlns:a16="http://schemas.microsoft.com/office/drawing/2014/main" val="3017170068"/>
                   </a:ext>
                 </a:extLst>
               </a:tr>
@@ -15039,7 +14797,7 @@
                 </a:tc>
                 <a:extLst>
                   <a:ext uri="{0D108BD9-81ED-4DB2-BD59-A6C34878D82A}">
-                    <a16:rowId xmlns:a16="http://schemas.microsoft.com/office/drawing/2014/main" val="2672258800"/>
+                    <a16:rowId xmlns:a16="http://schemas.microsoft.com/office/drawing/2014/main" val="1772222138"/>
                   </a:ext>
                 </a:extLst>
               </a:tr>
@@ -15130,7 +14888,7 @@
                 </a:tc>
                 <a:extLst>
                   <a:ext uri="{0D108BD9-81ED-4DB2-BD59-A6C34878D82A}">
-                    <a16:rowId xmlns:a16="http://schemas.microsoft.com/office/drawing/2014/main" val="431767679"/>
+                    <a16:rowId xmlns:a16="http://schemas.microsoft.com/office/drawing/2014/main" val="977965795"/>
                   </a:ext>
                 </a:extLst>
               </a:tr>
@@ -15227,7 +14985,7 @@
                 </a:tc>
                 <a:extLst>
                   <a:ext uri="{0D108BD9-81ED-4DB2-BD59-A6C34878D82A}">
-                    <a16:rowId xmlns:a16="http://schemas.microsoft.com/office/drawing/2014/main" val="895981161"/>
+                    <a16:rowId xmlns:a16="http://schemas.microsoft.com/office/drawing/2014/main" val="3380548906"/>
                   </a:ext>
                 </a:extLst>
               </a:tr>
@@ -15318,7 +15076,7 @@
                 </a:tc>
                 <a:extLst>
                   <a:ext uri="{0D108BD9-81ED-4DB2-BD59-A6C34878D82A}">
-                    <a16:rowId xmlns:a16="http://schemas.microsoft.com/office/drawing/2014/main" val="1484753629"/>
+                    <a16:rowId xmlns:a16="http://schemas.microsoft.com/office/drawing/2014/main" val="2057878320"/>
                   </a:ext>
                 </a:extLst>
               </a:tr>
@@ -15415,7 +15173,7 @@
                 </a:tc>
                 <a:extLst>
                   <a:ext uri="{0D108BD9-81ED-4DB2-BD59-A6C34878D82A}">
-                    <a16:rowId xmlns:a16="http://schemas.microsoft.com/office/drawing/2014/main" val="802850315"/>
+                    <a16:rowId xmlns:a16="http://schemas.microsoft.com/office/drawing/2014/main" val="182976912"/>
                   </a:ext>
                 </a:extLst>
               </a:tr>
@@ -15428,7 +15186,7 @@
           <p:cNvPr id="7" name="TextBox 6">
             <a:extLst>
               <a:ext uri="{FF2B5EF4-FFF2-40B4-BE49-F238E27FC236}">
-                <a16:creationId xmlns:a16="http://schemas.microsoft.com/office/drawing/2014/main" id="{11D47714-9A39-4C47-9D56-20CF25B589AE}"/>
+                <a16:creationId xmlns:a16="http://schemas.microsoft.com/office/drawing/2014/main" id="{3D376E5C-A807-2830-3F89-0C14F488F350}"/>
               </a:ext>
             </a:extLst>
           </p:cNvPr>
@@ -15479,7 +15237,7 @@
           <p:cNvPr id="8" name="TextBox 7">
             <a:extLst>
               <a:ext uri="{FF2B5EF4-FFF2-40B4-BE49-F238E27FC236}">
-                <a16:creationId xmlns:a16="http://schemas.microsoft.com/office/drawing/2014/main" id="{9CDC6331-5A4D-8687-FF66-7FEC8BC7CA09}"/>
+                <a16:creationId xmlns:a16="http://schemas.microsoft.com/office/drawing/2014/main" id="{DD25A54E-9795-3AC9-1764-3E51DD1B1D1F}"/>
               </a:ext>
             </a:extLst>
           </p:cNvPr>
@@ -15524,7 +15282,7 @@
           <p:cNvPr id="9" name="TextBox 8">
             <a:extLst>
               <a:ext uri="{FF2B5EF4-FFF2-40B4-BE49-F238E27FC236}">
-                <a16:creationId xmlns:a16="http://schemas.microsoft.com/office/drawing/2014/main" id="{67E6E872-7584-42BA-1969-62713D6FDD3D}"/>
+                <a16:creationId xmlns:a16="http://schemas.microsoft.com/office/drawing/2014/main" id="{10D9A29D-026D-9900-0B6C-23D4D714F8D8}"/>
               </a:ext>
             </a:extLst>
           </p:cNvPr>
@@ -15567,7 +15325,7 @@
     </p:spTree>
     <p:extLst>
       <p:ext uri="{BB962C8B-B14F-4D97-AF65-F5344CB8AC3E}">
-        <p14:creationId xmlns:p14="http://schemas.microsoft.com/office/powerpoint/2010/main" val="4094274428"/>
+        <p14:creationId xmlns:p14="http://schemas.microsoft.com/office/powerpoint/2010/main" val="3827166992"/>
       </p:ext>
     </p:extLst>
   </p:cSld>
@@ -15607,7 +15365,7 @@
           <p:cNvPr id="2" name="TextBox 1">
             <a:extLst>
               <a:ext uri="{FF2B5EF4-FFF2-40B4-BE49-F238E27FC236}">
-                <a16:creationId xmlns:a16="http://schemas.microsoft.com/office/drawing/2014/main" id="{9AAA906C-D57C-FB9D-98C8-9C5C2FB8AD2E}"/>
+                <a16:creationId xmlns:a16="http://schemas.microsoft.com/office/drawing/2014/main" id="{4243E131-17AE-2C61-8098-CC0F892428C6}"/>
               </a:ext>
             </a:extLst>
           </p:cNvPr>
@@ -15658,7 +15416,7 @@
           <p:cNvPr id="3" name="TextBox 2">
             <a:extLst>
               <a:ext uri="{FF2B5EF4-FFF2-40B4-BE49-F238E27FC236}">
-                <a16:creationId xmlns:a16="http://schemas.microsoft.com/office/drawing/2014/main" id="{A4C198BB-E7EC-9154-EBEE-590E18A61514}"/>
+                <a16:creationId xmlns:a16="http://schemas.microsoft.com/office/drawing/2014/main" id="{8E6D1A39-401A-A307-A78B-72E25AC41821}"/>
               </a:ext>
             </a:extLst>
           </p:cNvPr>
@@ -15709,7 +15467,7 @@
           <p:cNvPr id="4" name="TextBox 3">
             <a:extLst>
               <a:ext uri="{FF2B5EF4-FFF2-40B4-BE49-F238E27FC236}">
-                <a16:creationId xmlns:a16="http://schemas.microsoft.com/office/drawing/2014/main" id="{4295B0A4-5C74-758F-9698-353E9274D8F0}"/>
+                <a16:creationId xmlns:a16="http://schemas.microsoft.com/office/drawing/2014/main" id="{3E400F46-8FA7-C273-F888-EE78ADF8B3CB}"/>
               </a:ext>
             </a:extLst>
           </p:cNvPr>
@@ -15761,7 +15519,7 @@
           <p:cNvPr id="5" name="Table 4">
             <a:extLst>
               <a:ext uri="{FF2B5EF4-FFF2-40B4-BE49-F238E27FC236}">
-                <a16:creationId xmlns:a16="http://schemas.microsoft.com/office/drawing/2014/main" id="{57925E37-E44B-2893-DD61-81BC0739CAB6}"/>
+                <a16:creationId xmlns:a16="http://schemas.microsoft.com/office/drawing/2014/main" id="{810EAC42-0669-44A8-0753-E3D7681CA9F4}"/>
               </a:ext>
             </a:extLst>
           </p:cNvPr>
@@ -15771,7 +15529,7 @@
           <p:nvPr>
             <p:extLst>
               <p:ext uri="{D42A27DB-BD31-4B8C-83A1-F6EECF244321}">
-                <p14:modId xmlns:p14="http://schemas.microsoft.com/office/powerpoint/2010/main" val="2645606805"/>
+                <p14:modId xmlns:p14="http://schemas.microsoft.com/office/powerpoint/2010/main" val="2892003583"/>
               </p:ext>
             </p:extLst>
           </p:nvPr>
@@ -15790,21 +15548,21 @@
                 <a:gridCol w="3810000">
                   <a:extLst>
                     <a:ext uri="{9D8B030D-6E8A-4147-A177-3AD203B41FA5}">
-                      <a16:colId xmlns:a16="http://schemas.microsoft.com/office/drawing/2014/main" val="3304361364"/>
+                      <a16:colId xmlns:a16="http://schemas.microsoft.com/office/drawing/2014/main" val="3842377772"/>
                     </a:ext>
                   </a:extLst>
                 </a:gridCol>
                 <a:gridCol w="4572000">
                   <a:extLst>
                     <a:ext uri="{9D8B030D-6E8A-4147-A177-3AD203B41FA5}">
-                      <a16:colId xmlns:a16="http://schemas.microsoft.com/office/drawing/2014/main" val="410694315"/>
+                      <a16:colId xmlns:a16="http://schemas.microsoft.com/office/drawing/2014/main" val="451885387"/>
                     </a:ext>
                   </a:extLst>
                 </a:gridCol>
                 <a:gridCol w="2540000">
                   <a:extLst>
                     <a:ext uri="{9D8B030D-6E8A-4147-A177-3AD203B41FA5}">
-                      <a16:colId xmlns:a16="http://schemas.microsoft.com/office/drawing/2014/main" val="1859349803"/>
+                      <a16:colId xmlns:a16="http://schemas.microsoft.com/office/drawing/2014/main" val="1933106445"/>
                     </a:ext>
                   </a:extLst>
                 </a:gridCol>
@@ -15938,7 +15696,7 @@
                 </a:tc>
                 <a:extLst>
                   <a:ext uri="{0D108BD9-81ED-4DB2-BD59-A6C34878D82A}">
-                    <a16:rowId xmlns:a16="http://schemas.microsoft.com/office/drawing/2014/main" val="4227138705"/>
+                    <a16:rowId xmlns:a16="http://schemas.microsoft.com/office/drawing/2014/main" val="1418020894"/>
                   </a:ext>
                 </a:extLst>
               </a:tr>
@@ -16071,7 +15829,7 @@
                 </a:tc>
                 <a:extLst>
                   <a:ext uri="{0D108BD9-81ED-4DB2-BD59-A6C34878D82A}">
-                    <a16:rowId xmlns:a16="http://schemas.microsoft.com/office/drawing/2014/main" val="1430032645"/>
+                    <a16:rowId xmlns:a16="http://schemas.microsoft.com/office/drawing/2014/main" val="4156437194"/>
                   </a:ext>
                 </a:extLst>
               </a:tr>
@@ -16204,7 +15962,7 @@
                 </a:tc>
                 <a:extLst>
                   <a:ext uri="{0D108BD9-81ED-4DB2-BD59-A6C34878D82A}">
-                    <a16:rowId xmlns:a16="http://schemas.microsoft.com/office/drawing/2014/main" val="4258313058"/>
+                    <a16:rowId xmlns:a16="http://schemas.microsoft.com/office/drawing/2014/main" val="2752199131"/>
                   </a:ext>
                 </a:extLst>
               </a:tr>
@@ -16337,7 +16095,7 @@
                 </a:tc>
                 <a:extLst>
                   <a:ext uri="{0D108BD9-81ED-4DB2-BD59-A6C34878D82A}">
-                    <a16:rowId xmlns:a16="http://schemas.microsoft.com/office/drawing/2014/main" val="28864441"/>
+                    <a16:rowId xmlns:a16="http://schemas.microsoft.com/office/drawing/2014/main" val="3035348186"/>
                   </a:ext>
                 </a:extLst>
               </a:tr>
@@ -16470,7 +16228,7 @@
                 </a:tc>
                 <a:extLst>
                   <a:ext uri="{0D108BD9-81ED-4DB2-BD59-A6C34878D82A}">
-                    <a16:rowId xmlns:a16="http://schemas.microsoft.com/office/drawing/2014/main" val="2949334616"/>
+                    <a16:rowId xmlns:a16="http://schemas.microsoft.com/office/drawing/2014/main" val="2322666053"/>
                   </a:ext>
                 </a:extLst>
               </a:tr>
@@ -16483,7 +16241,7 @@
           <p:cNvPr id="6" name="TextBox 5">
             <a:extLst>
               <a:ext uri="{FF2B5EF4-FFF2-40B4-BE49-F238E27FC236}">
-                <a16:creationId xmlns:a16="http://schemas.microsoft.com/office/drawing/2014/main" id="{23230B7E-27AF-D5EB-44D4-B199D086251D}"/>
+                <a16:creationId xmlns:a16="http://schemas.microsoft.com/office/drawing/2014/main" id="{BBDFB472-41E9-004B-6C01-5AEA93B55158}"/>
               </a:ext>
             </a:extLst>
           </p:cNvPr>
@@ -16528,7 +16286,7 @@
           <p:cNvPr id="7" name="TextBox 6">
             <a:extLst>
               <a:ext uri="{FF2B5EF4-FFF2-40B4-BE49-F238E27FC236}">
-                <a16:creationId xmlns:a16="http://schemas.microsoft.com/office/drawing/2014/main" id="{76900C8B-1292-08B6-BF7D-FBCAD9CEB608}"/>
+                <a16:creationId xmlns:a16="http://schemas.microsoft.com/office/drawing/2014/main" id="{3256E32D-E1A6-0992-8FD8-B8D94141E8ED}"/>
               </a:ext>
             </a:extLst>
           </p:cNvPr>
@@ -16571,7 +16329,7 @@
     </p:spTree>
     <p:extLst>
       <p:ext uri="{BB962C8B-B14F-4D97-AF65-F5344CB8AC3E}">
-        <p14:creationId xmlns:p14="http://schemas.microsoft.com/office/powerpoint/2010/main" val="2702726541"/>
+        <p14:creationId xmlns:p14="http://schemas.microsoft.com/office/powerpoint/2010/main" val="3160738275"/>
       </p:ext>
     </p:extLst>
   </p:cSld>
@@ -16611,7 +16369,7 @@
           <p:cNvPr id="2" name="TextBox 1">
             <a:extLst>
               <a:ext uri="{FF2B5EF4-FFF2-40B4-BE49-F238E27FC236}">
-                <a16:creationId xmlns:a16="http://schemas.microsoft.com/office/drawing/2014/main" id="{267F16DC-E9A8-B583-0594-20534728AA84}"/>
+                <a16:creationId xmlns:a16="http://schemas.microsoft.com/office/drawing/2014/main" id="{6754BA4F-2081-6184-CADA-B1BB1B456DF7}"/>
               </a:ext>
             </a:extLst>
           </p:cNvPr>
@@ -16656,7 +16414,7 @@
           <p:cNvPr id="3" name="TextBox 2">
             <a:extLst>
               <a:ext uri="{FF2B5EF4-FFF2-40B4-BE49-F238E27FC236}">
-                <a16:creationId xmlns:a16="http://schemas.microsoft.com/office/drawing/2014/main" id="{477D7371-2124-813E-6C93-DF86E6823E16}"/>
+                <a16:creationId xmlns:a16="http://schemas.microsoft.com/office/drawing/2014/main" id="{96C0138E-FD65-9CAC-375B-68D8326ED1A6}"/>
               </a:ext>
             </a:extLst>
           </p:cNvPr>
@@ -16707,7 +16465,7 @@
           <p:cNvPr id="4" name="Table 3">
             <a:extLst>
               <a:ext uri="{FF2B5EF4-FFF2-40B4-BE49-F238E27FC236}">
-                <a16:creationId xmlns:a16="http://schemas.microsoft.com/office/drawing/2014/main" id="{B508A277-545E-17A1-C5C0-5D37E204B9BD}"/>
+                <a16:creationId xmlns:a16="http://schemas.microsoft.com/office/drawing/2014/main" id="{06773C2D-0F05-4D4F-D982-43565BC41D90}"/>
               </a:ext>
             </a:extLst>
           </p:cNvPr>
@@ -16717,7 +16475,7 @@
           <p:nvPr>
             <p:extLst>
               <p:ext uri="{D42A27DB-BD31-4B8C-83A1-F6EECF244321}">
-                <p14:modId xmlns:p14="http://schemas.microsoft.com/office/powerpoint/2010/main" val="2390203610"/>
+                <p14:modId xmlns:p14="http://schemas.microsoft.com/office/powerpoint/2010/main" val="959667966"/>
               </p:ext>
             </p:extLst>
           </p:nvPr>
@@ -16736,35 +16494,35 @@
                 <a:gridCol w="3810000">
                   <a:extLst>
                     <a:ext uri="{9D8B030D-6E8A-4147-A177-3AD203B41FA5}">
-                      <a16:colId xmlns:a16="http://schemas.microsoft.com/office/drawing/2014/main" val="1403984627"/>
+                      <a16:colId xmlns:a16="http://schemas.microsoft.com/office/drawing/2014/main" val="48464989"/>
                     </a:ext>
                   </a:extLst>
                 </a:gridCol>
                 <a:gridCol w="1016000">
                   <a:extLst>
                     <a:ext uri="{9D8B030D-6E8A-4147-A177-3AD203B41FA5}">
-                      <a16:colId xmlns:a16="http://schemas.microsoft.com/office/drawing/2014/main" val="431130825"/>
+                      <a16:colId xmlns:a16="http://schemas.microsoft.com/office/drawing/2014/main" val="2021075385"/>
                     </a:ext>
                   </a:extLst>
                 </a:gridCol>
                 <a:gridCol w="2032000">
                   <a:extLst>
                     <a:ext uri="{9D8B030D-6E8A-4147-A177-3AD203B41FA5}">
-                      <a16:colId xmlns:a16="http://schemas.microsoft.com/office/drawing/2014/main" val="123444724"/>
+                      <a16:colId xmlns:a16="http://schemas.microsoft.com/office/drawing/2014/main" val="2017696373"/>
                     </a:ext>
                   </a:extLst>
                 </a:gridCol>
                 <a:gridCol w="2032000">
                   <a:extLst>
                     <a:ext uri="{9D8B030D-6E8A-4147-A177-3AD203B41FA5}">
-                      <a16:colId xmlns:a16="http://schemas.microsoft.com/office/drawing/2014/main" val="416654287"/>
+                      <a16:colId xmlns:a16="http://schemas.microsoft.com/office/drawing/2014/main" val="3276573649"/>
                     </a:ext>
                   </a:extLst>
                 </a:gridCol>
                 <a:gridCol w="2032000">
                   <a:extLst>
                     <a:ext uri="{9D8B030D-6E8A-4147-A177-3AD203B41FA5}">
-                      <a16:colId xmlns:a16="http://schemas.microsoft.com/office/drawing/2014/main" val="2836748067"/>
+                      <a16:colId xmlns:a16="http://schemas.microsoft.com/office/drawing/2014/main" val="1496618332"/>
                     </a:ext>
                   </a:extLst>
                 </a:gridCol>
@@ -16982,7 +16740,7 @@
                 </a:tc>
                 <a:extLst>
                   <a:ext uri="{0D108BD9-81ED-4DB2-BD59-A6C34878D82A}">
-                    <a16:rowId xmlns:a16="http://schemas.microsoft.com/office/drawing/2014/main" val="2302773172"/>
+                    <a16:rowId xmlns:a16="http://schemas.microsoft.com/office/drawing/2014/main" val="1541756970"/>
                   </a:ext>
                 </a:extLst>
               </a:tr>
@@ -17199,7 +16957,7 @@
                 </a:tc>
                 <a:extLst>
                   <a:ext uri="{0D108BD9-81ED-4DB2-BD59-A6C34878D82A}">
-                    <a16:rowId xmlns:a16="http://schemas.microsoft.com/office/drawing/2014/main" val="826111151"/>
+                    <a16:rowId xmlns:a16="http://schemas.microsoft.com/office/drawing/2014/main" val="3695385704"/>
                   </a:ext>
                 </a:extLst>
               </a:tr>
@@ -17416,7 +17174,7 @@
                 </a:tc>
                 <a:extLst>
                   <a:ext uri="{0D108BD9-81ED-4DB2-BD59-A6C34878D82A}">
-                    <a16:rowId xmlns:a16="http://schemas.microsoft.com/office/drawing/2014/main" val="407550352"/>
+                    <a16:rowId xmlns:a16="http://schemas.microsoft.com/office/drawing/2014/main" val="2143837066"/>
                   </a:ext>
                 </a:extLst>
               </a:tr>
@@ -17633,7 +17391,7 @@
                 </a:tc>
                 <a:extLst>
                   <a:ext uri="{0D108BD9-81ED-4DB2-BD59-A6C34878D82A}">
-                    <a16:rowId xmlns:a16="http://schemas.microsoft.com/office/drawing/2014/main" val="510581478"/>
+                    <a16:rowId xmlns:a16="http://schemas.microsoft.com/office/drawing/2014/main" val="2730495830"/>
                   </a:ext>
                 </a:extLst>
               </a:tr>
@@ -17850,7 +17608,7 @@
                 </a:tc>
                 <a:extLst>
                   <a:ext uri="{0D108BD9-81ED-4DB2-BD59-A6C34878D82A}">
-                    <a16:rowId xmlns:a16="http://schemas.microsoft.com/office/drawing/2014/main" val="1336223254"/>
+                    <a16:rowId xmlns:a16="http://schemas.microsoft.com/office/drawing/2014/main" val="3294962298"/>
                   </a:ext>
                 </a:extLst>
               </a:tr>
@@ -18067,7 +17825,7 @@
                 </a:tc>
                 <a:extLst>
                   <a:ext uri="{0D108BD9-81ED-4DB2-BD59-A6C34878D82A}">
-                    <a16:rowId xmlns:a16="http://schemas.microsoft.com/office/drawing/2014/main" val="3429864367"/>
+                    <a16:rowId xmlns:a16="http://schemas.microsoft.com/office/drawing/2014/main" val="4053149952"/>
                   </a:ext>
                 </a:extLst>
               </a:tr>
@@ -18080,7 +17838,7 @@
           <p:cNvPr id="5" name="TextBox 4">
             <a:extLst>
               <a:ext uri="{FF2B5EF4-FFF2-40B4-BE49-F238E27FC236}">
-                <a16:creationId xmlns:a16="http://schemas.microsoft.com/office/drawing/2014/main" id="{2898D917-2511-1486-E907-98233E8BA860}"/>
+                <a16:creationId xmlns:a16="http://schemas.microsoft.com/office/drawing/2014/main" id="{E5CE15E1-73EA-51D2-115C-41080844E63C}"/>
               </a:ext>
             </a:extLst>
           </p:cNvPr>
@@ -18131,7 +17889,7 @@
           <p:cNvPr id="6" name="TextBox 5">
             <a:extLst>
               <a:ext uri="{FF2B5EF4-FFF2-40B4-BE49-F238E27FC236}">
-                <a16:creationId xmlns:a16="http://schemas.microsoft.com/office/drawing/2014/main" id="{AC7826E2-B5EC-6632-FBA0-796D04871956}"/>
+                <a16:creationId xmlns:a16="http://schemas.microsoft.com/office/drawing/2014/main" id="{DD1BB334-010A-803C-4B89-C19C80B13100}"/>
               </a:ext>
             </a:extLst>
           </p:cNvPr>
@@ -18176,7 +17934,7 @@
           <p:cNvPr id="7" name="TextBox 6">
             <a:extLst>
               <a:ext uri="{FF2B5EF4-FFF2-40B4-BE49-F238E27FC236}">
-                <a16:creationId xmlns:a16="http://schemas.microsoft.com/office/drawing/2014/main" id="{8F5E7923-F7CF-5407-C272-CBEEC8E3F4BF}"/>
+                <a16:creationId xmlns:a16="http://schemas.microsoft.com/office/drawing/2014/main" id="{CA47ACCF-AC19-864D-EC59-3BCED631FA44}"/>
               </a:ext>
             </a:extLst>
           </p:cNvPr>
@@ -18219,7 +17977,7 @@
     </p:spTree>
     <p:extLst>
       <p:ext uri="{BB962C8B-B14F-4D97-AF65-F5344CB8AC3E}">
-        <p14:creationId xmlns:p14="http://schemas.microsoft.com/office/powerpoint/2010/main" val="2556659909"/>
+        <p14:creationId xmlns:p14="http://schemas.microsoft.com/office/powerpoint/2010/main" val="1700884233"/>
       </p:ext>
     </p:extLst>
   </p:cSld>

</xml_diff>